<commit_message>
Slides: add four EDA slides, team details and owners, takeaway bars
</commit_message>
<xml_diff>
--- a/slides/review1.pptx
+++ b/slides/review1.pptx
@@ -13,6 +13,10 @@
     <p:sldId id="258" r:id="rId4"/>
     <p:sldId id="259" r:id="rId5"/>
     <p:sldId id="260" r:id="rId6"/>
+    <p:sldId id="266" r:id="rId17"/>
+    <p:sldId id="267" r:id="rId18"/>
+    <p:sldId id="268" r:id="rId19"/>
+    <p:sldId id="269" r:id="rId20"/>
     <p:sldId id="261" r:id="rId7"/>
     <p:sldId id="262" r:id="rId8"/>
     <p:sldId id="263" r:id="rId9"/>
@@ -2890,7 +2894,7 @@
           </a:p>
           <a:p>
             <a:r>
-              <a:t>Introduce the project in one sentence: we help a small indie studio decide what to fix before Steam's refund window closes, which feature combinations to back, and when to patch. Fill in the team number, member names and register numbers (highlighted on the slide).</a:t>
+              <a:t>Introduce the project in one sentence: we help a small indie studio decide what to fix before Steam's refund window closes, which feature combinations to back, and when to patch.</a:t>
             </a:r>
           </a:p>
         </p:txBody>
@@ -2967,12 +2971,12 @@
           <a:lstStyle/>
           <a:p>
             <a:r>
-              <a:t>Suggested speaker: the fifth member and Shantharam. 1:30.</a:t>
+              <a:t>Suggested speakers: all five, about 15 seconds each. 1:15.</a:t>
             </a:r>
           </a:p>
           <a:p>
             <a:r>
-              <a:t>Each member names their own contribution and shows the evidence link. Pending work is what remains before and after Review 1. Review 2 is on 13 October, so the plan is compressed into 6–12 October. Fill in the highlighted register numbers and the fifth member's row.</a:t>
+              <a:t>Each member states their own contribution and evidence link, then the Review 2 task they own.</a:t>
             </a:r>
           </a:p>
         </p:txBody>
@@ -2995,6 +2999,306 @@
             <a:endParaRPr/>
           </a:p>
         </p:txBody>
+      </p:sp>
+    </p:spTree>
+  </p:cSld>
+  <p:clrMapOvr>
+    <a:masterClrMapping/>
+  </p:clrMapOvr>
+</p:notes>
+</file>
+
+<file path=ppt/notesSlides/notesSlide11.xml><?xml version="1.0" encoding="utf-8"?>
+<p:notes xmlns:a="http://schemas.openxmlformats.org/drawingml/2006/main" xmlns:p="http://schemas.openxmlformats.org/presentationml/2006/main" xmlns:r="http://schemas.openxmlformats.org/officeDocument/2006/relationships">
+  <p:cSld>
+    <p:spTree>
+      <p:nvGrpSpPr>
+        <p:cNvPr id="1" name=""/>
+        <p:cNvGrpSpPr/>
+        <p:nvPr/>
+      </p:nvGrpSpPr>
+      <p:grpSpPr>
+        <a:xfrm>
+          <a:off x="0" y="0"/>
+          <a:ext cx="0" cy="0"/>
+          <a:chOff x="0" y="0"/>
+          <a:chExt cx="0" cy="0"/>
+        </a:xfrm>
+      </p:grpSpPr>
+      <p:sp>
+        <p:nvSpPr>
+          <p:cNvPr id="2" name="Slide Image Placeholder 1"/>
+          <p:cNvSpPr>
+            <a:spLocks noGrp="1"/>
+          </p:cNvSpPr>
+          <p:nvPr>
+            <p:ph type="sldImg" idx="2"/>
+          </p:nvPr>
+        </p:nvSpPr>
+        <p:spPr/>
+      </p:sp>
+      <p:sp>
+        <p:nvSpPr>
+          <p:cNvPr id="3" name="Notes Placeholder 2"/>
+          <p:cNvSpPr>
+            <a:spLocks noGrp="1"/>
+          </p:cNvSpPr>
+          <p:nvPr>
+            <p:ph type="body" idx="3" sz="quarter"/>
+          </p:nvPr>
+        </p:nvSpPr>
+        <p:spPr/>
+        <p:txBody>
+          <a:bodyPr/>
+          <a:lstStyle/>
+          <a:p>
+            <a:r>
+              <a:t>Suggested speaker: Srihitha. 0:45.</a:t>
+            </a:r>
+          </a:p>
+          <a:p>
+            <a:r>
+              <a:t>From the EDA notebook section 3: the high-risk label is a negative share of 30% or more, on games with enough reviews for a stable rate.</a:t>
+            </a:r>
+          </a:p>
+        </p:txBody>
+      </p:sp>
+      <p:sp>
+        <p:nvSpPr>
+          <p:cNvPr id="4" name="Slide Number Placeholder 3"/>
+          <p:cNvSpPr>
+            <a:spLocks noGrp="1"/>
+          </p:cNvSpPr>
+          <p:nvPr>
+            <p:ph type="sldNum" idx="5" sz="quarter"/>
+          </p:nvPr>
+        </p:nvSpPr>
+        <p:spPr/>
+      </p:sp>
+    </p:spTree>
+  </p:cSld>
+  <p:clrMapOvr>
+    <a:masterClrMapping/>
+  </p:clrMapOvr>
+</p:notes>
+</file>
+
+<file path=ppt/notesSlides/notesSlide12.xml><?xml version="1.0" encoding="utf-8"?>
+<p:notes xmlns:a="http://schemas.openxmlformats.org/drawingml/2006/main" xmlns:p="http://schemas.openxmlformats.org/presentationml/2006/main" xmlns:r="http://schemas.openxmlformats.org/officeDocument/2006/relationships">
+  <p:cSld>
+    <p:spTree>
+      <p:nvGrpSpPr>
+        <p:cNvPr id="1" name=""/>
+        <p:cNvGrpSpPr/>
+        <p:nvPr/>
+      </p:nvGrpSpPr>
+      <p:grpSpPr>
+        <a:xfrm>
+          <a:off x="0" y="0"/>
+          <a:ext cx="0" cy="0"/>
+          <a:chOff x="0" y="0"/>
+          <a:chExt cx="0" cy="0"/>
+        </a:xfrm>
+      </p:grpSpPr>
+      <p:sp>
+        <p:nvSpPr>
+          <p:cNvPr id="2" name="Slide Image Placeholder 1"/>
+          <p:cNvSpPr>
+            <a:spLocks noGrp="1"/>
+          </p:cNvSpPr>
+          <p:nvPr>
+            <p:ph type="sldImg" idx="2"/>
+          </p:nvPr>
+        </p:nvSpPr>
+        <p:spPr/>
+      </p:sp>
+      <p:sp>
+        <p:nvSpPr>
+          <p:cNvPr id="3" name="Notes Placeholder 2"/>
+          <p:cNvSpPr>
+            <a:spLocks noGrp="1"/>
+          </p:cNvSpPr>
+          <p:nvPr>
+            <p:ph type="body" idx="3" sz="quarter"/>
+          </p:nvPr>
+        </p:nvSpPr>
+        <p:spPr/>
+        <p:txBody>
+          <a:bodyPr/>
+          <a:lstStyle/>
+          <a:p>
+            <a:r>
+              <a:t>Suggested speaker: Srihitha. 0:45.</a:t>
+            </a:r>
+          </a:p>
+          <a:p>
+            <a:r>
+              <a:t>Bars show the high-risk rate with Wilson 95% intervals. Release year is confounded with exposure time. Store attributes were captured at the snapshot date, not at launch.</a:t>
+            </a:r>
+          </a:p>
+        </p:txBody>
+      </p:sp>
+      <p:sp>
+        <p:nvSpPr>
+          <p:cNvPr id="4" name="Slide Number Placeholder 3"/>
+          <p:cNvSpPr>
+            <a:spLocks noGrp="1"/>
+          </p:cNvSpPr>
+          <p:nvPr>
+            <p:ph type="sldNum" idx="5" sz="quarter"/>
+          </p:nvPr>
+        </p:nvSpPr>
+        <p:spPr/>
+      </p:sp>
+    </p:spTree>
+  </p:cSld>
+  <p:clrMapOvr>
+    <a:masterClrMapping/>
+  </p:clrMapOvr>
+</p:notes>
+</file>
+
+<file path=ppt/notesSlides/notesSlide13.xml><?xml version="1.0" encoding="utf-8"?>
+<p:notes xmlns:a="http://schemas.openxmlformats.org/drawingml/2006/main" xmlns:p="http://schemas.openxmlformats.org/presentationml/2006/main" xmlns:r="http://schemas.openxmlformats.org/officeDocument/2006/relationships">
+  <p:cSld>
+    <p:spTree>
+      <p:nvGrpSpPr>
+        <p:cNvPr id="1" name=""/>
+        <p:cNvGrpSpPr/>
+        <p:nvPr/>
+      </p:nvGrpSpPr>
+      <p:grpSpPr>
+        <a:xfrm>
+          <a:off x="0" y="0"/>
+          <a:ext cx="0" cy="0"/>
+          <a:chOff x="0" y="0"/>
+          <a:chExt cx="0" cy="0"/>
+        </a:xfrm>
+      </p:grpSpPr>
+      <p:sp>
+        <p:nvSpPr>
+          <p:cNvPr id="2" name="Slide Image Placeholder 1"/>
+          <p:cNvSpPr>
+            <a:spLocks noGrp="1"/>
+          </p:cNvSpPr>
+          <p:nvPr>
+            <p:ph type="sldImg" idx="2"/>
+          </p:nvPr>
+        </p:nvSpPr>
+        <p:spPr/>
+      </p:sp>
+      <p:sp>
+        <p:nvSpPr>
+          <p:cNvPr id="3" name="Notes Placeholder 2"/>
+          <p:cNvSpPr>
+            <a:spLocks noGrp="1"/>
+          </p:cNvSpPr>
+          <p:nvPr>
+            <p:ph type="body" idx="3" sz="quarter"/>
+          </p:nvPr>
+        </p:nvSpPr>
+        <p:spPr/>
+        <p:txBody>
+          <a:bodyPr/>
+          <a:lstStyle/>
+          <a:p>
+            <a:r>
+              <a:t>Suggested speaker: Srihitha. 0:45.</a:t>
+            </a:r>
+          </a:p>
+          <a:p>
+            <a:r>
+              <a:t>Spearman correlations on games with enough reviews. This slide is why the protocol bans outcome and after-the-fact columns as features.</a:t>
+            </a:r>
+          </a:p>
+        </p:txBody>
+      </p:sp>
+      <p:sp>
+        <p:nvSpPr>
+          <p:cNvPr id="4" name="Slide Number Placeholder 3"/>
+          <p:cNvSpPr>
+            <a:spLocks noGrp="1"/>
+          </p:cNvSpPr>
+          <p:nvPr>
+            <p:ph type="sldNum" idx="5" sz="quarter"/>
+          </p:nvPr>
+        </p:nvSpPr>
+        <p:spPr/>
+      </p:sp>
+    </p:spTree>
+  </p:cSld>
+  <p:clrMapOvr>
+    <a:masterClrMapping/>
+  </p:clrMapOvr>
+</p:notes>
+</file>
+
+<file path=ppt/notesSlides/notesSlide14.xml><?xml version="1.0" encoding="utf-8"?>
+<p:notes xmlns:a="http://schemas.openxmlformats.org/drawingml/2006/main" xmlns:p="http://schemas.openxmlformats.org/presentationml/2006/main" xmlns:r="http://schemas.openxmlformats.org/officeDocument/2006/relationships">
+  <p:cSld>
+    <p:spTree>
+      <p:nvGrpSpPr>
+        <p:cNvPr id="1" name=""/>
+        <p:cNvGrpSpPr/>
+        <p:nvPr/>
+      </p:nvGrpSpPr>
+      <p:grpSpPr>
+        <a:xfrm>
+          <a:off x="0" y="0"/>
+          <a:ext cx="0" cy="0"/>
+          <a:chOff x="0" y="0"/>
+          <a:chExt cx="0" cy="0"/>
+        </a:xfrm>
+      </p:grpSpPr>
+      <p:sp>
+        <p:nvSpPr>
+          <p:cNvPr id="2" name="Slide Image Placeholder 1"/>
+          <p:cNvSpPr>
+            <a:spLocks noGrp="1"/>
+          </p:cNvSpPr>
+          <p:nvPr>
+            <p:ph type="sldImg" idx="2"/>
+          </p:nvPr>
+        </p:nvSpPr>
+        <p:spPr/>
+      </p:sp>
+      <p:sp>
+        <p:nvSpPr>
+          <p:cNvPr id="3" name="Notes Placeholder 2"/>
+          <p:cNvSpPr>
+            <a:spLocks noGrp="1"/>
+          </p:cNvSpPr>
+          <p:nvPr>
+            <p:ph type="body" idx="3" sz="quarter"/>
+          </p:nvPr>
+        </p:nvSpPr>
+        <p:spPr/>
+        <p:txBody>
+          <a:bodyPr/>
+          <a:lstStyle/>
+          <a:p>
+            <a:r>
+              <a:t>Suggested speaker: Srihitha. 0:45.</a:t>
+            </a:r>
+          </a:p>
+          <a:p>
+            <a:r>
+              <a:t>From EDA section 11. Pairs are ranked by the confidence bound nearest the overall rate so small samples cannot top the list. Not causal.</a:t>
+            </a:r>
+          </a:p>
+        </p:txBody>
+      </p:sp>
+      <p:sp>
+        <p:nvSpPr>
+          <p:cNvPr id="4" name="Slide Number Placeholder 3"/>
+          <p:cNvSpPr>
+            <a:spLocks noGrp="1"/>
+          </p:cNvSpPr>
+          <p:nvPr>
+            <p:ph type="sldNum" idx="5" sz="quarter"/>
+          </p:nvPr>
+        </p:nvSpPr>
+        <p:spPr/>
       </p:sp>
     </p:spTree>
   </p:cSld>
@@ -3049,7 +3353,7 @@
           <a:lstStyle/>
           <a:p>
             <a:r>
-              <a:t>Suggested speaker: Shantharam. 1:30.</a:t>
+              <a:t>Suggested speaker: Tejaswini (problem statement owner). 1:00.</a:t>
             </a:r>
           </a:p>
           <a:p>
@@ -3131,7 +3435,7 @@
           <a:lstStyle/>
           <a:p>
             <a:r>
-              <a:t>Suggested speaker: Shantharam. 1:30.</a:t>
+              <a:t>Suggested speaker: Shantharam. 1:00.</a:t>
             </a:r>
           </a:p>
           <a:p>
@@ -3213,7 +3517,7 @@
           <a:lstStyle/>
           <a:p>
             <a:r>
-              <a:t>Suggested speaker: Shantharam. 1:30.</a:t>
+              <a:t>Suggested speaker: Shantharam. 1:00.</a:t>
             </a:r>
           </a:p>
           <a:p>
@@ -3295,7 +3599,7 @@
           <a:lstStyle/>
           <a:p>
             <a:r>
-              <a:t>Suggested speaker: Srihitha (EDA author). 2:00.</a:t>
+              <a:t>Suggested speaker: Srihitha (EDA author). 1:00, then four more EDA slides.</a:t>
             </a:r>
           </a:p>
           <a:p>
@@ -3377,7 +3681,7 @@
           <a:lstStyle/>
           <a:p>
             <a:r>
-              <a:t>Suggested speaker: Gayas (dimensionality reduction). 1:30.</a:t>
+              <a:t>Suggested speaker: Gayas (dimensionality reduction). 1:15.</a:t>
             </a:r>
           </a:p>
           <a:p>
@@ -3459,7 +3763,7 @@
           <a:lstStyle/>
           <a:p>
             <a:r>
-              <a:t>Suggested speaker: Pradeep (XGBoost models). 1:30.</a:t>
+              <a:t>Suggested speaker: Pradeep (XGBoost models) and Shantharam. 1:15.</a:t>
             </a:r>
           </a:p>
           <a:p>
@@ -3541,7 +3845,7 @@
           <a:lstStyle/>
           <a:p>
             <a:r>
-              <a:t>Suggested speaker: Pradeep and Shantharam. 2:30.</a:t>
+              <a:t>Suggested speaker: Pradeep and Shantharam. 2:00.</a:t>
             </a:r>
           </a:p>
           <a:p>
@@ -3623,12 +3927,12 @@
           <a:lstStyle/>
           <a:p>
             <a:r>
-              <a:t>Suggested speaker: Shantharam (board admin). 1:00.</a:t>
+              <a:t>Suggested speaker: Shantharam (board admin). 0:45.</a:t>
             </a:r>
           </a:p>
           <a:p>
             <a:r>
-              <a:t>The board uses the five required stages, and every card has an owner (where assigned), a due date and an Evidence field. Activity history is also visible in GitHub: merged pull requests and commits with dates. Table is a snapshot of the board; update it if owners change before the review.</a:t>
+              <a:t>The board uses the five required stages; every card has an owner, a due date and an Evidence field. Activity history is also visible in GitHub as dated pull requests and commits. The table is a snapshot of the board.</a:t>
             </a:r>
           </a:p>
         </p:txBody>
@@ -4123,7 +4427,7 @@
               </a:defRPr>
             </a:pPr>
             <a:r>
-              <a:rPr sz="2100" b="0" i="0">
+              <a:rPr sz="1700" b="0" i="0">
                 <a:solidFill>
                   <a:srgbClr val="FFFFFF"/>
                 </a:solidFill>
@@ -4139,7 +4443,7 @@
               </a:spcAft>
             </a:pPr>
             <a:r>
-              <a:rPr sz="2100" b="0" i="0">
+              <a:rPr sz="1700" b="0" i="0">
                 <a:solidFill>
                   <a:srgbClr val="DFEAF3"/>
                 </a:solidFill>
@@ -4155,13 +4459,13 @@
               </a:spcAft>
             </a:pPr>
             <a:r>
-              <a:rPr sz="2100" b="0" i="0">
+              <a:rPr sz="1700" b="0" i="0">
                 <a:solidFill>
                   <a:srgbClr val="DFEAF3"/>
                 </a:solidFill>
                 <a:latin typeface="Bitstream Charter"/>
               </a:rPr>
-              <a:t>Review 1</a:t>
+              <a:t>Review 1  •  23CSE452 Business Analytics</a:t>
             </a:r>
           </a:p>
           <a:p>
@@ -4171,13 +4475,13 @@
               </a:spcAft>
             </a:pPr>
             <a:r>
-              <a:rPr sz="2100" b="0" i="0">
+              <a:rPr sz="1700" b="0" i="0">
                 <a:solidFill>
                   <a:srgbClr val="DFEAF3"/>
                 </a:solidFill>
                 <a:latin typeface="Bitstream Charter"/>
               </a:rPr>
-              <a:t>23CSE452 Business Analytics</a:t>
+              <a:t>Data Analysis and Predictive Modelling</a:t>
             </a:r>
           </a:p>
           <a:p>
@@ -4187,13 +4491,13 @@
               </a:spcAft>
             </a:pPr>
             <a:r>
-              <a:rPr sz="2100" b="0" i="0">
+              <a:rPr sz="1700" b="0" i="0">
                 <a:solidFill>
                   <a:srgbClr val="DFEAF3"/>
                 </a:solidFill>
                 <a:latin typeface="Bitstream Charter"/>
               </a:rPr>
-              <a:t>Data Analysis and Predictive Modelling</a:t>
+              <a:t/>
             </a:r>
           </a:p>
           <a:p>
@@ -4203,13 +4507,13 @@
               </a:spcAft>
             </a:pPr>
             <a:r>
-              <a:rPr sz="2100" b="0" i="0">
-                <a:solidFill>
-                  <a:srgbClr val="DFEAF3"/>
+              <a:rPr sz="1700" b="1" i="0">
+                <a:solidFill>
+                  <a:srgbClr val="FFFFFF"/>
                 </a:solidFill>
                 <a:latin typeface="Bitstream Charter"/>
               </a:rPr>
-              <a:t/>
+              <a:t>Group 1</a:t>
             </a:r>
           </a:p>
           <a:p>
@@ -4219,22 +4523,13 @@
               </a:spcAft>
             </a:pPr>
             <a:r>
-              <a:rPr sz="2100" b="0" i="0">
+              <a:rPr sz="1700" b="0" i="0">
                 <a:solidFill>
                   <a:srgbClr val="DFEAF3"/>
                 </a:solidFill>
                 <a:latin typeface="Bitstream Charter"/>
               </a:rPr>
-              <a:t>Team number: </a:t>
-            </a:r>
-            <a:r>
-              <a:rPr sz="2100" b="1" i="0">
-                <a:solidFill>
-                  <a:srgbClr val="FFC857"/>
-                </a:solidFill>
-                <a:latin typeface="Bitstream Charter"/>
-              </a:rPr>
-              <a:t>[enter team number]</a:t>
+              <a:t>Thotakura Srihitha  •  CB.SC.U4CSE23450</a:t>
             </a:r>
           </a:p>
           <a:p>
@@ -4244,31 +4539,13 @@
               </a:spcAft>
             </a:pPr>
             <a:r>
-              <a:rPr sz="2100" b="0" i="0">
+              <a:rPr sz="1700" b="0" i="0">
                 <a:solidFill>
                   <a:srgbClr val="DFEAF3"/>
                 </a:solidFill>
                 <a:latin typeface="Bitstream Charter"/>
               </a:rPr>
-              <a:t>Members: </a:t>
-            </a:r>
-            <a:r>
-              <a:rPr sz="2100" b="0" i="0">
-                <a:solidFill>
-                  <a:srgbClr val="DFEAF3"/>
-                </a:solidFill>
-                <a:latin typeface="Bitstream Charter"/>
-              </a:rPr>
-              <a:t>Shantharam P, Gayas Sheik, Srihitha, Pradeep Sasidharan, </a:t>
-            </a:r>
-            <a:r>
-              <a:rPr sz="2100" b="1" i="0">
-                <a:solidFill>
-                  <a:srgbClr val="FFC857"/>
-                </a:solidFill>
-                <a:latin typeface="Bitstream Charter"/>
-              </a:rPr>
-              <a:t>[member 5]</a:t>
+              <a:t>Gayas Sheik  •  CB.SC.U4CSE23118</a:t>
             </a:r>
           </a:p>
           <a:p>
@@ -4278,22 +4555,45 @@
               </a:spcAft>
             </a:pPr>
             <a:r>
-              <a:rPr sz="2100" b="0" i="0">
+              <a:rPr sz="1700" b="0" i="0">
                 <a:solidFill>
                   <a:srgbClr val="DFEAF3"/>
                 </a:solidFill>
                 <a:latin typeface="Bitstream Charter"/>
               </a:rPr>
-              <a:t>Register numbers: </a:t>
-            </a:r>
-            <a:r>
-              <a:rPr sz="2100" b="1" i="0">
-                <a:solidFill>
-                  <a:srgbClr val="FFC857"/>
+              <a:t>Shantharam P  •  CB.SC.U4CSE23146</a:t>
+            </a:r>
+          </a:p>
+          <a:p>
+            <a:pPr>
+              <a:spcAft>
+                <a:spcPts val="300"/>
+              </a:spcAft>
+            </a:pPr>
+            <a:r>
+              <a:rPr sz="1700" b="0" i="0">
+                <a:solidFill>
+                  <a:srgbClr val="DFEAF3"/>
                 </a:solidFill>
                 <a:latin typeface="Bitstream Charter"/>
               </a:rPr>
-              <a:t>[add register numbers]</a:t>
+              <a:t>Pradeep Sasidharan  •  CB.SC.U4CSE23232</a:t>
+            </a:r>
+          </a:p>
+          <a:p>
+            <a:pPr>
+              <a:spcAft>
+                <a:spcPts val="300"/>
+              </a:spcAft>
+            </a:pPr>
+            <a:r>
+              <a:rPr sz="1700" b="0" i="0">
+                <a:solidFill>
+                  <a:srgbClr val="DFEAF3"/>
+                </a:solidFill>
+                <a:latin typeface="Bitstream Charter"/>
+              </a:rPr>
+              <a:t>Valikala Tejaswini  •  CB.SC.U4CSE23752</a:t>
             </a:r>
           </a:p>
         </p:txBody>
@@ -4560,7 +4860,7 @@
                 <a:ea typeface="Bitstream Charter"/>
                 <a:cs typeface="Bitstream Charter"/>
               </a:rPr>
-              <a:t>10</a:t>
+              <a:t>14</a:t>
             </a:r>
           </a:p>
         </p:txBody>
@@ -4574,8 +4874,8 @@
           <p:nvPr/>
         </p:nvGraphicFramePr>
         <p:xfrm>
-          <a:off x="722376" y="1481328"/>
-          <a:ext cx="10744200" cy="2743200"/>
+          <a:off x="722376" y="1417320"/>
+          <a:ext cx="10744200" cy="3401568"/>
         </p:xfrm>
         <a:graphic>
           <a:graphicData uri="http://schemas.openxmlformats.org/drawingml/2006/table">
@@ -4584,11 +4884,11 @@
                 <a:tableStyleId>{2D5ABB26-0587-4C30-8999-92F81FD0307C}</a:tableStyleId>
               </a:tblPr>
               <a:tblGrid>
-                <a:gridCol w="2148840"/>
-                <a:gridCol w="6126480"/>
-                <a:gridCol w="2468880"/>
+                <a:gridCol w="2194560"/>
+                <a:gridCol w="5486400"/>
+                <a:gridCol w="3063240"/>
               </a:tblGrid>
-              <a:tr h="457200">
+              <a:tr h="566928">
                 <a:tc>
                   <a:txBody>
                     <a:bodyPr wrap="square"/>
@@ -4601,7 +4901,7 @@
                           </a:solidFill>
                           <a:latin typeface="Bitstream Charter"/>
                         </a:rPr>
-                        <a:t>Member / register no.</a:t>
+                        <a:t>Member / roll no.</a:t>
                       </a:r>
                     </a:p>
                   </a:txBody>
@@ -4623,7 +4923,7 @@
                           </a:solidFill>
                           <a:latin typeface="Bitstream Charter"/>
                         </a:rPr>
-                        <a:t>Completed tasks and evidence</a:t>
+                        <a:t>Completed in Review 1, with evidence</a:t>
                       </a:r>
                     </a:p>
                   </a:txBody>
@@ -4645,7 +4945,7 @@
                           </a:solidFill>
                           <a:latin typeface="Bitstream Charter"/>
                         </a:rPr>
-                        <a:t>Pending work</a:t>
+                        <a:t>Review 2 ownership</a:t>
                       </a:r>
                     </a:p>
                   </a:txBody>
@@ -4656,7 +4956,7 @@
                   </a:tcPr>
                 </a:tc>
               </a:tr>
-              <a:tr h="457200">
+              <a:tr h="566928">
                 <a:tc>
                   <a:txBody>
                     <a:bodyPr wrap="square"/>
@@ -4672,22 +4972,203 @@
                         <a:t>Shantharam P</a:t>
                       </a:r>
                       <a:r>
+                        <a:rPr sz="850" b="0" i="0">
+                          <a:solidFill>
+                            <a:srgbClr val="48677E"/>
+                          </a:solidFill>
+                          <a:latin typeface="Bitstream Charter"/>
+                        </a:rPr>
+                        <a:t>  CB.SC.U4CSE23146</a:t>
+                      </a:r>
+                    </a:p>
+                  </a:txBody>
+                  <a:tcPr marL="64008" marR="64008" marT="32004" marB="32004" anchor="ctr">
+                    <a:lnB w="9525" cap="flat" cmpd="sng" algn="ctr">
+                      <a:solidFill>
+                        <a:srgbClr val="C9D6E2"/>
+                      </a:solidFill>
+                      <a:prstDash val="solid"/>
+                    </a:lnB>
+                    <a:solidFill>
+                      <a:srgbClr val="FFFFFF"/>
+                    </a:solidFill>
+                  </a:tcPr>
+                </a:tc>
+                <a:tc>
+                  <a:txBody>
+                    <a:bodyPr wrap="square"/>
+                    <a:lstStyle/>
+                    <a:p>
+                      <a:r>
                         <a:rPr sz="950" b="0" i="0">
                           <a:solidFill>
                             <a:srgbClr val="263C50"/>
                           </a:solidFill>
                           <a:latin typeface="Bitstream Charter"/>
                         </a:rPr>
-                        <a:t> / </a:t>
-                      </a:r>
+                        <a:t>Data collection and cleaning, dataset documentation, shared split and targets, Logistic Regression / Random Forest / LightGBM, model comparison and text models, notebook, board. Evidence: src/collect, src/clean, src/models, notebooks/review1</a:t>
+                      </a:r>
+                    </a:p>
+                  </a:txBody>
+                  <a:tcPr marL="64008" marR="64008" marT="32004" marB="32004" anchor="ctr">
+                    <a:lnB w="9525" cap="flat" cmpd="sng" algn="ctr">
+                      <a:solidFill>
+                        <a:srgbClr val="C9D6E2"/>
+                      </a:solidFill>
+                      <a:prstDash val="solid"/>
+                    </a:lnB>
+                    <a:solidFill>
+                      <a:srgbClr val="FFFFFF"/>
+                    </a:solidFill>
+                  </a:tcPr>
+                </a:tc>
+                <a:tc>
+                  <a:txBody>
+                    <a:bodyPr wrap="square"/>
+                    <a:lstStyle/>
+                    <a:p>
+                      <a:r>
+                        <a:rPr sz="950" b="0" i="0">
+                          <a:solidFill>
+                            <a:srgbClr val="263C50"/>
+                          </a:solidFill>
+                          <a:latin typeface="Bitstream Charter"/>
+                        </a:rPr>
+                        <a:t>Deployment, final report, Review 2 slides (#43, #45, #46)</a:t>
+                      </a:r>
+                    </a:p>
+                  </a:txBody>
+                  <a:tcPr marL="64008" marR="64008" marT="32004" marB="32004" anchor="ctr">
+                    <a:lnB w="9525" cap="flat" cmpd="sng" algn="ctr">
+                      <a:solidFill>
+                        <a:srgbClr val="C9D6E2"/>
+                      </a:solidFill>
+                      <a:prstDash val="solid"/>
+                    </a:lnB>
+                    <a:solidFill>
+                      <a:srgbClr val="FFFFFF"/>
+                    </a:solidFill>
+                  </a:tcPr>
+                </a:tc>
+              </a:tr>
+              <a:tr h="566928">
+                <a:tc>
+                  <a:txBody>
+                    <a:bodyPr wrap="square"/>
+                    <a:lstStyle/>
+                    <a:p>
                       <a:r>
                         <a:rPr sz="950" b="1" i="0">
                           <a:solidFill>
-                            <a:srgbClr val="B7791F"/>
-                          </a:solidFill>
-                          <a:latin typeface="Bitstream Charter"/>
-                        </a:rPr>
-                        <a:t>[reg. no.]</a:t>
+                            <a:srgbClr val="263C50"/>
+                          </a:solidFill>
+                          <a:latin typeface="Bitstream Charter"/>
+                        </a:rPr>
+                        <a:t>Pradeep Sasidharan</a:t>
+                      </a:r>
+                      <a:r>
+                        <a:rPr sz="850" b="0" i="0">
+                          <a:solidFill>
+                            <a:srgbClr val="48677E"/>
+                          </a:solidFill>
+                          <a:latin typeface="Bitstream Charter"/>
+                        </a:rPr>
+                        <a:t>  CB.SC.U4CSE23232</a:t>
+                      </a:r>
+                    </a:p>
+                  </a:txBody>
+                  <a:tcPr marL="64008" marR="64008" marT="32004" marB="32004" anchor="ctr">
+                    <a:lnB w="9525" cap="flat" cmpd="sng" algn="ctr">
+                      <a:solidFill>
+                        <a:srgbClr val="C9D6E2"/>
+                      </a:solidFill>
+                      <a:prstDash val="solid"/>
+                    </a:lnB>
+                    <a:solidFill>
+                      <a:srgbClr val="EAF0F6"/>
+                    </a:solidFill>
+                  </a:tcPr>
+                </a:tc>
+                <a:tc>
+                  <a:txBody>
+                    <a:bodyPr wrap="square"/>
+                    <a:lstStyle/>
+                    <a:p>
+                      <a:r>
+                        <a:rPr sz="950" b="0" i="0">
+                          <a:solidFill>
+                            <a:srgbClr val="263C50"/>
+                          </a:solidFill>
+                          <a:latin typeface="Bitstream Charter"/>
+                        </a:rPr>
+                        <a:t>XGBoost review-level and game-level models with SHAP and curves; evaluation with Shantharam. Evidence: PR #55, src/models/*_xgboost.py</a:t>
+                      </a:r>
+                    </a:p>
+                  </a:txBody>
+                  <a:tcPr marL="64008" marR="64008" marT="32004" marB="32004" anchor="ctr">
+                    <a:lnB w="9525" cap="flat" cmpd="sng" algn="ctr">
+                      <a:solidFill>
+                        <a:srgbClr val="C9D6E2"/>
+                      </a:solidFill>
+                      <a:prstDash val="solid"/>
+                    </a:lnB>
+                    <a:solidFill>
+                      <a:srgbClr val="EAF0F6"/>
+                    </a:solidFill>
+                  </a:tcPr>
+                </a:tc>
+                <a:tc>
+                  <a:txBody>
+                    <a:bodyPr wrap="square"/>
+                    <a:lstStyle/>
+                    <a:p>
+                      <a:r>
+                        <a:rPr sz="950" b="0" i="0">
+                          <a:solidFill>
+                            <a:srgbClr val="263C50"/>
+                          </a:solidFill>
+                          <a:latin typeface="Bitstream Charter"/>
+                        </a:rPr>
+                        <a:t>Association rules: transactions, Apriori/FP-Growth, rule evaluation (#34–#36)</a:t>
+                      </a:r>
+                    </a:p>
+                  </a:txBody>
+                  <a:tcPr marL="64008" marR="64008" marT="32004" marB="32004" anchor="ctr">
+                    <a:lnB w="9525" cap="flat" cmpd="sng" algn="ctr">
+                      <a:solidFill>
+                        <a:srgbClr val="C9D6E2"/>
+                      </a:solidFill>
+                      <a:prstDash val="solid"/>
+                    </a:lnB>
+                    <a:solidFill>
+                      <a:srgbClr val="EAF0F6"/>
+                    </a:solidFill>
+                  </a:tcPr>
+                </a:tc>
+              </a:tr>
+              <a:tr h="566928">
+                <a:tc>
+                  <a:txBody>
+                    <a:bodyPr wrap="square"/>
+                    <a:lstStyle/>
+                    <a:p>
+                      <a:r>
+                        <a:rPr sz="950" b="1" i="0">
+                          <a:solidFill>
+                            <a:srgbClr val="263C50"/>
+                          </a:solidFill>
+                          <a:latin typeface="Bitstream Charter"/>
+                        </a:rPr>
+                        <a:t>Gayas Sheik</a:t>
+                      </a:r>
+                      <a:r>
+                        <a:rPr sz="850" b="0" i="0">
+                          <a:solidFill>
+                            <a:srgbClr val="48677E"/>
+                          </a:solidFill>
+                          <a:latin typeface="Bitstream Charter"/>
+                        </a:rPr>
+                        <a:t>  CB.SC.U4CSE23118</a:t>
                       </a:r>
                     </a:p>
                   </a:txBody>
@@ -4715,7 +5196,7 @@
                           </a:solidFill>
                           <a:latin typeface="Bitstream Charter"/>
                         </a:rPr>
-                        <a:t>Data collection and cleaning, dataset documentation, shared split, features and game tiers, model comparison and text models, findings, problem statement, notebook, board. Evidence: src/collect, src/clean, src/features, src/models, docs/</a:t>
+                        <a:t>Feature engineering and tag dimensionality reduction (train-only fit, portable paths). Evidence: PRs #2, #49, #50, src/dimensionality_reduction</a:t>
                       </a:r>
                     </a:p>
                   </a:txBody>
@@ -4743,7 +5224,7 @@
                           </a:solidFill>
                           <a:latin typeface="Bitstream Charter"/>
                         </a:rPr>
-                        <a:t>Slides rehearsal; board owners</a:t>
+                        <a:t>Patch-impact analysis, reproducibility, launch-risk scorer page (#38, #39, #42)</a:t>
                       </a:r>
                     </a:p>
                   </a:txBody>
@@ -4760,7 +5241,7 @@
                   </a:tcPr>
                 </a:tc>
               </a:tr>
-              <a:tr h="457200">
+              <a:tr h="566928">
                 <a:tc>
                   <a:txBody>
                     <a:bodyPr wrap="square"/>
@@ -4773,8 +5254,36 @@
                           </a:solidFill>
                           <a:latin typeface="Bitstream Charter"/>
                         </a:rPr>
-                        <a:t>Gayas Sheik</a:t>
-                      </a:r>
+                        <a:t>Thotakura Srihitha</a:t>
+                      </a:r>
+                      <a:r>
+                        <a:rPr sz="850" b="0" i="0">
+                          <a:solidFill>
+                            <a:srgbClr val="48677E"/>
+                          </a:solidFill>
+                          <a:latin typeface="Bitstream Charter"/>
+                        </a:rPr>
+                        <a:t>  CB.SC.U4CSE23450</a:t>
+                      </a:r>
+                    </a:p>
+                  </a:txBody>
+                  <a:tcPr marL="64008" marR="64008" marT="32004" marB="32004" anchor="ctr">
+                    <a:lnB w="9525" cap="flat" cmpd="sng" algn="ctr">
+                      <a:solidFill>
+                        <a:srgbClr val="C9D6E2"/>
+                      </a:solidFill>
+                      <a:prstDash val="solid"/>
+                    </a:lnB>
+                    <a:solidFill>
+                      <a:srgbClr val="EAF0F6"/>
+                    </a:solidFill>
+                  </a:tcPr>
+                </a:tc>
+                <a:tc>
+                  <a:txBody>
+                    <a:bodyPr wrap="square"/>
+                    <a:lstStyle/>
+                    <a:p>
                       <a:r>
                         <a:rPr sz="950" b="0" i="0">
                           <a:solidFill>
@@ -4782,28 +5291,86 @@
                           </a:solidFill>
                           <a:latin typeface="Bitstream Charter"/>
                         </a:rPr>
-                        <a:t> / </a:t>
-                      </a:r>
+                        <a:t>Exploratory analysis: 29 figures, association tests and tag combinations. Evidence: PR #1, notebooks/02_EDA_Visualizations.ipynb</a:t>
+                      </a:r>
+                    </a:p>
+                  </a:txBody>
+                  <a:tcPr marL="64008" marR="64008" marT="32004" marB="32004" anchor="ctr">
+                    <a:lnB w="9525" cap="flat" cmpd="sng" algn="ctr">
+                      <a:solidFill>
+                        <a:srgbClr val="C9D6E2"/>
+                      </a:solidFill>
+                      <a:prstDash val="solid"/>
+                    </a:lnB>
+                    <a:solidFill>
+                      <a:srgbClr val="EAF0F6"/>
+                    </a:solidFill>
+                  </a:tcPr>
+                </a:tc>
+                <a:tc>
+                  <a:txBody>
+                    <a:bodyPr wrap="square"/>
+                    <a:lstStyle/>
+                    <a:p>
+                      <a:r>
+                        <a:rPr sz="950" b="0" i="0">
+                          <a:solidFill>
+                            <a:srgbClr val="263C50"/>
+                          </a:solidFill>
+                          <a:latin typeface="Bitstream Charter"/>
+                        </a:rPr>
+                        <a:t>Dashboard wireframe and market / rule explorer pages (#37, #40, #41)</a:t>
+                      </a:r>
+                    </a:p>
+                  </a:txBody>
+                  <a:tcPr marL="64008" marR="64008" marT="32004" marB="32004" anchor="ctr">
+                    <a:lnB w="9525" cap="flat" cmpd="sng" algn="ctr">
+                      <a:solidFill>
+                        <a:srgbClr val="C9D6E2"/>
+                      </a:solidFill>
+                      <a:prstDash val="solid"/>
+                    </a:lnB>
+                    <a:solidFill>
+                      <a:srgbClr val="EAF0F6"/>
+                    </a:solidFill>
+                  </a:tcPr>
+                </a:tc>
+              </a:tr>
+              <a:tr h="566928">
+                <a:tc>
+                  <a:txBody>
+                    <a:bodyPr wrap="square"/>
+                    <a:lstStyle/>
+                    <a:p>
                       <a:r>
                         <a:rPr sz="950" b="1" i="0">
                           <a:solidFill>
-                            <a:srgbClr val="B7791F"/>
-                          </a:solidFill>
-                          <a:latin typeface="Bitstream Charter"/>
-                        </a:rPr>
-                        <a:t>[reg. no.]</a:t>
-                      </a:r>
-                    </a:p>
-                  </a:txBody>
-                  <a:tcPr marL="64008" marR="64008" marT="32004" marB="32004" anchor="ctr">
-                    <a:lnB w="9525" cap="flat" cmpd="sng" algn="ctr">
-                      <a:solidFill>
-                        <a:srgbClr val="C9D6E2"/>
-                      </a:solidFill>
-                      <a:prstDash val="solid"/>
-                    </a:lnB>
-                    <a:solidFill>
-                      <a:srgbClr val="EAF0F6"/>
+                            <a:srgbClr val="263C50"/>
+                          </a:solidFill>
+                          <a:latin typeface="Bitstream Charter"/>
+                        </a:rPr>
+                        <a:t>Valikala Tejaswini</a:t>
+                      </a:r>
+                      <a:r>
+                        <a:rPr sz="850" b="0" i="0">
+                          <a:solidFill>
+                            <a:srgbClr val="48677E"/>
+                          </a:solidFill>
+                          <a:latin typeface="Bitstream Charter"/>
+                        </a:rPr>
+                        <a:t>  CB.SC.U4CSE23752</a:t>
+                      </a:r>
+                    </a:p>
+                  </a:txBody>
+                  <a:tcPr marL="64008" marR="64008" marT="32004" marB="32004" anchor="ctr">
+                    <a:lnB w="9525" cap="flat" cmpd="sng" algn="ctr">
+                      <a:solidFill>
+                        <a:srgbClr val="C9D6E2"/>
+                      </a:solidFill>
+                      <a:prstDash val="solid"/>
+                    </a:lnB>
+                    <a:solidFill>
+                      <a:srgbClr val="FFFFFF"/>
                     </a:solidFill>
                   </a:tcPr>
                 </a:tc>
@@ -4819,19 +5386,19 @@
                           </a:solidFill>
                           <a:latin typeface="Bitstream Charter"/>
                         </a:rPr>
-                        <a:t>Tag dimensionality reduction (train/test fit, portable paths), co-author of the feature pipeline. Evidence: PRs #2, #49, #50; src/dimensionality_reduction</a:t>
-                      </a:r>
-                    </a:p>
-                  </a:txBody>
-                  <a:tcPr marL="64008" marR="64008" marT="32004" marB="32004" anchor="ctr">
-                    <a:lnB w="9525" cap="flat" cmpd="sng" algn="ctr">
-                      <a:solidFill>
-                        <a:srgbClr val="C9D6E2"/>
-                      </a:solidFill>
-                      <a:prstDash val="solid"/>
-                    </a:lnB>
-                    <a:solidFill>
-                      <a:srgbClr val="EAF0F6"/>
+                        <a:t>Problem statement and research gap; the Review 1 chart pack. Evidence: docs/problem_statement.md, figures/</a:t>
+                      </a:r>
+                    </a:p>
+                  </a:txBody>
+                  <a:tcPr marL="64008" marR="64008" marT="32004" marB="32004" anchor="ctr">
+                    <a:lnB w="9525" cap="flat" cmpd="sng" algn="ctr">
+                      <a:solidFill>
+                        <a:srgbClr val="C9D6E2"/>
+                      </a:solidFill>
+                      <a:prstDash val="solid"/>
+                    </a:lnB>
+                    <a:solidFill>
+                      <a:srgbClr val="FFFFFF"/>
                     </a:solidFill>
                   </a:tcPr>
                 </a:tc>
@@ -4847,319 +5414,7 @@
                           </a:solidFill>
                           <a:latin typeface="Bitstream Charter"/>
                         </a:rPr>
-                        <a:t>Contribution summaries (#29); analysis-table card (#15)</a:t>
-                      </a:r>
-                    </a:p>
-                  </a:txBody>
-                  <a:tcPr marL="64008" marR="64008" marT="32004" marB="32004" anchor="ctr">
-                    <a:lnB w="9525" cap="flat" cmpd="sng" algn="ctr">
-                      <a:solidFill>
-                        <a:srgbClr val="C9D6E2"/>
-                      </a:solidFill>
-                      <a:prstDash val="solid"/>
-                    </a:lnB>
-                    <a:solidFill>
-                      <a:srgbClr val="EAF0F6"/>
-                    </a:solidFill>
-                  </a:tcPr>
-                </a:tc>
-              </a:tr>
-              <a:tr h="457200">
-                <a:tc>
-                  <a:txBody>
-                    <a:bodyPr wrap="square"/>
-                    <a:lstStyle/>
-                    <a:p>
-                      <a:r>
-                        <a:rPr sz="950" b="1" i="0">
-                          <a:solidFill>
-                            <a:srgbClr val="263C50"/>
-                          </a:solidFill>
-                          <a:latin typeface="Bitstream Charter"/>
-                        </a:rPr>
-                        <a:t>Srihitha</a:t>
-                      </a:r>
-                      <a:r>
-                        <a:rPr sz="950" b="0" i="0">
-                          <a:solidFill>
-                            <a:srgbClr val="263C50"/>
-                          </a:solidFill>
-                          <a:latin typeface="Bitstream Charter"/>
-                        </a:rPr>
-                        <a:t> / </a:t>
-                      </a:r>
-                      <a:r>
-                        <a:rPr sz="950" b="1" i="0">
-                          <a:solidFill>
-                            <a:srgbClr val="B7791F"/>
-                          </a:solidFill>
-                          <a:latin typeface="Bitstream Charter"/>
-                        </a:rPr>
-                        <a:t>[reg. no.]</a:t>
-                      </a:r>
-                    </a:p>
-                  </a:txBody>
-                  <a:tcPr marL="64008" marR="64008" marT="32004" marB="32004" anchor="ctr">
-                    <a:lnB w="9525" cap="flat" cmpd="sng" algn="ctr">
-                      <a:solidFill>
-                        <a:srgbClr val="C9D6E2"/>
-                      </a:solidFill>
-                      <a:prstDash val="solid"/>
-                    </a:lnB>
-                    <a:solidFill>
-                      <a:srgbClr val="FFFFFF"/>
-                    </a:solidFill>
-                  </a:tcPr>
-                </a:tc>
-                <a:tc>
-                  <a:txBody>
-                    <a:bodyPr wrap="square"/>
-                    <a:lstStyle/>
-                    <a:p>
-                      <a:r>
-                        <a:rPr sz="950" b="0" i="0">
-                          <a:solidFill>
-                            <a:srgbClr val="263C50"/>
-                          </a:solidFill>
-                          <a:latin typeface="Bitstream Charter"/>
-                        </a:rPr>
-                        <a:t>EDA notebook with 29 figures. Evidence: PR #1; notebooks/02_EDA_Visualizations.ipynb</a:t>
-                      </a:r>
-                    </a:p>
-                  </a:txBody>
-                  <a:tcPr marL="64008" marR="64008" marT="32004" marB="32004" anchor="ctr">
-                    <a:lnB w="9525" cap="flat" cmpd="sng" algn="ctr">
-                      <a:solidFill>
-                        <a:srgbClr val="C9D6E2"/>
-                      </a:solidFill>
-                      <a:prstDash val="solid"/>
-                    </a:lnB>
-                    <a:solidFill>
-                      <a:srgbClr val="FFFFFF"/>
-                    </a:solidFill>
-                  </a:tcPr>
-                </a:tc>
-                <a:tc>
-                  <a:txBody>
-                    <a:bodyPr wrap="square"/>
-                    <a:lstStyle/>
-                    <a:p>
-                      <a:r>
-                        <a:rPr sz="950" b="0" i="0">
-                          <a:solidFill>
-                            <a:srgbClr val="263C50"/>
-                          </a:solidFill>
-                          <a:latin typeface="Bitstream Charter"/>
-                        </a:rPr>
-                        <a:t>Final charts for slides (#22)</a:t>
-                      </a:r>
-                    </a:p>
-                  </a:txBody>
-                  <a:tcPr marL="64008" marR="64008" marT="32004" marB="32004" anchor="ctr">
-                    <a:lnB w="9525" cap="flat" cmpd="sng" algn="ctr">
-                      <a:solidFill>
-                        <a:srgbClr val="C9D6E2"/>
-                      </a:solidFill>
-                      <a:prstDash val="solid"/>
-                    </a:lnB>
-                    <a:solidFill>
-                      <a:srgbClr val="FFFFFF"/>
-                    </a:solidFill>
-                  </a:tcPr>
-                </a:tc>
-              </a:tr>
-              <a:tr h="457200">
-                <a:tc>
-                  <a:txBody>
-                    <a:bodyPr wrap="square"/>
-                    <a:lstStyle/>
-                    <a:p>
-                      <a:r>
-                        <a:rPr sz="950" b="1" i="0">
-                          <a:solidFill>
-                            <a:srgbClr val="263C50"/>
-                          </a:solidFill>
-                          <a:latin typeface="Bitstream Charter"/>
-                        </a:rPr>
-                        <a:t>Pradeep Sasidharan</a:t>
-                      </a:r>
-                      <a:r>
-                        <a:rPr sz="950" b="0" i="0">
-                          <a:solidFill>
-                            <a:srgbClr val="263C50"/>
-                          </a:solidFill>
-                          <a:latin typeface="Bitstream Charter"/>
-                        </a:rPr>
-                        <a:t> / </a:t>
-                      </a:r>
-                      <a:r>
-                        <a:rPr sz="950" b="1" i="0">
-                          <a:solidFill>
-                            <a:srgbClr val="B7791F"/>
-                          </a:solidFill>
-                          <a:latin typeface="Bitstream Charter"/>
-                        </a:rPr>
-                        <a:t>[reg. no.]</a:t>
-                      </a:r>
-                    </a:p>
-                  </a:txBody>
-                  <a:tcPr marL="64008" marR="64008" marT="32004" marB="32004" anchor="ctr">
-                    <a:lnB w="9525" cap="flat" cmpd="sng" algn="ctr">
-                      <a:solidFill>
-                        <a:srgbClr val="C9D6E2"/>
-                      </a:solidFill>
-                      <a:prstDash val="solid"/>
-                    </a:lnB>
-                    <a:solidFill>
-                      <a:srgbClr val="EAF0F6"/>
-                    </a:solidFill>
-                  </a:tcPr>
-                </a:tc>
-                <a:tc>
-                  <a:txBody>
-                    <a:bodyPr wrap="square"/>
-                    <a:lstStyle/>
-                    <a:p>
-                      <a:r>
-                        <a:rPr sz="950" b="0" i="0">
-                          <a:solidFill>
-                            <a:srgbClr val="263C50"/>
-                          </a:solidFill>
-                          <a:latin typeface="Bitstream Charter"/>
-                        </a:rPr>
-                        <a:t>XGBoost review and game models with SHAP and curves. Evidence: PR #55; src/models/*_xgboost.py</a:t>
-                      </a:r>
-                    </a:p>
-                  </a:txBody>
-                  <a:tcPr marL="64008" marR="64008" marT="32004" marB="32004" anchor="ctr">
-                    <a:lnB w="9525" cap="flat" cmpd="sng" algn="ctr">
-                      <a:solidFill>
-                        <a:srgbClr val="C9D6E2"/>
-                      </a:solidFill>
-                      <a:prstDash val="solid"/>
-                    </a:lnB>
-                    <a:solidFill>
-                      <a:srgbClr val="EAF0F6"/>
-                    </a:solidFill>
-                  </a:tcPr>
-                </a:tc>
-                <a:tc>
-                  <a:txBody>
-                    <a:bodyPr wrap="square"/>
-                    <a:lstStyle/>
-                    <a:p>
-                      <a:r>
-                        <a:rPr sz="950" b="0" i="0">
-                          <a:solidFill>
-                            <a:srgbClr val="263C50"/>
-                          </a:solidFill>
-                          <a:latin typeface="Bitstream Charter"/>
-                        </a:rPr>
-                        <a:t>Tune XGBoost (--tune)</a:t>
-                      </a:r>
-                    </a:p>
-                  </a:txBody>
-                  <a:tcPr marL="64008" marR="64008" marT="32004" marB="32004" anchor="ctr">
-                    <a:lnB w="9525" cap="flat" cmpd="sng" algn="ctr">
-                      <a:solidFill>
-                        <a:srgbClr val="C9D6E2"/>
-                      </a:solidFill>
-                      <a:prstDash val="solid"/>
-                    </a:lnB>
-                    <a:solidFill>
-                      <a:srgbClr val="EAF0F6"/>
-                    </a:solidFill>
-                  </a:tcPr>
-                </a:tc>
-              </a:tr>
-              <a:tr h="457200">
-                <a:tc>
-                  <a:txBody>
-                    <a:bodyPr wrap="square"/>
-                    <a:lstStyle/>
-                    <a:p>
-                      <a:r>
-                        <a:rPr sz="950" b="1" i="0">
-                          <a:solidFill>
-                            <a:srgbClr val="B7791F"/>
-                          </a:solidFill>
-                          <a:latin typeface="Bitstream Charter"/>
-                        </a:rPr>
-                        <a:t>[Member 5]</a:t>
-                      </a:r>
-                      <a:r>
-                        <a:rPr sz="950" b="0" i="0">
-                          <a:solidFill>
-                            <a:srgbClr val="263C50"/>
-                          </a:solidFill>
-                          <a:latin typeface="Bitstream Charter"/>
-                        </a:rPr>
-                        <a:t> / </a:t>
-                      </a:r>
-                      <a:r>
-                        <a:rPr sz="950" b="1" i="0">
-                          <a:solidFill>
-                            <a:srgbClr val="B7791F"/>
-                          </a:solidFill>
-                          <a:latin typeface="Bitstream Charter"/>
-                        </a:rPr>
-                        <a:t>[reg. no.]</a:t>
-                      </a:r>
-                    </a:p>
-                  </a:txBody>
-                  <a:tcPr marL="64008" marR="64008" marT="32004" marB="32004" anchor="ctr">
-                    <a:lnB w="9525" cap="flat" cmpd="sng" algn="ctr">
-                      <a:solidFill>
-                        <a:srgbClr val="C9D6E2"/>
-                      </a:solidFill>
-                      <a:prstDash val="solid"/>
-                    </a:lnB>
-                    <a:solidFill>
-                      <a:srgbClr val="FFFFFF"/>
-                    </a:solidFill>
-                  </a:tcPr>
-                </a:tc>
-                <a:tc>
-                  <a:txBody>
-                    <a:bodyPr wrap="square"/>
-                    <a:lstStyle/>
-                    <a:p>
-                      <a:r>
-                        <a:rPr sz="950" b="1" i="0">
-                          <a:solidFill>
-                            <a:srgbClr val="B7791F"/>
-                          </a:solidFill>
-                          <a:latin typeface="Bitstream Charter"/>
-                        </a:rPr>
-                        <a:t>[add contribution and evidence link]</a:t>
-                      </a:r>
-                    </a:p>
-                  </a:txBody>
-                  <a:tcPr marL="64008" marR="64008" marT="32004" marB="32004" anchor="ctr">
-                    <a:lnB w="9525" cap="flat" cmpd="sng" algn="ctr">
-                      <a:solidFill>
-                        <a:srgbClr val="C9D6E2"/>
-                      </a:solidFill>
-                      <a:prstDash val="solid"/>
-                    </a:lnB>
-                    <a:solidFill>
-                      <a:srgbClr val="FFFFFF"/>
-                    </a:solidFill>
-                  </a:tcPr>
-                </a:tc>
-                <a:tc>
-                  <a:txBody>
-                    <a:bodyPr wrap="square"/>
-                    <a:lstStyle/>
-                    <a:p>
-                      <a:r>
-                        <a:rPr sz="950" b="1" i="0">
-                          <a:solidFill>
-                            <a:srgbClr val="B7791F"/>
-                          </a:solidFill>
-                          <a:latin typeface="Bitstream Charter"/>
-                        </a:rPr>
-                        <a:t>[add]</a:t>
+                        <a:t>Text mining and topic modelling, text evaluation, combined insights (#31–#33, #44)</a:t>
                       </a:r>
                     </a:p>
                   </a:txBody>
@@ -5188,8 +5443,8 @@
         </p:nvSpPr>
         <p:spPr>
           <a:xfrm>
-            <a:off x="722376" y="4297680"/>
-            <a:ext cx="6035040" cy="1737360"/>
+            <a:off x="722376" y="5120640"/>
+            <a:ext cx="6035040" cy="1371600"/>
           </a:xfrm>
           <a:prstGeom prst="rect">
             <a:avLst/>
@@ -5204,11 +5459,11 @@
           <a:p>
             <a:pPr>
               <a:spcAft>
-                <a:spcPts val="300"/>
+                <a:spcPts val="200"/>
               </a:spcAft>
             </a:pPr>
             <a:r>
-              <a:rPr sz="1100" b="1" i="0">
+              <a:rPr sz="1050" b="1" i="0">
                 <a:solidFill>
                   <a:srgbClr val="132C43"/>
                 </a:solidFill>
@@ -5220,65 +5475,65 @@
           <a:p>
             <a:pPr>
               <a:spcAft>
-                <a:spcPts val="300"/>
+                <a:spcPts val="200"/>
               </a:spcAft>
             </a:pPr>
             <a:r>
-              <a:rPr sz="1100" b="0" i="0">
+              <a:rPr sz="1050" b="0" i="0">
                 <a:solidFill>
                   <a:srgbClr val="263C50"/>
                 </a:solidFill>
                 <a:latin typeface="Bitstream Charter"/>
               </a:rPr>
-              <a:t>6–8 Oct  text mining (#31–#33), association rules (#34–#36), dashboard wireframe (#37)</a:t>
+              <a:t>6–8 Oct  text mining (Tejaswini), association rules (Pradeep), dashboard wireframe (Srihitha)</a:t>
             </a:r>
           </a:p>
           <a:p>
             <a:pPr>
               <a:spcAft>
-                <a:spcPts val="300"/>
+                <a:spcPts val="200"/>
               </a:spcAft>
             </a:pPr>
             <a:r>
-              <a:rPr sz="1100" b="0" i="0">
+              <a:rPr sz="1050" b="0" i="0">
                 <a:solidFill>
                   <a:srgbClr val="263C50"/>
                 </a:solidFill>
                 <a:latin typeface="Bitstream Charter"/>
               </a:rPr>
-              <a:t>8–10 Oct  dashboard pages, patch-impact analysis (#38, #40–#43)</a:t>
+              <a:t>8–10 Oct  dashboard pages (Srihitha, Gayas), patch impact (Gayas)</a:t>
             </a:r>
           </a:p>
           <a:p>
             <a:pPr>
               <a:spcAft>
-                <a:spcPts val="300"/>
+                <a:spcPts val="200"/>
               </a:spcAft>
             </a:pPr>
             <a:r>
-              <a:rPr sz="1100" b="0" i="0">
+              <a:rPr sz="1050" b="0" i="0">
                 <a:solidFill>
                   <a:srgbClr val="263C50"/>
                 </a:solidFill>
                 <a:latin typeface="Bitstream Charter"/>
               </a:rPr>
-              <a:t>10–11 Oct  combined insights, final report, reproducibility (#39, #44, #45)</a:t>
+              <a:t>10–11 Oct  combined insights (Tejaswini), final report, deployment (Shantharam)</a:t>
             </a:r>
           </a:p>
           <a:p>
             <a:pPr>
               <a:spcAft>
-                <a:spcPts val="300"/>
+                <a:spcPts val="200"/>
               </a:spcAft>
             </a:pPr>
             <a:r>
-              <a:rPr sz="1100" b="0" i="0">
+              <a:rPr sz="1050" b="0" i="0">
                 <a:solidFill>
                   <a:srgbClr val="263C50"/>
                 </a:solidFill>
                 <a:latin typeface="Bitstream Charter"/>
               </a:rPr>
-              <a:t>12 Oct  slides and rehearsal (#46, #47).  Owners to be confirmed on the board</a:t>
+              <a:t>12 Oct  slides and rehearsal (all)</a:t>
             </a:r>
           </a:p>
         </p:txBody>
@@ -5291,8 +5546,8 @@
         </p:nvSpPr>
         <p:spPr>
           <a:xfrm>
-            <a:off x="6949440" y="4297680"/>
-            <a:ext cx="4572000" cy="1737360"/>
+            <a:off x="6949440" y="5120640"/>
+            <a:ext cx="4572000" cy="1371600"/>
           </a:xfrm>
           <a:prstGeom prst="rect">
             <a:avLst/>
@@ -5307,11 +5562,11 @@
           <a:p>
             <a:pPr>
               <a:spcAft>
-                <a:spcPts val="300"/>
+                <a:spcPts val="200"/>
               </a:spcAft>
             </a:pPr>
             <a:r>
-              <a:rPr sz="1100" b="1" i="0">
+              <a:rPr sz="1050" b="1" i="0">
                 <a:solidFill>
                   <a:srgbClr val="132C43"/>
                 </a:solidFill>
@@ -5323,11 +5578,11 @@
           <a:p>
             <a:pPr>
               <a:spcAft>
-                <a:spcPts val="300"/>
+                <a:spcPts val="200"/>
               </a:spcAft>
             </a:pPr>
             <a:r>
-              <a:rPr sz="1100" b="1" i="0">
+              <a:rPr sz="1050" b="1" i="0">
                 <a:solidFill>
                   <a:srgbClr val="263C50"/>
                 </a:solidFill>
@@ -5336,7 +5591,7 @@
               <a:t>Notebook: </a:t>
             </a:r>
             <a:r>
-              <a:rPr sz="1100" b="0" i="0">
+              <a:rPr sz="1050" b="0" i="0">
                 <a:solidFill>
                   <a:srgbClr val="48677E"/>
                 </a:solidFill>
@@ -5349,78 +5604,79 @@
           <a:p>
             <a:pPr>
               <a:spcAft>
-                <a:spcPts val="300"/>
+                <a:spcPts val="200"/>
               </a:spcAft>
             </a:pPr>
             <a:r>
-              <a:rPr sz="1100" b="1" i="0">
+              <a:rPr sz="1050" b="1" i="0">
                 <a:solidFill>
                   <a:srgbClr val="263C50"/>
                 </a:solidFill>
                 <a:latin typeface="Bitstream Charter"/>
               </a:rPr>
-              <a:t>Data documentation: </a:t>
-            </a:r>
-            <a:r>
-              <a:rPr sz="1100" b="0" i="0">
+              <a:t>EDA notebook: </a:t>
+            </a:r>
+            <a:r>
+              <a:rPr sz="1050" b="0" i="0">
                 <a:solidFill>
                   <a:srgbClr val="48677E"/>
                 </a:solidFill>
                 <a:latin typeface="Bitstream Charter"/>
                 <a:hlinkClick r:id="rId4"/>
               </a:rPr>
-              <a:t>docs/data_documentation.md</a:t>
+              <a:t>notebooks/02_EDA_Visualizations.ipynb</a:t>
             </a:r>
           </a:p>
           <a:p>
             <a:pPr>
               <a:spcAft>
-                <a:spcPts val="300"/>
+                <a:spcPts val="200"/>
               </a:spcAft>
             </a:pPr>
             <a:r>
-              <a:rPr sz="1100" b="1" i="0">
+              <a:rPr sz="1050" b="1" i="0">
                 <a:solidFill>
                   <a:srgbClr val="263C50"/>
                 </a:solidFill>
                 <a:latin typeface="Bitstream Charter"/>
               </a:rPr>
-              <a:t>Board: </a:t>
-            </a:r>
-            <a:r>
-              <a:rPr sz="1100" b="0" i="0">
+              <a:t>Data documentation: </a:t>
+            </a:r>
+            <a:r>
+              <a:rPr sz="1050" b="0" i="0">
                 <a:solidFill>
                   <a:srgbClr val="48677E"/>
                 </a:solidFill>
                 <a:latin typeface="Bitstream Charter"/>
                 <a:hlinkClick r:id="rId5"/>
               </a:rPr>
-              <a:t>github.com/users/Shan713/projects/1</a:t>
+              <a:t>docs/data_documentation.md</a:t>
             </a:r>
           </a:p>
           <a:p>
             <a:pPr>
               <a:spcAft>
-                <a:spcPts val="300"/>
+                <a:spcPts val="200"/>
               </a:spcAft>
             </a:pPr>
             <a:r>
-              <a:rPr sz="1100" b="1" i="0">
+              <a:rPr sz="1050" b="1" i="0">
                 <a:solidFill>
                   <a:srgbClr val="263C50"/>
                 </a:solidFill>
                 <a:latin typeface="Bitstream Charter"/>
               </a:rPr>
-              <a:t>Contribution summary: </a:t>
-            </a:r>
-            <a:r>
-              <a:rPr sz="1100" b="0" i="0">
-                <a:solidFill>
-                  <a:srgbClr val="B7791F"/>
-                </a:solidFill>
-                <a:latin typeface="Bitstream Charter"/>
+              <a:t>Board: </a:t>
+            </a:r>
+            <a:r>
+              <a:rPr sz="1050" b="0" i="0">
+                <a:solidFill>
+                  <a:srgbClr val="48677E"/>
+                </a:solidFill>
+                <a:latin typeface="Bitstream Charter"/>
+                <a:hlinkClick r:id="rId6"/>
               </a:rPr>
-              <a:t>docs/contributions_r1.md (to be added)</a:t>
+              <a:t>github.com/users/Shan713/projects/1</a:t>
             </a:r>
           </a:p>
         </p:txBody>
@@ -5431,6 +5687,1510 @@
         <p14:creationId xmlns:p14="http://schemas.microsoft.com/office/powerpoint/2010/main" val="1065099268"/>
       </p:ext>
     </p:extLst>
+  </p:cSld>
+  <p:clrMapOvr>
+    <a:masterClrMapping/>
+  </p:clrMapOvr>
+</p:sld>
+</file>
+
+<file path=ppt/slides/slide11.xml><?xml version="1.0" encoding="utf-8"?>
+<p:sld xmlns:a="http://schemas.openxmlformats.org/drawingml/2006/main" xmlns:p="http://schemas.openxmlformats.org/presentationml/2006/main" xmlns:r="http://schemas.openxmlformats.org/officeDocument/2006/relationships">
+  <p:cSld>
+    <p:bg>
+      <p:bgPr>
+        <a:solidFill>
+          <a:srgbClr val="F7F9FC"/>
+        </a:solidFill>
+        <a:effectLst/>
+      </p:bgPr>
+    </p:bg>
+    <p:spTree>
+      <p:nvGrpSpPr>
+        <p:cNvPr id="1" name=""/>
+        <p:cNvGrpSpPr/>
+        <p:nvPr/>
+      </p:nvGrpSpPr>
+      <p:grpSpPr/>
+      <p:sp>
+        <p:nvSpPr>
+          <p:cNvPr id="5" name="Rectangle 4">
+            <a:extLst>
+              <a:ext uri="{FF2B5EF4-FFF2-40B4-BE49-F238E27FC236}">
+                <a16:creationId xmlns:a16="http://schemas.microsoft.com/office/drawing/2014/main" id="{27979FDE-990F-4C15-B33C-B2975BF50CD9}"/>
+              </a:ext>
+            </a:extLst>
+          </p:cNvPr>
+          <p:cNvSpPr>
+            <a:spLocks noGrp="1"/>
+          </p:cNvSpPr>
+          <p:nvPr/>
+        </p:nvSpPr>
+        <p:spPr>
+          <a:xfrm>
+            <a:off x="685800" y="523875"/>
+            <a:ext cx="10820400" cy="952500"/>
+          </a:xfrm>
+          <a:prstGeom prst="rect">
+            <a:avLst/>
+          </a:prstGeom>
+          <a:noFill/>
+          <a:ln w="0">
+            <a:noFill/>
+          </a:ln>
+        </p:spPr>
+        <p:txBody>
+          <a:bodyPr wrap="square">
+            <a:noAutofit/>
+          </a:bodyPr>
+          <a:lstStyle/>
+          <a:p>
+            <a:pPr>
+              <a:spcAft>
+                <a:spcPts val="400"/>
+              </a:spcAft>
+              <a:defRPr sz="3300" b="1">
+                <a:solidFill>
+                  <a:srgbClr val="132C43"/>
+                </a:solidFill>
+                <a:latin typeface="Bitstream Charter"/>
+                <a:ea typeface="Bitstream Charter"/>
+                <a:cs typeface="Bitstream Charter"/>
+              </a:defRPr>
+            </a:pPr>
+            <a:r>
+              <a:rPr sz="3300" b="1" i="0">
+                <a:solidFill>
+                  <a:srgbClr val="132C43"/>
+                </a:solidFill>
+                <a:latin typeface="Bitstream Charter"/>
+              </a:rPr>
+              <a:t>EDA: Target and Game Population</a:t>
+            </a:r>
+          </a:p>
+        </p:txBody>
+      </p:sp>
+      <p:sp>
+        <p:nvSpPr>
+          <p:cNvPr id="4" name="Rectangle 3">
+            <a:extLst>
+              <a:ext uri="{FF2B5EF4-FFF2-40B4-BE49-F238E27FC236}">
+                <a16:creationId xmlns:a16="http://schemas.microsoft.com/office/drawing/2014/main" id="{C795E4D0-3C0B-473C-BB65-A65A174FB43B}"/>
+              </a:ext>
+            </a:extLst>
+          </p:cNvPr>
+          <p:cNvSpPr>
+            <a:spLocks noGrp="1"/>
+          </p:cNvSpPr>
+          <p:nvPr/>
+        </p:nvSpPr>
+        <p:spPr>
+          <a:xfrm>
+            <a:off x="11049000" y="6076950"/>
+            <a:ext cx="476250" cy="381000"/>
+          </a:xfrm>
+          <a:prstGeom prst="rect">
+            <a:avLst/>
+          </a:prstGeom>
+          <a:noFill/>
+          <a:ln w="0">
+            <a:noFill/>
+          </a:ln>
+        </p:spPr>
+        <p:txBody>
+          <a:bodyPr>
+            <a:noAutofit/>
+          </a:bodyPr>
+          <a:lstStyle/>
+          <a:p>
+            <a:pPr>
+              <a:defRPr sz="1500" b="0">
+                <a:solidFill>
+                  <a:srgbClr val="48677E"/>
+                </a:solidFill>
+                <a:latin typeface="Bitstream Charter"/>
+                <a:ea typeface="Bitstream Charter"/>
+                <a:cs typeface="Bitstream Charter"/>
+              </a:defRPr>
+            </a:pPr>
+            <a:r>
+              <a:rPr sz="1500" b="0">
+                <a:solidFill>
+                  <a:srgbClr val="48677E"/>
+                </a:solidFill>
+                <a:latin typeface="Bitstream Charter"/>
+                <a:ea typeface="Bitstream Charter"/>
+                <a:cs typeface="Bitstream Charter"/>
+              </a:rPr>
+              <a:t>06</a:t>
+            </a:r>
+          </a:p>
+        </p:txBody>
+      </p:sp>
+      <p:pic>
+        <p:nvPicPr>
+          <p:cNvPr id="6" name="Picture 5" descr="03_target_definition.png"/>
+          <p:cNvPicPr>
+            <a:picLocks noChangeAspect="1"/>
+          </p:cNvPicPr>
+          <p:nvPr/>
+        </p:nvPicPr>
+        <p:blipFill>
+          <a:blip r:embed="rId2"/>
+          <a:stretch>
+            <a:fillRect/>
+          </a:stretch>
+        </p:blipFill>
+        <p:spPr>
+          <a:xfrm>
+            <a:off x="603504" y="1463040"/>
+            <a:ext cx="10972800" cy="2794273"/>
+          </a:xfrm>
+          <a:prstGeom prst="rect">
+            <a:avLst/>
+          </a:prstGeom>
+        </p:spPr>
+      </p:pic>
+      <p:sp>
+        <p:nvSpPr>
+          <p:cNvPr id="7" name="TextBox 6"/>
+          <p:cNvSpPr txBox="1"/>
+          <p:nvPr/>
+        </p:nvSpPr>
+        <p:spPr>
+          <a:xfrm>
+            <a:off x="722376" y="4343400"/>
+            <a:ext cx="3520440" cy="1188720"/>
+          </a:xfrm>
+          <a:prstGeom prst="rect">
+            <a:avLst/>
+          </a:prstGeom>
+          <a:noFill/>
+        </p:spPr>
+        <p:txBody>
+          <a:bodyPr wrap="square" lIns="45720" rIns="45720" tIns="27432" bIns="27432">
+            <a:spAutoFit/>
+          </a:bodyPr>
+          <a:lstStyle/>
+          <a:p>
+            <a:pPr>
+              <a:spcAft>
+                <a:spcPts val="400"/>
+              </a:spcAft>
+            </a:pPr>
+            <a:r>
+              <a:rPr sz="1150" b="1" i="0">
+                <a:solidFill>
+                  <a:srgbClr val="132C43"/>
+                </a:solidFill>
+                <a:latin typeface="Bitstream Charter"/>
+              </a:rPr>
+              <a:t>High-risk label  </a:t>
+            </a:r>
+            <a:r>
+              <a:rPr sz="1150" b="0" i="0">
+                <a:solidFill>
+                  <a:srgbClr val="263C50"/>
+                </a:solidFill>
+                <a:latin typeface="Bitstream Charter"/>
+              </a:rPr>
+              <a:t>216 of 1,490 games (14.5%) have a negative share of 30% or more; 10.4% of all 1.65M reviews are negative.</a:t>
+            </a:r>
+          </a:p>
+        </p:txBody>
+      </p:sp>
+      <p:sp>
+        <p:nvSpPr>
+          <p:cNvPr id="8" name="TextBox 7"/>
+          <p:cNvSpPr txBox="1"/>
+          <p:nvPr/>
+        </p:nvSpPr>
+        <p:spPr>
+          <a:xfrm>
+            <a:off x="4343400" y="4343400"/>
+            <a:ext cx="3520440" cy="1188720"/>
+          </a:xfrm>
+          <a:prstGeom prst="rect">
+            <a:avLst/>
+          </a:prstGeom>
+          <a:noFill/>
+        </p:spPr>
+        <p:txBody>
+          <a:bodyPr wrap="square" lIns="45720" rIns="45720" tIns="27432" bIns="27432">
+            <a:spAutoFit/>
+          </a:bodyPr>
+          <a:lstStyle/>
+          <a:p>
+            <a:pPr>
+              <a:spcAft>
+                <a:spcPts val="400"/>
+              </a:spcAft>
+            </a:pPr>
+            <a:r>
+              <a:rPr sz="1150" b="1" i="0">
+                <a:solidFill>
+                  <a:srgbClr val="132C43"/>
+                </a:solidFill>
+                <a:latin typeface="Bitstream Charter"/>
+              </a:rPr>
+              <a:t>Shape  </a:t>
+            </a:r>
+            <a:r>
+              <a:rPr sz="1150" b="0" i="0">
+                <a:solidFill>
+                  <a:srgbClr val="263C50"/>
+                </a:solidFill>
+                <a:latin typeface="Bitstream Charter"/>
+              </a:rPr>
+              <a:t>Most games sit below 25% negative; the long tail above 30% is the risk group, so we use PR-AUC and class weights, not accuracy.</a:t>
+            </a:r>
+          </a:p>
+        </p:txBody>
+      </p:sp>
+      <p:sp>
+        <p:nvSpPr>
+          <p:cNvPr id="9" name="TextBox 8"/>
+          <p:cNvSpPr txBox="1"/>
+          <p:nvPr/>
+        </p:nvSpPr>
+        <p:spPr>
+          <a:xfrm>
+            <a:off x="7955279" y="4343400"/>
+            <a:ext cx="3520440" cy="1188720"/>
+          </a:xfrm>
+          <a:prstGeom prst="rect">
+            <a:avLst/>
+          </a:prstGeom>
+          <a:noFill/>
+        </p:spPr>
+        <p:txBody>
+          <a:bodyPr wrap="square" lIns="45720" rIns="45720" tIns="27432" bIns="27432">
+            <a:spAutoFit/>
+          </a:bodyPr>
+          <a:lstStyle/>
+          <a:p>
+            <a:pPr>
+              <a:spcAft>
+                <a:spcPts val="400"/>
+              </a:spcAft>
+            </a:pPr>
+            <a:r>
+              <a:rPr sz="1150" b="1" i="0">
+                <a:solidFill>
+                  <a:srgbClr val="132C43"/>
+                </a:solidFill>
+                <a:latin typeface="Bitstream Charter"/>
+              </a:rPr>
+              <a:t>Steam’s own labels  </a:t>
+            </a:r>
+            <a:r>
+              <a:rPr sz="1150" b="0" i="0">
+                <a:solidFill>
+                  <a:srgbClr val="263C50"/>
+                </a:solidFill>
+                <a:latin typeface="Bitstream Charter"/>
+              </a:rPr>
+              <a:t>Almost all games are Positive or better; Mostly Negative is rare. The EDA used this binary label; modelling later moved to three tiers (docs/game_target.md).</a:t>
+            </a:r>
+          </a:p>
+        </p:txBody>
+      </p:sp>
+      <p:sp>
+        <p:nvSpPr>
+          <p:cNvPr id="10" name="Rectangle 9"/>
+          <p:cNvSpPr/>
+          <p:nvPr/>
+        </p:nvSpPr>
+        <p:spPr>
+          <a:xfrm>
+            <a:off x="722376" y="5623560"/>
+            <a:ext cx="64008" cy="457200"/>
+          </a:xfrm>
+          <a:prstGeom prst="rect">
+            <a:avLst/>
+          </a:prstGeom>
+          <a:solidFill>
+            <a:srgbClr val="D1495B"/>
+          </a:solidFill>
+          <a:ln>
+            <a:noFill/>
+          </a:ln>
+        </p:spPr>
+        <p:style>
+          <a:lnRef idx="1">
+            <a:schemeClr val="accent1"/>
+          </a:lnRef>
+          <a:fillRef idx="3">
+            <a:schemeClr val="accent1"/>
+          </a:fillRef>
+          <a:effectRef idx="2">
+            <a:schemeClr val="accent1"/>
+          </a:effectRef>
+          <a:fontRef idx="minor">
+            <a:schemeClr val="lt1"/>
+          </a:fontRef>
+        </p:style>
+        <p:txBody>
+          <a:bodyPr rtlCol="0" anchor="ctr"/>
+          <a:lstStyle/>
+          <a:p>
+            <a:pPr algn="ctr"/>
+          </a:p>
+        </p:txBody>
+      </p:sp>
+      <p:sp>
+        <p:nvSpPr>
+          <p:cNvPr id="11" name="Rectangle 10"/>
+          <p:cNvSpPr/>
+          <p:nvPr/>
+        </p:nvSpPr>
+        <p:spPr>
+          <a:xfrm>
+            <a:off x="786384" y="5623560"/>
+            <a:ext cx="10680192" cy="457200"/>
+          </a:xfrm>
+          <a:prstGeom prst="rect">
+            <a:avLst/>
+          </a:prstGeom>
+          <a:solidFill>
+            <a:srgbClr val="EAF0F6"/>
+          </a:solidFill>
+          <a:ln>
+            <a:noFill/>
+          </a:ln>
+        </p:spPr>
+        <p:style>
+          <a:lnRef idx="1">
+            <a:schemeClr val="accent1"/>
+          </a:lnRef>
+          <a:fillRef idx="3">
+            <a:schemeClr val="accent1"/>
+          </a:fillRef>
+          <a:effectRef idx="2">
+            <a:schemeClr val="accent1"/>
+          </a:effectRef>
+          <a:fontRef idx="minor">
+            <a:schemeClr val="lt1"/>
+          </a:fontRef>
+        </p:style>
+        <p:txBody>
+          <a:bodyPr rtlCol="0" anchor="ctr" lIns="137160" wrap="square"/>
+          <a:lstStyle/>
+          <a:p>
+            <a:pPr algn="l">
+              <a:spcAft>
+                <a:spcPts val="0"/>
+              </a:spcAft>
+            </a:pPr>
+            <a:r>
+              <a:rPr sz="1250" b="1" i="0">
+                <a:solidFill>
+                  <a:srgbClr val="D1495B"/>
+                </a:solidFill>
+                <a:latin typeface="Bitstream Charter"/>
+              </a:rPr>
+              <a:t>Takeaway  </a:t>
+            </a:r>
+            <a:r>
+              <a:rPr sz="1250" b="1" i="0">
+                <a:solidFill>
+                  <a:srgbClr val="132C43"/>
+                </a:solidFill>
+                <a:latin typeface="Bitstream Charter"/>
+              </a:rPr>
+              <a:t>Risk is a minority outcome concentrated in a tail, so metrics and splits are built around rare cases.</a:t>
+            </a:r>
+          </a:p>
+        </p:txBody>
+      </p:sp>
+    </p:spTree>
+  </p:cSld>
+  <p:clrMapOvr>
+    <a:masterClrMapping/>
+  </p:clrMapOvr>
+</p:sld>
+</file>
+
+<file path=ppt/slides/slide12.xml><?xml version="1.0" encoding="utf-8"?>
+<p:sld xmlns:a="http://schemas.openxmlformats.org/drawingml/2006/main" xmlns:p="http://schemas.openxmlformats.org/presentationml/2006/main" xmlns:r="http://schemas.openxmlformats.org/officeDocument/2006/relationships">
+  <p:cSld>
+    <p:bg>
+      <p:bgPr>
+        <a:solidFill>
+          <a:srgbClr val="F7F9FC"/>
+        </a:solidFill>
+        <a:effectLst/>
+      </p:bgPr>
+    </p:bg>
+    <p:spTree>
+      <p:nvGrpSpPr>
+        <p:cNvPr id="1" name=""/>
+        <p:cNvGrpSpPr/>
+        <p:nvPr/>
+      </p:nvGrpSpPr>
+      <p:grpSpPr/>
+      <p:sp>
+        <p:nvSpPr>
+          <p:cNvPr id="5" name="Rectangle 4">
+            <a:extLst>
+              <a:ext uri="{FF2B5EF4-FFF2-40B4-BE49-F238E27FC236}">
+                <a16:creationId xmlns:a16="http://schemas.microsoft.com/office/drawing/2014/main" id="{27979FDE-990F-4C15-B33C-B2975BF50CD9}"/>
+              </a:ext>
+            </a:extLst>
+          </p:cNvPr>
+          <p:cNvSpPr>
+            <a:spLocks noGrp="1"/>
+          </p:cNvSpPr>
+          <p:nvPr/>
+        </p:nvSpPr>
+        <p:spPr>
+          <a:xfrm>
+            <a:off x="685800" y="523875"/>
+            <a:ext cx="10820400" cy="952500"/>
+          </a:xfrm>
+          <a:prstGeom prst="rect">
+            <a:avLst/>
+          </a:prstGeom>
+          <a:noFill/>
+          <a:ln w="0">
+            <a:noFill/>
+          </a:ln>
+        </p:spPr>
+        <p:txBody>
+          <a:bodyPr wrap="square">
+            <a:noAutofit/>
+          </a:bodyPr>
+          <a:lstStyle/>
+          <a:p>
+            <a:pPr>
+              <a:spcAft>
+                <a:spcPts val="400"/>
+              </a:spcAft>
+              <a:defRPr sz="3300" b="1">
+                <a:solidFill>
+                  <a:srgbClr val="132C43"/>
+                </a:solidFill>
+                <a:latin typeface="Bitstream Charter"/>
+                <a:ea typeface="Bitstream Charter"/>
+                <a:cs typeface="Bitstream Charter"/>
+              </a:defRPr>
+            </a:pPr>
+            <a:r>
+              <a:rPr sz="3300" b="1" i="0">
+                <a:solidFill>
+                  <a:srgbClr val="132C43"/>
+                </a:solidFill>
+                <a:latin typeface="Bitstream Charter"/>
+              </a:rPr>
+              <a:t>EDA: Game Features and Risk</a:t>
+            </a:r>
+          </a:p>
+        </p:txBody>
+      </p:sp>
+      <p:sp>
+        <p:nvSpPr>
+          <p:cNvPr id="4" name="Rectangle 3">
+            <a:extLst>
+              <a:ext uri="{FF2B5EF4-FFF2-40B4-BE49-F238E27FC236}">
+                <a16:creationId xmlns:a16="http://schemas.microsoft.com/office/drawing/2014/main" id="{C795E4D0-3C0B-473C-BB65-A65A174FB43B}"/>
+              </a:ext>
+            </a:extLst>
+          </p:cNvPr>
+          <p:cNvSpPr>
+            <a:spLocks noGrp="1"/>
+          </p:cNvSpPr>
+          <p:nvPr/>
+        </p:nvSpPr>
+        <p:spPr>
+          <a:xfrm>
+            <a:off x="11049000" y="6076950"/>
+            <a:ext cx="476250" cy="381000"/>
+          </a:xfrm>
+          <a:prstGeom prst="rect">
+            <a:avLst/>
+          </a:prstGeom>
+          <a:noFill/>
+          <a:ln w="0">
+            <a:noFill/>
+          </a:ln>
+        </p:spPr>
+        <p:txBody>
+          <a:bodyPr>
+            <a:noAutofit/>
+          </a:bodyPr>
+          <a:lstStyle/>
+          <a:p>
+            <a:pPr>
+              <a:defRPr sz="1500" b="0">
+                <a:solidFill>
+                  <a:srgbClr val="48677E"/>
+                </a:solidFill>
+                <a:latin typeface="Bitstream Charter"/>
+                <a:ea typeface="Bitstream Charter"/>
+                <a:cs typeface="Bitstream Charter"/>
+              </a:defRPr>
+            </a:pPr>
+            <a:r>
+              <a:rPr sz="1500" b="0">
+                <a:solidFill>
+                  <a:srgbClr val="48677E"/>
+                </a:solidFill>
+                <a:latin typeface="Bitstream Charter"/>
+                <a:ea typeface="Bitstream Charter"/>
+                <a:cs typeface="Bitstream Charter"/>
+              </a:rPr>
+              <a:t>07</a:t>
+            </a:r>
+          </a:p>
+        </p:txBody>
+      </p:sp>
+      <p:pic>
+        <p:nvPicPr>
+          <p:cNvPr id="6" name="Picture 5" descr="10_risk_by_game_features.png"/>
+          <p:cNvPicPr>
+            <a:picLocks noChangeAspect="1"/>
+          </p:cNvPicPr>
+          <p:nvPr/>
+        </p:nvPicPr>
+        <p:blipFill>
+          <a:blip r:embed="rId2"/>
+          <a:stretch>
+            <a:fillRect/>
+          </a:stretch>
+        </p:blipFill>
+        <p:spPr>
+          <a:xfrm>
+            <a:off x="548640" y="1463040"/>
+            <a:ext cx="7668961" cy="4023360"/>
+          </a:xfrm>
+          <a:prstGeom prst="rect">
+            <a:avLst/>
+          </a:prstGeom>
+        </p:spPr>
+      </p:pic>
+      <p:sp>
+        <p:nvSpPr>
+          <p:cNvPr id="7" name="TextBox 6"/>
+          <p:cNvSpPr txBox="1"/>
+          <p:nvPr/>
+        </p:nvSpPr>
+        <p:spPr>
+          <a:xfrm>
+            <a:off x="8366760" y="1508760"/>
+            <a:ext cx="3200400" cy="4023360"/>
+          </a:xfrm>
+          <a:prstGeom prst="rect">
+            <a:avLst/>
+          </a:prstGeom>
+          <a:noFill/>
+        </p:spPr>
+        <p:txBody>
+          <a:bodyPr wrap="square" lIns="45720" rIns="45720" tIns="27432" bIns="27432">
+            <a:spAutoFit/>
+          </a:bodyPr>
+          <a:lstStyle/>
+          <a:p>
+            <a:pPr>
+              <a:spcAft>
+                <a:spcPts val="500"/>
+              </a:spcAft>
+            </a:pPr>
+            <a:r>
+              <a:rPr sz="1100" b="1" i="0">
+                <a:solidFill>
+                  <a:srgbClr val="132C43"/>
+                </a:solidFill>
+                <a:latin typeface="Bitstream Charter"/>
+              </a:rPr>
+              <a:t>High-risk rate by band (overall 14.5%, dashed line)</a:t>
+            </a:r>
+          </a:p>
+          <a:p>
+            <a:pPr>
+              <a:spcAft>
+                <a:spcPts val="500"/>
+              </a:spcAft>
+            </a:pPr>
+            <a:r>
+              <a:rPr sz="1100" b="1" i="0">
+                <a:solidFill>
+                  <a:srgbClr val="263C50"/>
+                </a:solidFill>
+                <a:latin typeface="Bitstream Charter"/>
+              </a:rPr>
+              <a:t>Release year: </a:t>
+            </a:r>
+            <a:r>
+              <a:rPr sz="1100" b="0" i="0">
+                <a:solidFill>
+                  <a:srgbClr val="263C50"/>
+                </a:solidFill>
+                <a:latin typeface="Bitstream Charter"/>
+              </a:rPr>
+              <a:t>2022 20.6% down to 2025 9.8%; recent games have had less time to collect negatives.</a:t>
+            </a:r>
+          </a:p>
+          <a:p>
+            <a:pPr>
+              <a:spcAft>
+                <a:spcPts val="500"/>
+              </a:spcAft>
+            </a:pPr>
+            <a:r>
+              <a:rPr sz="1100" b="1" i="0">
+                <a:solidFill>
+                  <a:srgbClr val="263C50"/>
+                </a:solidFill>
+                <a:latin typeface="Bitstream Charter"/>
+              </a:rPr>
+              <a:t>Languages: </a:t>
+            </a:r>
+            <a:r>
+              <a:rPr sz="1100" b="0" i="0">
+                <a:solidFill>
+                  <a:srgbClr val="263C50"/>
+                </a:solidFill>
+                <a:latin typeface="Bitstream Charter"/>
+              </a:rPr>
+              <a:t>13+ languages 9.3% against 15.9% for 2–3.</a:t>
+            </a:r>
+          </a:p>
+          <a:p>
+            <a:pPr>
+              <a:spcAft>
+                <a:spcPts val="500"/>
+              </a:spcAft>
+            </a:pPr>
+            <a:r>
+              <a:rPr sz="1100" b="1" i="0">
+                <a:solidFill>
+                  <a:srgbClr val="263C50"/>
+                </a:solidFill>
+                <a:latin typeface="Bitstream Charter"/>
+              </a:rPr>
+              <a:t>DLC: </a:t>
+            </a:r>
+            <a:r>
+              <a:rPr sz="1100" b="0" i="0">
+                <a:solidFill>
+                  <a:srgbClr val="263C50"/>
+                </a:solidFill>
+                <a:latin typeface="Bitstream Charter"/>
+              </a:rPr>
+              <a:t>1–2 DLC 7.1% against 16.5% with none.</a:t>
+            </a:r>
+          </a:p>
+          <a:p>
+            <a:pPr>
+              <a:spcAft>
+                <a:spcPts val="500"/>
+              </a:spcAft>
+            </a:pPr>
+            <a:r>
+              <a:rPr sz="1100" b="1" i="0">
+                <a:solidFill>
+                  <a:srgbClr val="263C50"/>
+                </a:solidFill>
+                <a:latin typeface="Bitstream Charter"/>
+              </a:rPr>
+              <a:t>Achievements: </a:t>
+            </a:r>
+            <a:r>
+              <a:rPr sz="1100" b="0" i="0">
+                <a:solidFill>
+                  <a:srgbClr val="263C50"/>
+                </a:solidFill>
+                <a:latin typeface="Bitstream Charter"/>
+              </a:rPr>
+              <a:t>not listed 21.5% against 11.1% with 100+.</a:t>
+            </a:r>
+          </a:p>
+          <a:p>
+            <a:pPr>
+              <a:spcAft>
+                <a:spcPts val="500"/>
+              </a:spcAft>
+            </a:pPr>
+            <a:r>
+              <a:rPr sz="1100" b="1" i="0">
+                <a:solidFill>
+                  <a:srgbClr val="263C50"/>
+                </a:solidFill>
+                <a:latin typeface="Bitstream Charter"/>
+              </a:rPr>
+              <a:t>Price: </a:t>
+            </a:r>
+            <a:r>
+              <a:rPr sz="1100" b="0" i="0">
+                <a:solidFill>
+                  <a:srgbClr val="263C50"/>
+                </a:solidFill>
+                <a:latin typeface="Bitstream Charter"/>
+              </a:rPr>
+              <a:t>free 18.4% against 13.0% at $5–10.</a:t>
+            </a:r>
+          </a:p>
+          <a:p>
+            <a:pPr>
+              <a:spcAft>
+                <a:spcPts val="500"/>
+              </a:spcAft>
+            </a:pPr>
+            <a:r>
+              <a:rPr sz="1100" b="0" i="1">
+                <a:solidFill>
+                  <a:srgbClr val="48677E"/>
+                </a:solidFill>
+                <a:latin typeface="Bitstream Charter"/>
+              </a:rPr>
+              <a:t>Review volume is an outcome, not a launch feature.</a:t>
+            </a:r>
+          </a:p>
+        </p:txBody>
+      </p:sp>
+      <p:sp>
+        <p:nvSpPr>
+          <p:cNvPr id="8" name="Rectangle 7"/>
+          <p:cNvSpPr/>
+          <p:nvPr/>
+        </p:nvSpPr>
+        <p:spPr>
+          <a:xfrm>
+            <a:off x="722376" y="5623560"/>
+            <a:ext cx="64008" cy="457200"/>
+          </a:xfrm>
+          <a:prstGeom prst="rect">
+            <a:avLst/>
+          </a:prstGeom>
+          <a:solidFill>
+            <a:srgbClr val="D1495B"/>
+          </a:solidFill>
+          <a:ln>
+            <a:noFill/>
+          </a:ln>
+        </p:spPr>
+        <p:style>
+          <a:lnRef idx="1">
+            <a:schemeClr val="accent1"/>
+          </a:lnRef>
+          <a:fillRef idx="3">
+            <a:schemeClr val="accent1"/>
+          </a:fillRef>
+          <a:effectRef idx="2">
+            <a:schemeClr val="accent1"/>
+          </a:effectRef>
+          <a:fontRef idx="minor">
+            <a:schemeClr val="lt1"/>
+          </a:fontRef>
+        </p:style>
+        <p:txBody>
+          <a:bodyPr rtlCol="0" anchor="ctr"/>
+          <a:lstStyle/>
+          <a:p>
+            <a:pPr algn="ctr"/>
+          </a:p>
+        </p:txBody>
+      </p:sp>
+      <p:sp>
+        <p:nvSpPr>
+          <p:cNvPr id="9" name="Rectangle 8"/>
+          <p:cNvSpPr/>
+          <p:nvPr/>
+        </p:nvSpPr>
+        <p:spPr>
+          <a:xfrm>
+            <a:off x="786384" y="5623560"/>
+            <a:ext cx="10680192" cy="457200"/>
+          </a:xfrm>
+          <a:prstGeom prst="rect">
+            <a:avLst/>
+          </a:prstGeom>
+          <a:solidFill>
+            <a:srgbClr val="EAF0F6"/>
+          </a:solidFill>
+          <a:ln>
+            <a:noFill/>
+          </a:ln>
+        </p:spPr>
+        <p:style>
+          <a:lnRef idx="1">
+            <a:schemeClr val="accent1"/>
+          </a:lnRef>
+          <a:fillRef idx="3">
+            <a:schemeClr val="accent1"/>
+          </a:fillRef>
+          <a:effectRef idx="2">
+            <a:schemeClr val="accent1"/>
+          </a:effectRef>
+          <a:fontRef idx="minor">
+            <a:schemeClr val="lt1"/>
+          </a:fontRef>
+        </p:style>
+        <p:txBody>
+          <a:bodyPr rtlCol="0" anchor="ctr" lIns="137160" wrap="square"/>
+          <a:lstStyle/>
+          <a:p>
+            <a:pPr algn="l">
+              <a:spcAft>
+                <a:spcPts val="0"/>
+              </a:spcAft>
+            </a:pPr>
+            <a:r>
+              <a:rPr sz="1250" b="1" i="0">
+                <a:solidFill>
+                  <a:srgbClr val="D1495B"/>
+                </a:solidFill>
+                <a:latin typeface="Bitstream Charter"/>
+              </a:rPr>
+              <a:t>Takeaway  </a:t>
+            </a:r>
+            <a:r>
+              <a:rPr sz="1250" b="1" i="0">
+                <a:solidFill>
+                  <a:srgbClr val="132C43"/>
+                </a:solidFill>
+                <a:latin typeface="Bitstream Charter"/>
+              </a:rPr>
+              <a:t>Store signals move risk by a few to about ten points and many intervals touch the average; none is decisive alone.</a:t>
+            </a:r>
+          </a:p>
+        </p:txBody>
+      </p:sp>
+    </p:spTree>
+  </p:cSld>
+  <p:clrMapOvr>
+    <a:masterClrMapping/>
+  </p:clrMapOvr>
+</p:sld>
+</file>
+
+<file path=ppt/slides/slide13.xml><?xml version="1.0" encoding="utf-8"?>
+<p:sld xmlns:a="http://schemas.openxmlformats.org/drawingml/2006/main" xmlns:p="http://schemas.openxmlformats.org/presentationml/2006/main" xmlns:r="http://schemas.openxmlformats.org/officeDocument/2006/relationships">
+  <p:cSld>
+    <p:bg>
+      <p:bgPr>
+        <a:solidFill>
+          <a:srgbClr val="F7F9FC"/>
+        </a:solidFill>
+        <a:effectLst/>
+      </p:bgPr>
+    </p:bg>
+    <p:spTree>
+      <p:nvGrpSpPr>
+        <p:cNvPr id="1" name=""/>
+        <p:cNvGrpSpPr/>
+        <p:nvPr/>
+      </p:nvGrpSpPr>
+      <p:grpSpPr/>
+      <p:sp>
+        <p:nvSpPr>
+          <p:cNvPr id="5" name="Rectangle 4">
+            <a:extLst>
+              <a:ext uri="{FF2B5EF4-FFF2-40B4-BE49-F238E27FC236}">
+                <a16:creationId xmlns:a16="http://schemas.microsoft.com/office/drawing/2014/main" id="{27979FDE-990F-4C15-B33C-B2975BF50CD9}"/>
+              </a:ext>
+            </a:extLst>
+          </p:cNvPr>
+          <p:cNvSpPr>
+            <a:spLocks noGrp="1"/>
+          </p:cNvSpPr>
+          <p:nvPr/>
+        </p:nvSpPr>
+        <p:spPr>
+          <a:xfrm>
+            <a:off x="685800" y="523875"/>
+            <a:ext cx="10820400" cy="952500"/>
+          </a:xfrm>
+          <a:prstGeom prst="rect">
+            <a:avLst/>
+          </a:prstGeom>
+          <a:noFill/>
+          <a:ln w="0">
+            <a:noFill/>
+          </a:ln>
+        </p:spPr>
+        <p:txBody>
+          <a:bodyPr wrap="square">
+            <a:noAutofit/>
+          </a:bodyPr>
+          <a:lstStyle/>
+          <a:p>
+            <a:pPr>
+              <a:spcAft>
+                <a:spcPts val="400"/>
+              </a:spcAft>
+              <a:defRPr sz="3300" b="1">
+                <a:solidFill>
+                  <a:srgbClr val="132C43"/>
+                </a:solidFill>
+                <a:latin typeface="Bitstream Charter"/>
+                <a:ea typeface="Bitstream Charter"/>
+                <a:cs typeface="Bitstream Charter"/>
+              </a:defRPr>
+            </a:pPr>
+            <a:r>
+              <a:rPr sz="3300" b="1" i="0">
+                <a:solidFill>
+                  <a:srgbClr val="132C43"/>
+                </a:solidFill>
+                <a:latin typeface="Bitstream Charter"/>
+              </a:rPr>
+              <a:t>EDA: Correlation and Leakage</a:t>
+            </a:r>
+          </a:p>
+        </p:txBody>
+      </p:sp>
+      <p:sp>
+        <p:nvSpPr>
+          <p:cNvPr id="4" name="Rectangle 3">
+            <a:extLst>
+              <a:ext uri="{FF2B5EF4-FFF2-40B4-BE49-F238E27FC236}">
+                <a16:creationId xmlns:a16="http://schemas.microsoft.com/office/drawing/2014/main" id="{C795E4D0-3C0B-473C-BB65-A65A174FB43B}"/>
+              </a:ext>
+            </a:extLst>
+          </p:cNvPr>
+          <p:cNvSpPr>
+            <a:spLocks noGrp="1"/>
+          </p:cNvSpPr>
+          <p:nvPr/>
+        </p:nvSpPr>
+        <p:spPr>
+          <a:xfrm>
+            <a:off x="11049000" y="6076950"/>
+            <a:ext cx="476250" cy="381000"/>
+          </a:xfrm>
+          <a:prstGeom prst="rect">
+            <a:avLst/>
+          </a:prstGeom>
+          <a:noFill/>
+          <a:ln w="0">
+            <a:noFill/>
+          </a:ln>
+        </p:spPr>
+        <p:txBody>
+          <a:bodyPr>
+            <a:noAutofit/>
+          </a:bodyPr>
+          <a:lstStyle/>
+          <a:p>
+            <a:pPr>
+              <a:defRPr sz="1500" b="0">
+                <a:solidFill>
+                  <a:srgbClr val="48677E"/>
+                </a:solidFill>
+                <a:latin typeface="Bitstream Charter"/>
+                <a:ea typeface="Bitstream Charter"/>
+                <a:cs typeface="Bitstream Charter"/>
+              </a:defRPr>
+            </a:pPr>
+            <a:r>
+              <a:rPr sz="1500" b="0">
+                <a:solidFill>
+                  <a:srgbClr val="48677E"/>
+                </a:solidFill>
+                <a:latin typeface="Bitstream Charter"/>
+                <a:ea typeface="Bitstream Charter"/>
+                <a:cs typeface="Bitstream Charter"/>
+              </a:rPr>
+              <a:t>08</a:t>
+            </a:r>
+          </a:p>
+        </p:txBody>
+      </p:sp>
+      <p:pic>
+        <p:nvPicPr>
+          <p:cNvPr id="6" name="Picture 5" descr="22_correlation_with_target.png"/>
+          <p:cNvPicPr>
+            <a:picLocks noChangeAspect="1"/>
+          </p:cNvPicPr>
+          <p:nvPr/>
+        </p:nvPicPr>
+        <p:blipFill>
+          <a:blip r:embed="rId2"/>
+          <a:stretch>
+            <a:fillRect/>
+          </a:stretch>
+        </p:blipFill>
+        <p:spPr>
+          <a:xfrm>
+            <a:off x="640080" y="1463040"/>
+            <a:ext cx="4985218" cy="4069080"/>
+          </a:xfrm>
+          <a:prstGeom prst="rect">
+            <a:avLst/>
+          </a:prstGeom>
+        </p:spPr>
+      </p:pic>
+      <p:sp>
+        <p:nvSpPr>
+          <p:cNvPr id="7" name="TextBox 6"/>
+          <p:cNvSpPr txBox="1"/>
+          <p:nvPr/>
+        </p:nvSpPr>
+        <p:spPr>
+          <a:xfrm>
+            <a:off x="6217920" y="1508760"/>
+            <a:ext cx="5303520" cy="4023360"/>
+          </a:xfrm>
+          <a:prstGeom prst="rect">
+            <a:avLst/>
+          </a:prstGeom>
+          <a:noFill/>
+        </p:spPr>
+        <p:txBody>
+          <a:bodyPr wrap="square" lIns="45720" rIns="45720" tIns="27432" bIns="27432">
+            <a:spAutoFit/>
+          </a:bodyPr>
+          <a:lstStyle/>
+          <a:p>
+            <a:pPr>
+              <a:spcAft>
+                <a:spcPts val="700"/>
+              </a:spcAft>
+            </a:pPr>
+            <a:r>
+              <a:rPr sz="1200" b="1" i="0">
+                <a:solidFill>
+                  <a:srgbClr val="132C43"/>
+                </a:solidFill>
+                <a:latin typeface="Bitstream Charter"/>
+              </a:rPr>
+              <a:t>Blue are launch-time store attributes; grey are post-release signals.</a:t>
+            </a:r>
+          </a:p>
+          <a:p>
+            <a:pPr>
+              <a:spcAft>
+                <a:spcPts val="700"/>
+              </a:spcAft>
+            </a:pPr>
+            <a:r>
+              <a:rPr sz="1200" b="1" i="0">
+                <a:solidFill>
+                  <a:srgbClr val="263C50"/>
+                </a:solidFill>
+                <a:latin typeface="Bitstream Charter"/>
+              </a:rPr>
+              <a:t>Launch time: </a:t>
+            </a:r>
+            <a:r>
+              <a:rPr sz="1200" b="0" i="0">
+                <a:solidFill>
+                  <a:srgbClr val="263C50"/>
+                </a:solidFill>
+                <a:latin typeface="Bitstream Charter"/>
+              </a:rPr>
+              <a:t>release year (−0.15), genre count (+0.13) and platforms (−0.09) are the strongest, all weak.</a:t>
+            </a:r>
+          </a:p>
+          <a:p>
+            <a:pPr>
+              <a:spcAft>
+                <a:spcPts val="700"/>
+              </a:spcAft>
+            </a:pPr>
+            <a:r>
+              <a:rPr sz="1200" b="1" i="0">
+                <a:solidFill>
+                  <a:srgbClr val="263C50"/>
+                </a:solidFill>
+                <a:latin typeface="Bitstream Charter"/>
+              </a:rPr>
+              <a:t>Post release: </a:t>
+            </a:r>
+            <a:r>
+              <a:rPr sz="1200" b="0" i="0">
+                <a:solidFill>
+                  <a:srgbClr val="263C50"/>
+                </a:solidFill>
+                <a:latin typeface="Bitstream Charter"/>
+              </a:rPr>
+              <a:t>refund share of reviews (+0.26) and developer-response share (+0.21) are the strongest. They are consequences of a bad reception, not predictors.</a:t>
+            </a:r>
+          </a:p>
+          <a:p>
+            <a:pPr>
+              <a:spcAft>
+                <a:spcPts val="700"/>
+              </a:spcAft>
+            </a:pPr>
+            <a:r>
+              <a:rPr sz="1200" b="1" i="0">
+                <a:solidFill>
+                  <a:srgbClr val="263C50"/>
+                </a:solidFill>
+                <a:latin typeface="Bitstream Charter"/>
+              </a:rPr>
+              <a:t>Tests: </a:t>
+            </a:r>
+            <a:r>
+              <a:rPr sz="1200" b="0" i="0">
+                <a:solidFill>
+                  <a:srgbClr val="263C50"/>
+                </a:solidFill>
+                <a:latin typeface="Bitstream Charter"/>
+              </a:rPr>
+              <a:t>7 of 12 banded features are significant after FDR correction, but the largest Cramér’s V is only 0.12.</a:t>
+            </a:r>
+          </a:p>
+          <a:p>
+            <a:pPr>
+              <a:spcAft>
+                <a:spcPts val="700"/>
+              </a:spcAft>
+            </a:pPr>
+            <a:r>
+              <a:rPr sz="1200" b="1" i="0">
+                <a:solidFill>
+                  <a:srgbClr val="263C50"/>
+                </a:solidFill>
+                <a:latin typeface="Bitstream Charter"/>
+              </a:rPr>
+              <a:t>Rule we follow: </a:t>
+            </a:r>
+            <a:r>
+              <a:rPr sz="1200" b="0" i="0">
+                <a:solidFill>
+                  <a:srgbClr val="263C50"/>
+                </a:solidFill>
+                <a:latin typeface="Bitstream Charter"/>
+              </a:rPr>
+              <a:t>the launch-risk model uses launch-time features only (docs/modelling_protocol.md).</a:t>
+            </a:r>
+          </a:p>
+        </p:txBody>
+      </p:sp>
+      <p:sp>
+        <p:nvSpPr>
+          <p:cNvPr id="8" name="Rectangle 7"/>
+          <p:cNvSpPr/>
+          <p:nvPr/>
+        </p:nvSpPr>
+        <p:spPr>
+          <a:xfrm>
+            <a:off x="722376" y="5623560"/>
+            <a:ext cx="64008" cy="457200"/>
+          </a:xfrm>
+          <a:prstGeom prst="rect">
+            <a:avLst/>
+          </a:prstGeom>
+          <a:solidFill>
+            <a:srgbClr val="D1495B"/>
+          </a:solidFill>
+          <a:ln>
+            <a:noFill/>
+          </a:ln>
+        </p:spPr>
+        <p:style>
+          <a:lnRef idx="1">
+            <a:schemeClr val="accent1"/>
+          </a:lnRef>
+          <a:fillRef idx="3">
+            <a:schemeClr val="accent1"/>
+          </a:fillRef>
+          <a:effectRef idx="2">
+            <a:schemeClr val="accent1"/>
+          </a:effectRef>
+          <a:fontRef idx="minor">
+            <a:schemeClr val="lt1"/>
+          </a:fontRef>
+        </p:style>
+        <p:txBody>
+          <a:bodyPr rtlCol="0" anchor="ctr"/>
+          <a:lstStyle/>
+          <a:p>
+            <a:pPr algn="ctr"/>
+          </a:p>
+        </p:txBody>
+      </p:sp>
+      <p:sp>
+        <p:nvSpPr>
+          <p:cNvPr id="9" name="Rectangle 8"/>
+          <p:cNvSpPr/>
+          <p:nvPr/>
+        </p:nvSpPr>
+        <p:spPr>
+          <a:xfrm>
+            <a:off x="786384" y="5623560"/>
+            <a:ext cx="10680192" cy="457200"/>
+          </a:xfrm>
+          <a:prstGeom prst="rect">
+            <a:avLst/>
+          </a:prstGeom>
+          <a:solidFill>
+            <a:srgbClr val="EAF0F6"/>
+          </a:solidFill>
+          <a:ln>
+            <a:noFill/>
+          </a:ln>
+        </p:spPr>
+        <p:style>
+          <a:lnRef idx="1">
+            <a:schemeClr val="accent1"/>
+          </a:lnRef>
+          <a:fillRef idx="3">
+            <a:schemeClr val="accent1"/>
+          </a:fillRef>
+          <a:effectRef idx="2">
+            <a:schemeClr val="accent1"/>
+          </a:effectRef>
+          <a:fontRef idx="minor">
+            <a:schemeClr val="lt1"/>
+          </a:fontRef>
+        </p:style>
+        <p:txBody>
+          <a:bodyPr rtlCol="0" anchor="ctr" lIns="137160" wrap="square"/>
+          <a:lstStyle/>
+          <a:p>
+            <a:pPr algn="l">
+              <a:spcAft>
+                <a:spcPts val="0"/>
+              </a:spcAft>
+            </a:pPr>
+            <a:r>
+              <a:rPr sz="1250" b="1" i="0">
+                <a:solidFill>
+                  <a:srgbClr val="D1495B"/>
+                </a:solidFill>
+                <a:latin typeface="Bitstream Charter"/>
+              </a:rPr>
+              <a:t>Takeaway  </a:t>
+            </a:r>
+            <a:r>
+              <a:rPr sz="1250" b="1" i="0">
+                <a:solidFill>
+                  <a:srgbClr val="132C43"/>
+                </a:solidFill>
+                <a:latin typeface="Bitstream Charter"/>
+              </a:rPr>
+              <a:t>Effects are small, and the strongest correlations are leaks; excluding them keeps our models honest.</a:t>
+            </a:r>
+          </a:p>
+        </p:txBody>
+      </p:sp>
+    </p:spTree>
+  </p:cSld>
+  <p:clrMapOvr>
+    <a:masterClrMapping/>
+  </p:clrMapOvr>
+</p:sld>
+</file>
+
+<file path=ppt/slides/slide14.xml><?xml version="1.0" encoding="utf-8"?>
+<p:sld xmlns:a="http://schemas.openxmlformats.org/drawingml/2006/main" xmlns:p="http://schemas.openxmlformats.org/presentationml/2006/main" xmlns:r="http://schemas.openxmlformats.org/officeDocument/2006/relationships">
+  <p:cSld>
+    <p:bg>
+      <p:bgPr>
+        <a:solidFill>
+          <a:srgbClr val="F7F9FC"/>
+        </a:solidFill>
+        <a:effectLst/>
+      </p:bgPr>
+    </p:bg>
+    <p:spTree>
+      <p:nvGrpSpPr>
+        <p:cNvPr id="1" name=""/>
+        <p:cNvGrpSpPr/>
+        <p:nvPr/>
+      </p:nvGrpSpPr>
+      <p:grpSpPr/>
+      <p:sp>
+        <p:nvSpPr>
+          <p:cNvPr id="5" name="Rectangle 4">
+            <a:extLst>
+              <a:ext uri="{FF2B5EF4-FFF2-40B4-BE49-F238E27FC236}">
+                <a16:creationId xmlns:a16="http://schemas.microsoft.com/office/drawing/2014/main" id="{27979FDE-990F-4C15-B33C-B2975BF50CD9}"/>
+              </a:ext>
+            </a:extLst>
+          </p:cNvPr>
+          <p:cNvSpPr>
+            <a:spLocks noGrp="1"/>
+          </p:cNvSpPr>
+          <p:nvPr/>
+        </p:nvSpPr>
+        <p:spPr>
+          <a:xfrm>
+            <a:off x="685800" y="523875"/>
+            <a:ext cx="10820400" cy="952500"/>
+          </a:xfrm>
+          <a:prstGeom prst="rect">
+            <a:avLst/>
+          </a:prstGeom>
+          <a:noFill/>
+          <a:ln w="0">
+            <a:noFill/>
+          </a:ln>
+        </p:spPr>
+        <p:txBody>
+          <a:bodyPr wrap="square">
+            <a:noAutofit/>
+          </a:bodyPr>
+          <a:lstStyle/>
+          <a:p>
+            <a:pPr>
+              <a:spcAft>
+                <a:spcPts val="400"/>
+              </a:spcAft>
+              <a:defRPr sz="3300" b="1">
+                <a:solidFill>
+                  <a:srgbClr val="132C43"/>
+                </a:solidFill>
+                <a:latin typeface="Bitstream Charter"/>
+                <a:ea typeface="Bitstream Charter"/>
+                <a:cs typeface="Bitstream Charter"/>
+              </a:defRPr>
+            </a:pPr>
+            <a:r>
+              <a:rPr sz="3300" b="1" i="0">
+                <a:solidFill>
+                  <a:srgbClr val="132C43"/>
+                </a:solidFill>
+                <a:latin typeface="Bitstream Charter"/>
+              </a:rPr>
+              <a:t>EDA: Tag Combinations</a:t>
+            </a:r>
+          </a:p>
+        </p:txBody>
+      </p:sp>
+      <p:sp>
+        <p:nvSpPr>
+          <p:cNvPr id="4" name="Rectangle 3">
+            <a:extLst>
+              <a:ext uri="{FF2B5EF4-FFF2-40B4-BE49-F238E27FC236}">
+                <a16:creationId xmlns:a16="http://schemas.microsoft.com/office/drawing/2014/main" id="{C795E4D0-3C0B-473C-BB65-A65A174FB43B}"/>
+              </a:ext>
+            </a:extLst>
+          </p:cNvPr>
+          <p:cNvSpPr>
+            <a:spLocks noGrp="1"/>
+          </p:cNvSpPr>
+          <p:nvPr/>
+        </p:nvSpPr>
+        <p:spPr>
+          <a:xfrm>
+            <a:off x="11049000" y="6076950"/>
+            <a:ext cx="476250" cy="381000"/>
+          </a:xfrm>
+          <a:prstGeom prst="rect">
+            <a:avLst/>
+          </a:prstGeom>
+          <a:noFill/>
+          <a:ln w="0">
+            <a:noFill/>
+          </a:ln>
+        </p:spPr>
+        <p:txBody>
+          <a:bodyPr>
+            <a:noAutofit/>
+          </a:bodyPr>
+          <a:lstStyle/>
+          <a:p>
+            <a:pPr>
+              <a:defRPr sz="1500" b="0">
+                <a:solidFill>
+                  <a:srgbClr val="48677E"/>
+                </a:solidFill>
+                <a:latin typeface="Bitstream Charter"/>
+                <a:ea typeface="Bitstream Charter"/>
+                <a:cs typeface="Bitstream Charter"/>
+              </a:defRPr>
+            </a:pPr>
+            <a:r>
+              <a:rPr sz="1500" b="0">
+                <a:solidFill>
+                  <a:srgbClr val="48677E"/>
+                </a:solidFill>
+                <a:latin typeface="Bitstream Charter"/>
+                <a:ea typeface="Bitstream Charter"/>
+                <a:cs typeface="Bitstream Charter"/>
+              </a:rPr>
+              <a:t>09</a:t>
+            </a:r>
+          </a:p>
+        </p:txBody>
+      </p:sp>
+      <p:pic>
+        <p:nvPicPr>
+          <p:cNvPr id="6" name="Picture 5" descr="25_tag_combinations_lower_and_higher_risk.png"/>
+          <p:cNvPicPr>
+            <a:picLocks noChangeAspect="1"/>
+          </p:cNvPicPr>
+          <p:nvPr/>
+        </p:nvPicPr>
+        <p:blipFill>
+          <a:blip r:embed="rId2"/>
+          <a:stretch>
+            <a:fillRect/>
+          </a:stretch>
+        </p:blipFill>
+        <p:spPr>
+          <a:xfrm>
+            <a:off x="1325880" y="1463040"/>
+            <a:ext cx="9509760" cy="3803904"/>
+          </a:xfrm>
+          <a:prstGeom prst="rect">
+            <a:avLst/>
+          </a:prstGeom>
+        </p:spPr>
+      </p:pic>
+      <p:sp>
+        <p:nvSpPr>
+          <p:cNvPr id="7" name="TextBox 6"/>
+          <p:cNvSpPr txBox="1"/>
+          <p:nvPr/>
+        </p:nvSpPr>
+        <p:spPr>
+          <a:xfrm>
+            <a:off x="722376" y="5285232"/>
+            <a:ext cx="10789920" cy="868680"/>
+          </a:xfrm>
+          <a:prstGeom prst="rect">
+            <a:avLst/>
+          </a:prstGeom>
+          <a:noFill/>
+        </p:spPr>
+        <p:txBody>
+          <a:bodyPr wrap="square" lIns="45720" rIns="45720" tIns="27432" bIns="27432">
+            <a:spAutoFit/>
+          </a:bodyPr>
+          <a:lstStyle/>
+          <a:p>
+            <a:pPr>
+              <a:spcAft>
+                <a:spcPts val="400"/>
+              </a:spcAft>
+            </a:pPr>
+            <a:r>
+              <a:rPr sz="1150" b="1" i="0">
+                <a:solidFill>
+                  <a:srgbClr val="132C43"/>
+                </a:solidFill>
+                <a:latin typeface="Bitstream Charter"/>
+              </a:rPr>
+              <a:t>Method  </a:t>
+            </a:r>
+            <a:r>
+              <a:rPr sz="1150" b="0" i="0">
+                <a:solidFill>
+                  <a:srgbClr val="263C50"/>
+                </a:solidFill>
+                <a:latin typeface="Bitstream Charter"/>
+              </a:rPr>
+              <a:t>pairs of the 30 most common tags, exact binomial test per pair, Benjamini–Hochberg FDR control: 5 lower-risk and 4 higher-risk pairs survive. </a:t>
+            </a:r>
+            <a:r>
+              <a:rPr sz="1150" b="0" i="0">
+                <a:solidFill>
+                  <a:srgbClr val="263C50"/>
+                </a:solidFill>
+                <a:latin typeface="Bitstream Charter"/>
+              </a:rPr>
+              <a:t>2D with Pixel Graphics, Strategy or Deckbuilding sit at 5–9% against 14.5% overall; RPG with PvE (33%) and 3D pairings (23–27%) sit highest. These are associations, which Review 2’s association rules extend.</a:t>
+            </a:r>
+          </a:p>
+        </p:txBody>
+      </p:sp>
+    </p:spTree>
   </p:cSld>
   <p:clrMapOvr>
     <a:masterClrMapping/>
@@ -5881,7 +7641,7 @@
         </p:nvSpPr>
         <p:spPr>
           <a:xfrm>
-            <a:off x="722376" y="5577840"/>
+            <a:off x="722376" y="4754880"/>
             <a:ext cx="10241280" cy="502920"/>
           </a:xfrm>
           <a:prstGeom prst="rect">
@@ -5924,6 +7684,114 @@
                 <a:latin typeface="Bitstream Charter"/>
               </a:rPr>
               <a:t>[2] Steam user review summary labels (Valve), Overwhelmingly Positive to Overwhelmingly Negative.   [3] SteamSpy owner estimates (steamspy.com).</a:t>
+            </a:r>
+          </a:p>
+        </p:txBody>
+      </p:sp>
+      <p:sp>
+        <p:nvSpPr>
+          <p:cNvPr id="8" name="Rectangle 7"/>
+          <p:cNvSpPr/>
+          <p:nvPr/>
+        </p:nvSpPr>
+        <p:spPr>
+          <a:xfrm>
+            <a:off x="722376" y="5577840"/>
+            <a:ext cx="64008" cy="457200"/>
+          </a:xfrm>
+          <a:prstGeom prst="rect">
+            <a:avLst/>
+          </a:prstGeom>
+          <a:solidFill>
+            <a:srgbClr val="D1495B"/>
+          </a:solidFill>
+          <a:ln>
+            <a:noFill/>
+          </a:ln>
+        </p:spPr>
+        <p:style>
+          <a:lnRef idx="1">
+            <a:schemeClr val="accent1"/>
+          </a:lnRef>
+          <a:fillRef idx="3">
+            <a:schemeClr val="accent1"/>
+          </a:fillRef>
+          <a:effectRef idx="2">
+            <a:schemeClr val="accent1"/>
+          </a:effectRef>
+          <a:fontRef idx="minor">
+            <a:schemeClr val="lt1"/>
+          </a:fontRef>
+        </p:style>
+        <p:txBody>
+          <a:bodyPr rtlCol="0" anchor="ctr"/>
+          <a:lstStyle/>
+          <a:p>
+            <a:pPr algn="ctr"/>
+          </a:p>
+        </p:txBody>
+      </p:sp>
+      <p:sp>
+        <p:nvSpPr>
+          <p:cNvPr id="9" name="Rectangle 8"/>
+          <p:cNvSpPr/>
+          <p:nvPr/>
+        </p:nvSpPr>
+        <p:spPr>
+          <a:xfrm>
+            <a:off x="786384" y="5577840"/>
+            <a:ext cx="10680192" cy="457200"/>
+          </a:xfrm>
+          <a:prstGeom prst="rect">
+            <a:avLst/>
+          </a:prstGeom>
+          <a:solidFill>
+            <a:srgbClr val="EAF0F6"/>
+          </a:solidFill>
+          <a:ln>
+            <a:noFill/>
+          </a:ln>
+        </p:spPr>
+        <p:style>
+          <a:lnRef idx="1">
+            <a:schemeClr val="accent1"/>
+          </a:lnRef>
+          <a:fillRef idx="3">
+            <a:schemeClr val="accent1"/>
+          </a:fillRef>
+          <a:effectRef idx="2">
+            <a:schemeClr val="accent1"/>
+          </a:effectRef>
+          <a:fontRef idx="minor">
+            <a:schemeClr val="lt1"/>
+          </a:fontRef>
+        </p:style>
+        <p:txBody>
+          <a:bodyPr rtlCol="0" anchor="ctr" lIns="137160" wrap="square"/>
+          <a:lstStyle/>
+          <a:p>
+            <a:pPr algn="l">
+              <a:spcAft>
+                <a:spcPts val="0"/>
+              </a:spcAft>
+            </a:pPr>
+            <a:r>
+              <a:rPr sz="1250" b="1" i="0">
+                <a:solidFill>
+                  <a:srgbClr val="D1495B"/>
+                </a:solidFill>
+                <a:latin typeface="Bitstream Charter"/>
+              </a:rPr>
+              <a:t>Takeaway  </a:t>
+            </a:r>
+            <a:r>
+              <a:rPr sz="1250" b="1" i="0">
+                <a:solidFill>
+                  <a:srgbClr val="132C43"/>
+                </a:solidFill>
+                <a:latin typeface="Bitstream Charter"/>
+              </a:rPr>
+              <a:t>Early negatives are costly because a refund is possible inside the first two hours, so we act inside that window.</a:t>
             </a:r>
           </a:p>
         </p:txBody>
@@ -8131,6 +9999,114 @@
           </a:p>
         </p:txBody>
       </p:sp>
+      <p:sp>
+        <p:nvSpPr>
+          <p:cNvPr id="17" name="Rectangle 16"/>
+          <p:cNvSpPr/>
+          <p:nvPr/>
+        </p:nvSpPr>
+        <p:spPr>
+          <a:xfrm>
+            <a:off x="722376" y="5577840"/>
+            <a:ext cx="64008" cy="457200"/>
+          </a:xfrm>
+          <a:prstGeom prst="rect">
+            <a:avLst/>
+          </a:prstGeom>
+          <a:solidFill>
+            <a:srgbClr val="D1495B"/>
+          </a:solidFill>
+          <a:ln>
+            <a:noFill/>
+          </a:ln>
+        </p:spPr>
+        <p:style>
+          <a:lnRef idx="1">
+            <a:schemeClr val="accent1"/>
+          </a:lnRef>
+          <a:fillRef idx="3">
+            <a:schemeClr val="accent1"/>
+          </a:fillRef>
+          <a:effectRef idx="2">
+            <a:schemeClr val="accent1"/>
+          </a:effectRef>
+          <a:fontRef idx="minor">
+            <a:schemeClr val="lt1"/>
+          </a:fontRef>
+        </p:style>
+        <p:txBody>
+          <a:bodyPr rtlCol="0" anchor="ctr"/>
+          <a:lstStyle/>
+          <a:p>
+            <a:pPr algn="ctr"/>
+          </a:p>
+        </p:txBody>
+      </p:sp>
+      <p:sp>
+        <p:nvSpPr>
+          <p:cNvPr id="18" name="Rectangle 17"/>
+          <p:cNvSpPr/>
+          <p:nvPr/>
+        </p:nvSpPr>
+        <p:spPr>
+          <a:xfrm>
+            <a:off x="786384" y="5577840"/>
+            <a:ext cx="10680192" cy="457200"/>
+          </a:xfrm>
+          <a:prstGeom prst="rect">
+            <a:avLst/>
+          </a:prstGeom>
+          <a:solidFill>
+            <a:srgbClr val="EAF0F6"/>
+          </a:solidFill>
+          <a:ln>
+            <a:noFill/>
+          </a:ln>
+        </p:spPr>
+        <p:style>
+          <a:lnRef idx="1">
+            <a:schemeClr val="accent1"/>
+          </a:lnRef>
+          <a:fillRef idx="3">
+            <a:schemeClr val="accent1"/>
+          </a:fillRef>
+          <a:effectRef idx="2">
+            <a:schemeClr val="accent1"/>
+          </a:effectRef>
+          <a:fontRef idx="minor">
+            <a:schemeClr val="lt1"/>
+          </a:fontRef>
+        </p:style>
+        <p:txBody>
+          <a:bodyPr rtlCol="0" anchor="ctr" lIns="137160" wrap="square"/>
+          <a:lstStyle/>
+          <a:p>
+            <a:pPr algn="l">
+              <a:spcAft>
+                <a:spcPts val="0"/>
+              </a:spcAft>
+            </a:pPr>
+            <a:r>
+              <a:rPr sz="1250" b="1" i="0">
+                <a:solidFill>
+                  <a:srgbClr val="D1495B"/>
+                </a:solidFill>
+                <a:latin typeface="Bitstream Charter"/>
+              </a:rPr>
+              <a:t>Takeaway  </a:t>
+            </a:r>
+            <a:r>
+              <a:rPr sz="1250" b="1" i="0">
+                <a:solidFill>
+                  <a:srgbClr val="132C43"/>
+                </a:solidFill>
+                <a:latin typeface="Bitstream Charter"/>
+              </a:rPr>
+              <a:t>Our own, documented, frozen dataset: 1,861 games and 1.65M reviews, ready for modelling.</a:t>
+            </a:r>
+          </a:p>
+        </p:txBody>
+      </p:sp>
     </p:spTree>
     <p:extLst>
       <p:ext uri="{BB962C8B-B14F-4D97-AF65-F5344CB8AC3E}">
@@ -9400,6 +11376,114 @@
                 <a:latin typeface="Bitstream Charter"/>
               </a:rPr>
               <a:t>Dropped rows are the exception; everything else is flagged and kept, so each analysis chooses what it needs (for example a text-mining flag).</a:t>
+            </a:r>
+          </a:p>
+        </p:txBody>
+      </p:sp>
+      <p:sp>
+        <p:nvSpPr>
+          <p:cNvPr id="10" name="Rectangle 9"/>
+          <p:cNvSpPr/>
+          <p:nvPr/>
+        </p:nvSpPr>
+        <p:spPr>
+          <a:xfrm>
+            <a:off x="722376" y="5577840"/>
+            <a:ext cx="64008" cy="457200"/>
+          </a:xfrm>
+          <a:prstGeom prst="rect">
+            <a:avLst/>
+          </a:prstGeom>
+          <a:solidFill>
+            <a:srgbClr val="D1495B"/>
+          </a:solidFill>
+          <a:ln>
+            <a:noFill/>
+          </a:ln>
+        </p:spPr>
+        <p:style>
+          <a:lnRef idx="1">
+            <a:schemeClr val="accent1"/>
+          </a:lnRef>
+          <a:fillRef idx="3">
+            <a:schemeClr val="accent1"/>
+          </a:fillRef>
+          <a:effectRef idx="2">
+            <a:schemeClr val="accent1"/>
+          </a:effectRef>
+          <a:fontRef idx="minor">
+            <a:schemeClr val="lt1"/>
+          </a:fontRef>
+        </p:style>
+        <p:txBody>
+          <a:bodyPr rtlCol="0" anchor="ctr"/>
+          <a:lstStyle/>
+          <a:p>
+            <a:pPr algn="ctr"/>
+          </a:p>
+        </p:txBody>
+      </p:sp>
+      <p:sp>
+        <p:nvSpPr>
+          <p:cNvPr id="11" name="Rectangle 10"/>
+          <p:cNvSpPr/>
+          <p:nvPr/>
+        </p:nvSpPr>
+        <p:spPr>
+          <a:xfrm>
+            <a:off x="786384" y="5577840"/>
+            <a:ext cx="10680192" cy="457200"/>
+          </a:xfrm>
+          <a:prstGeom prst="rect">
+            <a:avLst/>
+          </a:prstGeom>
+          <a:solidFill>
+            <a:srgbClr val="EAF0F6"/>
+          </a:solidFill>
+          <a:ln>
+            <a:noFill/>
+          </a:ln>
+        </p:spPr>
+        <p:style>
+          <a:lnRef idx="1">
+            <a:schemeClr val="accent1"/>
+          </a:lnRef>
+          <a:fillRef idx="3">
+            <a:schemeClr val="accent1"/>
+          </a:fillRef>
+          <a:effectRef idx="2">
+            <a:schemeClr val="accent1"/>
+          </a:effectRef>
+          <a:fontRef idx="minor">
+            <a:schemeClr val="lt1"/>
+          </a:fontRef>
+        </p:style>
+        <p:txBody>
+          <a:bodyPr rtlCol="0" anchor="ctr" lIns="137160" wrap="square"/>
+          <a:lstStyle/>
+          <a:p>
+            <a:pPr algn="l">
+              <a:spcAft>
+                <a:spcPts val="0"/>
+              </a:spcAft>
+            </a:pPr>
+            <a:r>
+              <a:rPr sz="1250" b="1" i="0">
+                <a:solidFill>
+                  <a:srgbClr val="D1495B"/>
+                </a:solidFill>
+                <a:latin typeface="Bitstream Charter"/>
+              </a:rPr>
+              <a:t>Takeaway  </a:t>
+            </a:r>
+            <a:r>
+              <a:rPr sz="1250" b="1" i="0">
+                <a:solidFill>
+                  <a:srgbClr val="132C43"/>
+                </a:solidFill>
+                <a:latin typeface="Bitstream Charter"/>
+              </a:rPr>
+              <a:t>Almost nothing is deleted: suspicious rows are flagged, so every analysis can choose its own rule.</a:t>
             </a:r>
           </a:p>
         </p:txBody>
@@ -9855,7 +11939,7 @@
                 <a:ea typeface="Bitstream Charter"/>
                 <a:cs typeface="Bitstream Charter"/>
               </a:rPr>
-              <a:t>06</a:t>
+              <a:t>10</a:t>
             </a:r>
           </a:p>
         </p:txBody>
@@ -10164,6 +12248,114 @@
                 <a:latin typeface="Bitstream Charter"/>
               </a:rPr>
               <a:t>the elbow of the curve keeps 75% of the variance. The first components read as action roguelike vs card/strategy, a polished store page vs 3D and free-to-play, and 2D pixel art vs 3D.</a:t>
+            </a:r>
+          </a:p>
+        </p:txBody>
+      </p:sp>
+      <p:sp>
+        <p:nvSpPr>
+          <p:cNvPr id="9" name="Rectangle 8"/>
+          <p:cNvSpPr/>
+          <p:nvPr/>
+        </p:nvSpPr>
+        <p:spPr>
+          <a:xfrm>
+            <a:off x="722376" y="5577840"/>
+            <a:ext cx="64008" cy="457200"/>
+          </a:xfrm>
+          <a:prstGeom prst="rect">
+            <a:avLst/>
+          </a:prstGeom>
+          <a:solidFill>
+            <a:srgbClr val="D1495B"/>
+          </a:solidFill>
+          <a:ln>
+            <a:noFill/>
+          </a:ln>
+        </p:spPr>
+        <p:style>
+          <a:lnRef idx="1">
+            <a:schemeClr val="accent1"/>
+          </a:lnRef>
+          <a:fillRef idx="3">
+            <a:schemeClr val="accent1"/>
+          </a:fillRef>
+          <a:effectRef idx="2">
+            <a:schemeClr val="accent1"/>
+          </a:effectRef>
+          <a:fontRef idx="minor">
+            <a:schemeClr val="lt1"/>
+          </a:fontRef>
+        </p:style>
+        <p:txBody>
+          <a:bodyPr rtlCol="0" anchor="ctr"/>
+          <a:lstStyle/>
+          <a:p>
+            <a:pPr algn="ctr"/>
+          </a:p>
+        </p:txBody>
+      </p:sp>
+      <p:sp>
+        <p:nvSpPr>
+          <p:cNvPr id="10" name="Rectangle 9"/>
+          <p:cNvSpPr/>
+          <p:nvPr/>
+        </p:nvSpPr>
+        <p:spPr>
+          <a:xfrm>
+            <a:off x="786384" y="5577840"/>
+            <a:ext cx="10680192" cy="457200"/>
+          </a:xfrm>
+          <a:prstGeom prst="rect">
+            <a:avLst/>
+          </a:prstGeom>
+          <a:solidFill>
+            <a:srgbClr val="EAF0F6"/>
+          </a:solidFill>
+          <a:ln>
+            <a:noFill/>
+          </a:ln>
+        </p:spPr>
+        <p:style>
+          <a:lnRef idx="1">
+            <a:schemeClr val="accent1"/>
+          </a:lnRef>
+          <a:fillRef idx="3">
+            <a:schemeClr val="accent1"/>
+          </a:fillRef>
+          <a:effectRef idx="2">
+            <a:schemeClr val="accent1"/>
+          </a:effectRef>
+          <a:fontRef idx="minor">
+            <a:schemeClr val="lt1"/>
+          </a:fontRef>
+        </p:style>
+        <p:txBody>
+          <a:bodyPr rtlCol="0" anchor="ctr" lIns="137160" wrap="square"/>
+          <a:lstStyle/>
+          <a:p>
+            <a:pPr algn="l">
+              <a:spcAft>
+                <a:spcPts val="0"/>
+              </a:spcAft>
+            </a:pPr>
+            <a:r>
+              <a:rPr sz="1250" b="1" i="0">
+                <a:solidFill>
+                  <a:srgbClr val="D1495B"/>
+                </a:solidFill>
+                <a:latin typeface="Bitstream Charter"/>
+              </a:rPr>
+              <a:t>Takeaway  </a:t>
+            </a:r>
+            <a:r>
+              <a:rPr sz="1250" b="1" i="0">
+                <a:solidFill>
+                  <a:srgbClr val="132C43"/>
+                </a:solidFill>
+                <a:latin typeface="Bitstream Charter"/>
+              </a:rPr>
+              <a:t>Tags shrink from 439 columns to 68 components, and review text adds the biggest lift in accuracy.</a:t>
             </a:r>
           </a:p>
         </p:txBody>
@@ -10315,7 +12507,7 @@
                 <a:ea typeface="Bitstream Charter"/>
                 <a:cs typeface="Bitstream Charter"/>
               </a:rPr>
-              <a:t>07</a:t>
+              <a:t>11</a:t>
             </a:r>
           </a:p>
         </p:txBody>
@@ -11040,7 +13232,7 @@
                 <a:ea typeface="Bitstream Charter"/>
                 <a:cs typeface="Bitstream Charter"/>
               </a:rPr>
-              <a:t>08</a:t>
+              <a:t>12</a:t>
             </a:r>
           </a:p>
         </p:txBody>
@@ -12347,7 +14539,7 @@
                 <a:ea typeface="Bitstream Charter"/>
                 <a:cs typeface="Bitstream Charter"/>
               </a:rPr>
-              <a:t>09</a:t>
+              <a:t>13</a:t>
             </a:r>
           </a:p>
         </p:txBody>
@@ -12439,16 +14631,7 @@
                 </a:solidFill>
                 <a:latin typeface="Bitstream Charter"/>
               </a:rPr>
-              <a:t>Review 1 cards: 29  </a:t>
-            </a:r>
-            <a:r>
-              <a:rPr sz="1250" b="0" i="0">
-                <a:solidFill>
-                  <a:srgbClr val="263C50"/>
-                </a:solidFill>
-                <a:latin typeface="Bitstream Charter"/>
-              </a:rPr>
-              <a:t>Completed 24, In Progress 1, To Do 1, Backlog 3.</a:t>
+              <a:t>46 cards, each with an owner, a due date and an Evidence link.</a:t>
             </a:r>
           </a:p>
         </p:txBody>
@@ -12472,10 +14655,10 @@
                 <a:tableStyleId>{2D5ABB26-0587-4C30-8999-92F81FD0307C}</a:tableStyleId>
               </a:tblPr>
               <a:tblGrid>
-                <a:gridCol w="2743200"/>
-                <a:gridCol w="1417320"/>
-                <a:gridCol w="868680"/>
-                <a:gridCol w="1188720"/>
+                <a:gridCol w="2651760"/>
+                <a:gridCol w="1737360"/>
+                <a:gridCol w="822960"/>
+                <a:gridCol w="1005840"/>
               </a:tblGrid>
               <a:tr h="283464">
                 <a:tc>
@@ -12512,7 +14695,7 @@
                           </a:solidFill>
                           <a:latin typeface="Bitstream Charter"/>
                         </a:rPr>
-                        <a:t>Assignee</a:t>
+                        <a:t>Owner</a:t>
                       </a:r>
                     </a:p>
                   </a:txBody>
@@ -12609,7 +14792,7 @@
                           </a:solidFill>
                           <a:latin typeface="Bitstream Charter"/>
                         </a:rPr>
-                        <a:t>Shan713</a:t>
+                        <a:t>Shantharam</a:t>
                       </a:r>
                     </a:p>
                   </a:txBody>
@@ -12724,7 +14907,7 @@
                           </a:solidFill>
                           <a:latin typeface="Bitstream Charter"/>
                         </a:rPr>
-                        <a:t>Shan713</a:t>
+                        <a:t>Shantharam</a:t>
                       </a:r>
                     </a:p>
                   </a:txBody>
@@ -12839,7 +15022,7 @@
                           </a:solidFill>
                           <a:latin typeface="Bitstream Charter"/>
                         </a:rPr>
-                        <a:t>srihithathotakura</a:t>
+                        <a:t>Srihitha</a:t>
                       </a:r>
                     </a:p>
                   </a:txBody>
@@ -12926,7 +15109,7 @@
                           </a:solidFill>
                           <a:latin typeface="Bitstream Charter"/>
                         </a:rPr>
-                        <a:t>#18  Feature engineering</a:t>
+                        <a:t>#21  EDA part 2</a:t>
                       </a:r>
                     </a:p>
                   </a:txBody>
@@ -12954,7 +15137,7 @@
                           </a:solidFill>
                           <a:latin typeface="Bitstream Charter"/>
                         </a:rPr>
-                        <a:t>gayas-sheik</a:t>
+                        <a:t>Srihitha</a:t>
                       </a:r>
                     </a:p>
                   </a:txBody>
@@ -12983,7 +15166,7 @@
                           </a:solidFill>
                           <a:latin typeface="Bitstream Charter"/>
                         </a:rPr>
-                        <a:t>15/10</a:t>
+                        <a:t>16/10</a:t>
                       </a:r>
                     </a:p>
                   </a:txBody>
@@ -13041,7 +15224,7 @@
                           </a:solidFill>
                           <a:latin typeface="Bitstream Charter"/>
                         </a:rPr>
-                        <a:t>#19  Dimensionality reduction</a:t>
+                        <a:t>#18  Feature engineering</a:t>
                       </a:r>
                     </a:p>
                   </a:txBody>
@@ -13069,7 +15252,7 @@
                           </a:solidFill>
                           <a:latin typeface="Bitstream Charter"/>
                         </a:rPr>
-                        <a:t>gayas-sheik</a:t>
+                        <a:t>Gayas</a:t>
                       </a:r>
                     </a:p>
                   </a:txBody>
@@ -13098,7 +15281,7 @@
                           </a:solidFill>
                           <a:latin typeface="Bitstream Charter"/>
                         </a:rPr>
-                        <a:t>16/10</a:t>
+                        <a:t>15/10</a:t>
                       </a:r>
                     </a:p>
                   </a:txBody>
@@ -13156,7 +15339,7 @@
                           </a:solidFill>
                           <a:latin typeface="Bitstream Charter"/>
                         </a:rPr>
-                        <a:t>#23  Targets, split, baseline</a:t>
+                        <a:t>#19  Dimensionality reduction</a:t>
                       </a:r>
                     </a:p>
                   </a:txBody>
@@ -13178,13 +15361,13 @@
                     <a:lstStyle/>
                     <a:p>
                       <a:r>
-                        <a:rPr sz="1000" b="1" i="0">
-                          <a:solidFill>
-                            <a:srgbClr val="D1495B"/>
-                          </a:solidFill>
-                          <a:latin typeface="Bitstream Charter"/>
-                        </a:rPr>
-                        <a:t>unassigned</a:t>
+                        <a:rPr sz="1000" b="0" i="0">
+                          <a:solidFill>
+                            <a:srgbClr val="263C50"/>
+                          </a:solidFill>
+                          <a:latin typeface="Bitstream Charter"/>
+                        </a:rPr>
+                        <a:t>Gayas</a:t>
                       </a:r>
                     </a:p>
                   </a:txBody>
@@ -13213,7 +15396,7 @@
                           </a:solidFill>
                           <a:latin typeface="Bitstream Charter"/>
                         </a:rPr>
-                        <a:t>15/10</a:t>
+                        <a:t>16/10</a:t>
                       </a:r>
                     </a:p>
                   </a:txBody>
@@ -13271,7 +15454,7 @@
                           </a:solidFill>
                           <a:latin typeface="Bitstream Charter"/>
                         </a:rPr>
-                        <a:t>#24  Review-level models</a:t>
+                        <a:t>#23  Targets, split, baseline</a:t>
                       </a:r>
                     </a:p>
                   </a:txBody>
@@ -13293,13 +15476,13 @@
                     <a:lstStyle/>
                     <a:p>
                       <a:r>
-                        <a:rPr sz="1000" b="1" i="0">
-                          <a:solidFill>
-                            <a:srgbClr val="D1495B"/>
-                          </a:solidFill>
-                          <a:latin typeface="Bitstream Charter"/>
-                        </a:rPr>
-                        <a:t>unassigned</a:t>
+                        <a:rPr sz="1000" b="0" i="0">
+                          <a:solidFill>
+                            <a:srgbClr val="263C50"/>
+                          </a:solidFill>
+                          <a:latin typeface="Bitstream Charter"/>
+                        </a:rPr>
+                        <a:t>Shantharam</a:t>
                       </a:r>
                     </a:p>
                   </a:txBody>
@@ -13328,7 +15511,7 @@
                           </a:solidFill>
                           <a:latin typeface="Bitstream Charter"/>
                         </a:rPr>
-                        <a:t>17/10</a:t>
+                        <a:t>15/10</a:t>
                       </a:r>
                     </a:p>
                   </a:txBody>
@@ -13386,7 +15569,7 @@
                           </a:solidFill>
                           <a:latin typeface="Bitstream Charter"/>
                         </a:rPr>
-                        <a:t>#25  Game-level models</a:t>
+                        <a:t>#24  Review-level models</a:t>
                       </a:r>
                     </a:p>
                   </a:txBody>
@@ -13408,13 +15591,13 @@
                     <a:lstStyle/>
                     <a:p>
                       <a:r>
-                        <a:rPr sz="1000" b="1" i="0">
-                          <a:solidFill>
-                            <a:srgbClr val="D1495B"/>
-                          </a:solidFill>
-                          <a:latin typeface="Bitstream Charter"/>
-                        </a:rPr>
-                        <a:t>unassigned</a:t>
+                        <a:rPr sz="1000" b="0" i="0">
+                          <a:solidFill>
+                            <a:srgbClr val="263C50"/>
+                          </a:solidFill>
+                          <a:latin typeface="Bitstream Charter"/>
+                        </a:rPr>
+                        <a:t>Shantharam, Pradeep</a:t>
                       </a:r>
                     </a:p>
                   </a:txBody>
@@ -13443,7 +15626,7 @@
                           </a:solidFill>
                           <a:latin typeface="Bitstream Charter"/>
                         </a:rPr>
-                        <a:t>18/10</a:t>
+                        <a:t>17/10</a:t>
                       </a:r>
                     </a:p>
                   </a:txBody>
@@ -13501,7 +15684,7 @@
                           </a:solidFill>
                           <a:latin typeface="Bitstream Charter"/>
                         </a:rPr>
-                        <a:t>#26  Evaluation and meaning</a:t>
+                        <a:t>#25  Game-level models</a:t>
                       </a:r>
                     </a:p>
                   </a:txBody>
@@ -13523,13 +15706,13 @@
                     <a:lstStyle/>
                     <a:p>
                       <a:r>
-                        <a:rPr sz="1000" b="1" i="0">
-                          <a:solidFill>
-                            <a:srgbClr val="D1495B"/>
-                          </a:solidFill>
-                          <a:latin typeface="Bitstream Charter"/>
-                        </a:rPr>
-                        <a:t>unassigned</a:t>
+                        <a:rPr sz="1000" b="0" i="0">
+                          <a:solidFill>
+                            <a:srgbClr val="263C50"/>
+                          </a:solidFill>
+                          <a:latin typeface="Bitstream Charter"/>
+                        </a:rPr>
+                        <a:t>Shantharam, Pradeep</a:t>
                       </a:r>
                     </a:p>
                   </a:txBody>
@@ -13558,7 +15741,7 @@
                           </a:solidFill>
                           <a:latin typeface="Bitstream Charter"/>
                         </a:rPr>
-                        <a:t>19/10</a:t>
+                        <a:t>18/10</a:t>
                       </a:r>
                     </a:p>
                   </a:txBody>
@@ -13616,7 +15799,7 @@
                           </a:solidFill>
                           <a:latin typeface="Bitstream Charter"/>
                         </a:rPr>
-                        <a:t>#27  Notebook and findings</a:t>
+                        <a:t>#26  Evaluation and meaning</a:t>
                       </a:r>
                     </a:p>
                   </a:txBody>
@@ -13638,13 +15821,13 @@
                     <a:lstStyle/>
                     <a:p>
                       <a:r>
-                        <a:rPr sz="1000" b="1" i="0">
-                          <a:solidFill>
-                            <a:srgbClr val="D1495B"/>
-                          </a:solidFill>
-                          <a:latin typeface="Bitstream Charter"/>
-                        </a:rPr>
-                        <a:t>unassigned</a:t>
+                        <a:rPr sz="1000" b="0" i="0">
+                          <a:solidFill>
+                            <a:srgbClr val="263C50"/>
+                          </a:solidFill>
+                          <a:latin typeface="Bitstream Charter"/>
+                        </a:rPr>
+                        <a:t>Shantharam, Pradeep</a:t>
                       </a:r>
                     </a:p>
                   </a:txBody>
@@ -13673,7 +15856,7 @@
                           </a:solidFill>
                           <a:latin typeface="Bitstream Charter"/>
                         </a:rPr>
-                        <a:t>20/10</a:t>
+                        <a:t>19/10</a:t>
                       </a:r>
                     </a:p>
                   </a:txBody>
@@ -13731,7 +15914,7 @@
                           </a:solidFill>
                           <a:latin typeface="Bitstream Charter"/>
                         </a:rPr>
-                        <a:t>#6  Problem statement</a:t>
+                        <a:t>#27  Notebook and findings</a:t>
                       </a:r>
                     </a:p>
                   </a:txBody>
@@ -13753,13 +15936,13 @@
                     <a:lstStyle/>
                     <a:p>
                       <a:r>
-                        <a:rPr sz="1000" b="1" i="0">
-                          <a:solidFill>
-                            <a:srgbClr val="D1495B"/>
-                          </a:solidFill>
-                          <a:latin typeface="Bitstream Charter"/>
-                        </a:rPr>
-                        <a:t>unassigned</a:t>
+                        <a:rPr sz="1000" b="0" i="0">
+                          <a:solidFill>
+                            <a:srgbClr val="263C50"/>
+                          </a:solidFill>
+                          <a:latin typeface="Bitstream Charter"/>
+                        </a:rPr>
+                        <a:t>Shantharam</a:t>
                       </a:r>
                     </a:p>
                   </a:txBody>
@@ -13788,7 +15971,7 @@
                           </a:solidFill>
                           <a:latin typeface="Bitstream Charter"/>
                         </a:rPr>
-                        <a:t>03/10</a:t>
+                        <a:t>20/10</a:t>
                       </a:r>
                     </a:p>
                   </a:txBody>
@@ -13846,7 +16029,7 @@
                           </a:solidFill>
                           <a:latin typeface="Bitstream Charter"/>
                         </a:rPr>
-                        <a:t>#22  Final charts</a:t>
+                        <a:t>#6  Problem statement</a:t>
                       </a:r>
                     </a:p>
                   </a:txBody>
@@ -13868,13 +16051,13 @@
                     <a:lstStyle/>
                     <a:p>
                       <a:r>
-                        <a:rPr sz="1000" b="1" i="0">
-                          <a:solidFill>
-                            <a:srgbClr val="D1495B"/>
-                          </a:solidFill>
-                          <a:latin typeface="Bitstream Charter"/>
-                        </a:rPr>
-                        <a:t>unassigned</a:t>
+                        <a:rPr sz="1000" b="0" i="0">
+                          <a:solidFill>
+                            <a:srgbClr val="263C50"/>
+                          </a:solidFill>
+                          <a:latin typeface="Bitstream Charter"/>
+                        </a:rPr>
+                        <a:t>Tejaswini</a:t>
                       </a:r>
                     </a:p>
                   </a:txBody>
@@ -13903,7 +16086,7 @@
                           </a:solidFill>
                           <a:latin typeface="Bitstream Charter"/>
                         </a:rPr>
-                        <a:t>04/10</a:t>
+                        <a:t>03/10</a:t>
                       </a:r>
                     </a:p>
                   </a:txBody>
@@ -13931,7 +16114,7 @@
                           </a:solidFill>
                           <a:latin typeface="Bitstream Charter"/>
                         </a:rPr>
-                        <a:t>In Progress</a:t>
+                        <a:t>Completed</a:t>
                       </a:r>
                     </a:p>
                   </a:txBody>
@@ -14061,7 +16244,7 @@
                 </a:solidFill>
                 <a:latin typeface="Bitstream Charter"/>
               </a:rPr>
-              <a:t>Model comparison, text models, business findings, problem statement, notebook (PRs #56, #57); review dates set.</a:t>
+              <a:t>Model comparison, text models, business findings, problem statement, notebook and slides (PRs #56–#58).</a:t>
             </a:r>
           </a:p>
           <a:p>
@@ -14077,7 +16260,7 @@
                 </a:solidFill>
                 <a:latin typeface="Bitstream Charter"/>
               </a:rPr>
-              <a:t>46 cards, 10 merged PRs, 31 commits by 4 contributors.</a:t>
+              <a:t>33 commits and 11 merged pull requests so far.</a:t>
             </a:r>
           </a:p>
           <a:p>

</xml_diff>

<commit_message>
Add text-model test detail (accuracy, confusion matrix) and three evaluation slides
</commit_message>
<xml_diff>
--- a/slides/review1.pptx
+++ b/slides/review1.pptx
@@ -20,6 +20,9 @@
     <p:sldId id="261" r:id="rId7"/>
     <p:sldId id="262" r:id="rId8"/>
     <p:sldId id="263" r:id="rId9"/>
+    <p:sldId id="270" r:id="rId21"/>
+    <p:sldId id="271" r:id="rId22"/>
+    <p:sldId id="272" r:id="rId23"/>
     <p:sldId id="264" r:id="rId10"/>
     <p:sldId id="265" r:id="rId11"/>
   </p:sldIdLst>
@@ -3284,6 +3287,231 @@
           <a:p>
             <a:r>
               <a:t>From EDA section 11. Pairs are ranked by the confidence bound nearest the overall rate so small samples cannot top the list. Not causal.</a:t>
+            </a:r>
+          </a:p>
+        </p:txBody>
+      </p:sp>
+      <p:sp>
+        <p:nvSpPr>
+          <p:cNvPr id="4" name="Slide Number Placeholder 3"/>
+          <p:cNvSpPr>
+            <a:spLocks noGrp="1"/>
+          </p:cNvSpPr>
+          <p:nvPr>
+            <p:ph type="sldNum" idx="5" sz="quarter"/>
+          </p:nvPr>
+        </p:nvSpPr>
+        <p:spPr/>
+      </p:sp>
+    </p:spTree>
+  </p:cSld>
+  <p:clrMapOvr>
+    <a:masterClrMapping/>
+  </p:clrMapOvr>
+</p:notes>
+</file>
+
+<file path=ppt/notesSlides/notesSlide15.xml><?xml version="1.0" encoding="utf-8"?>
+<p:notes xmlns:a="http://schemas.openxmlformats.org/drawingml/2006/main" xmlns:p="http://schemas.openxmlformats.org/presentationml/2006/main" xmlns:r="http://schemas.openxmlformats.org/officeDocument/2006/relationships">
+  <p:cSld>
+    <p:spTree>
+      <p:nvGrpSpPr>
+        <p:cNvPr id="1" name=""/>
+        <p:cNvGrpSpPr/>
+        <p:nvPr/>
+      </p:nvGrpSpPr>
+      <p:grpSpPr>
+        <a:xfrm>
+          <a:off x="0" y="0"/>
+          <a:ext cx="0" cy="0"/>
+          <a:chOff x="0" y="0"/>
+          <a:chExt cx="0" cy="0"/>
+        </a:xfrm>
+      </p:grpSpPr>
+      <p:sp>
+        <p:nvSpPr>
+          <p:cNvPr id="2" name="Slide Image Placeholder 1"/>
+          <p:cNvSpPr>
+            <a:spLocks noGrp="1"/>
+          </p:cNvSpPr>
+          <p:nvPr>
+            <p:ph type="sldImg" idx="2"/>
+          </p:nvPr>
+        </p:nvSpPr>
+        <p:spPr/>
+      </p:sp>
+      <p:sp>
+        <p:nvSpPr>
+          <p:cNvPr id="3" name="Notes Placeholder 2"/>
+          <p:cNvSpPr>
+            <a:spLocks noGrp="1"/>
+          </p:cNvSpPr>
+          <p:nvPr>
+            <p:ph type="body" idx="3" sz="quarter"/>
+          </p:nvPr>
+        </p:nvSpPr>
+        <p:spPr/>
+        <p:txBody>
+          <a:bodyPr/>
+          <a:lstStyle/>
+          <a:p>
+            <a:r>
+              <a:t>Suggested speaker: Shantharam. 1:00.</a:t>
+            </a:r>
+          </a:p>
+          <a:p>
+            <a:r>
+              <a:t>The threshold was set on out-of-fold predictions (0.788) and the test set was scored once: python -m src.models.review_text_detail. Accuracy alone is misleading with 10% negatives, so we show it next to the always-positive baseline, balanced accuracy, precision, recall, F1, MCC and ROC-AUC.</a:t>
+            </a:r>
+          </a:p>
+        </p:txBody>
+      </p:sp>
+      <p:sp>
+        <p:nvSpPr>
+          <p:cNvPr id="4" name="Slide Number Placeholder 3"/>
+          <p:cNvSpPr>
+            <a:spLocks noGrp="1"/>
+          </p:cNvSpPr>
+          <p:nvPr>
+            <p:ph type="sldNum" idx="5" sz="quarter"/>
+          </p:nvPr>
+        </p:nvSpPr>
+        <p:spPr/>
+      </p:sp>
+    </p:spTree>
+  </p:cSld>
+  <p:clrMapOvr>
+    <a:masterClrMapping/>
+  </p:clrMapOvr>
+</p:notes>
+</file>
+
+<file path=ppt/notesSlides/notesSlide16.xml><?xml version="1.0" encoding="utf-8"?>
+<p:notes xmlns:a="http://schemas.openxmlformats.org/drawingml/2006/main" xmlns:p="http://schemas.openxmlformats.org/presentationml/2006/main" xmlns:r="http://schemas.openxmlformats.org/officeDocument/2006/relationships">
+  <p:cSld>
+    <p:spTree>
+      <p:nvGrpSpPr>
+        <p:cNvPr id="1" name=""/>
+        <p:cNvGrpSpPr/>
+        <p:nvPr/>
+      </p:nvGrpSpPr>
+      <p:grpSpPr>
+        <a:xfrm>
+          <a:off x="0" y="0"/>
+          <a:ext cx="0" cy="0"/>
+          <a:chOff x="0" y="0"/>
+          <a:chExt cx="0" cy="0"/>
+        </a:xfrm>
+      </p:grpSpPr>
+      <p:sp>
+        <p:nvSpPr>
+          <p:cNvPr id="2" name="Slide Image Placeholder 1"/>
+          <p:cNvSpPr>
+            <a:spLocks noGrp="1"/>
+          </p:cNvSpPr>
+          <p:nvPr>
+            <p:ph type="sldImg" idx="2"/>
+          </p:nvPr>
+        </p:nvSpPr>
+        <p:spPr/>
+      </p:sp>
+      <p:sp>
+        <p:nvSpPr>
+          <p:cNvPr id="3" name="Notes Placeholder 2"/>
+          <p:cNvSpPr>
+            <a:spLocks noGrp="1"/>
+          </p:cNvSpPr>
+          <p:nvPr>
+            <p:ph type="body" idx="3" sz="quarter"/>
+          </p:nvPr>
+        </p:nvSpPr>
+        <p:spPr/>
+        <p:txBody>
+          <a:bodyPr/>
+          <a:lstStyle/>
+          <a:p>
+            <a:r>
+              <a:t>Suggested speaker: Pradeep. 1:00.</a:t>
+            </a:r>
+          </a:p>
+          <a:p>
+            <a:r>
+              <a:t>Bars are test scores (scored once); diamonds are cross-validation means with spread; the black whiskers are bootstrap intervals. Cross-validation is slightly optimistic, so quote the test numbers.</a:t>
+            </a:r>
+          </a:p>
+        </p:txBody>
+      </p:sp>
+      <p:sp>
+        <p:nvSpPr>
+          <p:cNvPr id="4" name="Slide Number Placeholder 3"/>
+          <p:cNvSpPr>
+            <a:spLocks noGrp="1"/>
+          </p:cNvSpPr>
+          <p:nvPr>
+            <p:ph type="sldNum" idx="5" sz="quarter"/>
+          </p:nvPr>
+        </p:nvSpPr>
+        <p:spPr/>
+      </p:sp>
+    </p:spTree>
+  </p:cSld>
+  <p:clrMapOvr>
+    <a:masterClrMapping/>
+  </p:clrMapOvr>
+</p:notes>
+</file>
+
+<file path=ppt/notesSlides/notesSlide17.xml><?xml version="1.0" encoding="utf-8"?>
+<p:notes xmlns:a="http://schemas.openxmlformats.org/drawingml/2006/main" xmlns:p="http://schemas.openxmlformats.org/presentationml/2006/main" xmlns:r="http://schemas.openxmlformats.org/officeDocument/2006/relationships">
+  <p:cSld>
+    <p:spTree>
+      <p:nvGrpSpPr>
+        <p:cNvPr id="1" name=""/>
+        <p:cNvGrpSpPr/>
+        <p:nvPr/>
+      </p:nvGrpSpPr>
+      <p:grpSpPr>
+        <a:xfrm>
+          <a:off x="0" y="0"/>
+          <a:ext cx="0" cy="0"/>
+          <a:chOff x="0" y="0"/>
+          <a:chExt cx="0" cy="0"/>
+        </a:xfrm>
+      </p:grpSpPr>
+      <p:sp>
+        <p:nvSpPr>
+          <p:cNvPr id="2" name="Slide Image Placeholder 1"/>
+          <p:cNvSpPr>
+            <a:spLocks noGrp="1"/>
+          </p:cNvSpPr>
+          <p:nvPr>
+            <p:ph type="sldImg" idx="2"/>
+          </p:nvPr>
+        </p:nvSpPr>
+        <p:spPr/>
+      </p:sp>
+      <p:sp>
+        <p:nvSpPr>
+          <p:cNvPr id="3" name="Notes Placeholder 2"/>
+          <p:cNvSpPr>
+            <a:spLocks noGrp="1"/>
+          </p:cNvSpPr>
+          <p:nvPr>
+            <p:ph type="body" idx="3" sz="quarter"/>
+          </p:nvPr>
+        </p:nvSpPr>
+        <p:spPr/>
+        <p:txBody>
+          <a:bodyPr/>
+          <a:lstStyle/>
+          <a:p>
+            <a:r>
+              <a:t>Suggested speaker: Pradeep. 0:45.</a:t>
+            </a:r>
+          </a:p>
+          <a:p>
+            <a:r>
+              <a:t>Mean absolute SHAP values from the XGBoost models (PR #55). The review model also uses reviewer-history columns collected at scrape time; these are not available at launch, which is one reason we report review-level results as explanatory.</a:t>
             </a:r>
           </a:p>
         </p:txBody>
@@ -4860,7 +5088,7 @@
                 <a:ea typeface="Bitstream Charter"/>
                 <a:cs typeface="Bitstream Charter"/>
               </a:rPr>
-              <a:t>14</a:t>
+              <a:t>17</a:t>
             </a:r>
           </a:p>
         </p:txBody>
@@ -7186,6 +7414,1850 @@
                 <a:latin typeface="Bitstream Charter"/>
               </a:rPr>
               <a:t>2D with Pixel Graphics, Strategy or Deckbuilding sit at 5–9% against 14.5% overall; RPG with PvE (33%) and 3D pairings (23–27%) sit highest. These are associations, which Review 2’s association rules extend.</a:t>
+            </a:r>
+          </a:p>
+        </p:txBody>
+      </p:sp>
+    </p:spTree>
+  </p:cSld>
+  <p:clrMapOvr>
+    <a:masterClrMapping/>
+  </p:clrMapOvr>
+</p:sld>
+</file>
+
+<file path=ppt/slides/slide15.xml><?xml version="1.0" encoding="utf-8"?>
+<p:sld xmlns:a="http://schemas.openxmlformats.org/drawingml/2006/main" xmlns:p="http://schemas.openxmlformats.org/presentationml/2006/main" xmlns:r="http://schemas.openxmlformats.org/officeDocument/2006/relationships">
+  <p:cSld>
+    <p:bg>
+      <p:bgPr>
+        <a:solidFill>
+          <a:srgbClr val="F7F9FC"/>
+        </a:solidFill>
+        <a:effectLst/>
+      </p:bgPr>
+    </p:bg>
+    <p:spTree>
+      <p:nvGrpSpPr>
+        <p:cNvPr id="1" name=""/>
+        <p:cNvGrpSpPr/>
+        <p:nvPr/>
+      </p:nvGrpSpPr>
+      <p:grpSpPr/>
+      <p:sp>
+        <p:nvSpPr>
+          <p:cNvPr id="5" name="Rectangle 4">
+            <a:extLst>
+              <a:ext uri="{FF2B5EF4-FFF2-40B4-BE49-F238E27FC236}">
+                <a16:creationId xmlns:a16="http://schemas.microsoft.com/office/drawing/2014/main" id="{27979FDE-990F-4C15-B33C-B2975BF50CD9}"/>
+              </a:ext>
+            </a:extLst>
+          </p:cNvPr>
+          <p:cNvSpPr>
+            <a:spLocks noGrp="1"/>
+          </p:cNvSpPr>
+          <p:nvPr/>
+        </p:nvSpPr>
+        <p:spPr>
+          <a:xfrm>
+            <a:off x="685800" y="523875"/>
+            <a:ext cx="10820400" cy="952500"/>
+          </a:xfrm>
+          <a:prstGeom prst="rect">
+            <a:avLst/>
+          </a:prstGeom>
+          <a:noFill/>
+          <a:ln w="0">
+            <a:noFill/>
+          </a:ln>
+        </p:spPr>
+        <p:txBody>
+          <a:bodyPr wrap="square">
+            <a:noAutofit/>
+          </a:bodyPr>
+          <a:lstStyle/>
+          <a:p>
+            <a:pPr>
+              <a:spcAft>
+                <a:spcPts val="400"/>
+              </a:spcAft>
+              <a:defRPr sz="3300" b="1">
+                <a:solidFill>
+                  <a:srgbClr val="132C43"/>
+                </a:solidFill>
+                <a:latin typeface="Bitstream Charter"/>
+                <a:ea typeface="Bitstream Charter"/>
+                <a:cs typeface="Bitstream Charter"/>
+              </a:defRPr>
+            </a:pPr>
+            <a:r>
+              <a:rPr sz="3300" b="1" i="0">
+                <a:solidFill>
+                  <a:srgbClr val="132C43"/>
+                </a:solidFill>
+                <a:latin typeface="Bitstream Charter"/>
+              </a:rPr>
+              <a:t>Evaluation: Text Model in Detail</a:t>
+            </a:r>
+          </a:p>
+        </p:txBody>
+      </p:sp>
+      <p:sp>
+        <p:nvSpPr>
+          <p:cNvPr id="4" name="Rectangle 3">
+            <a:extLst>
+              <a:ext uri="{FF2B5EF4-FFF2-40B4-BE49-F238E27FC236}">
+                <a16:creationId xmlns:a16="http://schemas.microsoft.com/office/drawing/2014/main" id="{C795E4D0-3C0B-473C-BB65-A65A174FB43B}"/>
+              </a:ext>
+            </a:extLst>
+          </p:cNvPr>
+          <p:cNvSpPr>
+            <a:spLocks noGrp="1"/>
+          </p:cNvSpPr>
+          <p:nvPr/>
+        </p:nvSpPr>
+        <p:spPr>
+          <a:xfrm>
+            <a:off x="11049000" y="6076950"/>
+            <a:ext cx="476250" cy="381000"/>
+          </a:xfrm>
+          <a:prstGeom prst="rect">
+            <a:avLst/>
+          </a:prstGeom>
+          <a:noFill/>
+          <a:ln w="0">
+            <a:noFill/>
+          </a:ln>
+        </p:spPr>
+        <p:txBody>
+          <a:bodyPr>
+            <a:noAutofit/>
+          </a:bodyPr>
+          <a:lstStyle/>
+          <a:p>
+            <a:pPr>
+              <a:defRPr sz="1500" b="0">
+                <a:solidFill>
+                  <a:srgbClr val="48677E"/>
+                </a:solidFill>
+                <a:latin typeface="Bitstream Charter"/>
+                <a:ea typeface="Bitstream Charter"/>
+                <a:cs typeface="Bitstream Charter"/>
+              </a:defRPr>
+            </a:pPr>
+            <a:r>
+              <a:rPr sz="1500" b="0">
+                <a:solidFill>
+                  <a:srgbClr val="48677E"/>
+                </a:solidFill>
+                <a:latin typeface="Bitstream Charter"/>
+                <a:ea typeface="Bitstream Charter"/>
+                <a:cs typeface="Bitstream Charter"/>
+              </a:rPr>
+              <a:t>13</a:t>
+            </a:r>
+          </a:p>
+        </p:txBody>
+      </p:sp>
+      <p:pic>
+        <p:nvPicPr>
+          <p:cNvPr id="6" name="Picture 5" descr="review_text_confusion.png"/>
+          <p:cNvPicPr>
+            <a:picLocks noChangeAspect="1"/>
+          </p:cNvPicPr>
+          <p:nvPr/>
+        </p:nvPicPr>
+        <p:blipFill>
+          <a:blip r:embed="rId2"/>
+          <a:stretch>
+            <a:fillRect/>
+          </a:stretch>
+        </p:blipFill>
+        <p:spPr>
+          <a:xfrm>
+            <a:off x="640080" y="1554480"/>
+            <a:ext cx="4000500" cy="3429000"/>
+          </a:xfrm>
+          <a:prstGeom prst="rect">
+            <a:avLst/>
+          </a:prstGeom>
+        </p:spPr>
+      </p:pic>
+      <p:graphicFrame>
+        <p:nvGraphicFramePr>
+          <p:cNvPr id="7" name="Table 6"/>
+          <p:cNvGraphicFramePr>
+            <a:graphicFrameLocks noGrp="1"/>
+          </p:cNvGraphicFramePr>
+          <p:nvPr/>
+        </p:nvGraphicFramePr>
+        <p:xfrm>
+          <a:off x="4800600" y="1600200"/>
+          <a:ext cx="6675120" cy="2633472"/>
+        </p:xfrm>
+        <a:graphic>
+          <a:graphicData uri="http://schemas.openxmlformats.org/drawingml/2006/table">
+            <a:tbl>
+              <a:tblPr firstRow="0" bandRow="0">
+                <a:tableStyleId>{2D5ABB26-0587-4C30-8999-92F81FD0307C}</a:tableStyleId>
+              </a:tblPr>
+              <a:tblGrid>
+                <a:gridCol w="2377440"/>
+                <a:gridCol w="1554480"/>
+                <a:gridCol w="2743200"/>
+              </a:tblGrid>
+              <a:tr h="329184">
+                <a:tc>
+                  <a:txBody>
+                    <a:bodyPr wrap="square"/>
+                    <a:lstStyle/>
+                    <a:p>
+                      <a:r>
+                        <a:rPr sz="1150" b="1" i="0">
+                          <a:solidFill>
+                            <a:srgbClr val="FFFFFF"/>
+                          </a:solidFill>
+                          <a:latin typeface="Bitstream Charter"/>
+                        </a:rPr>
+                        <a:t>Measure (test set)</a:t>
+                      </a:r>
+                    </a:p>
+                  </a:txBody>
+                  <a:tcPr marL="64008" marR="64008" marT="32004" marB="32004" anchor="ctr">
+                    <a:solidFill>
+                      <a:srgbClr val="132C43"/>
+                    </a:solidFill>
+                  </a:tcPr>
+                </a:tc>
+                <a:tc>
+                  <a:txBody>
+                    <a:bodyPr wrap="square"/>
+                    <a:lstStyle/>
+                    <a:p>
+                      <a:pPr algn="ctr"/>
+                      <a:r>
+                        <a:rPr sz="1150" b="1" i="0">
+                          <a:solidFill>
+                            <a:srgbClr val="FFFFFF"/>
+                          </a:solidFill>
+                          <a:latin typeface="Bitstream Charter"/>
+                        </a:rPr>
+                        <a:t>Text model</a:t>
+                      </a:r>
+                    </a:p>
+                  </a:txBody>
+                  <a:tcPr marL="64008" marR="64008" marT="32004" marB="32004" anchor="ctr">
+                    <a:solidFill>
+                      <a:srgbClr val="132C43"/>
+                    </a:solidFill>
+                  </a:tcPr>
+                </a:tc>
+                <a:tc>
+                  <a:txBody>
+                    <a:bodyPr wrap="square"/>
+                    <a:lstStyle/>
+                    <a:p>
+                      <a:pPr algn="ctr"/>
+                      <a:r>
+                        <a:rPr sz="1150" b="1" i="0">
+                          <a:solidFill>
+                            <a:srgbClr val="FFFFFF"/>
+                          </a:solidFill>
+                          <a:latin typeface="Bitstream Charter"/>
+                        </a:rPr>
+                        <a:t>Always-positive baseline</a:t>
+                      </a:r>
+                    </a:p>
+                  </a:txBody>
+                  <a:tcPr marL="64008" marR="64008" marT="32004" marB="32004" anchor="ctr">
+                    <a:solidFill>
+                      <a:srgbClr val="132C43"/>
+                    </a:solidFill>
+                  </a:tcPr>
+                </a:tc>
+              </a:tr>
+              <a:tr h="329184">
+                <a:tc>
+                  <a:txBody>
+                    <a:bodyPr wrap="square"/>
+                    <a:lstStyle/>
+                    <a:p>
+                      <a:r>
+                        <a:rPr sz="1150" b="0" i="0">
+                          <a:solidFill>
+                            <a:srgbClr val="263C50"/>
+                          </a:solidFill>
+                          <a:latin typeface="Bitstream Charter"/>
+                        </a:rPr>
+                        <a:t>Accuracy</a:t>
+                      </a:r>
+                    </a:p>
+                  </a:txBody>
+                  <a:tcPr marL="64008" marR="64008" marT="32004" marB="32004" anchor="ctr">
+                    <a:lnB w="9525" cap="flat" cmpd="sng" algn="ctr">
+                      <a:solidFill>
+                        <a:srgbClr val="C9D6E2"/>
+                      </a:solidFill>
+                      <a:prstDash val="solid"/>
+                    </a:lnB>
+                    <a:solidFill>
+                      <a:srgbClr val="FFFFFF"/>
+                    </a:solidFill>
+                  </a:tcPr>
+                </a:tc>
+                <a:tc>
+                  <a:txBody>
+                    <a:bodyPr wrap="square"/>
+                    <a:lstStyle/>
+                    <a:p>
+                      <a:pPr algn="ctr"/>
+                      <a:r>
+                        <a:rPr sz="1150" b="0" i="0">
+                          <a:solidFill>
+                            <a:srgbClr val="263C50"/>
+                          </a:solidFill>
+                          <a:latin typeface="Bitstream Charter"/>
+                        </a:rPr>
+                        <a:t>93.6%</a:t>
+                      </a:r>
+                    </a:p>
+                  </a:txBody>
+                  <a:tcPr marL="64008" marR="64008" marT="32004" marB="32004" anchor="ctr">
+                    <a:lnB w="9525" cap="flat" cmpd="sng" algn="ctr">
+                      <a:solidFill>
+                        <a:srgbClr val="C9D6E2"/>
+                      </a:solidFill>
+                      <a:prstDash val="solid"/>
+                    </a:lnB>
+                    <a:solidFill>
+                      <a:srgbClr val="FFFFFF"/>
+                    </a:solidFill>
+                  </a:tcPr>
+                </a:tc>
+                <a:tc>
+                  <a:txBody>
+                    <a:bodyPr wrap="square"/>
+                    <a:lstStyle/>
+                    <a:p>
+                      <a:pPr algn="ctr"/>
+                      <a:r>
+                        <a:rPr sz="1150" b="0" i="0">
+                          <a:solidFill>
+                            <a:srgbClr val="263C50"/>
+                          </a:solidFill>
+                          <a:latin typeface="Bitstream Charter"/>
+                        </a:rPr>
+                        <a:t>88.5% (always positive)</a:t>
+                      </a:r>
+                    </a:p>
+                  </a:txBody>
+                  <a:tcPr marL="64008" marR="64008" marT="32004" marB="32004" anchor="ctr">
+                    <a:lnB w="9525" cap="flat" cmpd="sng" algn="ctr">
+                      <a:solidFill>
+                        <a:srgbClr val="C9D6E2"/>
+                      </a:solidFill>
+                      <a:prstDash val="solid"/>
+                    </a:lnB>
+                    <a:solidFill>
+                      <a:srgbClr val="FFFFFF"/>
+                    </a:solidFill>
+                  </a:tcPr>
+                </a:tc>
+              </a:tr>
+              <a:tr h="329184">
+                <a:tc>
+                  <a:txBody>
+                    <a:bodyPr wrap="square"/>
+                    <a:lstStyle/>
+                    <a:p>
+                      <a:r>
+                        <a:rPr sz="1150" b="0" i="0">
+                          <a:solidFill>
+                            <a:srgbClr val="263C50"/>
+                          </a:solidFill>
+                          <a:latin typeface="Bitstream Charter"/>
+                        </a:rPr>
+                        <a:t>Balanced accuracy</a:t>
+                      </a:r>
+                    </a:p>
+                  </a:txBody>
+                  <a:tcPr marL="64008" marR="64008" marT="32004" marB="32004" anchor="ctr">
+                    <a:lnB w="9525" cap="flat" cmpd="sng" algn="ctr">
+                      <a:solidFill>
+                        <a:srgbClr val="C9D6E2"/>
+                      </a:solidFill>
+                      <a:prstDash val="solid"/>
+                    </a:lnB>
+                    <a:solidFill>
+                      <a:srgbClr val="EAF0F6"/>
+                    </a:solidFill>
+                  </a:tcPr>
+                </a:tc>
+                <a:tc>
+                  <a:txBody>
+                    <a:bodyPr wrap="square"/>
+                    <a:lstStyle/>
+                    <a:p>
+                      <a:pPr algn="ctr"/>
+                      <a:r>
+                        <a:rPr sz="1150" b="0" i="0">
+                          <a:solidFill>
+                            <a:srgbClr val="263C50"/>
+                          </a:solidFill>
+                          <a:latin typeface="Bitstream Charter"/>
+                        </a:rPr>
+                        <a:t>84.4%</a:t>
+                      </a:r>
+                    </a:p>
+                  </a:txBody>
+                  <a:tcPr marL="64008" marR="64008" marT="32004" marB="32004" anchor="ctr">
+                    <a:lnB w="9525" cap="flat" cmpd="sng" algn="ctr">
+                      <a:solidFill>
+                        <a:srgbClr val="C9D6E2"/>
+                      </a:solidFill>
+                      <a:prstDash val="solid"/>
+                    </a:lnB>
+                    <a:solidFill>
+                      <a:srgbClr val="EAF0F6"/>
+                    </a:solidFill>
+                  </a:tcPr>
+                </a:tc>
+                <a:tc>
+                  <a:txBody>
+                    <a:bodyPr wrap="square"/>
+                    <a:lstStyle/>
+                    <a:p>
+                      <a:pPr algn="ctr"/>
+                      <a:r>
+                        <a:rPr sz="1150" b="0" i="0">
+                          <a:solidFill>
+                            <a:srgbClr val="263C50"/>
+                          </a:solidFill>
+                          <a:latin typeface="Bitstream Charter"/>
+                        </a:rPr>
+                        <a:t>50.0%</a:t>
+                      </a:r>
+                    </a:p>
+                  </a:txBody>
+                  <a:tcPr marL="64008" marR="64008" marT="32004" marB="32004" anchor="ctr">
+                    <a:lnB w="9525" cap="flat" cmpd="sng" algn="ctr">
+                      <a:solidFill>
+                        <a:srgbClr val="C9D6E2"/>
+                      </a:solidFill>
+                      <a:prstDash val="solid"/>
+                    </a:lnB>
+                    <a:solidFill>
+                      <a:srgbClr val="EAF0F6"/>
+                    </a:solidFill>
+                  </a:tcPr>
+                </a:tc>
+              </a:tr>
+              <a:tr h="329184">
+                <a:tc>
+                  <a:txBody>
+                    <a:bodyPr wrap="square"/>
+                    <a:lstStyle/>
+                    <a:p>
+                      <a:r>
+                        <a:rPr sz="1150" b="0" i="0">
+                          <a:solidFill>
+                            <a:srgbClr val="263C50"/>
+                          </a:solidFill>
+                          <a:latin typeface="Bitstream Charter"/>
+                        </a:rPr>
+                        <a:t>Precision (negative)</a:t>
+                      </a:r>
+                    </a:p>
+                  </a:txBody>
+                  <a:tcPr marL="64008" marR="64008" marT="32004" marB="32004" anchor="ctr">
+                    <a:lnB w="9525" cap="flat" cmpd="sng" algn="ctr">
+                      <a:solidFill>
+                        <a:srgbClr val="C9D6E2"/>
+                      </a:solidFill>
+                      <a:prstDash val="solid"/>
+                    </a:lnB>
+                    <a:solidFill>
+                      <a:srgbClr val="FFFFFF"/>
+                    </a:solidFill>
+                  </a:tcPr>
+                </a:tc>
+                <a:tc>
+                  <a:txBody>
+                    <a:bodyPr wrap="square"/>
+                    <a:lstStyle/>
+                    <a:p>
+                      <a:pPr algn="ctr"/>
+                      <a:r>
+                        <a:rPr sz="1150" b="0" i="0">
+                          <a:solidFill>
+                            <a:srgbClr val="263C50"/>
+                          </a:solidFill>
+                          <a:latin typeface="Bitstream Charter"/>
+                        </a:rPr>
+                        <a:t>0.72</a:t>
+                      </a:r>
+                    </a:p>
+                  </a:txBody>
+                  <a:tcPr marL="64008" marR="64008" marT="32004" marB="32004" anchor="ctr">
+                    <a:lnB w="9525" cap="flat" cmpd="sng" algn="ctr">
+                      <a:solidFill>
+                        <a:srgbClr val="C9D6E2"/>
+                      </a:solidFill>
+                      <a:prstDash val="solid"/>
+                    </a:lnB>
+                    <a:solidFill>
+                      <a:srgbClr val="FFFFFF"/>
+                    </a:solidFill>
+                  </a:tcPr>
+                </a:tc>
+                <a:tc>
+                  <a:txBody>
+                    <a:bodyPr wrap="square"/>
+                    <a:lstStyle/>
+                    <a:p>
+                      <a:pPr algn="ctr"/>
+                      <a:r>
+                        <a:rPr sz="1150" b="0" i="0">
+                          <a:solidFill>
+                            <a:srgbClr val="263C50"/>
+                          </a:solidFill>
+                          <a:latin typeface="Bitstream Charter"/>
+                        </a:rPr>
+                        <a:t>0.00</a:t>
+                      </a:r>
+                    </a:p>
+                  </a:txBody>
+                  <a:tcPr marL="64008" marR="64008" marT="32004" marB="32004" anchor="ctr">
+                    <a:lnB w="9525" cap="flat" cmpd="sng" algn="ctr">
+                      <a:solidFill>
+                        <a:srgbClr val="C9D6E2"/>
+                      </a:solidFill>
+                      <a:prstDash val="solid"/>
+                    </a:lnB>
+                    <a:solidFill>
+                      <a:srgbClr val="FFFFFF"/>
+                    </a:solidFill>
+                  </a:tcPr>
+                </a:tc>
+              </a:tr>
+              <a:tr h="329184">
+                <a:tc>
+                  <a:txBody>
+                    <a:bodyPr wrap="square"/>
+                    <a:lstStyle/>
+                    <a:p>
+                      <a:r>
+                        <a:rPr sz="1150" b="0" i="0">
+                          <a:solidFill>
+                            <a:srgbClr val="263C50"/>
+                          </a:solidFill>
+                          <a:latin typeface="Bitstream Charter"/>
+                        </a:rPr>
+                        <a:t>Recall (negative)</a:t>
+                      </a:r>
+                    </a:p>
+                  </a:txBody>
+                  <a:tcPr marL="64008" marR="64008" marT="32004" marB="32004" anchor="ctr">
+                    <a:lnB w="9525" cap="flat" cmpd="sng" algn="ctr">
+                      <a:solidFill>
+                        <a:srgbClr val="C9D6E2"/>
+                      </a:solidFill>
+                      <a:prstDash val="solid"/>
+                    </a:lnB>
+                    <a:solidFill>
+                      <a:srgbClr val="EAF0F6"/>
+                    </a:solidFill>
+                  </a:tcPr>
+                </a:tc>
+                <a:tc>
+                  <a:txBody>
+                    <a:bodyPr wrap="square"/>
+                    <a:lstStyle/>
+                    <a:p>
+                      <a:pPr algn="ctr"/>
+                      <a:r>
+                        <a:rPr sz="1150" b="0" i="0">
+                          <a:solidFill>
+                            <a:srgbClr val="263C50"/>
+                          </a:solidFill>
+                          <a:latin typeface="Bitstream Charter"/>
+                        </a:rPr>
+                        <a:t>0.72</a:t>
+                      </a:r>
+                    </a:p>
+                  </a:txBody>
+                  <a:tcPr marL="64008" marR="64008" marT="32004" marB="32004" anchor="ctr">
+                    <a:lnB w="9525" cap="flat" cmpd="sng" algn="ctr">
+                      <a:solidFill>
+                        <a:srgbClr val="C9D6E2"/>
+                      </a:solidFill>
+                      <a:prstDash val="solid"/>
+                    </a:lnB>
+                    <a:solidFill>
+                      <a:srgbClr val="EAF0F6"/>
+                    </a:solidFill>
+                  </a:tcPr>
+                </a:tc>
+                <a:tc>
+                  <a:txBody>
+                    <a:bodyPr wrap="square"/>
+                    <a:lstStyle/>
+                    <a:p>
+                      <a:pPr algn="ctr"/>
+                      <a:r>
+                        <a:rPr sz="1150" b="0" i="0">
+                          <a:solidFill>
+                            <a:srgbClr val="263C50"/>
+                          </a:solidFill>
+                          <a:latin typeface="Bitstream Charter"/>
+                        </a:rPr>
+                        <a:t>0.00</a:t>
+                      </a:r>
+                    </a:p>
+                  </a:txBody>
+                  <a:tcPr marL="64008" marR="64008" marT="32004" marB="32004" anchor="ctr">
+                    <a:lnB w="9525" cap="flat" cmpd="sng" algn="ctr">
+                      <a:solidFill>
+                        <a:srgbClr val="C9D6E2"/>
+                      </a:solidFill>
+                      <a:prstDash val="solid"/>
+                    </a:lnB>
+                    <a:solidFill>
+                      <a:srgbClr val="EAF0F6"/>
+                    </a:solidFill>
+                  </a:tcPr>
+                </a:tc>
+              </a:tr>
+              <a:tr h="329184">
+                <a:tc>
+                  <a:txBody>
+                    <a:bodyPr wrap="square"/>
+                    <a:lstStyle/>
+                    <a:p>
+                      <a:r>
+                        <a:rPr sz="1150" b="0" i="0">
+                          <a:solidFill>
+                            <a:srgbClr val="263C50"/>
+                          </a:solidFill>
+                          <a:latin typeface="Bitstream Charter"/>
+                        </a:rPr>
+                        <a:t>F1 (negative)</a:t>
+                      </a:r>
+                    </a:p>
+                  </a:txBody>
+                  <a:tcPr marL="64008" marR="64008" marT="32004" marB="32004" anchor="ctr">
+                    <a:lnB w="9525" cap="flat" cmpd="sng" algn="ctr">
+                      <a:solidFill>
+                        <a:srgbClr val="C9D6E2"/>
+                      </a:solidFill>
+                      <a:prstDash val="solid"/>
+                    </a:lnB>
+                    <a:solidFill>
+                      <a:srgbClr val="FFFFFF"/>
+                    </a:solidFill>
+                  </a:tcPr>
+                </a:tc>
+                <a:tc>
+                  <a:txBody>
+                    <a:bodyPr wrap="square"/>
+                    <a:lstStyle/>
+                    <a:p>
+                      <a:pPr algn="ctr"/>
+                      <a:r>
+                        <a:rPr sz="1150" b="0" i="0">
+                          <a:solidFill>
+                            <a:srgbClr val="263C50"/>
+                          </a:solidFill>
+                          <a:latin typeface="Bitstream Charter"/>
+                        </a:rPr>
+                        <a:t>0.72</a:t>
+                      </a:r>
+                    </a:p>
+                  </a:txBody>
+                  <a:tcPr marL="64008" marR="64008" marT="32004" marB="32004" anchor="ctr">
+                    <a:lnB w="9525" cap="flat" cmpd="sng" algn="ctr">
+                      <a:solidFill>
+                        <a:srgbClr val="C9D6E2"/>
+                      </a:solidFill>
+                      <a:prstDash val="solid"/>
+                    </a:lnB>
+                    <a:solidFill>
+                      <a:srgbClr val="FFFFFF"/>
+                    </a:solidFill>
+                  </a:tcPr>
+                </a:tc>
+                <a:tc>
+                  <a:txBody>
+                    <a:bodyPr wrap="square"/>
+                    <a:lstStyle/>
+                    <a:p>
+                      <a:pPr algn="ctr"/>
+                      <a:r>
+                        <a:rPr sz="1150" b="0" i="0">
+                          <a:solidFill>
+                            <a:srgbClr val="263C50"/>
+                          </a:solidFill>
+                          <a:latin typeface="Bitstream Charter"/>
+                        </a:rPr>
+                        <a:t>0.00</a:t>
+                      </a:r>
+                    </a:p>
+                  </a:txBody>
+                  <a:tcPr marL="64008" marR="64008" marT="32004" marB="32004" anchor="ctr">
+                    <a:lnB w="9525" cap="flat" cmpd="sng" algn="ctr">
+                      <a:solidFill>
+                        <a:srgbClr val="C9D6E2"/>
+                      </a:solidFill>
+                      <a:prstDash val="solid"/>
+                    </a:lnB>
+                    <a:solidFill>
+                      <a:srgbClr val="FFFFFF"/>
+                    </a:solidFill>
+                  </a:tcPr>
+                </a:tc>
+              </a:tr>
+              <a:tr h="329184">
+                <a:tc>
+                  <a:txBody>
+                    <a:bodyPr wrap="square"/>
+                    <a:lstStyle/>
+                    <a:p>
+                      <a:r>
+                        <a:rPr sz="1150" b="0" i="0">
+                          <a:solidFill>
+                            <a:srgbClr val="263C50"/>
+                          </a:solidFill>
+                          <a:latin typeface="Bitstream Charter"/>
+                        </a:rPr>
+                        <a:t>Matthews correlation</a:t>
+                      </a:r>
+                    </a:p>
+                  </a:txBody>
+                  <a:tcPr marL="64008" marR="64008" marT="32004" marB="32004" anchor="ctr">
+                    <a:lnB w="9525" cap="flat" cmpd="sng" algn="ctr">
+                      <a:solidFill>
+                        <a:srgbClr val="C9D6E2"/>
+                      </a:solidFill>
+                      <a:prstDash val="solid"/>
+                    </a:lnB>
+                    <a:solidFill>
+                      <a:srgbClr val="EAF0F6"/>
+                    </a:solidFill>
+                  </a:tcPr>
+                </a:tc>
+                <a:tc>
+                  <a:txBody>
+                    <a:bodyPr wrap="square"/>
+                    <a:lstStyle/>
+                    <a:p>
+                      <a:pPr algn="ctr"/>
+                      <a:r>
+                        <a:rPr sz="1150" b="0" i="0">
+                          <a:solidFill>
+                            <a:srgbClr val="263C50"/>
+                          </a:solidFill>
+                          <a:latin typeface="Bitstream Charter"/>
+                        </a:rPr>
+                        <a:t>0.68</a:t>
+                      </a:r>
+                    </a:p>
+                  </a:txBody>
+                  <a:tcPr marL="64008" marR="64008" marT="32004" marB="32004" anchor="ctr">
+                    <a:lnB w="9525" cap="flat" cmpd="sng" algn="ctr">
+                      <a:solidFill>
+                        <a:srgbClr val="C9D6E2"/>
+                      </a:solidFill>
+                      <a:prstDash val="solid"/>
+                    </a:lnB>
+                    <a:solidFill>
+                      <a:srgbClr val="EAF0F6"/>
+                    </a:solidFill>
+                  </a:tcPr>
+                </a:tc>
+                <a:tc>
+                  <a:txBody>
+                    <a:bodyPr wrap="square"/>
+                    <a:lstStyle/>
+                    <a:p>
+                      <a:pPr algn="ctr"/>
+                      <a:r>
+                        <a:rPr sz="1150" b="0" i="0">
+                          <a:solidFill>
+                            <a:srgbClr val="263C50"/>
+                          </a:solidFill>
+                          <a:latin typeface="Bitstream Charter"/>
+                        </a:rPr>
+                        <a:t>0.00</a:t>
+                      </a:r>
+                    </a:p>
+                  </a:txBody>
+                  <a:tcPr marL="64008" marR="64008" marT="32004" marB="32004" anchor="ctr">
+                    <a:lnB w="9525" cap="flat" cmpd="sng" algn="ctr">
+                      <a:solidFill>
+                        <a:srgbClr val="C9D6E2"/>
+                      </a:solidFill>
+                      <a:prstDash val="solid"/>
+                    </a:lnB>
+                    <a:solidFill>
+                      <a:srgbClr val="EAF0F6"/>
+                    </a:solidFill>
+                  </a:tcPr>
+                </a:tc>
+              </a:tr>
+              <a:tr h="329184">
+                <a:tc>
+                  <a:txBody>
+                    <a:bodyPr wrap="square"/>
+                    <a:lstStyle/>
+                    <a:p>
+                      <a:r>
+                        <a:rPr sz="1150" b="0" i="0">
+                          <a:solidFill>
+                            <a:srgbClr val="263C50"/>
+                          </a:solidFill>
+                          <a:latin typeface="Bitstream Charter"/>
+                        </a:rPr>
+                        <a:t>ROC-AUC / PR-AUC</a:t>
+                      </a:r>
+                    </a:p>
+                  </a:txBody>
+                  <a:tcPr marL="64008" marR="64008" marT="32004" marB="32004" anchor="ctr">
+                    <a:lnB w="9525" cap="flat" cmpd="sng" algn="ctr">
+                      <a:solidFill>
+                        <a:srgbClr val="C9D6E2"/>
+                      </a:solidFill>
+                      <a:prstDash val="solid"/>
+                    </a:lnB>
+                    <a:solidFill>
+                      <a:srgbClr val="FFFFFF"/>
+                    </a:solidFill>
+                  </a:tcPr>
+                </a:tc>
+                <a:tc>
+                  <a:txBody>
+                    <a:bodyPr wrap="square"/>
+                    <a:lstStyle/>
+                    <a:p>
+                      <a:pPr algn="ctr"/>
+                      <a:r>
+                        <a:rPr sz="1150" b="0" i="0">
+                          <a:solidFill>
+                            <a:srgbClr val="263C50"/>
+                          </a:solidFill>
+                          <a:latin typeface="Bitstream Charter"/>
+                        </a:rPr>
+                        <a:t>0.955 / 0.785</a:t>
+                      </a:r>
+                    </a:p>
+                  </a:txBody>
+                  <a:tcPr marL="64008" marR="64008" marT="32004" marB="32004" anchor="ctr">
+                    <a:lnB w="9525" cap="flat" cmpd="sng" algn="ctr">
+                      <a:solidFill>
+                        <a:srgbClr val="C9D6E2"/>
+                      </a:solidFill>
+                      <a:prstDash val="solid"/>
+                    </a:lnB>
+                    <a:solidFill>
+                      <a:srgbClr val="FFFFFF"/>
+                    </a:solidFill>
+                  </a:tcPr>
+                </a:tc>
+                <a:tc>
+                  <a:txBody>
+                    <a:bodyPr wrap="square"/>
+                    <a:lstStyle/>
+                    <a:p>
+                      <a:pPr algn="ctr"/>
+                      <a:r>
+                        <a:rPr sz="1150" b="0" i="0">
+                          <a:solidFill>
+                            <a:srgbClr val="263C50"/>
+                          </a:solidFill>
+                          <a:latin typeface="Bitstream Charter"/>
+                        </a:rPr>
+                        <a:t>0.500 / 0.115</a:t>
+                      </a:r>
+                    </a:p>
+                  </a:txBody>
+                  <a:tcPr marL="64008" marR="64008" marT="32004" marB="32004" anchor="ctr">
+                    <a:lnB w="9525" cap="flat" cmpd="sng" algn="ctr">
+                      <a:solidFill>
+                        <a:srgbClr val="C9D6E2"/>
+                      </a:solidFill>
+                      <a:prstDash val="solid"/>
+                    </a:lnB>
+                    <a:solidFill>
+                      <a:srgbClr val="FFFFFF"/>
+                    </a:solidFill>
+                  </a:tcPr>
+                </a:tc>
+              </a:tr>
+            </a:tbl>
+          </a:graphicData>
+        </a:graphic>
+      </p:graphicFrame>
+      <p:sp>
+        <p:nvSpPr>
+          <p:cNvPr id="8" name="TextBox 7"/>
+          <p:cNvSpPr txBox="1"/>
+          <p:nvPr/>
+        </p:nvSpPr>
+        <p:spPr>
+          <a:xfrm>
+            <a:off x="4800600" y="4434840"/>
+            <a:ext cx="6675120" cy="1097280"/>
+          </a:xfrm>
+          <a:prstGeom prst="rect">
+            <a:avLst/>
+          </a:prstGeom>
+          <a:noFill/>
+        </p:spPr>
+        <p:txBody>
+          <a:bodyPr wrap="square" lIns="45720" rIns="45720" tIns="27432" bIns="27432">
+            <a:spAutoFit/>
+          </a:bodyPr>
+          <a:lstStyle/>
+          <a:p>
+            <a:pPr>
+              <a:spcAft>
+                <a:spcPts val="400"/>
+              </a:spcAft>
+            </a:pPr>
+            <a:r>
+              <a:rPr sz="1150" b="1" i="0">
+                <a:solidFill>
+                  <a:srgbClr val="132C43"/>
+                </a:solidFill>
+                <a:latin typeface="Bitstream Charter"/>
+              </a:rPr>
+              <a:t>How to read it  </a:t>
+            </a:r>
+            <a:r>
+              <a:rPr sz="1150" b="0" i="0">
+                <a:solidFill>
+                  <a:srgbClr val="263C50"/>
+                </a:solidFill>
+                <a:latin typeface="Bitstream Charter"/>
+              </a:rPr>
+              <a:t>120,487 English test reviews from games the model never saw. Accuracy of 93.6% sits above the 90% mark, but the baseline already scores 88.5%, so the honest evidence is the rest of the table: it catches 72% of negative reviews at 72% precision.</a:t>
+            </a:r>
+          </a:p>
+        </p:txBody>
+      </p:sp>
+      <p:sp>
+        <p:nvSpPr>
+          <p:cNvPr id="9" name="Rectangle 8"/>
+          <p:cNvSpPr/>
+          <p:nvPr/>
+        </p:nvSpPr>
+        <p:spPr>
+          <a:xfrm>
+            <a:off x="722376" y="5577840"/>
+            <a:ext cx="64008" cy="457200"/>
+          </a:xfrm>
+          <a:prstGeom prst="rect">
+            <a:avLst/>
+          </a:prstGeom>
+          <a:solidFill>
+            <a:srgbClr val="D1495B"/>
+          </a:solidFill>
+          <a:ln>
+            <a:noFill/>
+          </a:ln>
+        </p:spPr>
+        <p:style>
+          <a:lnRef idx="1">
+            <a:schemeClr val="accent1"/>
+          </a:lnRef>
+          <a:fillRef idx="3">
+            <a:schemeClr val="accent1"/>
+          </a:fillRef>
+          <a:effectRef idx="2">
+            <a:schemeClr val="accent1"/>
+          </a:effectRef>
+          <a:fontRef idx="minor">
+            <a:schemeClr val="lt1"/>
+          </a:fontRef>
+        </p:style>
+        <p:txBody>
+          <a:bodyPr rtlCol="0" anchor="ctr"/>
+          <a:lstStyle/>
+          <a:p>
+            <a:pPr algn="ctr"/>
+          </a:p>
+        </p:txBody>
+      </p:sp>
+      <p:sp>
+        <p:nvSpPr>
+          <p:cNvPr id="10" name="Rectangle 9"/>
+          <p:cNvSpPr/>
+          <p:nvPr/>
+        </p:nvSpPr>
+        <p:spPr>
+          <a:xfrm>
+            <a:off x="786384" y="5577840"/>
+            <a:ext cx="10680192" cy="457200"/>
+          </a:xfrm>
+          <a:prstGeom prst="rect">
+            <a:avLst/>
+          </a:prstGeom>
+          <a:solidFill>
+            <a:srgbClr val="EAF0F6"/>
+          </a:solidFill>
+          <a:ln>
+            <a:noFill/>
+          </a:ln>
+        </p:spPr>
+        <p:style>
+          <a:lnRef idx="1">
+            <a:schemeClr val="accent1"/>
+          </a:lnRef>
+          <a:fillRef idx="3">
+            <a:schemeClr val="accent1"/>
+          </a:fillRef>
+          <a:effectRef idx="2">
+            <a:schemeClr val="accent1"/>
+          </a:effectRef>
+          <a:fontRef idx="minor">
+            <a:schemeClr val="lt1"/>
+          </a:fontRef>
+        </p:style>
+        <p:txBody>
+          <a:bodyPr rtlCol="0" anchor="ctr" lIns="137160" wrap="square"/>
+          <a:lstStyle/>
+          <a:p>
+            <a:pPr algn="l">
+              <a:spcAft>
+                <a:spcPts val="0"/>
+              </a:spcAft>
+            </a:pPr>
+            <a:r>
+              <a:rPr sz="1250" b="1" i="0">
+                <a:solidFill>
+                  <a:srgbClr val="D1495B"/>
+                </a:solidFill>
+                <a:latin typeface="Bitstream Charter"/>
+              </a:rPr>
+              <a:t>Takeaway  </a:t>
+            </a:r>
+            <a:r>
+              <a:rPr sz="1250" b="1" i="0">
+                <a:solidFill>
+                  <a:srgbClr val="132C43"/>
+                </a:solidFill>
+                <a:latin typeface="Bitstream Charter"/>
+              </a:rPr>
+              <a:t>Reading a review's own text separates negative from positive reviews very well, but it detects a complaint, it does not forecast one.</a:t>
+            </a:r>
+          </a:p>
+        </p:txBody>
+      </p:sp>
+    </p:spTree>
+  </p:cSld>
+  <p:clrMapOvr>
+    <a:masterClrMapping/>
+  </p:clrMapOvr>
+</p:sld>
+</file>
+
+<file path=ppt/slides/slide16.xml><?xml version="1.0" encoding="utf-8"?>
+<p:sld xmlns:a="http://schemas.openxmlformats.org/drawingml/2006/main" xmlns:p="http://schemas.openxmlformats.org/presentationml/2006/main" xmlns:r="http://schemas.openxmlformats.org/officeDocument/2006/relationships">
+  <p:cSld>
+    <p:bg>
+      <p:bgPr>
+        <a:solidFill>
+          <a:srgbClr val="F7F9FC"/>
+        </a:solidFill>
+        <a:effectLst/>
+      </p:bgPr>
+    </p:bg>
+    <p:spTree>
+      <p:nvGrpSpPr>
+        <p:cNvPr id="1" name=""/>
+        <p:cNvGrpSpPr/>
+        <p:nvPr/>
+      </p:nvGrpSpPr>
+      <p:grpSpPr/>
+      <p:sp>
+        <p:nvSpPr>
+          <p:cNvPr id="5" name="Rectangle 4">
+            <a:extLst>
+              <a:ext uri="{FF2B5EF4-FFF2-40B4-BE49-F238E27FC236}">
+                <a16:creationId xmlns:a16="http://schemas.microsoft.com/office/drawing/2014/main" id="{27979FDE-990F-4C15-B33C-B2975BF50CD9}"/>
+              </a:ext>
+            </a:extLst>
+          </p:cNvPr>
+          <p:cNvSpPr>
+            <a:spLocks noGrp="1"/>
+          </p:cNvSpPr>
+          <p:nvPr/>
+        </p:nvSpPr>
+        <p:spPr>
+          <a:xfrm>
+            <a:off x="685800" y="523875"/>
+            <a:ext cx="10820400" cy="952500"/>
+          </a:xfrm>
+          <a:prstGeom prst="rect">
+            <a:avLst/>
+          </a:prstGeom>
+          <a:noFill/>
+          <a:ln w="0">
+            <a:noFill/>
+          </a:ln>
+        </p:spPr>
+        <p:txBody>
+          <a:bodyPr wrap="square">
+            <a:noAutofit/>
+          </a:bodyPr>
+          <a:lstStyle/>
+          <a:p>
+            <a:pPr>
+              <a:spcAft>
+                <a:spcPts val="400"/>
+              </a:spcAft>
+              <a:defRPr sz="3300" b="1">
+                <a:solidFill>
+                  <a:srgbClr val="132C43"/>
+                </a:solidFill>
+                <a:latin typeface="Bitstream Charter"/>
+                <a:ea typeface="Bitstream Charter"/>
+                <a:cs typeface="Bitstream Charter"/>
+              </a:defRPr>
+            </a:pPr>
+            <a:r>
+              <a:rPr sz="3300" b="1" i="0">
+                <a:solidFill>
+                  <a:srgbClr val="132C43"/>
+                </a:solidFill>
+                <a:latin typeface="Bitstream Charter"/>
+              </a:rPr>
+              <a:t>Evaluation: All Models Compared</a:t>
+            </a:r>
+          </a:p>
+        </p:txBody>
+      </p:sp>
+      <p:sp>
+        <p:nvSpPr>
+          <p:cNvPr id="4" name="Rectangle 3">
+            <a:extLst>
+              <a:ext uri="{FF2B5EF4-FFF2-40B4-BE49-F238E27FC236}">
+                <a16:creationId xmlns:a16="http://schemas.microsoft.com/office/drawing/2014/main" id="{C795E4D0-3C0B-473C-BB65-A65A174FB43B}"/>
+              </a:ext>
+            </a:extLst>
+          </p:cNvPr>
+          <p:cNvSpPr>
+            <a:spLocks noGrp="1"/>
+          </p:cNvSpPr>
+          <p:nvPr/>
+        </p:nvSpPr>
+        <p:spPr>
+          <a:xfrm>
+            <a:off x="11049000" y="6076950"/>
+            <a:ext cx="476250" cy="381000"/>
+          </a:xfrm>
+          <a:prstGeom prst="rect">
+            <a:avLst/>
+          </a:prstGeom>
+          <a:noFill/>
+          <a:ln w="0">
+            <a:noFill/>
+          </a:ln>
+        </p:spPr>
+        <p:txBody>
+          <a:bodyPr>
+            <a:noAutofit/>
+          </a:bodyPr>
+          <a:lstStyle/>
+          <a:p>
+            <a:pPr>
+              <a:defRPr sz="1500" b="0">
+                <a:solidFill>
+                  <a:srgbClr val="48677E"/>
+                </a:solidFill>
+                <a:latin typeface="Bitstream Charter"/>
+                <a:ea typeface="Bitstream Charter"/>
+                <a:cs typeface="Bitstream Charter"/>
+              </a:defRPr>
+            </a:pPr>
+            <a:r>
+              <a:rPr sz="1500" b="0">
+                <a:solidFill>
+                  <a:srgbClr val="48677E"/>
+                </a:solidFill>
+                <a:latin typeface="Bitstream Charter"/>
+                <a:ea typeface="Bitstream Charter"/>
+                <a:cs typeface="Bitstream Charter"/>
+              </a:rPr>
+              <a:t>14</a:t>
+            </a:r>
+          </a:p>
+        </p:txBody>
+      </p:sp>
+      <p:pic>
+        <p:nvPicPr>
+          <p:cNvPr id="6" name="Picture 5" descr="model_comparison.png"/>
+          <p:cNvPicPr>
+            <a:picLocks noChangeAspect="1"/>
+          </p:cNvPicPr>
+          <p:nvPr/>
+        </p:nvPicPr>
+        <p:blipFill>
+          <a:blip r:embed="rId2"/>
+          <a:stretch>
+            <a:fillRect/>
+          </a:stretch>
+        </p:blipFill>
+        <p:spPr>
+          <a:xfrm>
+            <a:off x="603504" y="1463040"/>
+            <a:ext cx="10972800" cy="2987040"/>
+          </a:xfrm>
+          <a:prstGeom prst="rect">
+            <a:avLst/>
+          </a:prstGeom>
+        </p:spPr>
+      </p:pic>
+      <p:sp>
+        <p:nvSpPr>
+          <p:cNvPr id="7" name="TextBox 6"/>
+          <p:cNvSpPr txBox="1"/>
+          <p:nvPr/>
+        </p:nvSpPr>
+        <p:spPr>
+          <a:xfrm>
+            <a:off x="722376" y="4526280"/>
+            <a:ext cx="3520440" cy="1005840"/>
+          </a:xfrm>
+          <a:prstGeom prst="rect">
+            <a:avLst/>
+          </a:prstGeom>
+          <a:noFill/>
+        </p:spPr>
+        <p:txBody>
+          <a:bodyPr wrap="square" lIns="45720" rIns="45720" tIns="27432" bIns="27432">
+            <a:spAutoFit/>
+          </a:bodyPr>
+          <a:lstStyle/>
+          <a:p>
+            <a:pPr>
+              <a:spcAft>
+                <a:spcPts val="400"/>
+              </a:spcAft>
+            </a:pPr>
+            <a:r>
+              <a:rPr sz="1100" b="1" i="0">
+                <a:solidFill>
+                  <a:srgbClr val="132C43"/>
+                </a:solidFill>
+                <a:latin typeface="Bitstream Charter"/>
+              </a:rPr>
+              <a:t>Review level  </a:t>
+            </a:r>
+            <a:r>
+              <a:rPr sz="1100" b="0" i="0">
+                <a:solidFill>
+                  <a:srgbClr val="263C50"/>
+                </a:solidFill>
+                <a:latin typeface="Bitstream Charter"/>
+              </a:rPr>
+              <a:t>The three tree models tie (their gaps are smaller than the fold spread); Logistic Regression is clearly weaker, so negativity is non-linear.</a:t>
+            </a:r>
+          </a:p>
+        </p:txBody>
+      </p:sp>
+      <p:sp>
+        <p:nvSpPr>
+          <p:cNvPr id="8" name="TextBox 7"/>
+          <p:cNvSpPr txBox="1"/>
+          <p:nvPr/>
+        </p:nvSpPr>
+        <p:spPr>
+          <a:xfrm>
+            <a:off x="4343400" y="4526280"/>
+            <a:ext cx="3520440" cy="1005840"/>
+          </a:xfrm>
+          <a:prstGeom prst="rect">
+            <a:avLst/>
+          </a:prstGeom>
+          <a:noFill/>
+        </p:spPr>
+        <p:txBody>
+          <a:bodyPr wrap="square" lIns="45720" rIns="45720" tIns="27432" bIns="27432">
+            <a:spAutoFit/>
+          </a:bodyPr>
+          <a:lstStyle/>
+          <a:p>
+            <a:pPr>
+              <a:spcAft>
+                <a:spcPts val="400"/>
+              </a:spcAft>
+            </a:pPr>
+            <a:r>
+              <a:rPr sz="1100" b="1" i="0">
+                <a:solidFill>
+                  <a:srgbClr val="132C43"/>
+                </a:solidFill>
+                <a:latin typeface="Bitstream Charter"/>
+              </a:rPr>
+              <a:t>Game level  </a:t>
+            </a:r>
+            <a:r>
+              <a:rPr sz="1100" b="0" i="0">
+                <a:solidFill>
+                  <a:srgbClr val="263C50"/>
+                </a:solidFill>
+                <a:latin typeface="Bitstream Charter"/>
+              </a:rPr>
+              <a:t>Simple models match boosting; every interval overlaps, so no model wins with only 299 test games.</a:t>
+            </a:r>
+          </a:p>
+        </p:txBody>
+      </p:sp>
+      <p:sp>
+        <p:nvSpPr>
+          <p:cNvPr id="9" name="TextBox 8"/>
+          <p:cNvSpPr txBox="1"/>
+          <p:nvPr/>
+        </p:nvSpPr>
+        <p:spPr>
+          <a:xfrm>
+            <a:off x="7955279" y="4526280"/>
+            <a:ext cx="3520440" cy="1005840"/>
+          </a:xfrm>
+          <a:prstGeom prst="rect">
+            <a:avLst/>
+          </a:prstGeom>
+          <a:noFill/>
+        </p:spPr>
+        <p:txBody>
+          <a:bodyPr wrap="square" lIns="45720" rIns="45720" tIns="27432" bIns="27432">
+            <a:spAutoFit/>
+          </a:bodyPr>
+          <a:lstStyle/>
+          <a:p>
+            <a:pPr>
+              <a:spcAft>
+                <a:spcPts val="400"/>
+              </a:spcAft>
+            </a:pPr>
+            <a:r>
+              <a:rPr sz="1100" b="1" i="0">
+                <a:solidFill>
+                  <a:srgbClr val="132C43"/>
+                </a:solidFill>
+                <a:latin typeface="Bitstream Charter"/>
+              </a:rPr>
+              <a:t>With text  </a:t>
+            </a:r>
+            <a:r>
+              <a:rPr sz="1100" b="0" i="0">
+                <a:solidFill>
+                  <a:srgbClr val="263C50"/>
+                </a:solidFill>
+                <a:latin typeface="Bitstream Charter"/>
+              </a:rPr>
+              <a:t>PR-AUC climbs from 0.36 (metadata) to 0.58 (78 text components) to 0.78 (full text).</a:t>
+            </a:r>
+          </a:p>
+        </p:txBody>
+      </p:sp>
+      <p:sp>
+        <p:nvSpPr>
+          <p:cNvPr id="10" name="Rectangle 9"/>
+          <p:cNvSpPr/>
+          <p:nvPr/>
+        </p:nvSpPr>
+        <p:spPr>
+          <a:xfrm>
+            <a:off x="722376" y="5577840"/>
+            <a:ext cx="64008" cy="457200"/>
+          </a:xfrm>
+          <a:prstGeom prst="rect">
+            <a:avLst/>
+          </a:prstGeom>
+          <a:solidFill>
+            <a:srgbClr val="D1495B"/>
+          </a:solidFill>
+          <a:ln>
+            <a:noFill/>
+          </a:ln>
+        </p:spPr>
+        <p:style>
+          <a:lnRef idx="1">
+            <a:schemeClr val="accent1"/>
+          </a:lnRef>
+          <a:fillRef idx="3">
+            <a:schemeClr val="accent1"/>
+          </a:fillRef>
+          <a:effectRef idx="2">
+            <a:schemeClr val="accent1"/>
+          </a:effectRef>
+          <a:fontRef idx="minor">
+            <a:schemeClr val="lt1"/>
+          </a:fontRef>
+        </p:style>
+        <p:txBody>
+          <a:bodyPr rtlCol="0" anchor="ctr"/>
+          <a:lstStyle/>
+          <a:p>
+            <a:pPr algn="ctr"/>
+          </a:p>
+        </p:txBody>
+      </p:sp>
+      <p:sp>
+        <p:nvSpPr>
+          <p:cNvPr id="11" name="Rectangle 10"/>
+          <p:cNvSpPr/>
+          <p:nvPr/>
+        </p:nvSpPr>
+        <p:spPr>
+          <a:xfrm>
+            <a:off x="786384" y="5577840"/>
+            <a:ext cx="10680192" cy="457200"/>
+          </a:xfrm>
+          <a:prstGeom prst="rect">
+            <a:avLst/>
+          </a:prstGeom>
+          <a:solidFill>
+            <a:srgbClr val="EAF0F6"/>
+          </a:solidFill>
+          <a:ln>
+            <a:noFill/>
+          </a:ln>
+        </p:spPr>
+        <p:style>
+          <a:lnRef idx="1">
+            <a:schemeClr val="accent1"/>
+          </a:lnRef>
+          <a:fillRef idx="3">
+            <a:schemeClr val="accent1"/>
+          </a:fillRef>
+          <a:effectRef idx="2">
+            <a:schemeClr val="accent1"/>
+          </a:effectRef>
+          <a:fontRef idx="minor">
+            <a:schemeClr val="lt1"/>
+          </a:fontRef>
+        </p:style>
+        <p:txBody>
+          <a:bodyPr rtlCol="0" anchor="ctr" lIns="137160" wrap="square"/>
+          <a:lstStyle/>
+          <a:p>
+            <a:pPr algn="l">
+              <a:spcAft>
+                <a:spcPts val="0"/>
+              </a:spcAft>
+            </a:pPr>
+            <a:r>
+              <a:rPr sz="1250" b="1" i="0">
+                <a:solidFill>
+                  <a:srgbClr val="D1495B"/>
+                </a:solidFill>
+                <a:latin typeface="Bitstream Charter"/>
+              </a:rPr>
+              <a:t>Takeaway  </a:t>
+            </a:r>
+            <a:r>
+              <a:rPr sz="1250" b="1" i="0">
+                <a:solidFill>
+                  <a:srgbClr val="132C43"/>
+                </a:solidFill>
+                <a:latin typeface="Bitstream Charter"/>
+              </a:rPr>
+              <a:t>Every model beats its baseline; the biggest gain by far comes from the information given, not the algorithm.</a:t>
+            </a:r>
+          </a:p>
+        </p:txBody>
+      </p:sp>
+    </p:spTree>
+  </p:cSld>
+  <p:clrMapOvr>
+    <a:masterClrMapping/>
+  </p:clrMapOvr>
+</p:sld>
+</file>
+
+<file path=ppt/slides/slide17.xml><?xml version="1.0" encoding="utf-8"?>
+<p:sld xmlns:a="http://schemas.openxmlformats.org/drawingml/2006/main" xmlns:p="http://schemas.openxmlformats.org/presentationml/2006/main" xmlns:r="http://schemas.openxmlformats.org/officeDocument/2006/relationships">
+  <p:cSld>
+    <p:bg>
+      <p:bgPr>
+        <a:solidFill>
+          <a:srgbClr val="F7F9FC"/>
+        </a:solidFill>
+        <a:effectLst/>
+      </p:bgPr>
+    </p:bg>
+    <p:spTree>
+      <p:nvGrpSpPr>
+        <p:cNvPr id="1" name=""/>
+        <p:cNvGrpSpPr/>
+        <p:nvPr/>
+      </p:nvGrpSpPr>
+      <p:grpSpPr/>
+      <p:sp>
+        <p:nvSpPr>
+          <p:cNvPr id="5" name="Rectangle 4">
+            <a:extLst>
+              <a:ext uri="{FF2B5EF4-FFF2-40B4-BE49-F238E27FC236}">
+                <a16:creationId xmlns:a16="http://schemas.microsoft.com/office/drawing/2014/main" id="{27979FDE-990F-4C15-B33C-B2975BF50CD9}"/>
+              </a:ext>
+            </a:extLst>
+          </p:cNvPr>
+          <p:cNvSpPr>
+            <a:spLocks noGrp="1"/>
+          </p:cNvSpPr>
+          <p:nvPr/>
+        </p:nvSpPr>
+        <p:spPr>
+          <a:xfrm>
+            <a:off x="685800" y="523875"/>
+            <a:ext cx="10820400" cy="952500"/>
+          </a:xfrm>
+          <a:prstGeom prst="rect">
+            <a:avLst/>
+          </a:prstGeom>
+          <a:noFill/>
+          <a:ln w="0">
+            <a:noFill/>
+          </a:ln>
+        </p:spPr>
+        <p:txBody>
+          <a:bodyPr wrap="square">
+            <a:noAutofit/>
+          </a:bodyPr>
+          <a:lstStyle/>
+          <a:p>
+            <a:pPr>
+              <a:spcAft>
+                <a:spcPts val="400"/>
+              </a:spcAft>
+              <a:defRPr sz="3300" b="1">
+                <a:solidFill>
+                  <a:srgbClr val="132C43"/>
+                </a:solidFill>
+                <a:latin typeface="Bitstream Charter"/>
+                <a:ea typeface="Bitstream Charter"/>
+                <a:cs typeface="Bitstream Charter"/>
+              </a:defRPr>
+            </a:pPr>
+            <a:r>
+              <a:rPr sz="3300" b="1" i="0">
+                <a:solidFill>
+                  <a:srgbClr val="132C43"/>
+                </a:solidFill>
+                <a:latin typeface="Bitstream Charter"/>
+              </a:rPr>
+              <a:t>Evaluation: What Drives the Predictions</a:t>
+            </a:r>
+          </a:p>
+        </p:txBody>
+      </p:sp>
+      <p:sp>
+        <p:nvSpPr>
+          <p:cNvPr id="4" name="Rectangle 3">
+            <a:extLst>
+              <a:ext uri="{FF2B5EF4-FFF2-40B4-BE49-F238E27FC236}">
+                <a16:creationId xmlns:a16="http://schemas.microsoft.com/office/drawing/2014/main" id="{C795E4D0-3C0B-473C-BB65-A65A174FB43B}"/>
+              </a:ext>
+            </a:extLst>
+          </p:cNvPr>
+          <p:cNvSpPr>
+            <a:spLocks noGrp="1"/>
+          </p:cNvSpPr>
+          <p:nvPr/>
+        </p:nvSpPr>
+        <p:spPr>
+          <a:xfrm>
+            <a:off x="11049000" y="6076950"/>
+            <a:ext cx="476250" cy="381000"/>
+          </a:xfrm>
+          <a:prstGeom prst="rect">
+            <a:avLst/>
+          </a:prstGeom>
+          <a:noFill/>
+          <a:ln w="0">
+            <a:noFill/>
+          </a:ln>
+        </p:spPr>
+        <p:txBody>
+          <a:bodyPr>
+            <a:noAutofit/>
+          </a:bodyPr>
+          <a:lstStyle/>
+          <a:p>
+            <a:pPr>
+              <a:defRPr sz="1500" b="0">
+                <a:solidFill>
+                  <a:srgbClr val="48677E"/>
+                </a:solidFill>
+                <a:latin typeface="Bitstream Charter"/>
+                <a:ea typeface="Bitstream Charter"/>
+                <a:cs typeface="Bitstream Charter"/>
+              </a:defRPr>
+            </a:pPr>
+            <a:r>
+              <a:rPr sz="1500" b="0">
+                <a:solidFill>
+                  <a:srgbClr val="48677E"/>
+                </a:solidFill>
+                <a:latin typeface="Bitstream Charter"/>
+                <a:ea typeface="Bitstream Charter"/>
+                <a:cs typeface="Bitstream Charter"/>
+              </a:rPr>
+              <a:t>15</a:t>
+            </a:r>
+          </a:p>
+        </p:txBody>
+      </p:sp>
+      <p:pic>
+        <p:nvPicPr>
+          <p:cNvPr id="6" name="Picture 5" descr="review_xgb_shap_bar.png"/>
+          <p:cNvPicPr>
+            <a:picLocks noChangeAspect="1"/>
+          </p:cNvPicPr>
+          <p:nvPr/>
+        </p:nvPicPr>
+        <p:blipFill>
+          <a:blip r:embed="rId2"/>
+          <a:stretch>
+            <a:fillRect/>
+          </a:stretch>
+        </p:blipFill>
+        <p:spPr>
+          <a:xfrm>
+            <a:off x="640080" y="1508760"/>
+            <a:ext cx="4400550" cy="3520440"/>
+          </a:xfrm>
+          <a:prstGeom prst="rect">
+            <a:avLst/>
+          </a:prstGeom>
+        </p:spPr>
+      </p:pic>
+      <p:pic>
+        <p:nvPicPr>
+          <p:cNvPr id="7" name="Picture 6" descr="game_xgb_shap_bar.png"/>
+          <p:cNvPicPr>
+            <a:picLocks noChangeAspect="1"/>
+          </p:cNvPicPr>
+          <p:nvPr/>
+        </p:nvPicPr>
+        <p:blipFill>
+          <a:blip r:embed="rId3"/>
+          <a:stretch>
+            <a:fillRect/>
+          </a:stretch>
+        </p:blipFill>
+        <p:spPr>
+          <a:xfrm>
+            <a:off x="6309360" y="1508760"/>
+            <a:ext cx="4400550" cy="3520440"/>
+          </a:xfrm>
+          <a:prstGeom prst="rect">
+            <a:avLst/>
+          </a:prstGeom>
+        </p:spPr>
+      </p:pic>
+      <p:sp>
+        <p:nvSpPr>
+          <p:cNvPr id="8" name="TextBox 7"/>
+          <p:cNvSpPr txBox="1"/>
+          <p:nvPr/>
+        </p:nvSpPr>
+        <p:spPr>
+          <a:xfrm>
+            <a:off x="722376" y="5029200"/>
+            <a:ext cx="5394960" cy="548640"/>
+          </a:xfrm>
+          <a:prstGeom prst="rect">
+            <a:avLst/>
+          </a:prstGeom>
+          <a:noFill/>
+        </p:spPr>
+        <p:txBody>
+          <a:bodyPr wrap="square" lIns="45720" rIns="45720" tIns="27432" bIns="27432">
+            <a:spAutoFit/>
+          </a:bodyPr>
+          <a:lstStyle/>
+          <a:p>
+            <a:pPr>
+              <a:spcAft>
+                <a:spcPts val="400"/>
+              </a:spcAft>
+            </a:pPr>
+            <a:r>
+              <a:rPr sz="1050" b="1" i="0">
+                <a:solidFill>
+                  <a:srgbClr val="132C43"/>
+                </a:solidFill>
+                <a:latin typeface="Bitstream Charter"/>
+              </a:rPr>
+              <a:t>Review level  </a:t>
+            </a:r>
+            <a:r>
+              <a:rPr sz="1050" b="0" i="0">
+                <a:solidFill>
+                  <a:srgbClr val="263C50"/>
+                </a:solidFill>
+                <a:latin typeface="Bitstream Charter"/>
+              </a:rPr>
+              <a:t>review length, Chinese-language reviews and playtime lead; price, patch timing and the refund-window flag follow.</a:t>
+            </a:r>
+          </a:p>
+        </p:txBody>
+      </p:sp>
+      <p:sp>
+        <p:nvSpPr>
+          <p:cNvPr id="9" name="TextBox 8"/>
+          <p:cNvSpPr txBox="1"/>
+          <p:nvPr/>
+        </p:nvSpPr>
+        <p:spPr>
+          <a:xfrm>
+            <a:off x="6355080" y="5029200"/>
+            <a:ext cx="5212080" cy="548640"/>
+          </a:xfrm>
+          <a:prstGeom prst="rect">
+            <a:avLst/>
+          </a:prstGeom>
+          <a:noFill/>
+        </p:spPr>
+        <p:txBody>
+          <a:bodyPr wrap="square" lIns="45720" rIns="45720" tIns="27432" bIns="27432">
+            <a:spAutoFit/>
+          </a:bodyPr>
+          <a:lstStyle/>
+          <a:p>
+            <a:pPr>
+              <a:spcAft>
+                <a:spcPts val="400"/>
+              </a:spcAft>
+            </a:pPr>
+            <a:r>
+              <a:rPr sz="1050" b="1" i="0">
+                <a:solidFill>
+                  <a:srgbClr val="132C43"/>
+                </a:solidFill>
+                <a:latin typeface="Bitstream Charter"/>
+              </a:rPr>
+              <a:t>Game level  </a:t>
+            </a:r>
+            <a:r>
+              <a:rPr sz="1050" b="0" i="0">
+                <a:solidFill>
+                  <a:srgbClr val="263C50"/>
+                </a:solidFill>
+                <a:latin typeface="Bitstream Charter"/>
+              </a:rPr>
+              <a:t>a few tag components and the achievement count lead, then launch year and price; each effect is small.</a:t>
+            </a:r>
+          </a:p>
+        </p:txBody>
+      </p:sp>
+      <p:sp>
+        <p:nvSpPr>
+          <p:cNvPr id="10" name="Rectangle 9"/>
+          <p:cNvSpPr/>
+          <p:nvPr/>
+        </p:nvSpPr>
+        <p:spPr>
+          <a:xfrm>
+            <a:off x="722376" y="5669280"/>
+            <a:ext cx="64008" cy="457200"/>
+          </a:xfrm>
+          <a:prstGeom prst="rect">
+            <a:avLst/>
+          </a:prstGeom>
+          <a:solidFill>
+            <a:srgbClr val="D1495B"/>
+          </a:solidFill>
+          <a:ln>
+            <a:noFill/>
+          </a:ln>
+        </p:spPr>
+        <p:style>
+          <a:lnRef idx="1">
+            <a:schemeClr val="accent1"/>
+          </a:lnRef>
+          <a:fillRef idx="3">
+            <a:schemeClr val="accent1"/>
+          </a:fillRef>
+          <a:effectRef idx="2">
+            <a:schemeClr val="accent1"/>
+          </a:effectRef>
+          <a:fontRef idx="minor">
+            <a:schemeClr val="lt1"/>
+          </a:fontRef>
+        </p:style>
+        <p:txBody>
+          <a:bodyPr rtlCol="0" anchor="ctr"/>
+          <a:lstStyle/>
+          <a:p>
+            <a:pPr algn="ctr"/>
+          </a:p>
+        </p:txBody>
+      </p:sp>
+      <p:sp>
+        <p:nvSpPr>
+          <p:cNvPr id="11" name="Rectangle 10"/>
+          <p:cNvSpPr/>
+          <p:nvPr/>
+        </p:nvSpPr>
+        <p:spPr>
+          <a:xfrm>
+            <a:off x="786384" y="5669280"/>
+            <a:ext cx="10680192" cy="457200"/>
+          </a:xfrm>
+          <a:prstGeom prst="rect">
+            <a:avLst/>
+          </a:prstGeom>
+          <a:solidFill>
+            <a:srgbClr val="EAF0F6"/>
+          </a:solidFill>
+          <a:ln>
+            <a:noFill/>
+          </a:ln>
+        </p:spPr>
+        <p:style>
+          <a:lnRef idx="1">
+            <a:schemeClr val="accent1"/>
+          </a:lnRef>
+          <a:fillRef idx="3">
+            <a:schemeClr val="accent1"/>
+          </a:fillRef>
+          <a:effectRef idx="2">
+            <a:schemeClr val="accent1"/>
+          </a:effectRef>
+          <a:fontRef idx="minor">
+            <a:schemeClr val="lt1"/>
+          </a:fontRef>
+        </p:style>
+        <p:txBody>
+          <a:bodyPr rtlCol="0" anchor="ctr" lIns="137160" wrap="square"/>
+          <a:lstStyle/>
+          <a:p>
+            <a:pPr algn="l">
+              <a:spcAft>
+                <a:spcPts val="0"/>
+              </a:spcAft>
+            </a:pPr>
+            <a:r>
+              <a:rPr sz="1250" b="1" i="0">
+                <a:solidFill>
+                  <a:srgbClr val="D1495B"/>
+                </a:solidFill>
+                <a:latin typeface="Bitstream Charter"/>
+              </a:rPr>
+              <a:t>Takeaway  </a:t>
+            </a:r>
+            <a:r>
+              <a:rPr sz="1250" b="1" i="0">
+                <a:solidFill>
+                  <a:srgbClr val="132C43"/>
+                </a:solidFill>
+                <a:latin typeface="Bitstream Charter"/>
+              </a:rPr>
+              <a:t>Importance shows what the model uses, not what causes a bad review; every effect here is an association.</a:t>
             </a:r>
           </a:p>
         </p:txBody>
@@ -14235,6 +16307,22 @@
                 </a:solidFill>
                 <a:latin typeface="Bitstream Charter"/>
               </a:rPr>
+              <a:t>text model accuracy: 93.6% (always-positive 88.5%)</a:t>
+            </a:r>
+          </a:p>
+          <a:p>
+            <a:pPr>
+              <a:spcAft>
+                <a:spcPts val="300"/>
+              </a:spcAft>
+            </a:pPr>
+            <a:r>
+              <a:rPr sz="1100" b="0" i="0">
+                <a:solidFill>
+                  <a:srgbClr val="263C50"/>
+                </a:solidFill>
+                <a:latin typeface="Bitstream Charter"/>
+              </a:rPr>
               <a:t>XGBoost (metadata): 0.24 / 0.52 / 0.33</a:t>
             </a:r>
           </a:p>
@@ -14539,7 +16627,7 @@
                 <a:ea typeface="Bitstream Charter"/>
                 <a:cs typeface="Bitstream Charter"/>
               </a:rPr>
-              <a:t>13</a:t>
+              <a:t>16</a:t>
             </a:r>
           </a:p>
         </p:txBody>
@@ -16260,7 +18348,7 @@
                 </a:solidFill>
                 <a:latin typeface="Bitstream Charter"/>
               </a:rPr>
-              <a:t>33 commits and 11 merged pull requests so far.</a:t>
+              <a:t>34 commits and 12 merged pull requests so far.</a:t>
             </a:r>
           </a:p>
           <a:p>

</xml_diff>

<commit_message>
Slides: name the SHAP drivers in plain words instead of pc_02 etc.
</commit_message>
<xml_diff>
--- a/slides/review1.pptx
+++ b/slides/review1.pptx
@@ -2661,6 +2661,448 @@
     <a:p>
       <a:pPr>
         <a:defRPr sz="900">
+          <a:solidFill>
+            <a:srgbClr val="263C50"/>
+          </a:solidFill>
+          <a:latin typeface="Bitstream Charter"/>
+        </a:defRPr>
+      </a:pPr>
+      <a:endParaRPr lang="en-US"/>
+    </a:p>
+  </c:txPr>
+  <c:externalData r:id="rId1">
+    <c:autoUpdate val="0"/>
+  </c:externalData>
+</c:chartSpace>
+</file>
+
+<file path=ppt/charts/chart6.xml><?xml version="1.0" encoding="utf-8"?>
+<c:chartSpace xmlns:c="http://schemas.openxmlformats.org/drawingml/2006/chart" xmlns:a="http://schemas.openxmlformats.org/drawingml/2006/main" xmlns:r="http://schemas.openxmlformats.org/officeDocument/2006/relationships">
+  <c:date1904 val="0"/>
+  <c:chart>
+    <c:title>
+      <c:tx>
+        <c:rich>
+          <a:bodyPr/>
+          <a:lstStyle/>
+          <a:p>
+            <a:r>
+              <a:rPr sz="1100" b="1" i="0">
+                <a:solidFill>
+                  <a:srgbClr val="132C43"/>
+                </a:solidFill>
+                <a:latin typeface="Bitstream Charter"/>
+              </a:rPr>
+              <a:t>Review level: what the model leans on</a:t>
+            </a:r>
+          </a:p>
+        </c:rich>
+      </c:tx>
+      <c:layout/>
+      <c:overlay val="0"/>
+    </c:title>
+    <c:autoTitleDeleted val="0"/>
+    <c:plotArea>
+      <c:barChart>
+        <c:barDir val="bar"/>
+        <c:grouping val="clustered"/>
+        <c:ser>
+          <c:idx val="0"/>
+          <c:order val="0"/>
+          <c:tx>
+            <c:strRef>
+              <c:f>Sheet1!$B$1</c:f>
+              <c:strCache>
+                <c:ptCount val="1"/>
+                <c:pt idx="0">
+                  <c:v>mean |SHAP|</c:v>
+                </c:pt>
+              </c:strCache>
+            </c:strRef>
+          </c:tx>
+          <c:spPr>
+            <a:solidFill>
+              <a:srgbClr val="5B8DB8"/>
+            </a:solidFill>
+          </c:spPr>
+          <c:cat>
+            <c:strRef>
+              <c:f>Sheet1!$A$2:$A$11</c:f>
+              <c:strCache>
+                <c:ptCount val="10"/>
+                <c:pt idx="0">
+                  <c:v>Days since last sale</c:v>
+                </c:pt>
+                <c:pt idx="1">
+                  <c:v>Days since last patch</c:v>
+                </c:pt>
+                <c:pt idx="2">
+                  <c:v>Days since launch</c:v>
+                </c:pt>
+                <c:pt idx="3">
+                  <c:v>Patches before the review</c:v>
+                </c:pt>
+                <c:pt idx="4">
+                  <c:v>Price</c:v>
+                </c:pt>
+                <c:pt idx="5">
+                  <c:v>Written in English</c:v>
+                </c:pt>
+                <c:pt idx="6">
+                  <c:v>Reviewer's past reviews</c:v>
+                </c:pt>
+                <c:pt idx="7">
+                  <c:v>Playtime at review</c:v>
+                </c:pt>
+                <c:pt idx="8">
+                  <c:v>Written in Simplified Chinese</c:v>
+                </c:pt>
+                <c:pt idx="9">
+                  <c:v>Review length (characters)</c:v>
+                </c:pt>
+              </c:strCache>
+            </c:strRef>
+          </c:cat>
+          <c:val>
+            <c:numRef>
+              <c:f>Sheet1!$B$2:$B$11</c:f>
+              <c:numCache>
+                <c:formatCode>General</c:formatCode>
+                <c:ptCount val="10"/>
+                <c:pt idx="0">
+                  <c:v>0.082770176</c:v>
+                </c:pt>
+                <c:pt idx="1">
+                  <c:v>0.08411249</c:v>
+                </c:pt>
+                <c:pt idx="2">
+                  <c:v>0.089827135</c:v>
+                </c:pt>
+                <c:pt idx="3">
+                  <c:v>0.11695448</c:v>
+                </c:pt>
+                <c:pt idx="4">
+                  <c:v>0.11866567</c:v>
+                </c:pt>
+                <c:pt idx="5">
+                  <c:v>0.12286878</c:v>
+                </c:pt>
+                <c:pt idx="6">
+                  <c:v>0.12592441</c:v>
+                </c:pt>
+                <c:pt idx="7">
+                  <c:v>0.2615643</c:v>
+                </c:pt>
+                <c:pt idx="8">
+                  <c:v>0.3669189</c:v>
+                </c:pt>
+                <c:pt idx="9">
+                  <c:v>0.46493286</c:v>
+                </c:pt>
+              </c:numCache>
+            </c:numRef>
+          </c:val>
+        </c:ser>
+        <c:dLbls>
+          <c:numFmt formatCode="0.00" sourceLinked="0"/>
+          <c:txPr>
+            <a:bodyPr/>
+            <a:lstStyle/>
+            <a:p>
+              <a:pPr>
+                <a:defRPr sz="1000"/>
+              </a:pPr>
+            </a:p>
+          </c:txPr>
+          <c:dLblPos val="outEnd"/>
+          <c:showLegendKey val="0"/>
+          <c:showVal val="1"/>
+          <c:showCatName val="0"/>
+          <c:showSerName val="0"/>
+          <c:showPercent val="0"/>
+          <c:showBubbleSize val="0"/>
+          <c:showLeaderLines val="1"/>
+        </c:dLbls>
+        <c:gapWidth val="45"/>
+        <c:axId val="-2068027336"/>
+        <c:axId val="-2113994440"/>
+      </c:barChart>
+      <c:catAx>
+        <c:axId val="-2068027336"/>
+        <c:scaling>
+          <c:orientation val="minMax"/>
+        </c:scaling>
+        <c:delete val="0"/>
+        <c:axPos val="l"/>
+        <c:majorTickMark val="out"/>
+        <c:minorTickMark val="none"/>
+        <c:tickLblPos val="nextTo"/>
+        <c:spPr>
+          <a:ln>
+            <a:solidFill>
+              <a:srgbClr val="C9D6E2"/>
+            </a:solidFill>
+          </a:ln>
+        </c:spPr>
+        <c:txPr>
+          <a:bodyPr/>
+          <a:lstStyle/>
+          <a:p>
+            <a:pPr>
+              <a:defRPr sz="1000"/>
+            </a:pPr>
+          </a:p>
+        </c:txPr>
+        <c:crossAx val="-2113994440"/>
+        <c:crosses val="autoZero"/>
+        <c:auto val="1"/>
+        <c:lblAlgn val="ctr"/>
+        <c:lblOffset val="100"/>
+        <c:noMultiLvlLbl val="0"/>
+      </c:catAx>
+      <c:valAx>
+        <c:axId val="-2113994440"/>
+        <c:scaling>
+          <c:min val="0.0"/>
+        </c:scaling>
+        <c:delete/>
+        <c:axPos val="b"/>
+        <c:majorTickMark val="out"/>
+        <c:minorTickMark val="none"/>
+        <c:tickLblPos val="nextTo"/>
+        <c:crossAx val="-2068027336"/>
+        <c:crosses val="autoZero"/>
+      </c:valAx>
+    </c:plotArea>
+    <c:dispBlanksAs val="gap"/>
+  </c:chart>
+  <c:txPr>
+    <a:bodyPr/>
+    <a:lstStyle/>
+    <a:p>
+      <a:pPr>
+        <a:defRPr sz="1000">
+          <a:solidFill>
+            <a:srgbClr val="263C50"/>
+          </a:solidFill>
+          <a:latin typeface="Bitstream Charter"/>
+        </a:defRPr>
+      </a:pPr>
+      <a:endParaRPr lang="en-US"/>
+    </a:p>
+  </c:txPr>
+  <c:externalData r:id="rId1">
+    <c:autoUpdate val="0"/>
+  </c:externalData>
+</c:chartSpace>
+</file>
+
+<file path=ppt/charts/chart7.xml><?xml version="1.0" encoding="utf-8"?>
+<c:chartSpace xmlns:c="http://schemas.openxmlformats.org/drawingml/2006/chart" xmlns:a="http://schemas.openxmlformats.org/drawingml/2006/main" xmlns:r="http://schemas.openxmlformats.org/officeDocument/2006/relationships">
+  <c:date1904 val="0"/>
+  <c:chart>
+    <c:title>
+      <c:tx>
+        <c:rich>
+          <a:bodyPr/>
+          <a:lstStyle/>
+          <a:p>
+            <a:r>
+              <a:rPr sz="1100" b="1" i="0">
+                <a:solidFill>
+                  <a:srgbClr val="132C43"/>
+                </a:solidFill>
+                <a:latin typeface="Bitstream Charter"/>
+              </a:rPr>
+              <a:t>Game level: what the model leans on (tag axes named by their top tags)</a:t>
+            </a:r>
+          </a:p>
+        </c:rich>
+      </c:tx>
+      <c:layout/>
+      <c:overlay val="0"/>
+    </c:title>
+    <c:autoTitleDeleted val="0"/>
+    <c:plotArea>
+      <c:barChart>
+        <c:barDir val="bar"/>
+        <c:grouping val="clustered"/>
+        <c:ser>
+          <c:idx val="0"/>
+          <c:order val="0"/>
+          <c:tx>
+            <c:strRef>
+              <c:f>Sheet1!$B$1</c:f>
+              <c:strCache>
+                <c:ptCount val="1"/>
+                <c:pt idx="0">
+                  <c:v>mean |SHAP|</c:v>
+                </c:pt>
+              </c:strCache>
+            </c:strRef>
+          </c:tx>
+          <c:spPr>
+            <a:solidFill>
+              <a:srgbClr val="3E9C6E"/>
+            </a:solidFill>
+          </c:spPr>
+          <c:cat>
+            <c:strRef>
+              <c:f>Sheet1!$A$2:$A$11</c:f>
+              <c:strCache>
+                <c:ptCount val="10"/>
+                <c:pt idx="0">
+                  <c:v>Loot, relaxing vs story-rich, funny</c:v>
+                </c:pt>
+                <c:pt idx="1">
+                  <c:v>Launch year</c:v>
+                </c:pt>
+                <c:pt idx="2">
+                  <c:v>Post-apocalyptic, zombies, story</c:v>
+                </c:pt>
+                <c:pt idx="3">
+                  <c:v>Cartoon deckbuilder vs top-down shooter</c:v>
+                </c:pt>
+                <c:pt idx="4">
+                  <c:v>Casual, arcade vs strategy, hack and slash</c:v>
+                </c:pt>
+                <c:pt idx="5">
+                  <c:v>RPG, fantasy vs casual, shooter</c:v>
+                </c:pt>
+                <c:pt idx="6">
+                  <c:v>Number of achievements</c:v>
+                </c:pt>
+                <c:pt idx="7">
+                  <c:v>2D pixel casual vs 3D adventure</c:v>
+                </c:pt>
+                <c:pt idx="8">
+                  <c:v>Roguelite, bullet hell vs adventure, pixel</c:v>
+                </c:pt>
+                <c:pt idx="9">
+                  <c:v>Store polish (Steam features) vs 3D / free</c:v>
+                </c:pt>
+              </c:strCache>
+            </c:strRef>
+          </c:cat>
+          <c:val>
+            <c:numRef>
+              <c:f>Sheet1!$B$2:$B$11</c:f>
+              <c:numCache>
+                <c:formatCode>General</c:formatCode>
+                <c:ptCount val="10"/>
+                <c:pt idx="0">
+                  <c:v>0.035455626</c:v>
+                </c:pt>
+                <c:pt idx="1">
+                  <c:v>0.035470154</c:v>
+                </c:pt>
+                <c:pt idx="2">
+                  <c:v>0.037882466</c:v>
+                </c:pt>
+                <c:pt idx="3">
+                  <c:v>0.039064217</c:v>
+                </c:pt>
+                <c:pt idx="4">
+                  <c:v>0.053518448</c:v>
+                </c:pt>
+                <c:pt idx="5">
+                  <c:v>0.05539743</c:v>
+                </c:pt>
+                <c:pt idx="6">
+                  <c:v>0.07229154</c:v>
+                </c:pt>
+                <c:pt idx="7">
+                  <c:v>0.09507317</c:v>
+                </c:pt>
+                <c:pt idx="8">
+                  <c:v>0.10334966</c:v>
+                </c:pt>
+                <c:pt idx="9">
+                  <c:v>0.11489248</c:v>
+                </c:pt>
+              </c:numCache>
+            </c:numRef>
+          </c:val>
+        </c:ser>
+        <c:dLbls>
+          <c:numFmt formatCode="0.00" sourceLinked="0"/>
+          <c:txPr>
+            <a:bodyPr/>
+            <a:lstStyle/>
+            <a:p>
+              <a:pPr>
+                <a:defRPr sz="1000"/>
+              </a:pPr>
+            </a:p>
+          </c:txPr>
+          <c:dLblPos val="outEnd"/>
+          <c:showLegendKey val="0"/>
+          <c:showVal val="1"/>
+          <c:showCatName val="0"/>
+          <c:showSerName val="0"/>
+          <c:showPercent val="0"/>
+          <c:showBubbleSize val="0"/>
+          <c:showLeaderLines val="1"/>
+        </c:dLbls>
+        <c:gapWidth val="45"/>
+        <c:axId val="-2068027336"/>
+        <c:axId val="-2113994440"/>
+      </c:barChart>
+      <c:catAx>
+        <c:axId val="-2068027336"/>
+        <c:scaling>
+          <c:orientation val="minMax"/>
+        </c:scaling>
+        <c:delete val="0"/>
+        <c:axPos val="l"/>
+        <c:majorTickMark val="out"/>
+        <c:minorTickMark val="none"/>
+        <c:tickLblPos val="nextTo"/>
+        <c:spPr>
+          <a:ln>
+            <a:solidFill>
+              <a:srgbClr val="C9D6E2"/>
+            </a:solidFill>
+          </a:ln>
+        </c:spPr>
+        <c:txPr>
+          <a:bodyPr/>
+          <a:lstStyle/>
+          <a:p>
+            <a:pPr>
+              <a:defRPr sz="1000"/>
+            </a:pPr>
+          </a:p>
+        </c:txPr>
+        <c:crossAx val="-2113994440"/>
+        <c:crosses val="autoZero"/>
+        <c:auto val="1"/>
+        <c:lblAlgn val="ctr"/>
+        <c:lblOffset val="100"/>
+        <c:noMultiLvlLbl val="0"/>
+      </c:catAx>
+      <c:valAx>
+        <c:axId val="-2113994440"/>
+        <c:scaling>
+          <c:min val="0.0"/>
+        </c:scaling>
+        <c:delete/>
+        <c:axPos val="b"/>
+        <c:majorTickMark val="out"/>
+        <c:minorTickMark val="none"/>
+        <c:tickLblPos val="nextTo"/>
+        <c:crossAx val="-2068027336"/>
+        <c:crosses val="autoZero"/>
+      </c:valAx>
+    </c:plotArea>
+    <c:dispBlanksAs val="gap"/>
+  </c:chart>
+  <c:txPr>
+    <a:bodyPr/>
+    <a:lstStyle/>
+    <a:p>
+      <a:pPr>
+        <a:defRPr sz="1000">
           <a:solidFill>
             <a:srgbClr val="263C50"/>
           </a:solidFill>
@@ -9010,54 +9452,42 @@
           </a:p>
         </p:txBody>
       </p:sp>
-      <p:pic>
-        <p:nvPicPr>
-          <p:cNvPr id="6" name="Picture 5" descr="review_xgb_shap_bar.png"/>
-          <p:cNvPicPr>
-            <a:picLocks noChangeAspect="1"/>
-          </p:cNvPicPr>
+      <p:graphicFrame>
+        <p:nvGraphicFramePr>
+          <p:cNvPr id="6" name="Chart 5"/>
+          <p:cNvGraphicFramePr>
+            <a:graphicFrameLocks noGrp="1"/>
+          </p:cNvGraphicFramePr>
           <p:nvPr/>
-        </p:nvPicPr>
-        <p:blipFill>
-          <a:blip r:embed="rId2"/>
-          <a:stretch>
-            <a:fillRect/>
-          </a:stretch>
-        </p:blipFill>
-        <p:spPr>
-          <a:xfrm>
-            <a:off x="640080" y="1508760"/>
-            <a:ext cx="4400550" cy="3520440"/>
-          </a:xfrm>
-          <a:prstGeom prst="rect">
-            <a:avLst/>
-          </a:prstGeom>
-        </p:spPr>
-      </p:pic>
-      <p:pic>
-        <p:nvPicPr>
-          <p:cNvPr id="7" name="Picture 6" descr="game_xgb_shap_bar.png"/>
-          <p:cNvPicPr>
-            <a:picLocks noChangeAspect="1"/>
-          </p:cNvPicPr>
+        </p:nvGraphicFramePr>
+        <p:xfrm>
+          <a:off x="548640" y="1463040"/>
+          <a:ext cx="5486400" cy="3657600"/>
+        </p:xfrm>
+        <a:graphic>
+          <a:graphicData uri="http://schemas.openxmlformats.org/drawingml/2006/chart">
+            <c:chart xmlns:c="http://schemas.openxmlformats.org/drawingml/2006/chart" r:id="rId2"/>
+          </a:graphicData>
+        </a:graphic>
+      </p:graphicFrame>
+      <p:graphicFrame>
+        <p:nvGraphicFramePr>
+          <p:cNvPr id="7" name="Chart 6"/>
+          <p:cNvGraphicFramePr>
+            <a:graphicFrameLocks noGrp="1"/>
+          </p:cNvGraphicFramePr>
           <p:nvPr/>
-        </p:nvPicPr>
-        <p:blipFill>
-          <a:blip r:embed="rId3"/>
-          <a:stretch>
-            <a:fillRect/>
-          </a:stretch>
-        </p:blipFill>
-        <p:spPr>
-          <a:xfrm>
-            <a:off x="6309360" y="1508760"/>
-            <a:ext cx="4400550" cy="3520440"/>
-          </a:xfrm>
-          <a:prstGeom prst="rect">
-            <a:avLst/>
-          </a:prstGeom>
-        </p:spPr>
-      </p:pic>
+        </p:nvGraphicFramePr>
+        <p:xfrm>
+          <a:off x="6217920" y="1463040"/>
+          <a:ext cx="5486400" cy="3657600"/>
+        </p:xfrm>
+        <a:graphic>
+          <a:graphicData uri="http://schemas.openxmlformats.org/drawingml/2006/chart">
+            <c:chart xmlns:c="http://schemas.openxmlformats.org/drawingml/2006/chart" r:id="rId3"/>
+          </a:graphicData>
+        </a:graphic>
+      </p:graphicFrame>
       <p:sp>
         <p:nvSpPr>
           <p:cNvPr id="8" name="TextBox 7"/>
@@ -9066,7 +9496,7 @@
         </p:nvSpPr>
         <p:spPr>
           <a:xfrm>
-            <a:off x="722376" y="5029200"/>
+            <a:off x="722376" y="5120640"/>
             <a:ext cx="5394960" cy="548640"/>
           </a:xfrm>
           <a:prstGeom prst="rect">
@@ -9101,7 +9531,7 @@
                 </a:solidFill>
                 <a:latin typeface="Bitstream Charter"/>
               </a:rPr>
-              <a:t>review length, Chinese-language reviews and playtime lead; price, patch timing and the refund-window flag follow.</a:t>
+              <a:t>review length, Chinese-language reviews and playtime lead; price, patch timing and the refund-window flag follow. The reviewer's past-review count is collected at scrape time, so this model explains reviews rather than scoring a launch.</a:t>
             </a:r>
           </a:p>
         </p:txBody>
@@ -9114,7 +9544,7 @@
         </p:nvSpPr>
         <p:spPr>
           <a:xfrm>
-            <a:off x="6355080" y="5029200"/>
+            <a:off x="6355080" y="5120640"/>
             <a:ext cx="5212080" cy="548640"/>
           </a:xfrm>
           <a:prstGeom prst="rect">
@@ -9149,7 +9579,7 @@
                 </a:solidFill>
                 <a:latin typeface="Bitstream Charter"/>
               </a:rPr>
-              <a:t>a few tag components and the achievement count lead, then launch year and price; each effect is small.</a:t>
+              <a:t>the strongest tag axes (their top tags are in the labels), then the achievement count; the full component list is in docs/feature_engineering.md. Each effect is small.</a:t>
             </a:r>
           </a:p>
         </p:txBody>
@@ -18348,7 +18778,7 @@
                 </a:solidFill>
                 <a:latin typeface="Bitstream Charter"/>
               </a:rPr>
-              <a:t>34 commits and 12 merged pull requests so far.</a:t>
+              <a:t>35 commits and 12 merged pull requests so far.</a:t>
             </a:r>
           </a:p>
           <a:p>

</xml_diff>

<commit_message>
Slides: show ROC-AUC and macro-F1 on the model comparison slide
</commit_message>
<xml_diff>
--- a/slides/review1.pptx
+++ b/slides/review1.pptx
@@ -280,11 +280,242 @@
           <c:max val="26.0"/>
           <c:min val="0.0"/>
         </c:scaling>
-        <c:delete/>
+        <c:delete val="0"/>
+        <c:axPos val="l"/>
+        <c:majorTickMark val="in"/>
+        <c:minorTickMark val="none"/>
+        <c:tickLblPos val="none"/>
+        <c:spPr>
+          <a:ln>
+            <a:noFill/>
+          </a:ln>
+        </c:spPr>
+        <c:crossAx val="-2068027336"/>
+        <c:crosses val="autoZero"/>
+      </c:valAx>
+    </c:plotArea>
+    <c:dispBlanksAs val="gap"/>
+  </c:chart>
+  <c:txPr>
+    <a:bodyPr/>
+    <a:lstStyle/>
+    <a:p>
+      <a:pPr>
+        <a:defRPr sz="1000">
+          <a:solidFill>
+            <a:srgbClr val="263C50"/>
+          </a:solidFill>
+          <a:latin typeface="Bitstream Charter"/>
+        </a:defRPr>
+      </a:pPr>
+      <a:endParaRPr lang="en-US"/>
+    </a:p>
+  </c:txPr>
+  <c:externalData r:id="rId1">
+    <c:autoUpdate val="0"/>
+  </c:externalData>
+</c:chartSpace>
+</file>
+
+<file path=ppt/charts/chart10.xml><?xml version="1.0" encoding="utf-8"?>
+<c:chartSpace xmlns:c="http://schemas.openxmlformats.org/drawingml/2006/chart" xmlns:a="http://schemas.openxmlformats.org/drawingml/2006/main" xmlns:r="http://schemas.openxmlformats.org/officeDocument/2006/relationships">
+  <c:date1904 val="0"/>
+  <c:chart>
+    <c:title>
+      <c:tx>
+        <c:rich>
+          <a:bodyPr/>
+          <a:lstStyle/>
+          <a:p>
+            <a:r>
+              <a:rPr sz="1100" b="1" i="0">
+                <a:solidFill>
+                  <a:srgbClr val="132C43"/>
+                </a:solidFill>
+                <a:latin typeface="Bitstream Charter"/>
+              </a:rPr>
+              <a:t>Game level: what the model leans on (tag axes named by their top tags)</a:t>
+            </a:r>
+          </a:p>
+        </c:rich>
+      </c:tx>
+      <c:layout/>
+      <c:overlay val="0"/>
+    </c:title>
+    <c:autoTitleDeleted val="0"/>
+    <c:plotArea>
+      <c:barChart>
+        <c:barDir val="bar"/>
+        <c:grouping val="clustered"/>
+        <c:ser>
+          <c:idx val="0"/>
+          <c:order val="0"/>
+          <c:tx>
+            <c:strRef>
+              <c:f>Sheet1!$B$1</c:f>
+              <c:strCache>
+                <c:ptCount val="1"/>
+                <c:pt idx="0">
+                  <c:v>mean |SHAP|</c:v>
+                </c:pt>
+              </c:strCache>
+            </c:strRef>
+          </c:tx>
+          <c:spPr>
+            <a:solidFill>
+              <a:srgbClr val="3E9C6E"/>
+            </a:solidFill>
+          </c:spPr>
+          <c:cat>
+            <c:strRef>
+              <c:f>Sheet1!$A$2:$A$11</c:f>
+              <c:strCache>
+                <c:ptCount val="10"/>
+                <c:pt idx="0">
+                  <c:v>Loot, relaxing vs story-rich, funny</c:v>
+                </c:pt>
+                <c:pt idx="1">
+                  <c:v>Launch year</c:v>
+                </c:pt>
+                <c:pt idx="2">
+                  <c:v>Post-apocalyptic, zombies, story</c:v>
+                </c:pt>
+                <c:pt idx="3">
+                  <c:v>Cartoon deckbuilder vs top-down shooter</c:v>
+                </c:pt>
+                <c:pt idx="4">
+                  <c:v>Casual, arcade vs strategy, hack and slash</c:v>
+                </c:pt>
+                <c:pt idx="5">
+                  <c:v>RPG, fantasy vs casual, shooter</c:v>
+                </c:pt>
+                <c:pt idx="6">
+                  <c:v>Number of achievements</c:v>
+                </c:pt>
+                <c:pt idx="7">
+                  <c:v>2D pixel casual vs 3D adventure</c:v>
+                </c:pt>
+                <c:pt idx="8">
+                  <c:v>Roguelite, bullet hell vs adventure, pixel</c:v>
+                </c:pt>
+                <c:pt idx="9">
+                  <c:v>Store polish (Steam features) vs 3D / free</c:v>
+                </c:pt>
+              </c:strCache>
+            </c:strRef>
+          </c:cat>
+          <c:val>
+            <c:numRef>
+              <c:f>Sheet1!$B$2:$B$11</c:f>
+              <c:numCache>
+                <c:formatCode>General</c:formatCode>
+                <c:ptCount val="10"/>
+                <c:pt idx="0">
+                  <c:v>0.035455626</c:v>
+                </c:pt>
+                <c:pt idx="1">
+                  <c:v>0.035470154</c:v>
+                </c:pt>
+                <c:pt idx="2">
+                  <c:v>0.037882466</c:v>
+                </c:pt>
+                <c:pt idx="3">
+                  <c:v>0.039064217</c:v>
+                </c:pt>
+                <c:pt idx="4">
+                  <c:v>0.053518448</c:v>
+                </c:pt>
+                <c:pt idx="5">
+                  <c:v>0.05539743</c:v>
+                </c:pt>
+                <c:pt idx="6">
+                  <c:v>0.07229154</c:v>
+                </c:pt>
+                <c:pt idx="7">
+                  <c:v>0.09507317</c:v>
+                </c:pt>
+                <c:pt idx="8">
+                  <c:v>0.10334966</c:v>
+                </c:pt>
+                <c:pt idx="9">
+                  <c:v>0.11489248</c:v>
+                </c:pt>
+              </c:numCache>
+            </c:numRef>
+          </c:val>
+        </c:ser>
+        <c:dLbls>
+          <c:numFmt formatCode="0.00" sourceLinked="0"/>
+          <c:txPr>
+            <a:bodyPr/>
+            <a:lstStyle/>
+            <a:p>
+              <a:pPr>
+                <a:defRPr sz="1000"/>
+              </a:pPr>
+            </a:p>
+          </c:txPr>
+          <c:dLblPos val="outEnd"/>
+          <c:showLegendKey val="0"/>
+          <c:showVal val="1"/>
+          <c:showCatName val="0"/>
+          <c:showSerName val="0"/>
+          <c:showPercent val="0"/>
+          <c:showBubbleSize val="0"/>
+          <c:showLeaderLines val="1"/>
+        </c:dLbls>
+        <c:gapWidth val="45"/>
+        <c:axId val="-2068027336"/>
+        <c:axId val="-2113994440"/>
+      </c:barChart>
+      <c:catAx>
+        <c:axId val="-2068027336"/>
+        <c:scaling>
+          <c:orientation val="minMax"/>
+        </c:scaling>
+        <c:delete val="0"/>
         <c:axPos val="l"/>
         <c:majorTickMark val="out"/>
         <c:minorTickMark val="none"/>
         <c:tickLblPos val="nextTo"/>
+        <c:spPr>
+          <a:ln>
+            <a:solidFill>
+              <a:srgbClr val="C9D6E2"/>
+            </a:solidFill>
+          </a:ln>
+        </c:spPr>
+        <c:txPr>
+          <a:bodyPr/>
+          <a:lstStyle/>
+          <a:p>
+            <a:pPr>
+              <a:defRPr sz="1000"/>
+            </a:pPr>
+          </a:p>
+        </c:txPr>
+        <c:crossAx val="-2113994440"/>
+        <c:crosses val="autoZero"/>
+        <c:auto val="1"/>
+        <c:lblAlgn val="ctr"/>
+        <c:lblOffset val="100"/>
+        <c:noMultiLvlLbl val="0"/>
+      </c:catAx>
+      <c:valAx>
+        <c:axId val="-2113994440"/>
+        <c:scaling>
+          <c:min val="0.0"/>
+        </c:scaling>
+        <c:delete val="0"/>
+        <c:axPos val="b"/>
+        <c:majorTickMark val="in"/>
+        <c:minorTickMark val="none"/>
+        <c:tickLblPos val="none"/>
+        <c:spPr>
+          <a:ln>
+            <a:noFill/>
+          </a:ln>
+        </c:spPr>
         <c:crossAx val="-2068027336"/>
         <c:crosses val="autoZero"/>
       </c:valAx>
@@ -539,11 +770,16 @@
           <c:max val="38.0"/>
           <c:min val="0.0"/>
         </c:scaling>
-        <c:delete/>
+        <c:delete val="0"/>
         <c:axPos val="l"/>
-        <c:majorTickMark val="out"/>
+        <c:majorTickMark val="in"/>
         <c:minorTickMark val="none"/>
-        <c:tickLblPos val="nextTo"/>
+        <c:tickLblPos val="none"/>
+        <c:spPr>
+          <a:ln>
+            <a:noFill/>
+          </a:ln>
+        </c:spPr>
         <c:crossAx val="-2068027336"/>
         <c:crosses val="autoZero"/>
       </c:valAx>
@@ -799,11 +1035,16 @@
           <c:max val="26.0"/>
           <c:min val="0.0"/>
         </c:scaling>
-        <c:delete/>
+        <c:delete val="0"/>
         <c:axPos val="l"/>
-        <c:majorTickMark val="out"/>
+        <c:majorTickMark val="in"/>
         <c:minorTickMark val="none"/>
-        <c:tickLblPos val="nextTo"/>
+        <c:tickLblPos val="none"/>
+        <c:spPr>
+          <a:ln>
+            <a:noFill/>
+          </a:ln>
+        </c:spPr>
         <c:crossAx val="-2068027336"/>
         <c:crosses val="autoZero"/>
       </c:valAx>
@@ -2644,11 +2885,16 @@
           <c:max val="1.0"/>
           <c:min val="0.0"/>
         </c:scaling>
-        <c:delete/>
+        <c:delete val="0"/>
         <c:axPos val="l"/>
-        <c:majorTickMark val="out"/>
+        <c:majorTickMark val="in"/>
         <c:minorTickMark val="none"/>
-        <c:tickLblPos val="nextTo"/>
+        <c:tickLblPos val="none"/>
+        <c:spPr>
+          <a:ln>
+            <a:noFill/>
+          </a:ln>
+        </c:spPr>
         <c:crossAx val="-2068027336"/>
         <c:crosses val="autoZero"/>
       </c:valAx>
@@ -2677,6 +2923,591 @@
 </file>
 
 <file path=ppt/charts/chart6.xml><?xml version="1.0" encoding="utf-8"?>
+<c:chartSpace xmlns:c="http://schemas.openxmlformats.org/drawingml/2006/chart" xmlns:a="http://schemas.openxmlformats.org/drawingml/2006/main" xmlns:r="http://schemas.openxmlformats.org/officeDocument/2006/relationships">
+  <c:date1904 val="0"/>
+  <c:chart>
+    <c:title>
+      <c:tx>
+        <c:rich>
+          <a:bodyPr/>
+          <a:lstStyle/>
+          <a:p>
+            <a:r>
+              <a:rPr sz="1000" b="1" i="0">
+                <a:solidFill>
+                  <a:srgbClr val="132C43"/>
+                </a:solidFill>
+                <a:latin typeface="Bitstream Charter"/>
+              </a:rPr>
+              <a:t>Review level, metadata only: ROC-AUC</a:t>
+            </a:r>
+          </a:p>
+        </c:rich>
+      </c:tx>
+      <c:layout/>
+      <c:overlay val="0"/>
+    </c:title>
+    <c:autoTitleDeleted val="0"/>
+    <c:plotArea>
+      <c:barChart>
+        <c:barDir val="col"/>
+        <c:grouping val="clustered"/>
+        <c:ser>
+          <c:idx val="0"/>
+          <c:order val="0"/>
+          <c:tx>
+            <c:strRef>
+              <c:f>Sheet1!$B$1</c:f>
+              <c:strCache>
+                <c:ptCount val="1"/>
+                <c:pt idx="0">
+                  <c:v>ROC-AUC</c:v>
+                </c:pt>
+              </c:strCache>
+            </c:strRef>
+          </c:tx>
+          <c:spPr>
+            <a:solidFill>
+              <a:srgbClr val="48677E"/>
+            </a:solidFill>
+          </c:spPr>
+          <c:cat>
+            <c:strRef>
+              <c:f>Sheet1!$A$2:$A$6</c:f>
+              <c:strCache>
+                <c:ptCount val="5"/>
+                <c:pt idx="0">
+                  <c:v>Dummy</c:v>
+                </c:pt>
+                <c:pt idx="1">
+                  <c:v>Logistic Reg.</c:v>
+                </c:pt>
+                <c:pt idx="2">
+                  <c:v>Random Forest</c:v>
+                </c:pt>
+                <c:pt idx="3">
+                  <c:v>LightGBM</c:v>
+                </c:pt>
+                <c:pt idx="4">
+                  <c:v>XGBoost</c:v>
+                </c:pt>
+              </c:strCache>
+            </c:strRef>
+          </c:cat>
+          <c:val>
+            <c:numRef>
+              <c:f>Sheet1!$B$2:$B$6</c:f>
+              <c:numCache>
+                <c:formatCode>General</c:formatCode>
+                <c:ptCount val="5"/>
+                <c:pt idx="0">
+                  <c:v>0.5</c:v>
+                </c:pt>
+                <c:pt idx="1">
+                  <c:v>0.663</c:v>
+                </c:pt>
+                <c:pt idx="2">
+                  <c:v>0.721</c:v>
+                </c:pt>
+                <c:pt idx="3">
+                  <c:v>0.729</c:v>
+                </c:pt>
+                <c:pt idx="4">
+                  <c:v>0.733</c:v>
+                </c:pt>
+              </c:numCache>
+            </c:numRef>
+          </c:val>
+        </c:ser>
+        <c:dLbls>
+          <c:numFmt formatCode="0.00" sourceLinked="0"/>
+          <c:txPr>
+            <a:bodyPr/>
+            <a:lstStyle/>
+            <a:p>
+              <a:pPr>
+                <a:defRPr sz="900"/>
+              </a:pPr>
+            </a:p>
+          </c:txPr>
+          <c:dLblPos val="outEnd"/>
+          <c:showLegendKey val="0"/>
+          <c:showVal val="1"/>
+          <c:showCatName val="0"/>
+          <c:showSerName val="0"/>
+          <c:showPercent val="0"/>
+          <c:showBubbleSize val="0"/>
+          <c:showLeaderLines val="1"/>
+        </c:dLbls>
+        <c:gapWidth val="50"/>
+        <c:axId val="-2068027336"/>
+        <c:axId val="-2113994440"/>
+      </c:barChart>
+      <c:catAx>
+        <c:axId val="-2068027336"/>
+        <c:scaling>
+          <c:orientation val="minMax"/>
+        </c:scaling>
+        <c:delete val="0"/>
+        <c:axPos val="b"/>
+        <c:majorTickMark val="out"/>
+        <c:minorTickMark val="none"/>
+        <c:tickLblPos val="nextTo"/>
+        <c:spPr>
+          <a:ln>
+            <a:solidFill>
+              <a:srgbClr val="C9D6E2"/>
+            </a:solidFill>
+          </a:ln>
+        </c:spPr>
+        <c:txPr>
+          <a:bodyPr/>
+          <a:lstStyle/>
+          <a:p>
+            <a:pPr>
+              <a:defRPr sz="900"/>
+            </a:pPr>
+          </a:p>
+        </c:txPr>
+        <c:crossAx val="-2113994440"/>
+        <c:crosses val="autoZero"/>
+        <c:auto val="1"/>
+        <c:lblAlgn val="ctr"/>
+        <c:lblOffset val="100"/>
+        <c:noMultiLvlLbl val="0"/>
+      </c:catAx>
+      <c:valAx>
+        <c:axId val="-2113994440"/>
+        <c:scaling>
+          <c:max val="1.0"/>
+          <c:min val="0.0"/>
+        </c:scaling>
+        <c:delete val="0"/>
+        <c:axPos val="l"/>
+        <c:majorTickMark val="in"/>
+        <c:minorTickMark val="none"/>
+        <c:tickLblPos val="none"/>
+        <c:spPr>
+          <a:ln>
+            <a:noFill/>
+          </a:ln>
+        </c:spPr>
+        <c:crossAx val="-2068027336"/>
+        <c:crosses val="autoZero"/>
+      </c:valAx>
+    </c:plotArea>
+    <c:dispBlanksAs val="gap"/>
+  </c:chart>
+  <c:txPr>
+    <a:bodyPr/>
+    <a:lstStyle/>
+    <a:p>
+      <a:pPr>
+        <a:defRPr sz="900">
+          <a:solidFill>
+            <a:srgbClr val="263C50"/>
+          </a:solidFill>
+          <a:latin typeface="Bitstream Charter"/>
+        </a:defRPr>
+      </a:pPr>
+      <a:endParaRPr lang="en-US"/>
+    </a:p>
+  </c:txPr>
+  <c:externalData r:id="rId1">
+    <c:autoUpdate val="0"/>
+  </c:externalData>
+</c:chartSpace>
+</file>
+
+<file path=ppt/charts/chart7.xml><?xml version="1.0" encoding="utf-8"?>
+<c:chartSpace xmlns:c="http://schemas.openxmlformats.org/drawingml/2006/chart" xmlns:a="http://schemas.openxmlformats.org/drawingml/2006/main" xmlns:r="http://schemas.openxmlformats.org/officeDocument/2006/relationships">
+  <c:date1904 val="0"/>
+  <c:chart>
+    <c:title>
+      <c:tx>
+        <c:rich>
+          <a:bodyPr/>
+          <a:lstStyle/>
+          <a:p>
+            <a:r>
+              <a:rPr sz="1000" b="1" i="0">
+                <a:solidFill>
+                  <a:srgbClr val="132C43"/>
+                </a:solidFill>
+                <a:latin typeface="Bitstream Charter"/>
+              </a:rPr>
+              <a:t>Game level, success tier: macro-F1</a:t>
+            </a:r>
+          </a:p>
+        </c:rich>
+      </c:tx>
+      <c:layout/>
+      <c:overlay val="0"/>
+    </c:title>
+    <c:autoTitleDeleted val="0"/>
+    <c:plotArea>
+      <c:barChart>
+        <c:barDir val="col"/>
+        <c:grouping val="clustered"/>
+        <c:ser>
+          <c:idx val="0"/>
+          <c:order val="0"/>
+          <c:tx>
+            <c:strRef>
+              <c:f>Sheet1!$B$1</c:f>
+              <c:strCache>
+                <c:ptCount val="1"/>
+                <c:pt idx="0">
+                  <c:v>macro-F1</c:v>
+                </c:pt>
+              </c:strCache>
+            </c:strRef>
+          </c:tx>
+          <c:spPr>
+            <a:solidFill>
+              <a:srgbClr val="48677E"/>
+            </a:solidFill>
+          </c:spPr>
+          <c:cat>
+            <c:strRef>
+              <c:f>Sheet1!$A$2:$A$6</c:f>
+              <c:strCache>
+                <c:ptCount val="5"/>
+                <c:pt idx="0">
+                  <c:v>Dummy</c:v>
+                </c:pt>
+                <c:pt idx="1">
+                  <c:v>Logistic Reg.</c:v>
+                </c:pt>
+                <c:pt idx="2">
+                  <c:v>Random Forest</c:v>
+                </c:pt>
+                <c:pt idx="3">
+                  <c:v>LightGBM</c:v>
+                </c:pt>
+                <c:pt idx="4">
+                  <c:v>XGBoost</c:v>
+                </c:pt>
+              </c:strCache>
+            </c:strRef>
+          </c:cat>
+          <c:val>
+            <c:numRef>
+              <c:f>Sheet1!$B$2:$B$6</c:f>
+              <c:numCache>
+                <c:formatCode>General</c:formatCode>
+                <c:ptCount val="5"/>
+                <c:pt idx="0">
+                  <c:v>0.2197</c:v>
+                </c:pt>
+                <c:pt idx="1">
+                  <c:v>0.4233</c:v>
+                </c:pt>
+                <c:pt idx="2">
+                  <c:v>0.4037</c:v>
+                </c:pt>
+                <c:pt idx="3">
+                  <c:v>0.4213</c:v>
+                </c:pt>
+                <c:pt idx="4">
+                  <c:v>0.3879</c:v>
+                </c:pt>
+              </c:numCache>
+            </c:numRef>
+          </c:val>
+        </c:ser>
+        <c:dLbls>
+          <c:numFmt formatCode="0.00" sourceLinked="0"/>
+          <c:txPr>
+            <a:bodyPr/>
+            <a:lstStyle/>
+            <a:p>
+              <a:pPr>
+                <a:defRPr sz="900"/>
+              </a:pPr>
+            </a:p>
+          </c:txPr>
+          <c:dLblPos val="outEnd"/>
+          <c:showLegendKey val="0"/>
+          <c:showVal val="1"/>
+          <c:showCatName val="0"/>
+          <c:showSerName val="0"/>
+          <c:showPercent val="0"/>
+          <c:showBubbleSize val="0"/>
+          <c:showLeaderLines val="1"/>
+        </c:dLbls>
+        <c:gapWidth val="50"/>
+        <c:axId val="-2068027336"/>
+        <c:axId val="-2113994440"/>
+      </c:barChart>
+      <c:catAx>
+        <c:axId val="-2068027336"/>
+        <c:scaling>
+          <c:orientation val="minMax"/>
+        </c:scaling>
+        <c:delete val="0"/>
+        <c:axPos val="b"/>
+        <c:majorTickMark val="out"/>
+        <c:minorTickMark val="none"/>
+        <c:tickLblPos val="nextTo"/>
+        <c:spPr>
+          <a:ln>
+            <a:solidFill>
+              <a:srgbClr val="C9D6E2"/>
+            </a:solidFill>
+          </a:ln>
+        </c:spPr>
+        <c:txPr>
+          <a:bodyPr/>
+          <a:lstStyle/>
+          <a:p>
+            <a:pPr>
+              <a:defRPr sz="900"/>
+            </a:pPr>
+          </a:p>
+        </c:txPr>
+        <c:crossAx val="-2113994440"/>
+        <c:crosses val="autoZero"/>
+        <c:auto val="1"/>
+        <c:lblAlgn val="ctr"/>
+        <c:lblOffset val="100"/>
+        <c:noMultiLvlLbl val="0"/>
+      </c:catAx>
+      <c:valAx>
+        <c:axId val="-2113994440"/>
+        <c:scaling>
+          <c:max val="1.0"/>
+          <c:min val="0.0"/>
+        </c:scaling>
+        <c:delete val="0"/>
+        <c:axPos val="l"/>
+        <c:majorTickMark val="in"/>
+        <c:minorTickMark val="none"/>
+        <c:tickLblPos val="none"/>
+        <c:spPr>
+          <a:ln>
+            <a:noFill/>
+          </a:ln>
+        </c:spPr>
+        <c:crossAx val="-2068027336"/>
+        <c:crosses val="autoZero"/>
+      </c:valAx>
+    </c:plotArea>
+    <c:dispBlanksAs val="gap"/>
+  </c:chart>
+  <c:txPr>
+    <a:bodyPr/>
+    <a:lstStyle/>
+    <a:p>
+      <a:pPr>
+        <a:defRPr sz="900">
+          <a:solidFill>
+            <a:srgbClr val="263C50"/>
+          </a:solidFill>
+          <a:latin typeface="Bitstream Charter"/>
+        </a:defRPr>
+      </a:pPr>
+      <a:endParaRPr lang="en-US"/>
+    </a:p>
+  </c:txPr>
+  <c:externalData r:id="rId1">
+    <c:autoUpdate val="0"/>
+  </c:externalData>
+</c:chartSpace>
+</file>
+
+<file path=ppt/charts/chart8.xml><?xml version="1.0" encoding="utf-8"?>
+<c:chartSpace xmlns:c="http://schemas.openxmlformats.org/drawingml/2006/chart" xmlns:a="http://schemas.openxmlformats.org/drawingml/2006/main" xmlns:r="http://schemas.openxmlformats.org/officeDocument/2006/relationships">
+  <c:date1904 val="0"/>
+  <c:chart>
+    <c:title>
+      <c:tx>
+        <c:rich>
+          <a:bodyPr/>
+          <a:lstStyle/>
+          <a:p>
+            <a:r>
+              <a:rPr sz="1000" b="1" i="0">
+                <a:solidFill>
+                  <a:srgbClr val="132C43"/>
+                </a:solidFill>
+                <a:latin typeface="Bitstream Charter"/>
+              </a:rPr>
+              <a:t>Review level, adding the text: ROC-AUC</a:t>
+            </a:r>
+          </a:p>
+        </c:rich>
+      </c:tx>
+      <c:layout/>
+      <c:overlay val="0"/>
+    </c:title>
+    <c:autoTitleDeleted val="0"/>
+    <c:plotArea>
+      <c:barChart>
+        <c:barDir val="col"/>
+        <c:grouping val="clustered"/>
+        <c:ser>
+          <c:idx val="0"/>
+          <c:order val="0"/>
+          <c:tx>
+            <c:strRef>
+              <c:f>Sheet1!$B$1</c:f>
+              <c:strCache>
+                <c:ptCount val="1"/>
+                <c:pt idx="0">
+                  <c:v>ROC-AUC</c:v>
+                </c:pt>
+              </c:strCache>
+            </c:strRef>
+          </c:tx>
+          <c:spPr>
+            <a:solidFill>
+              <a:srgbClr val="132C43"/>
+            </a:solidFill>
+          </c:spPr>
+          <c:cat>
+            <c:strRef>
+              <c:f>Sheet1!$A$2:$A$5</c:f>
+              <c:strCache>
+                <c:ptCount val="4"/>
+                <c:pt idx="0">
+                  <c:v>Dummy</c:v>
+                </c:pt>
+                <c:pt idx="1">
+                  <c:v>metadata</c:v>
+                </c:pt>
+                <c:pt idx="2">
+                  <c:v>+ text SVD</c:v>
+                </c:pt>
+                <c:pt idx="3">
+                  <c:v>full text</c:v>
+                </c:pt>
+              </c:strCache>
+            </c:strRef>
+          </c:cat>
+          <c:val>
+            <c:numRef>
+              <c:f>Sheet1!$B$2:$B$5</c:f>
+              <c:numCache>
+                <c:formatCode>General</c:formatCode>
+                <c:ptCount val="4"/>
+                <c:pt idx="0">
+                  <c:v>0.5</c:v>
+                </c:pt>
+                <c:pt idx="1">
+                  <c:v>0.758</c:v>
+                </c:pt>
+                <c:pt idx="2">
+                  <c:v>0.892</c:v>
+                </c:pt>
+                <c:pt idx="3">
+                  <c:v>0.955</c:v>
+                </c:pt>
+              </c:numCache>
+            </c:numRef>
+          </c:val>
+        </c:ser>
+        <c:dLbls>
+          <c:numFmt formatCode="0.00" sourceLinked="0"/>
+          <c:txPr>
+            <a:bodyPr/>
+            <a:lstStyle/>
+            <a:p>
+              <a:pPr>
+                <a:defRPr sz="900"/>
+              </a:pPr>
+            </a:p>
+          </c:txPr>
+          <c:dLblPos val="outEnd"/>
+          <c:showLegendKey val="0"/>
+          <c:showVal val="1"/>
+          <c:showCatName val="0"/>
+          <c:showSerName val="0"/>
+          <c:showPercent val="0"/>
+          <c:showBubbleSize val="0"/>
+          <c:showLeaderLines val="1"/>
+        </c:dLbls>
+        <c:gapWidth val="50"/>
+        <c:axId val="-2068027336"/>
+        <c:axId val="-2113994440"/>
+      </c:barChart>
+      <c:catAx>
+        <c:axId val="-2068027336"/>
+        <c:scaling>
+          <c:orientation val="minMax"/>
+        </c:scaling>
+        <c:delete val="0"/>
+        <c:axPos val="b"/>
+        <c:majorTickMark val="out"/>
+        <c:minorTickMark val="none"/>
+        <c:tickLblPos val="nextTo"/>
+        <c:spPr>
+          <a:ln>
+            <a:solidFill>
+              <a:srgbClr val="C9D6E2"/>
+            </a:solidFill>
+          </a:ln>
+        </c:spPr>
+        <c:txPr>
+          <a:bodyPr/>
+          <a:lstStyle/>
+          <a:p>
+            <a:pPr>
+              <a:defRPr sz="900"/>
+            </a:pPr>
+          </a:p>
+        </c:txPr>
+        <c:crossAx val="-2113994440"/>
+        <c:crosses val="autoZero"/>
+        <c:auto val="1"/>
+        <c:lblAlgn val="ctr"/>
+        <c:lblOffset val="100"/>
+        <c:noMultiLvlLbl val="0"/>
+      </c:catAx>
+      <c:valAx>
+        <c:axId val="-2113994440"/>
+        <c:scaling>
+          <c:max val="1.0"/>
+          <c:min val="0.0"/>
+        </c:scaling>
+        <c:delete val="0"/>
+        <c:axPos val="l"/>
+        <c:majorTickMark val="in"/>
+        <c:minorTickMark val="none"/>
+        <c:tickLblPos val="none"/>
+        <c:spPr>
+          <a:ln>
+            <a:noFill/>
+          </a:ln>
+        </c:spPr>
+        <c:crossAx val="-2068027336"/>
+        <c:crosses val="autoZero"/>
+      </c:valAx>
+    </c:plotArea>
+    <c:dispBlanksAs val="gap"/>
+  </c:chart>
+  <c:txPr>
+    <a:bodyPr/>
+    <a:lstStyle/>
+    <a:p>
+      <a:pPr>
+        <a:defRPr sz="900">
+          <a:solidFill>
+            <a:srgbClr val="263C50"/>
+          </a:solidFill>
+          <a:latin typeface="Bitstream Charter"/>
+        </a:defRPr>
+      </a:pPr>
+      <a:endParaRPr lang="en-US"/>
+    </a:p>
+  </c:txPr>
+  <c:externalData r:id="rId1">
+    <c:autoUpdate val="0"/>
+  </c:externalData>
+</c:chartSpace>
+</file>
+
+<file path=ppt/charts/chart9.xml><?xml version="1.0" encoding="utf-8"?>
 <c:chartSpace xmlns:c="http://schemas.openxmlformats.org/drawingml/2006/chart" xmlns:a="http://schemas.openxmlformats.org/drawingml/2006/main" xmlns:r="http://schemas.openxmlformats.org/officeDocument/2006/relationships">
   <c:date1904 val="0"/>
   <c:chart>
@@ -2865,232 +3696,16 @@
         <c:scaling>
           <c:min val="0.0"/>
         </c:scaling>
-        <c:delete/>
+        <c:delete val="0"/>
         <c:axPos val="b"/>
-        <c:majorTickMark val="out"/>
+        <c:majorTickMark val="in"/>
         <c:minorTickMark val="none"/>
-        <c:tickLblPos val="nextTo"/>
-        <c:crossAx val="-2068027336"/>
-        <c:crosses val="autoZero"/>
-      </c:valAx>
-    </c:plotArea>
-    <c:dispBlanksAs val="gap"/>
-  </c:chart>
-  <c:txPr>
-    <a:bodyPr/>
-    <a:lstStyle/>
-    <a:p>
-      <a:pPr>
-        <a:defRPr sz="1000">
-          <a:solidFill>
-            <a:srgbClr val="263C50"/>
-          </a:solidFill>
-          <a:latin typeface="Bitstream Charter"/>
-        </a:defRPr>
-      </a:pPr>
-      <a:endParaRPr lang="en-US"/>
-    </a:p>
-  </c:txPr>
-  <c:externalData r:id="rId1">
-    <c:autoUpdate val="0"/>
-  </c:externalData>
-</c:chartSpace>
-</file>
-
-<file path=ppt/charts/chart7.xml><?xml version="1.0" encoding="utf-8"?>
-<c:chartSpace xmlns:c="http://schemas.openxmlformats.org/drawingml/2006/chart" xmlns:a="http://schemas.openxmlformats.org/drawingml/2006/main" xmlns:r="http://schemas.openxmlformats.org/officeDocument/2006/relationships">
-  <c:date1904 val="0"/>
-  <c:chart>
-    <c:title>
-      <c:tx>
-        <c:rich>
-          <a:bodyPr/>
-          <a:lstStyle/>
-          <a:p>
-            <a:r>
-              <a:rPr sz="1100" b="1" i="0">
-                <a:solidFill>
-                  <a:srgbClr val="132C43"/>
-                </a:solidFill>
-                <a:latin typeface="Bitstream Charter"/>
-              </a:rPr>
-              <a:t>Game level: what the model leans on (tag axes named by their top tags)</a:t>
-            </a:r>
-          </a:p>
-        </c:rich>
-      </c:tx>
-      <c:layout/>
-      <c:overlay val="0"/>
-    </c:title>
-    <c:autoTitleDeleted val="0"/>
-    <c:plotArea>
-      <c:barChart>
-        <c:barDir val="bar"/>
-        <c:grouping val="clustered"/>
-        <c:ser>
-          <c:idx val="0"/>
-          <c:order val="0"/>
-          <c:tx>
-            <c:strRef>
-              <c:f>Sheet1!$B$1</c:f>
-              <c:strCache>
-                <c:ptCount val="1"/>
-                <c:pt idx="0">
-                  <c:v>mean |SHAP|</c:v>
-                </c:pt>
-              </c:strCache>
-            </c:strRef>
-          </c:tx>
-          <c:spPr>
-            <a:solidFill>
-              <a:srgbClr val="3E9C6E"/>
-            </a:solidFill>
-          </c:spPr>
-          <c:cat>
-            <c:strRef>
-              <c:f>Sheet1!$A$2:$A$11</c:f>
-              <c:strCache>
-                <c:ptCount val="10"/>
-                <c:pt idx="0">
-                  <c:v>Loot, relaxing vs story-rich, funny</c:v>
-                </c:pt>
-                <c:pt idx="1">
-                  <c:v>Launch year</c:v>
-                </c:pt>
-                <c:pt idx="2">
-                  <c:v>Post-apocalyptic, zombies, story</c:v>
-                </c:pt>
-                <c:pt idx="3">
-                  <c:v>Cartoon deckbuilder vs top-down shooter</c:v>
-                </c:pt>
-                <c:pt idx="4">
-                  <c:v>Casual, arcade vs strategy, hack and slash</c:v>
-                </c:pt>
-                <c:pt idx="5">
-                  <c:v>RPG, fantasy vs casual, shooter</c:v>
-                </c:pt>
-                <c:pt idx="6">
-                  <c:v>Number of achievements</c:v>
-                </c:pt>
-                <c:pt idx="7">
-                  <c:v>2D pixel casual vs 3D adventure</c:v>
-                </c:pt>
-                <c:pt idx="8">
-                  <c:v>Roguelite, bullet hell vs adventure, pixel</c:v>
-                </c:pt>
-                <c:pt idx="9">
-                  <c:v>Store polish (Steam features) vs 3D / free</c:v>
-                </c:pt>
-              </c:strCache>
-            </c:strRef>
-          </c:cat>
-          <c:val>
-            <c:numRef>
-              <c:f>Sheet1!$B$2:$B$11</c:f>
-              <c:numCache>
-                <c:formatCode>General</c:formatCode>
-                <c:ptCount val="10"/>
-                <c:pt idx="0">
-                  <c:v>0.035455626</c:v>
-                </c:pt>
-                <c:pt idx="1">
-                  <c:v>0.035470154</c:v>
-                </c:pt>
-                <c:pt idx="2">
-                  <c:v>0.037882466</c:v>
-                </c:pt>
-                <c:pt idx="3">
-                  <c:v>0.039064217</c:v>
-                </c:pt>
-                <c:pt idx="4">
-                  <c:v>0.053518448</c:v>
-                </c:pt>
-                <c:pt idx="5">
-                  <c:v>0.05539743</c:v>
-                </c:pt>
-                <c:pt idx="6">
-                  <c:v>0.07229154</c:v>
-                </c:pt>
-                <c:pt idx="7">
-                  <c:v>0.09507317</c:v>
-                </c:pt>
-                <c:pt idx="8">
-                  <c:v>0.10334966</c:v>
-                </c:pt>
-                <c:pt idx="9">
-                  <c:v>0.11489248</c:v>
-                </c:pt>
-              </c:numCache>
-            </c:numRef>
-          </c:val>
-        </c:ser>
-        <c:dLbls>
-          <c:numFmt formatCode="0.00" sourceLinked="0"/>
-          <c:txPr>
-            <a:bodyPr/>
-            <a:lstStyle/>
-            <a:p>
-              <a:pPr>
-                <a:defRPr sz="1000"/>
-              </a:pPr>
-            </a:p>
-          </c:txPr>
-          <c:dLblPos val="outEnd"/>
-          <c:showLegendKey val="0"/>
-          <c:showVal val="1"/>
-          <c:showCatName val="0"/>
-          <c:showSerName val="0"/>
-          <c:showPercent val="0"/>
-          <c:showBubbleSize val="0"/>
-          <c:showLeaderLines val="1"/>
-        </c:dLbls>
-        <c:gapWidth val="45"/>
-        <c:axId val="-2068027336"/>
-        <c:axId val="-2113994440"/>
-      </c:barChart>
-      <c:catAx>
-        <c:axId val="-2068027336"/>
-        <c:scaling>
-          <c:orientation val="minMax"/>
-        </c:scaling>
-        <c:delete val="0"/>
-        <c:axPos val="l"/>
-        <c:majorTickMark val="out"/>
-        <c:minorTickMark val="none"/>
-        <c:tickLblPos val="nextTo"/>
+        <c:tickLblPos val="none"/>
         <c:spPr>
           <a:ln>
-            <a:solidFill>
-              <a:srgbClr val="C9D6E2"/>
-            </a:solidFill>
+            <a:noFill/>
           </a:ln>
         </c:spPr>
-        <c:txPr>
-          <a:bodyPr/>
-          <a:lstStyle/>
-          <a:p>
-            <a:pPr>
-              <a:defRPr sz="1000"/>
-            </a:pPr>
-          </a:p>
-        </c:txPr>
-        <c:crossAx val="-2113994440"/>
-        <c:crosses val="autoZero"/>
-        <c:auto val="1"/>
-        <c:lblAlgn val="ctr"/>
-        <c:lblOffset val="100"/>
-        <c:noMultiLvlLbl val="0"/>
-      </c:catAx>
-      <c:valAx>
-        <c:axId val="-2113994440"/>
-        <c:scaling>
-          <c:min val="0.0"/>
-        </c:scaling>
-        <c:delete/>
-        <c:axPos val="b"/>
-        <c:majorTickMark val="out"/>
-        <c:minorTickMark val="none"/>
-        <c:tickLblPos val="nextTo"/>
         <c:crossAx val="-2068027336"/>
         <c:crosses val="autoZero"/>
       </c:valAx>
@@ -9035,33 +9650,63 @@
           </a:p>
         </p:txBody>
       </p:sp>
-      <p:pic>
-        <p:nvPicPr>
-          <p:cNvPr id="6" name="Picture 5" descr="model_comparison.png"/>
-          <p:cNvPicPr>
-            <a:picLocks noChangeAspect="1"/>
-          </p:cNvPicPr>
+      <p:graphicFrame>
+        <p:nvGraphicFramePr>
+          <p:cNvPr id="6" name="Chart 5"/>
+          <p:cNvGraphicFramePr>
+            <a:graphicFrameLocks noGrp="1"/>
+          </p:cNvGraphicFramePr>
           <p:nvPr/>
-        </p:nvPicPr>
-        <p:blipFill>
-          <a:blip r:embed="rId2"/>
-          <a:stretch>
-            <a:fillRect/>
-          </a:stretch>
-        </p:blipFill>
-        <p:spPr>
-          <a:xfrm>
-            <a:off x="603504" y="1463040"/>
-            <a:ext cx="10972800" cy="2987040"/>
-          </a:xfrm>
-          <a:prstGeom prst="rect">
-            <a:avLst/>
-          </a:prstGeom>
-        </p:spPr>
-      </p:pic>
+        </p:nvGraphicFramePr>
+        <p:xfrm>
+          <a:off x="640080" y="1463040"/>
+          <a:ext cx="3657600" cy="2971800"/>
+        </p:xfrm>
+        <a:graphic>
+          <a:graphicData uri="http://schemas.openxmlformats.org/drawingml/2006/chart">
+            <c:chart xmlns:c="http://schemas.openxmlformats.org/drawingml/2006/chart" r:id="rId2"/>
+          </a:graphicData>
+        </a:graphic>
+      </p:graphicFrame>
+      <p:graphicFrame>
+        <p:nvGraphicFramePr>
+          <p:cNvPr id="7" name="Chart 6"/>
+          <p:cNvGraphicFramePr>
+            <a:graphicFrameLocks noGrp="1"/>
+          </p:cNvGraphicFramePr>
+          <p:nvPr/>
+        </p:nvGraphicFramePr>
+        <p:xfrm>
+          <a:off x="4343400" y="1463040"/>
+          <a:ext cx="3657600" cy="2971800"/>
+        </p:xfrm>
+        <a:graphic>
+          <a:graphicData uri="http://schemas.openxmlformats.org/drawingml/2006/chart">
+            <c:chart xmlns:c="http://schemas.openxmlformats.org/drawingml/2006/chart" r:id="rId3"/>
+          </a:graphicData>
+        </a:graphic>
+      </p:graphicFrame>
+      <p:graphicFrame>
+        <p:nvGraphicFramePr>
+          <p:cNvPr id="8" name="Chart 7"/>
+          <p:cNvGraphicFramePr>
+            <a:graphicFrameLocks noGrp="1"/>
+          </p:cNvGraphicFramePr>
+          <p:nvPr/>
+        </p:nvGraphicFramePr>
+        <p:xfrm>
+          <a:off x="8046720" y="1463040"/>
+          <a:ext cx="3657600" cy="2971800"/>
+        </p:xfrm>
+        <a:graphic>
+          <a:graphicData uri="http://schemas.openxmlformats.org/drawingml/2006/chart">
+            <c:chart xmlns:c="http://schemas.openxmlformats.org/drawingml/2006/chart" r:id="rId4"/>
+          </a:graphicData>
+        </a:graphic>
+      </p:graphicFrame>
       <p:sp>
         <p:nvSpPr>
-          <p:cNvPr id="7" name="TextBox 6"/>
+          <p:cNvPr id="9" name="TextBox 8"/>
           <p:cNvSpPr txBox="1"/>
           <p:nvPr/>
         </p:nvSpPr>
@@ -9109,7 +9754,7 @@
       </p:sp>
       <p:sp>
         <p:nvSpPr>
-          <p:cNvPr id="8" name="TextBox 7"/>
+          <p:cNvPr id="10" name="TextBox 9"/>
           <p:cNvSpPr txBox="1"/>
           <p:nvPr/>
         </p:nvSpPr>
@@ -9157,7 +9802,7 @@
       </p:sp>
       <p:sp>
         <p:nvSpPr>
-          <p:cNvPr id="9" name="TextBox 8"/>
+          <p:cNvPr id="11" name="TextBox 10"/>
           <p:cNvSpPr txBox="1"/>
           <p:nvPr/>
         </p:nvSpPr>
@@ -9198,14 +9843,14 @@
                 </a:solidFill>
                 <a:latin typeface="Bitstream Charter"/>
               </a:rPr>
-              <a:t>PR-AUC climbs from 0.36 (metadata) to 0.58 (78 text components) to 0.78 (full text).</a:t>
+              <a:t>ROC-AUC climbs from 0.76 (metadata) to 0.89 (78 text components) to 0.955 (full text); accuracy 93.6% against 88.5% for always-positive. PR-AUC is on slide 12.</a:t>
             </a:r>
           </a:p>
         </p:txBody>
       </p:sp>
       <p:sp>
         <p:nvSpPr>
-          <p:cNvPr id="10" name="Rectangle 9"/>
+          <p:cNvPr id="12" name="Rectangle 11"/>
           <p:cNvSpPr/>
           <p:nvPr/>
         </p:nvSpPr>
@@ -9248,7 +9893,7 @@
       </p:sp>
       <p:sp>
         <p:nvSpPr>
-          <p:cNvPr id="11" name="Rectangle 10"/>
+          <p:cNvPr id="13" name="Rectangle 12"/>
           <p:cNvSpPr/>
           <p:nvPr/>
         </p:nvSpPr>
@@ -18778,7 +19423,7 @@
                 </a:solidFill>
                 <a:latin typeface="Bitstream Charter"/>
               </a:rPr>
-              <a:t>35 commits and 12 merged pull requests so far.</a:t>
+              <a:t>36 commits and 12 merged pull requests so far.</a:t>
             </a:r>
           </a:p>
           <a:p>

</xml_diff>

<commit_message>
Slides: add related work and what makes IndieGuard different
</commit_message>
<xml_diff>
--- a/slides/review1.pptx
+++ b/slides/review1.pptx
@@ -10,6 +10,7 @@
   <p:sldIdLst>
     <p:sldId id="256" r:id="rId2"/>
     <p:sldId id="257" r:id="rId3"/>
+    <p:sldId id="273" r:id="rId24"/>
     <p:sldId id="258" r:id="rId4"/>
     <p:sldId id="259" r:id="rId5"/>
     <p:sldId id="260" r:id="rId6"/>
@@ -4569,6 +4570,81 @@
           <a:p>
             <a:r>
               <a:t>Mean absolute SHAP values from the XGBoost models (PR #55). The review model also uses reviewer-history columns collected at scrape time; these are not available at launch, which is one reason we report review-level results as explanatory.</a:t>
+            </a:r>
+          </a:p>
+        </p:txBody>
+      </p:sp>
+      <p:sp>
+        <p:nvSpPr>
+          <p:cNvPr id="4" name="Slide Number Placeholder 3"/>
+          <p:cNvSpPr>
+            <a:spLocks noGrp="1"/>
+          </p:cNvSpPr>
+          <p:nvPr>
+            <p:ph type="sldNum" idx="5" sz="quarter"/>
+          </p:nvPr>
+        </p:nvSpPr>
+        <p:spPr/>
+      </p:sp>
+    </p:spTree>
+  </p:cSld>
+  <p:clrMapOvr>
+    <a:masterClrMapping/>
+  </p:clrMapOvr>
+</p:notes>
+</file>
+
+<file path=ppt/notesSlides/notesSlide18.xml><?xml version="1.0" encoding="utf-8"?>
+<p:notes xmlns:a="http://schemas.openxmlformats.org/drawingml/2006/main" xmlns:p="http://schemas.openxmlformats.org/presentationml/2006/main" xmlns:r="http://schemas.openxmlformats.org/officeDocument/2006/relationships">
+  <p:cSld>
+    <p:spTree>
+      <p:nvGrpSpPr>
+        <p:cNvPr id="1" name=""/>
+        <p:cNvGrpSpPr/>
+        <p:nvPr/>
+      </p:nvGrpSpPr>
+      <p:grpSpPr>
+        <a:xfrm>
+          <a:off x="0" y="0"/>
+          <a:ext cx="0" cy="0"/>
+          <a:chOff x="0" y="0"/>
+          <a:chExt cx="0" cy="0"/>
+        </a:xfrm>
+      </p:grpSpPr>
+      <p:sp>
+        <p:nvSpPr>
+          <p:cNvPr id="2" name="Slide Image Placeholder 1"/>
+          <p:cNvSpPr>
+            <a:spLocks noGrp="1"/>
+          </p:cNvSpPr>
+          <p:nvPr>
+            <p:ph type="sldImg" idx="2"/>
+          </p:nvPr>
+        </p:nvSpPr>
+        <p:spPr/>
+      </p:sp>
+      <p:sp>
+        <p:nvSpPr>
+          <p:cNvPr id="3" name="Notes Placeholder 2"/>
+          <p:cNvSpPr>
+            <a:spLocks noGrp="1"/>
+          </p:cNvSpPr>
+          <p:nvPr>
+            <p:ph type="body" idx="3" sz="quarter"/>
+          </p:nvPr>
+        </p:nvSpPr>
+        <p:spPr/>
+        <p:txBody>
+          <a:bodyPr/>
+          <a:lstStyle/>
+          <a:p>
+            <a:r>
+              <a:t>Suggested speaker: Tejaswini (problem statement owner). 0:45.</a:t>
+            </a:r>
+          </a:p>
+          <a:p>
+            <a:r>
+              <a:t>Three verified references. Lin et al.: about 11M reviews across 6,224 games, negative reviews arrive quickly and criticise design more than bugs. De Luisa et al.: Bayesian popularity prediction. Jorge and Pardo: helpfulness prediction on Brazilian-Portuguese reviews. We claim novelty only in combination: a complete single-niche dataset, playtime-at-review and the refund window, two linked prediction levels, and a leakage-safe protocol. To our knowledge no prior Steam study frames it this way; do not claim more than that.</a:t>
             </a:r>
           </a:p>
         </p:txBody>
@@ -6145,7 +6221,7 @@
                 <a:ea typeface="Bitstream Charter"/>
                 <a:cs typeface="Bitstream Charter"/>
               </a:rPr>
-              <a:t>17</a:t>
+              <a:t>18</a:t>
             </a:r>
           </a:p>
         </p:txBody>
@@ -7107,7 +7183,7 @@
                 <a:ea typeface="Bitstream Charter"/>
                 <a:cs typeface="Bitstream Charter"/>
               </a:rPr>
-              <a:t>06</a:t>
+              <a:t>07</a:t>
             </a:r>
           </a:p>
         </p:txBody>
@@ -7524,7 +7600,7 @@
                 <a:ea typeface="Bitstream Charter"/>
                 <a:cs typeface="Bitstream Charter"/>
               </a:rPr>
-              <a:t>07</a:t>
+              <a:t>08</a:t>
             </a:r>
           </a:p>
         </p:txBody>
@@ -7977,7 +8053,7 @@
                 <a:ea typeface="Bitstream Charter"/>
                 <a:cs typeface="Bitstream Charter"/>
               </a:rPr>
-              <a:t>08</a:t>
+              <a:t>09</a:t>
             </a:r>
           </a:p>
         </p:txBody>
@@ -8389,7 +8465,7 @@
                 <a:ea typeface="Bitstream Charter"/>
                 <a:cs typeface="Bitstream Charter"/>
               </a:rPr>
-              <a:t>09</a:t>
+              <a:t>10</a:t>
             </a:r>
           </a:p>
         </p:txBody>
@@ -8611,7 +8687,7 @@
                 <a:ea typeface="Bitstream Charter"/>
                 <a:cs typeface="Bitstream Charter"/>
               </a:rPr>
-              <a:t>13</a:t>
+              <a:t>14</a:t>
             </a:r>
           </a:p>
         </p:txBody>
@@ -9645,7 +9721,7 @@
                 <a:ea typeface="Bitstream Charter"/>
                 <a:cs typeface="Bitstream Charter"/>
               </a:rPr>
-              <a:t>14</a:t>
+              <a:t>15</a:t>
             </a:r>
           </a:p>
         </p:txBody>
@@ -10092,7 +10168,7 @@
                 <a:ea typeface="Bitstream Charter"/>
                 <a:cs typeface="Bitstream Charter"/>
               </a:rPr>
-              <a:t>15</a:t>
+              <a:t>16</a:t>
             </a:r>
           </a:p>
         </p:txBody>
@@ -10333,6 +10409,857 @@
                 <a:latin typeface="Bitstream Charter"/>
               </a:rPr>
               <a:t>Importance shows what the model uses, not what causes a bad review; every effect here is an association.</a:t>
+            </a:r>
+          </a:p>
+        </p:txBody>
+      </p:sp>
+    </p:spTree>
+  </p:cSld>
+  <p:clrMapOvr>
+    <a:masterClrMapping/>
+  </p:clrMapOvr>
+</p:sld>
+</file>
+
+<file path=ppt/slides/slide18.xml><?xml version="1.0" encoding="utf-8"?>
+<p:sld xmlns:a="http://schemas.openxmlformats.org/drawingml/2006/main" xmlns:p="http://schemas.openxmlformats.org/presentationml/2006/main" xmlns:r="http://schemas.openxmlformats.org/officeDocument/2006/relationships">
+  <p:cSld>
+    <p:bg>
+      <p:bgPr>
+        <a:solidFill>
+          <a:srgbClr val="F7F9FC"/>
+        </a:solidFill>
+        <a:effectLst/>
+      </p:bgPr>
+    </p:bg>
+    <p:spTree>
+      <p:nvGrpSpPr>
+        <p:cNvPr id="1" name=""/>
+        <p:cNvGrpSpPr/>
+        <p:nvPr/>
+      </p:nvGrpSpPr>
+      <p:grpSpPr/>
+      <p:sp>
+        <p:nvSpPr>
+          <p:cNvPr id="5" name="Rectangle 4">
+            <a:extLst>
+              <a:ext uri="{FF2B5EF4-FFF2-40B4-BE49-F238E27FC236}">
+                <a16:creationId xmlns:a16="http://schemas.microsoft.com/office/drawing/2014/main" id="{27979FDE-990F-4C15-B33C-B2975BF50CD9}"/>
+              </a:ext>
+            </a:extLst>
+          </p:cNvPr>
+          <p:cNvSpPr>
+            <a:spLocks noGrp="1"/>
+          </p:cNvSpPr>
+          <p:nvPr/>
+        </p:nvSpPr>
+        <p:spPr>
+          <a:xfrm>
+            <a:off x="685800" y="523875"/>
+            <a:ext cx="10820400" cy="952500"/>
+          </a:xfrm>
+          <a:prstGeom prst="rect">
+            <a:avLst/>
+          </a:prstGeom>
+          <a:noFill/>
+          <a:ln w="0">
+            <a:noFill/>
+          </a:ln>
+        </p:spPr>
+        <p:txBody>
+          <a:bodyPr wrap="square">
+            <a:noAutofit/>
+          </a:bodyPr>
+          <a:lstStyle/>
+          <a:p>
+            <a:pPr>
+              <a:spcAft>
+                <a:spcPts val="400"/>
+              </a:spcAft>
+              <a:defRPr sz="3300" b="1">
+                <a:solidFill>
+                  <a:srgbClr val="132C43"/>
+                </a:solidFill>
+                <a:latin typeface="Bitstream Charter"/>
+                <a:ea typeface="Bitstream Charter"/>
+                <a:cs typeface="Bitstream Charter"/>
+              </a:defRPr>
+            </a:pPr>
+            <a:r>
+              <a:rPr sz="3300" b="1" i="0">
+                <a:solidFill>
+                  <a:srgbClr val="132C43"/>
+                </a:solidFill>
+                <a:latin typeface="Bitstream Charter"/>
+              </a:rPr>
+              <a:t>Related Work and Our Contribution</a:t>
+            </a:r>
+          </a:p>
+        </p:txBody>
+      </p:sp>
+      <p:sp>
+        <p:nvSpPr>
+          <p:cNvPr id="4" name="Rectangle 3">
+            <a:extLst>
+              <a:ext uri="{FF2B5EF4-FFF2-40B4-BE49-F238E27FC236}">
+                <a16:creationId xmlns:a16="http://schemas.microsoft.com/office/drawing/2014/main" id="{C795E4D0-3C0B-473C-BB65-A65A174FB43B}"/>
+              </a:ext>
+            </a:extLst>
+          </p:cNvPr>
+          <p:cNvSpPr>
+            <a:spLocks noGrp="1"/>
+          </p:cNvSpPr>
+          <p:nvPr/>
+        </p:nvSpPr>
+        <p:spPr>
+          <a:xfrm>
+            <a:off x="11049000" y="6076950"/>
+            <a:ext cx="476250" cy="381000"/>
+          </a:xfrm>
+          <a:prstGeom prst="rect">
+            <a:avLst/>
+          </a:prstGeom>
+          <a:noFill/>
+          <a:ln w="0">
+            <a:noFill/>
+          </a:ln>
+        </p:spPr>
+        <p:txBody>
+          <a:bodyPr>
+            <a:noAutofit/>
+          </a:bodyPr>
+          <a:lstStyle/>
+          <a:p>
+            <a:pPr>
+              <a:defRPr sz="1500" b="0">
+                <a:solidFill>
+                  <a:srgbClr val="48677E"/>
+                </a:solidFill>
+                <a:latin typeface="Bitstream Charter"/>
+                <a:ea typeface="Bitstream Charter"/>
+                <a:cs typeface="Bitstream Charter"/>
+              </a:defRPr>
+            </a:pPr>
+            <a:r>
+              <a:rPr sz="1500" b="0">
+                <a:solidFill>
+                  <a:srgbClr val="48677E"/>
+                </a:solidFill>
+                <a:latin typeface="Bitstream Charter"/>
+                <a:ea typeface="Bitstream Charter"/>
+                <a:cs typeface="Bitstream Charter"/>
+              </a:rPr>
+              <a:t>03</a:t>
+            </a:r>
+          </a:p>
+        </p:txBody>
+      </p:sp>
+      <p:graphicFrame>
+        <p:nvGraphicFramePr>
+          <p:cNvPr id="6" name="Table 5"/>
+          <p:cNvGraphicFramePr>
+            <a:graphicFrameLocks noGrp="1"/>
+          </p:cNvGraphicFramePr>
+          <p:nvPr/>
+        </p:nvGraphicFramePr>
+        <p:xfrm>
+          <a:off x="722376" y="1463040"/>
+          <a:ext cx="6720840" cy="2926080"/>
+        </p:xfrm>
+        <a:graphic>
+          <a:graphicData uri="http://schemas.openxmlformats.org/drawingml/2006/table">
+            <a:tbl>
+              <a:tblPr firstRow="0" bandRow="0">
+                <a:tableStyleId>{2D5ABB26-0587-4C30-8999-92F81FD0307C}</a:tableStyleId>
+              </a:tblPr>
+              <a:tblGrid>
+                <a:gridCol w="1645920"/>
+                <a:gridCol w="2743200"/>
+                <a:gridCol w="2331720"/>
+              </a:tblGrid>
+              <a:tr h="320040">
+                <a:tc>
+                  <a:txBody>
+                    <a:bodyPr wrap="square"/>
+                    <a:lstStyle/>
+                    <a:p>
+                      <a:r>
+                        <a:rPr sz="950" b="1" i="0">
+                          <a:solidFill>
+                            <a:srgbClr val="FFFFFF"/>
+                          </a:solidFill>
+                          <a:latin typeface="Bitstream Charter"/>
+                        </a:rPr>
+                        <a:t>Previous study</a:t>
+                      </a:r>
+                    </a:p>
+                  </a:txBody>
+                  <a:tcPr marL="64008" marR="64008" marT="32004" marB="32004" anchor="ctr">
+                    <a:solidFill>
+                      <a:srgbClr val="132C43"/>
+                    </a:solidFill>
+                  </a:tcPr>
+                </a:tc>
+                <a:tc>
+                  <a:txBody>
+                    <a:bodyPr wrap="square"/>
+                    <a:lstStyle/>
+                    <a:p>
+                      <a:r>
+                        <a:rPr sz="950" b="1" i="0">
+                          <a:solidFill>
+                            <a:srgbClr val="FFFFFF"/>
+                          </a:solidFill>
+                          <a:latin typeface="Bitstream Charter"/>
+                        </a:rPr>
+                        <a:t>What it did</a:t>
+                      </a:r>
+                    </a:p>
+                  </a:txBody>
+                  <a:tcPr marL="64008" marR="64008" marT="32004" marB="32004" anchor="ctr">
+                    <a:solidFill>
+                      <a:srgbClr val="132C43"/>
+                    </a:solidFill>
+                  </a:tcPr>
+                </a:tc>
+                <a:tc>
+                  <a:txBody>
+                    <a:bodyPr wrap="square"/>
+                    <a:lstStyle/>
+                    <a:p>
+                      <a:r>
+                        <a:rPr sz="950" b="1" i="0">
+                          <a:solidFill>
+                            <a:srgbClr val="FFFFFF"/>
+                          </a:solidFill>
+                          <a:latin typeface="Bitstream Charter"/>
+                        </a:rPr>
+                        <a:t>What it leaves open</a:t>
+                      </a:r>
+                    </a:p>
+                  </a:txBody>
+                  <a:tcPr marL="64008" marR="64008" marT="32004" marB="32004" anchor="ctr">
+                    <a:solidFill>
+                      <a:srgbClr val="132C43"/>
+                    </a:solidFill>
+                  </a:tcPr>
+                </a:tc>
+              </a:tr>
+              <a:tr h="868680">
+                <a:tc>
+                  <a:txBody>
+                    <a:bodyPr wrap="square"/>
+                    <a:lstStyle/>
+                    <a:p>
+                      <a:r>
+                        <a:rPr sz="950" b="1" i="0">
+                          <a:solidFill>
+                            <a:srgbClr val="263C50"/>
+                          </a:solidFill>
+                          <a:latin typeface="Bitstream Charter"/>
+                        </a:rPr>
+                        <a:t>Lin et al. (2018)</a:t>
+                      </a:r>
+                      <a:r>
+                        <a:rPr sz="850" b="0" i="0">
+                          <a:solidFill>
+                            <a:srgbClr val="48677E"/>
+                          </a:solidFill>
+                          <a:latin typeface="Bitstream Charter"/>
+                        </a:rPr>
+                        <a:t>
+Empirical Software Eng. [1]</a:t>
+                      </a:r>
+                    </a:p>
+                  </a:txBody>
+                  <a:tcPr marL="64008" marR="64008" marT="32004" marB="32004" anchor="ctr">
+                    <a:lnB w="9525" cap="flat" cmpd="sng" algn="ctr">
+                      <a:solidFill>
+                        <a:srgbClr val="C9D6E2"/>
+                      </a:solidFill>
+                      <a:prstDash val="solid"/>
+                    </a:lnB>
+                    <a:solidFill>
+                      <a:srgbClr val="FFFFFF"/>
+                    </a:solidFill>
+                  </a:tcPr>
+                </a:tc>
+                <a:tc>
+                  <a:txBody>
+                    <a:bodyPr wrap="square"/>
+                    <a:lstStyle/>
+                    <a:p>
+                      <a:r>
+                        <a:rPr sz="950" b="0" i="0">
+                          <a:solidFill>
+                            <a:srgbClr val="263C50"/>
+                          </a:solidFill>
+                          <a:latin typeface="Bitstream Charter"/>
+                        </a:rPr>
+                        <a:t>Studied about 11M reviews of 6,224 Steam games (2016 snapshot): negative reviews come quickly, and players criticise game design more than bugs.</a:t>
+                      </a:r>
+                    </a:p>
+                  </a:txBody>
+                  <a:tcPr marL="64008" marR="64008" marT="32004" marB="32004" anchor="ctr">
+                    <a:lnB w="9525" cap="flat" cmpd="sng" algn="ctr">
+                      <a:solidFill>
+                        <a:srgbClr val="C9D6E2"/>
+                      </a:solidFill>
+                      <a:prstDash val="solid"/>
+                    </a:lnB>
+                    <a:solidFill>
+                      <a:srgbClr val="FFFFFF"/>
+                    </a:solidFill>
+                  </a:tcPr>
+                </a:tc>
+                <a:tc>
+                  <a:txBody>
+                    <a:bodyPr wrap="square"/>
+                    <a:lstStyle/>
+                    <a:p>
+                      <a:r>
+                        <a:rPr sz="950" b="0" i="0">
+                          <a:solidFill>
+                            <a:srgbClr val="263C50"/>
+                          </a:solidFill>
+                          <a:latin typeface="Bitstream Charter"/>
+                        </a:rPr>
+                        <a:t>A whole-platform, descriptive study; not a single niche, and not a model scored on unseen games.</a:t>
+                      </a:r>
+                    </a:p>
+                  </a:txBody>
+                  <a:tcPr marL="64008" marR="64008" marT="32004" marB="32004" anchor="ctr">
+                    <a:lnB w="9525" cap="flat" cmpd="sng" algn="ctr">
+                      <a:solidFill>
+                        <a:srgbClr val="C9D6E2"/>
+                      </a:solidFill>
+                      <a:prstDash val="solid"/>
+                    </a:lnB>
+                    <a:solidFill>
+                      <a:srgbClr val="FFFFFF"/>
+                    </a:solidFill>
+                  </a:tcPr>
+                </a:tc>
+              </a:tr>
+              <a:tr h="868680">
+                <a:tc>
+                  <a:txBody>
+                    <a:bodyPr wrap="square"/>
+                    <a:lstStyle/>
+                    <a:p>
+                      <a:r>
+                        <a:rPr sz="950" b="1" i="0">
+                          <a:solidFill>
+                            <a:srgbClr val="263C50"/>
+                          </a:solidFill>
+                          <a:latin typeface="Bitstream Charter"/>
+                        </a:rPr>
+                        <a:t>De Luisa et al. (2021)</a:t>
+                      </a:r>
+                      <a:r>
+                        <a:rPr sz="850" b="0" i="0">
+                          <a:solidFill>
+                            <a:srgbClr val="48677E"/>
+                          </a:solidFill>
+                          <a:latin typeface="Bitstream Charter"/>
+                        </a:rPr>
+                        <a:t>
+arXiv:2110.02896 [4]</a:t>
+                      </a:r>
+                    </a:p>
+                  </a:txBody>
+                  <a:tcPr marL="64008" marR="64008" marT="32004" marB="32004" anchor="ctr">
+                    <a:lnB w="9525" cap="flat" cmpd="sng" algn="ctr">
+                      <a:solidFill>
+                        <a:srgbClr val="C9D6E2"/>
+                      </a:solidFill>
+                      <a:prstDash val="solid"/>
+                    </a:lnB>
+                    <a:solidFill>
+                      <a:srgbClr val="EAF0F6"/>
+                    </a:solidFill>
+                  </a:tcPr>
+                </a:tc>
+                <a:tc>
+                  <a:txBody>
+                    <a:bodyPr wrap="square"/>
+                    <a:lstStyle/>
+                    <a:p>
+                      <a:r>
+                        <a:rPr sz="950" b="0" i="0">
+                          <a:solidFill>
+                            <a:srgbClr val="263C50"/>
+                          </a:solidFill>
+                          <a:latin typeface="Bitstream Charter"/>
+                        </a:rPr>
+                        <a:t>Bayesian models predict a game's early popularity (player numbers) from price, size, languages, release date and genre.</a:t>
+                      </a:r>
+                    </a:p>
+                  </a:txBody>
+                  <a:tcPr marL="64008" marR="64008" marT="32004" marB="32004" anchor="ctr">
+                    <a:lnB w="9525" cap="flat" cmpd="sng" algn="ctr">
+                      <a:solidFill>
+                        <a:srgbClr val="C9D6E2"/>
+                      </a:solidFill>
+                      <a:prstDash val="solid"/>
+                    </a:lnB>
+                    <a:solidFill>
+                      <a:srgbClr val="EAF0F6"/>
+                    </a:solidFill>
+                  </a:tcPr>
+                </a:tc>
+                <a:tc>
+                  <a:txBody>
+                    <a:bodyPr wrap="square"/>
+                    <a:lstStyle/>
+                    <a:p>
+                      <a:r>
+                        <a:rPr sz="950" b="0" i="0">
+                          <a:solidFill>
+                            <a:srgbClr val="263C50"/>
+                          </a:solidFill>
+                          <a:latin typeface="Bitstream Charter"/>
+                        </a:rPr>
+                        <a:t>Predicts popularity, not review sentiment; ignores what players write and when they write it.</a:t>
+                      </a:r>
+                    </a:p>
+                  </a:txBody>
+                  <a:tcPr marL="64008" marR="64008" marT="32004" marB="32004" anchor="ctr">
+                    <a:lnB w="9525" cap="flat" cmpd="sng" algn="ctr">
+                      <a:solidFill>
+                        <a:srgbClr val="C9D6E2"/>
+                      </a:solidFill>
+                      <a:prstDash val="solid"/>
+                    </a:lnB>
+                    <a:solidFill>
+                      <a:srgbClr val="EAF0F6"/>
+                    </a:solidFill>
+                  </a:tcPr>
+                </a:tc>
+              </a:tr>
+              <a:tr h="868680">
+                <a:tc>
+                  <a:txBody>
+                    <a:bodyPr wrap="square"/>
+                    <a:lstStyle/>
+                    <a:p>
+                      <a:r>
+                        <a:rPr sz="950" b="1" i="0">
+                          <a:solidFill>
+                            <a:srgbClr val="263C50"/>
+                          </a:solidFill>
+                          <a:latin typeface="Bitstream Charter"/>
+                        </a:rPr>
+                        <a:t>Jorge and Pardo (2023)</a:t>
+                      </a:r>
+                      <a:r>
+                        <a:rPr sz="850" b="0" i="0">
+                          <a:solidFill>
+                            <a:srgbClr val="48677E"/>
+                          </a:solidFill>
+                          <a:latin typeface="Bitstream Charter"/>
+                        </a:rPr>
+                        <a:t>
+SteamBR, BraSNAM [5]</a:t>
+                      </a:r>
+                    </a:p>
+                  </a:txBody>
+                  <a:tcPr marL="64008" marR="64008" marT="32004" marB="32004" anchor="ctr">
+                    <a:lnB w="9525" cap="flat" cmpd="sng" algn="ctr">
+                      <a:solidFill>
+                        <a:srgbClr val="C9D6E2"/>
+                      </a:solidFill>
+                      <a:prstDash val="solid"/>
+                    </a:lnB>
+                    <a:solidFill>
+                      <a:srgbClr val="FFFFFF"/>
+                    </a:solidFill>
+                  </a:tcPr>
+                </a:tc>
+                <a:tc>
+                  <a:txBody>
+                    <a:bodyPr wrap="square"/>
+                    <a:lstStyle/>
+                    <a:p>
+                      <a:r>
+                        <a:rPr sz="950" b="0" i="0">
+                          <a:solidFill>
+                            <a:srgbClr val="263C50"/>
+                          </a:solidFill>
+                          <a:latin typeface="Bitstream Charter"/>
+                        </a:rPr>
+                        <a:t>A dataset of 2.8M Brazilian-Portuguese reviews of 12,000+ games, with a model that predicts which reviews are helpful.</a:t>
+                      </a:r>
+                    </a:p>
+                  </a:txBody>
+                  <a:tcPr marL="64008" marR="64008" marT="32004" marB="32004" anchor="ctr">
+                    <a:lnB w="9525" cap="flat" cmpd="sng" algn="ctr">
+                      <a:solidFill>
+                        <a:srgbClr val="C9D6E2"/>
+                      </a:solidFill>
+                      <a:prstDash val="solid"/>
+                    </a:lnB>
+                    <a:solidFill>
+                      <a:srgbClr val="FFFFFF"/>
+                    </a:solidFill>
+                  </a:tcPr>
+                </a:tc>
+                <a:tc>
+                  <a:txBody>
+                    <a:bodyPr wrap="square"/>
+                    <a:lstStyle/>
+                    <a:p>
+                      <a:r>
+                        <a:rPr sz="950" b="0" i="0">
+                          <a:solidFill>
+                            <a:srgbClr val="263C50"/>
+                          </a:solidFill>
+                          <a:latin typeface="Bitstream Charter"/>
+                        </a:rPr>
+                        <a:t>Predicts helpfulness, not whether a review is negative or what a studio should fix.</a:t>
+                      </a:r>
+                    </a:p>
+                  </a:txBody>
+                  <a:tcPr marL="64008" marR="64008" marT="32004" marB="32004" anchor="ctr">
+                    <a:lnB w="9525" cap="flat" cmpd="sng" algn="ctr">
+                      <a:solidFill>
+                        <a:srgbClr val="C9D6E2"/>
+                      </a:solidFill>
+                      <a:prstDash val="solid"/>
+                    </a:lnB>
+                    <a:solidFill>
+                      <a:srgbClr val="FFFFFF"/>
+                    </a:solidFill>
+                  </a:tcPr>
+                </a:tc>
+              </a:tr>
+            </a:tbl>
+          </a:graphicData>
+        </a:graphic>
+      </p:graphicFrame>
+      <p:sp>
+        <p:nvSpPr>
+          <p:cNvPr id="7" name="TextBox 6"/>
+          <p:cNvSpPr txBox="1"/>
+          <p:nvPr/>
+        </p:nvSpPr>
+        <p:spPr>
+          <a:xfrm>
+            <a:off x="722376" y="4526280"/>
+            <a:ext cx="6675120" cy="822960"/>
+          </a:xfrm>
+          <a:prstGeom prst="rect">
+            <a:avLst/>
+          </a:prstGeom>
+          <a:noFill/>
+        </p:spPr>
+        <p:txBody>
+          <a:bodyPr wrap="square" lIns="45720" rIns="45720" tIns="27432" bIns="27432">
+            <a:spAutoFit/>
+          </a:bodyPr>
+          <a:lstStyle/>
+          <a:p>
+            <a:pPr>
+              <a:spcAft>
+                <a:spcPts val="200"/>
+              </a:spcAft>
+            </a:pPr>
+            <a:r>
+              <a:rPr sz="850" b="0" i="0">
+                <a:solidFill>
+                  <a:srgbClr val="48677E"/>
+                </a:solidFill>
+                <a:latin typeface="Bitstream Charter"/>
+              </a:rPr>
+              <a:t>[1] Lin, D., Bezemer, C.-P., Zou, Y., Hassan, A. E. An empirical study of game reviews on the Steam platform. Empirical Software Engineering (2018). doi:10.1007/s10664-018-9627-4</a:t>
+            </a:r>
+          </a:p>
+          <a:p>
+            <a:pPr>
+              <a:spcAft>
+                <a:spcPts val="200"/>
+              </a:spcAft>
+            </a:pPr>
+            <a:r>
+              <a:rPr sz="850" b="0" i="0">
+                <a:solidFill>
+                  <a:srgbClr val="48677E"/>
+                </a:solidFill>
+                <a:latin typeface="Bitstream Charter"/>
+              </a:rPr>
+              <a:t>[4] De Luisa, A., et al. Predicting the Popularity of Games on Steam (2021). arXiv:2110.02896.   [5] Jorge, G. A. Z., Pardo, T. A. S. SteamBR: a dataset for game reviews and evaluation of a state-of-the-art method for helpfulness prediction. BraSNAM (2023).</a:t>
+            </a:r>
+          </a:p>
+        </p:txBody>
+      </p:sp>
+      <p:sp>
+        <p:nvSpPr>
+          <p:cNvPr id="8" name="TextBox 7"/>
+          <p:cNvSpPr txBox="1"/>
+          <p:nvPr/>
+        </p:nvSpPr>
+        <p:spPr>
+          <a:xfrm>
+            <a:off x="7726679" y="1463040"/>
+            <a:ext cx="3794760" cy="4114800"/>
+          </a:xfrm>
+          <a:prstGeom prst="rect">
+            <a:avLst/>
+          </a:prstGeom>
+          <a:noFill/>
+        </p:spPr>
+        <p:txBody>
+          <a:bodyPr wrap="square" lIns="45720" rIns="45720" tIns="27432" bIns="27432">
+            <a:spAutoFit/>
+          </a:bodyPr>
+          <a:lstStyle/>
+          <a:p>
+            <a:pPr>
+              <a:spcAft>
+                <a:spcPts val="600"/>
+              </a:spcAft>
+            </a:pPr>
+            <a:r>
+              <a:rPr sz="1300" b="1" i="0">
+                <a:solidFill>
+                  <a:srgbClr val="132C43"/>
+                </a:solidFill>
+                <a:latin typeface="Bitstream Charter"/>
+              </a:rPr>
+              <a:t>What IndieGuard does differently</a:t>
+            </a:r>
+          </a:p>
+          <a:p>
+            <a:pPr>
+              <a:spcAft>
+                <a:spcPts val="600"/>
+              </a:spcAft>
+            </a:pPr>
+            <a:r>
+              <a:rPr sz="1100" b="1" i="0">
+                <a:solidFill>
+                  <a:srgbClr val="D1495B"/>
+                </a:solidFill>
+                <a:latin typeface="Bitstream Charter"/>
+              </a:rPr>
+              <a:t>1  A niche, collected whole. </a:t>
+            </a:r>
+            <a:r>
+              <a:rPr sz="1100" b="0" i="0">
+                <a:solidFill>
+                  <a:srgbClr val="263C50"/>
+                </a:solidFill>
+                <a:latin typeface="Bitstream Charter"/>
+              </a:rPr>
+              <a:t>1,861 indie roguelikes and 1.65M reviews, scraped by us in October 2026, with 99.95% coverage.</a:t>
+            </a:r>
+          </a:p>
+          <a:p>
+            <a:pPr>
+              <a:spcAft>
+                <a:spcPts val="600"/>
+              </a:spcAft>
+            </a:pPr>
+            <a:r>
+              <a:rPr sz="1100" b="1" i="0">
+                <a:solidFill>
+                  <a:srgbClr val="D1495B"/>
+                </a:solidFill>
+                <a:latin typeface="Bitstream Charter"/>
+              </a:rPr>
+              <a:t>2  Playtime at review. </a:t>
+            </a:r>
+            <a:r>
+              <a:rPr sz="1100" b="0" i="0">
+                <a:solidFill>
+                  <a:srgbClr val="263C50"/>
+                </a:solidFill>
+                <a:latin typeface="Bitstream Charter"/>
+              </a:rPr>
+              <a:t>We separate reviews written inside the 2-hour refund window: 21.2% negative against 8.8% later.</a:t>
+            </a:r>
+          </a:p>
+          <a:p>
+            <a:pPr>
+              <a:spcAft>
+                <a:spcPts val="600"/>
+              </a:spcAft>
+            </a:pPr>
+            <a:r>
+              <a:rPr sz="1100" b="1" i="0">
+                <a:solidFill>
+                  <a:srgbClr val="D1495B"/>
+                </a:solidFill>
+                <a:latin typeface="Bitstream Charter"/>
+              </a:rPr>
+              <a:t>3  Two linked levels. </a:t>
+            </a:r>
+            <a:r>
+              <a:rPr sz="1100" b="0" i="0">
+                <a:solidFill>
+                  <a:srgbClr val="263C50"/>
+                </a:solidFill>
+                <a:latin typeface="Bitstream Charter"/>
+              </a:rPr>
+              <a:t>Review-level negativity and game-level success tiers, plus patch and sale timing.</a:t>
+            </a:r>
+          </a:p>
+          <a:p>
+            <a:pPr>
+              <a:spcAft>
+                <a:spcPts val="600"/>
+              </a:spcAft>
+            </a:pPr>
+            <a:r>
+              <a:rPr sz="1100" b="1" i="0">
+                <a:solidFill>
+                  <a:srgbClr val="D1495B"/>
+                </a:solidFill>
+                <a:latin typeface="Bitstream Charter"/>
+              </a:rPr>
+              <a:t>4  Leakage-safe by design. </a:t>
+            </a:r>
+            <a:r>
+              <a:rPr sz="1100" b="0" i="0">
+                <a:solidFill>
+                  <a:srgbClr val="263C50"/>
+                </a:solidFill>
+                <a:latin typeface="Bitstream Charter"/>
+              </a:rPr>
+              <a:t>Split by game, train-only fitting, baselines, test scored once, and honest negative results.</a:t>
+            </a:r>
+          </a:p>
+          <a:p>
+            <a:pPr>
+              <a:spcAft>
+                <a:spcPts val="600"/>
+              </a:spcAft>
+            </a:pPr>
+            <a:r>
+              <a:rPr sz="1100" b="1" i="0">
+                <a:solidFill>
+                  <a:srgbClr val="D1495B"/>
+                </a:solidFill>
+                <a:latin typeface="Bitstream Charter"/>
+              </a:rPr>
+              <a:t>5  Built for the studio. </a:t>
+            </a:r>
+            <a:r>
+              <a:rPr sz="1100" b="0" i="0">
+                <a:solidFill>
+                  <a:srgbClr val="263C50"/>
+                </a:solidFill>
+                <a:latin typeface="Bitstream Charter"/>
+              </a:rPr>
+              <a:t>Findings say what to fix first and when to patch; Review 2 adds association rules, topic models and a dashboard.</a:t>
+            </a:r>
+          </a:p>
+        </p:txBody>
+      </p:sp>
+      <p:sp>
+        <p:nvSpPr>
+          <p:cNvPr id="9" name="Rectangle 8"/>
+          <p:cNvSpPr/>
+          <p:nvPr/>
+        </p:nvSpPr>
+        <p:spPr>
+          <a:xfrm>
+            <a:off x="722376" y="5577840"/>
+            <a:ext cx="64008" cy="457200"/>
+          </a:xfrm>
+          <a:prstGeom prst="rect">
+            <a:avLst/>
+          </a:prstGeom>
+          <a:solidFill>
+            <a:srgbClr val="D1495B"/>
+          </a:solidFill>
+          <a:ln>
+            <a:noFill/>
+          </a:ln>
+        </p:spPr>
+        <p:style>
+          <a:lnRef idx="1">
+            <a:schemeClr val="accent1"/>
+          </a:lnRef>
+          <a:fillRef idx="3">
+            <a:schemeClr val="accent1"/>
+          </a:fillRef>
+          <a:effectRef idx="2">
+            <a:schemeClr val="accent1"/>
+          </a:effectRef>
+          <a:fontRef idx="minor">
+            <a:schemeClr val="lt1"/>
+          </a:fontRef>
+        </p:style>
+        <p:txBody>
+          <a:bodyPr rtlCol="0" anchor="ctr"/>
+          <a:lstStyle/>
+          <a:p>
+            <a:pPr algn="ctr"/>
+          </a:p>
+        </p:txBody>
+      </p:sp>
+      <p:sp>
+        <p:nvSpPr>
+          <p:cNvPr id="10" name="Rectangle 9"/>
+          <p:cNvSpPr/>
+          <p:nvPr/>
+        </p:nvSpPr>
+        <p:spPr>
+          <a:xfrm>
+            <a:off x="786384" y="5577840"/>
+            <a:ext cx="10680192" cy="457200"/>
+          </a:xfrm>
+          <a:prstGeom prst="rect">
+            <a:avLst/>
+          </a:prstGeom>
+          <a:solidFill>
+            <a:srgbClr val="EAF0F6"/>
+          </a:solidFill>
+          <a:ln>
+            <a:noFill/>
+          </a:ln>
+        </p:spPr>
+        <p:style>
+          <a:lnRef idx="1">
+            <a:schemeClr val="accent1"/>
+          </a:lnRef>
+          <a:fillRef idx="3">
+            <a:schemeClr val="accent1"/>
+          </a:fillRef>
+          <a:effectRef idx="2">
+            <a:schemeClr val="accent1"/>
+          </a:effectRef>
+          <a:fontRef idx="minor">
+            <a:schemeClr val="lt1"/>
+          </a:fontRef>
+        </p:style>
+        <p:txBody>
+          <a:bodyPr rtlCol="0" anchor="ctr" lIns="137160" wrap="square"/>
+          <a:lstStyle/>
+          <a:p>
+            <a:pPr algn="l">
+              <a:spcAft>
+                <a:spcPts val="0"/>
+              </a:spcAft>
+            </a:pPr>
+            <a:r>
+              <a:rPr sz="1250" b="1" i="0">
+                <a:solidFill>
+                  <a:srgbClr val="D1495B"/>
+                </a:solidFill>
+                <a:latin typeface="Bitstream Charter"/>
+              </a:rPr>
+              <a:t>Takeaway  </a:t>
+            </a:r>
+            <a:r>
+              <a:rPr sz="1250" b="1" i="0">
+                <a:solidFill>
+                  <a:srgbClr val="132C43"/>
+                </a:solidFill>
+                <a:latin typeface="Bitstream Charter"/>
+              </a:rPr>
+              <a:t>Same platform, new question: what to fix before the refund window closes, not just what is popular.</a:t>
             </a:r>
           </a:p>
         </p:txBody>
@@ -11090,7 +12017,7 @@
                 <a:ea typeface="Bitstream Charter"/>
                 <a:cs typeface="Bitstream Charter"/>
               </a:rPr>
-              <a:t>03</a:t>
+              <a:t>04</a:t>
             </a:r>
           </a:p>
         </p:txBody>
@@ -13401,7 +14328,7 @@
                 <a:ea typeface="Bitstream Charter"/>
                 <a:cs typeface="Bitstream Charter"/>
               </a:rPr>
-              <a:t>04</a:t>
+              <a:t>05</a:t>
             </a:r>
           </a:p>
         </p:txBody>
@@ -14782,7 +15709,7 @@
                 <a:ea typeface="Bitstream Charter"/>
                 <a:cs typeface="Bitstream Charter"/>
               </a:rPr>
-              <a:t>05</a:t>
+              <a:t>06</a:t>
             </a:r>
           </a:p>
         </p:txBody>
@@ -15086,7 +16013,7 @@
                 <a:ea typeface="Bitstream Charter"/>
                 <a:cs typeface="Bitstream Charter"/>
               </a:rPr>
-              <a:t>10</a:t>
+              <a:t>11</a:t>
             </a:r>
           </a:p>
         </p:txBody>
@@ -15654,7 +16581,7 @@
                 <a:ea typeface="Bitstream Charter"/>
                 <a:cs typeface="Bitstream Charter"/>
               </a:rPr>
-              <a:t>11</a:t>
+              <a:t>12</a:t>
             </a:r>
           </a:p>
         </p:txBody>
@@ -16379,7 +17306,7 @@
                 <a:ea typeface="Bitstream Charter"/>
                 <a:cs typeface="Bitstream Charter"/>
               </a:rPr>
-              <a:t>12</a:t>
+              <a:t>13</a:t>
             </a:r>
           </a:p>
         </p:txBody>
@@ -17702,7 +18629,7 @@
                 <a:ea typeface="Bitstream Charter"/>
                 <a:cs typeface="Bitstream Charter"/>
               </a:rPr>
-              <a:t>16</a:t>
+              <a:t>17</a:t>
             </a:r>
           </a:p>
         </p:txBody>
@@ -19423,7 +20350,7 @@
                 </a:solidFill>
                 <a:latin typeface="Bitstream Charter"/>
               </a:rPr>
-              <a:t>36 commits and 12 merged pull requests so far.</a:t>
+              <a:t>37 commits and 12 merged pull requests so far.</a:t>
             </a:r>
           </a:p>
           <a:p>

</xml_diff>

<commit_message>
Slides: add two data acquisition slides (pipeline, one game step by step)
</commit_message>
<xml_diff>
--- a/slides/review1.pptx
+++ b/slides/review1.pptx
@@ -12,6 +12,8 @@
     <p:sldId id="257" r:id="rId3"/>
     <p:sldId id="273" r:id="rId24"/>
     <p:sldId id="258" r:id="rId4"/>
+    <p:sldId id="274" r:id="rId25"/>
+    <p:sldId id="275" r:id="rId26"/>
     <p:sldId id="259" r:id="rId5"/>
     <p:sldId id="260" r:id="rId6"/>
     <p:sldId id="266" r:id="rId17"/>
@@ -4669,6 +4671,81 @@
 </p:notes>
 </file>
 
+<file path=ppt/notesSlides/notesSlide19.xml><?xml version="1.0" encoding="utf-8"?>
+<p:notes xmlns:a="http://schemas.openxmlformats.org/drawingml/2006/main" xmlns:p="http://schemas.openxmlformats.org/presentationml/2006/main" xmlns:r="http://schemas.openxmlformats.org/officeDocument/2006/relationships">
+  <p:cSld>
+    <p:spTree>
+      <p:nvGrpSpPr>
+        <p:cNvPr id="1" name=""/>
+        <p:cNvGrpSpPr/>
+        <p:nvPr/>
+      </p:nvGrpSpPr>
+      <p:grpSpPr>
+        <a:xfrm>
+          <a:off x="0" y="0"/>
+          <a:ext cx="0" cy="0"/>
+          <a:chOff x="0" y="0"/>
+          <a:chExt cx="0" cy="0"/>
+        </a:xfrm>
+      </p:grpSpPr>
+      <p:sp>
+        <p:nvSpPr>
+          <p:cNvPr id="2" name="Slide Image Placeholder 1"/>
+          <p:cNvSpPr>
+            <a:spLocks noGrp="1"/>
+          </p:cNvSpPr>
+          <p:nvPr>
+            <p:ph type="sldImg" idx="2"/>
+          </p:nvPr>
+        </p:nvSpPr>
+        <p:spPr/>
+      </p:sp>
+      <p:sp>
+        <p:nvSpPr>
+          <p:cNvPr id="3" name="Notes Placeholder 2"/>
+          <p:cNvSpPr>
+            <a:spLocks noGrp="1"/>
+          </p:cNvSpPr>
+          <p:nvPr>
+            <p:ph type="body" idx="3" sz="quarter"/>
+          </p:nvPr>
+        </p:nvSpPr>
+        <p:spPr/>
+        <p:txBody>
+          <a:bodyPr/>
+          <a:lstStyle/>
+          <a:p>
+            <a:r>
+              <a:t>Suggested speaker: Shantharam. 0:45.</a:t>
+            </a:r>
+          </a:p>
+          <a:p>
+            <a:r>
+              <a:t>Walk left to right. Stage 1 finds the 1,861 games. Stage 2 is the scraper: five kinds of file per game (store page, tags, SteamSpy, news, reviews). Stages 3 and 4 turn raw JSON into clean tables; only empty reviews are dropped. Stage 5 is what the models read. The four boxes underneath are the safety rails: throttling, retry and resume, privacy, and the frozen manifest.</a:t>
+            </a:r>
+          </a:p>
+        </p:txBody>
+      </p:sp>
+      <p:sp>
+        <p:nvSpPr>
+          <p:cNvPr id="4" name="Slide Number Placeholder 3"/>
+          <p:cNvSpPr>
+            <a:spLocks noGrp="1"/>
+          </p:cNvSpPr>
+          <p:nvPr>
+            <p:ph type="sldNum" idx="5" sz="quarter"/>
+          </p:nvPr>
+        </p:nvSpPr>
+        <p:spPr/>
+      </p:sp>
+    </p:spTree>
+  </p:cSld>
+  <p:clrMapOvr>
+    <a:masterClrMapping/>
+  </p:clrMapOvr>
+</p:notes>
+</file>
+
 <file path=ppt/notesSlides/notesSlide2.xml><?xml version="1.0" encoding="utf-8"?>
 <p:notes xmlns:a="http://schemas.openxmlformats.org/drawingml/2006/main" xmlns:r="http://schemas.openxmlformats.org/officeDocument/2006/relationships" xmlns:p="http://schemas.openxmlformats.org/presentationml/2006/main">
   <p:cSld>
@@ -4742,6 +4819,81 @@
             <a:endParaRPr/>
           </a:p>
         </p:txBody>
+      </p:sp>
+    </p:spTree>
+  </p:cSld>
+  <p:clrMapOvr>
+    <a:masterClrMapping/>
+  </p:clrMapOvr>
+</p:notes>
+</file>
+
+<file path=ppt/notesSlides/notesSlide20.xml><?xml version="1.0" encoding="utf-8"?>
+<p:notes xmlns:a="http://schemas.openxmlformats.org/drawingml/2006/main" xmlns:p="http://schemas.openxmlformats.org/presentationml/2006/main" xmlns:r="http://schemas.openxmlformats.org/officeDocument/2006/relationships">
+  <p:cSld>
+    <p:spTree>
+      <p:nvGrpSpPr>
+        <p:cNvPr id="1" name=""/>
+        <p:cNvGrpSpPr/>
+        <p:nvPr/>
+      </p:nvGrpSpPr>
+      <p:grpSpPr>
+        <a:xfrm>
+          <a:off x="0" y="0"/>
+          <a:ext cx="0" cy="0"/>
+          <a:chOff x="0" y="0"/>
+          <a:chExt cx="0" cy="0"/>
+        </a:xfrm>
+      </p:grpSpPr>
+      <p:sp>
+        <p:nvSpPr>
+          <p:cNvPr id="2" name="Slide Image Placeholder 1"/>
+          <p:cNvSpPr>
+            <a:spLocks noGrp="1"/>
+          </p:cNvSpPr>
+          <p:nvPr>
+            <p:ph type="sldImg" idx="2"/>
+          </p:nvPr>
+        </p:nvSpPr>
+        <p:spPr/>
+      </p:sp>
+      <p:sp>
+        <p:nvSpPr>
+          <p:cNvPr id="3" name="Notes Placeholder 2"/>
+          <p:cNvSpPr>
+            <a:spLocks noGrp="1"/>
+          </p:cNvSpPr>
+          <p:nvPr>
+            <p:ph type="body" idx="3" sz="quarter"/>
+          </p:nvPr>
+        </p:nvSpPr>
+        <p:spPr/>
+        <p:txBody>
+          <a:bodyPr/>
+          <a:lstStyle/>
+          <a:p>
+            <a:r>
+              <a:t>Suggested speaker: Shantharam. 0:45.</a:t>
+            </a:r>
+          </a:p>
+          <a:p>
+            <a:r>
+              <a:t>This is the loop in src/collect/reviews.py (scrape_game). Steam gives a cursor with each page; we send it back for the next page. Every page is appended and checkpointed, so a crash resumes at the same page. The table on the right is one real record: the two things we remove are personal details and hardware; the reviewer ID becomes a salted hash. Coverage check: the .done.json file stores Steam's reported total next to the number we got (99.95% for complete games).</a:t>
+            </a:r>
+          </a:p>
+        </p:txBody>
+      </p:sp>
+      <p:sp>
+        <p:nvSpPr>
+          <p:cNvPr id="4" name="Slide Number Placeholder 3"/>
+          <p:cNvSpPr>
+            <a:spLocks noGrp="1"/>
+          </p:cNvSpPr>
+          <p:nvPr>
+            <p:ph type="sldNum" idx="5" sz="quarter"/>
+          </p:nvPr>
+        </p:nvSpPr>
+        <p:spPr/>
       </p:sp>
     </p:spTree>
   </p:cSld>
@@ -6221,7 +6373,7 @@
                 <a:ea typeface="Bitstream Charter"/>
                 <a:cs typeface="Bitstream Charter"/>
               </a:rPr>
-              <a:t>18</a:t>
+              <a:t>20</a:t>
             </a:r>
           </a:p>
         </p:txBody>
@@ -7183,7 +7335,7 @@
                 <a:ea typeface="Bitstream Charter"/>
                 <a:cs typeface="Bitstream Charter"/>
               </a:rPr>
-              <a:t>07</a:t>
+              <a:t>09</a:t>
             </a:r>
           </a:p>
         </p:txBody>
@@ -7600,7 +7752,7 @@
                 <a:ea typeface="Bitstream Charter"/>
                 <a:cs typeface="Bitstream Charter"/>
               </a:rPr>
-              <a:t>08</a:t>
+              <a:t>10</a:t>
             </a:r>
           </a:p>
         </p:txBody>
@@ -8053,7 +8205,7 @@
                 <a:ea typeface="Bitstream Charter"/>
                 <a:cs typeface="Bitstream Charter"/>
               </a:rPr>
-              <a:t>09</a:t>
+              <a:t>11</a:t>
             </a:r>
           </a:p>
         </p:txBody>
@@ -8465,7 +8617,7 @@
                 <a:ea typeface="Bitstream Charter"/>
                 <a:cs typeface="Bitstream Charter"/>
               </a:rPr>
-              <a:t>10</a:t>
+              <a:t>12</a:t>
             </a:r>
           </a:p>
         </p:txBody>
@@ -8687,7 +8839,7 @@
                 <a:ea typeface="Bitstream Charter"/>
                 <a:cs typeface="Bitstream Charter"/>
               </a:rPr>
-              <a:t>14</a:t>
+              <a:t>16</a:t>
             </a:r>
           </a:p>
         </p:txBody>
@@ -9721,7 +9873,7 @@
                 <a:ea typeface="Bitstream Charter"/>
                 <a:cs typeface="Bitstream Charter"/>
               </a:rPr>
-              <a:t>15</a:t>
+              <a:t>17</a:t>
             </a:r>
           </a:p>
         </p:txBody>
@@ -10168,7 +10320,7 @@
                 <a:ea typeface="Bitstream Charter"/>
                 <a:cs typeface="Bitstream Charter"/>
               </a:rPr>
-              <a:t>16</a:t>
+              <a:t>18</a:t>
             </a:r>
           </a:p>
         </p:txBody>
@@ -11260,6 +11412,1994 @@
                 <a:latin typeface="Bitstream Charter"/>
               </a:rPr>
               <a:t>Same platform, new question: what to fix before the refund window closes, not just what is popular.</a:t>
+            </a:r>
+          </a:p>
+        </p:txBody>
+      </p:sp>
+    </p:spTree>
+  </p:cSld>
+  <p:clrMapOvr>
+    <a:masterClrMapping/>
+  </p:clrMapOvr>
+</p:sld>
+</file>
+
+<file path=ppt/slides/slide19.xml><?xml version="1.0" encoding="utf-8"?>
+<p:sld xmlns:a="http://schemas.openxmlformats.org/drawingml/2006/main" xmlns:p="http://schemas.openxmlformats.org/presentationml/2006/main" xmlns:r="http://schemas.openxmlformats.org/officeDocument/2006/relationships">
+  <p:cSld>
+    <p:bg>
+      <p:bgPr>
+        <a:solidFill>
+          <a:srgbClr val="F7F9FC"/>
+        </a:solidFill>
+        <a:effectLst/>
+      </p:bgPr>
+    </p:bg>
+    <p:spTree>
+      <p:nvGrpSpPr>
+        <p:cNvPr id="1" name=""/>
+        <p:cNvGrpSpPr/>
+        <p:nvPr/>
+      </p:nvGrpSpPr>
+      <p:grpSpPr/>
+      <p:sp>
+        <p:nvSpPr>
+          <p:cNvPr id="5" name="Rectangle 4">
+            <a:extLst>
+              <a:ext uri="{FF2B5EF4-FFF2-40B4-BE49-F238E27FC236}">
+                <a16:creationId xmlns:a16="http://schemas.microsoft.com/office/drawing/2014/main" id="{27979FDE-990F-4C15-B33C-B2975BF50CD9}"/>
+              </a:ext>
+            </a:extLst>
+          </p:cNvPr>
+          <p:cNvSpPr>
+            <a:spLocks noGrp="1"/>
+          </p:cNvSpPr>
+          <p:nvPr/>
+        </p:nvSpPr>
+        <p:spPr>
+          <a:xfrm>
+            <a:off x="685800" y="523875"/>
+            <a:ext cx="10820400" cy="952500"/>
+          </a:xfrm>
+          <a:prstGeom prst="rect">
+            <a:avLst/>
+          </a:prstGeom>
+          <a:noFill/>
+          <a:ln w="0">
+            <a:noFill/>
+          </a:ln>
+        </p:spPr>
+        <p:txBody>
+          <a:bodyPr wrap="square">
+            <a:noAutofit/>
+          </a:bodyPr>
+          <a:lstStyle/>
+          <a:p>
+            <a:pPr>
+              <a:spcAft>
+                <a:spcPts val="400"/>
+              </a:spcAft>
+              <a:defRPr sz="3300" b="1">
+                <a:solidFill>
+                  <a:srgbClr val="132C43"/>
+                </a:solidFill>
+                <a:latin typeface="Bitstream Charter"/>
+                <a:ea typeface="Bitstream Charter"/>
+                <a:cs typeface="Bitstream Charter"/>
+              </a:defRPr>
+            </a:pPr>
+            <a:r>
+              <a:rPr sz="3300" b="1" i="0">
+                <a:solidFill>
+                  <a:srgbClr val="132C43"/>
+                </a:solidFill>
+                <a:latin typeface="Bitstream Charter"/>
+              </a:rPr>
+              <a:t>Data Acquisition: The Pipeline</a:t>
+            </a:r>
+          </a:p>
+        </p:txBody>
+      </p:sp>
+      <p:sp>
+        <p:nvSpPr>
+          <p:cNvPr id="4" name="Rectangle 3">
+            <a:extLst>
+              <a:ext uri="{FF2B5EF4-FFF2-40B4-BE49-F238E27FC236}">
+                <a16:creationId xmlns:a16="http://schemas.microsoft.com/office/drawing/2014/main" id="{C795E4D0-3C0B-473C-BB65-A65A174FB43B}"/>
+              </a:ext>
+            </a:extLst>
+          </p:cNvPr>
+          <p:cNvSpPr>
+            <a:spLocks noGrp="1"/>
+          </p:cNvSpPr>
+          <p:nvPr/>
+        </p:nvSpPr>
+        <p:spPr>
+          <a:xfrm>
+            <a:off x="11049000" y="6076950"/>
+            <a:ext cx="476250" cy="381000"/>
+          </a:xfrm>
+          <a:prstGeom prst="rect">
+            <a:avLst/>
+          </a:prstGeom>
+          <a:noFill/>
+          <a:ln w="0">
+            <a:noFill/>
+          </a:ln>
+        </p:spPr>
+        <p:txBody>
+          <a:bodyPr>
+            <a:noAutofit/>
+          </a:bodyPr>
+          <a:lstStyle/>
+          <a:p>
+            <a:pPr>
+              <a:defRPr sz="1500" b="0">
+                <a:solidFill>
+                  <a:srgbClr val="48677E"/>
+                </a:solidFill>
+                <a:latin typeface="Bitstream Charter"/>
+                <a:ea typeface="Bitstream Charter"/>
+                <a:cs typeface="Bitstream Charter"/>
+              </a:defRPr>
+            </a:pPr>
+            <a:r>
+              <a:rPr sz="1500" b="0">
+                <a:solidFill>
+                  <a:srgbClr val="48677E"/>
+                </a:solidFill>
+                <a:latin typeface="Bitstream Charter"/>
+                <a:ea typeface="Bitstream Charter"/>
+                <a:cs typeface="Bitstream Charter"/>
+              </a:rPr>
+              <a:t>05</a:t>
+            </a:r>
+          </a:p>
+        </p:txBody>
+      </p:sp>
+      <p:sp>
+        <p:nvSpPr>
+          <p:cNvPr id="6" name="Rectangle 5"/>
+          <p:cNvSpPr/>
+          <p:nvPr/>
+        </p:nvSpPr>
+        <p:spPr>
+          <a:xfrm>
+            <a:off x="722376" y="1508760"/>
+            <a:ext cx="1993392" cy="457200"/>
+          </a:xfrm>
+          <a:prstGeom prst="rect">
+            <a:avLst/>
+          </a:prstGeom>
+          <a:solidFill>
+            <a:srgbClr val="132C43"/>
+          </a:solidFill>
+          <a:ln>
+            <a:noFill/>
+          </a:ln>
+          <a:effectLst/>
+        </p:spPr>
+        <p:style>
+          <a:lnRef idx="1">
+            <a:schemeClr val="accent1"/>
+          </a:lnRef>
+          <a:fillRef idx="3">
+            <a:schemeClr val="accent1"/>
+          </a:fillRef>
+          <a:effectRef idx="2">
+            <a:schemeClr val="accent1"/>
+          </a:effectRef>
+          <a:fontRef idx="minor">
+            <a:schemeClr val="lt1"/>
+          </a:fontRef>
+        </p:style>
+        <p:txBody>
+          <a:bodyPr rtlCol="0" anchor="ctr" wrap="square"/>
+          <a:lstStyle/>
+          <a:p>
+            <a:pPr algn="l">
+              <a:spcAft>
+                <a:spcPts val="200"/>
+              </a:spcAft>
+            </a:pPr>
+            <a:r>
+              <a:rPr sz="1250" b="1" i="0">
+                <a:solidFill>
+                  <a:srgbClr val="FFFFFF"/>
+                </a:solidFill>
+                <a:latin typeface="Bitstream Charter"/>
+              </a:rPr>
+              <a:t>1  Find the games</a:t>
+            </a:r>
+          </a:p>
+        </p:txBody>
+      </p:sp>
+      <p:sp>
+        <p:nvSpPr>
+          <p:cNvPr id="7" name="Rectangle 6"/>
+          <p:cNvSpPr/>
+          <p:nvPr/>
+        </p:nvSpPr>
+        <p:spPr>
+          <a:xfrm>
+            <a:off x="722376" y="1965960"/>
+            <a:ext cx="1993392" cy="1600200"/>
+          </a:xfrm>
+          <a:prstGeom prst="rect">
+            <a:avLst/>
+          </a:prstGeom>
+          <a:solidFill>
+            <a:srgbClr val="FFFFFF"/>
+          </a:solidFill>
+          <a:ln w="9525">
+            <a:solidFill>
+              <a:srgbClr val="C9D6E2"/>
+            </a:solidFill>
+          </a:ln>
+          <a:effectLst/>
+        </p:spPr>
+        <p:style>
+          <a:lnRef idx="1">
+            <a:schemeClr val="accent1"/>
+          </a:lnRef>
+          <a:fillRef idx="3">
+            <a:schemeClr val="accent1"/>
+          </a:fillRef>
+          <a:effectRef idx="2">
+            <a:schemeClr val="accent1"/>
+          </a:effectRef>
+          <a:fontRef idx="minor">
+            <a:schemeClr val="lt1"/>
+          </a:fontRef>
+        </p:style>
+        <p:txBody>
+          <a:bodyPr rtlCol="0" anchor="t" wrap="square"/>
+          <a:lstStyle/>
+          <a:p>
+            <a:pPr algn="l">
+              <a:spcAft>
+                <a:spcPts val="400"/>
+              </a:spcAft>
+            </a:pPr>
+            <a:r>
+              <a:rPr sz="1000" b="1" i="0">
+                <a:solidFill>
+                  <a:srgbClr val="48677E"/>
+                </a:solidFill>
+                <a:latin typeface="Bitstream Charter"/>
+              </a:rPr>
+              <a:t>Store search</a:t>
+            </a:r>
+          </a:p>
+          <a:p>
+            <a:pPr algn="l">
+              <a:spcAft>
+                <a:spcPts val="400"/>
+              </a:spcAft>
+            </a:pPr>
+            <a:r>
+              <a:rPr sz="1150" b="0" i="0">
+                <a:solidFill>
+                  <a:srgbClr val="263C50"/>
+                </a:solidFill>
+                <a:latin typeface="Bitstream Charter"/>
+              </a:rPr>
+              <a:t>• Tags: Indie + 5 roguelike tags</a:t>
+            </a:r>
+          </a:p>
+          <a:p>
+            <a:pPr algn="l">
+              <a:spcAft>
+                <a:spcPts val="400"/>
+              </a:spcAft>
+            </a:pPr>
+            <a:r>
+              <a:rPr sz="1150" b="0" i="0">
+                <a:solidFill>
+                  <a:srgbClr val="263C50"/>
+                </a:solidFill>
+                <a:latin typeface="Bitstream Charter"/>
+              </a:rPr>
+              <a:t>• Released 2022 to 2025</a:t>
+            </a:r>
+          </a:p>
+          <a:p>
+            <a:pPr algn="l">
+              <a:spcAft>
+                <a:spcPts val="400"/>
+              </a:spcAft>
+            </a:pPr>
+            <a:r>
+              <a:rPr sz="1150" b="0" i="0">
+                <a:solidFill>
+                  <a:srgbClr val="263C50"/>
+                </a:solidFill>
+                <a:latin typeface="Bitstream Charter"/>
+              </a:rPr>
+              <a:t>• Games only, newest first</a:t>
+            </a:r>
+          </a:p>
+        </p:txBody>
+      </p:sp>
+      <p:sp>
+        <p:nvSpPr>
+          <p:cNvPr id="8" name="Rectangle 7"/>
+          <p:cNvSpPr/>
+          <p:nvPr/>
+        </p:nvSpPr>
+        <p:spPr>
+          <a:xfrm>
+            <a:off x="722376" y="3566160"/>
+            <a:ext cx="1993392" cy="914400"/>
+          </a:xfrm>
+          <a:prstGeom prst="rect">
+            <a:avLst/>
+          </a:prstGeom>
+          <a:solidFill>
+            <a:srgbClr val="EAF0F6"/>
+          </a:solidFill>
+          <a:ln w="9525">
+            <a:solidFill>
+              <a:srgbClr val="C9D6E2"/>
+            </a:solidFill>
+          </a:ln>
+          <a:effectLst/>
+        </p:spPr>
+        <p:style>
+          <a:lnRef idx="1">
+            <a:schemeClr val="accent1"/>
+          </a:lnRef>
+          <a:fillRef idx="3">
+            <a:schemeClr val="accent1"/>
+          </a:fillRef>
+          <a:effectRef idx="2">
+            <a:schemeClr val="accent1"/>
+          </a:effectRef>
+          <a:fontRef idx="minor">
+            <a:schemeClr val="lt1"/>
+          </a:fontRef>
+        </p:style>
+        <p:txBody>
+          <a:bodyPr rtlCol="0" anchor="t" wrap="square"/>
+          <a:lstStyle/>
+          <a:p>
+            <a:pPr algn="l">
+              <a:spcAft>
+                <a:spcPts val="100"/>
+              </a:spcAft>
+            </a:pPr>
+            <a:r>
+              <a:rPr sz="850" b="1" i="0">
+                <a:solidFill>
+                  <a:srgbClr val="48677E"/>
+                </a:solidFill>
+                <a:latin typeface="Bitstream Charter"/>
+              </a:rPr>
+              <a:t>OUTPUT</a:t>
+            </a:r>
+          </a:p>
+          <a:p>
+            <a:pPr algn="l">
+              <a:spcAft>
+                <a:spcPts val="100"/>
+              </a:spcAft>
+            </a:pPr>
+            <a:r>
+              <a:rPr sz="1000" b="0" i="0">
+                <a:solidFill>
+                  <a:srgbClr val="263C50"/>
+                </a:solidFill>
+                <a:latin typeface="Bitstream Charter"/>
+              </a:rPr>
+              <a:t>universe/candidates.csv</a:t>
+            </a:r>
+          </a:p>
+          <a:p>
+            <a:pPr algn="l">
+              <a:spcAft>
+                <a:spcPts val="100"/>
+              </a:spcAft>
+            </a:pPr>
+            <a:r>
+              <a:rPr sz="1200" b="1" i="0">
+                <a:solidFill>
+                  <a:srgbClr val="132C43"/>
+                </a:solidFill>
+                <a:latin typeface="Bitstream Charter"/>
+              </a:rPr>
+              <a:t>1,861 games</a:t>
+            </a:r>
+          </a:p>
+        </p:txBody>
+      </p:sp>
+      <p:sp>
+        <p:nvSpPr>
+          <p:cNvPr id="9" name="Right Arrow 8"/>
+          <p:cNvSpPr/>
+          <p:nvPr/>
+        </p:nvSpPr>
+        <p:spPr>
+          <a:xfrm>
+            <a:off x="2697480" y="1600200"/>
+            <a:ext cx="219456" cy="274320"/>
+          </a:xfrm>
+          <a:prstGeom prst="rightArrow">
+            <a:avLst/>
+          </a:prstGeom>
+          <a:solidFill>
+            <a:srgbClr val="D1495B"/>
+          </a:solidFill>
+          <a:ln>
+            <a:noFill/>
+          </a:ln>
+          <a:effectLst/>
+        </p:spPr>
+        <p:style>
+          <a:lnRef idx="1">
+            <a:schemeClr val="accent1"/>
+          </a:lnRef>
+          <a:fillRef idx="3">
+            <a:schemeClr val="accent1"/>
+          </a:fillRef>
+          <a:effectRef idx="2">
+            <a:schemeClr val="accent1"/>
+          </a:effectRef>
+          <a:fontRef idx="minor">
+            <a:schemeClr val="lt1"/>
+          </a:fontRef>
+        </p:style>
+        <p:txBody>
+          <a:bodyPr rtlCol="0" anchor="ctr"/>
+          <a:lstStyle/>
+          <a:p>
+            <a:pPr algn="ctr"/>
+          </a:p>
+        </p:txBody>
+      </p:sp>
+      <p:sp>
+        <p:nvSpPr>
+          <p:cNvPr id="10" name="Rectangle 9"/>
+          <p:cNvSpPr/>
+          <p:nvPr/>
+        </p:nvSpPr>
+        <p:spPr>
+          <a:xfrm>
+            <a:off x="2898648" y="1508760"/>
+            <a:ext cx="1993392" cy="457200"/>
+          </a:xfrm>
+          <a:prstGeom prst="rect">
+            <a:avLst/>
+          </a:prstGeom>
+          <a:solidFill>
+            <a:srgbClr val="D1495B"/>
+          </a:solidFill>
+          <a:ln>
+            <a:noFill/>
+          </a:ln>
+          <a:effectLst/>
+        </p:spPr>
+        <p:style>
+          <a:lnRef idx="1">
+            <a:schemeClr val="accent1"/>
+          </a:lnRef>
+          <a:fillRef idx="3">
+            <a:schemeClr val="accent1"/>
+          </a:fillRef>
+          <a:effectRef idx="2">
+            <a:schemeClr val="accent1"/>
+          </a:effectRef>
+          <a:fontRef idx="minor">
+            <a:schemeClr val="lt1"/>
+          </a:fontRef>
+        </p:style>
+        <p:txBody>
+          <a:bodyPr rtlCol="0" anchor="ctr" wrap="square"/>
+          <a:lstStyle/>
+          <a:p>
+            <a:pPr algn="l">
+              <a:spcAft>
+                <a:spcPts val="200"/>
+              </a:spcAft>
+            </a:pPr>
+            <a:r>
+              <a:rPr sz="1250" b="1" i="0">
+                <a:solidFill>
+                  <a:srgbClr val="FFFFFF"/>
+                </a:solidFill>
+                <a:latin typeface="Bitstream Charter"/>
+              </a:rPr>
+              <a:t>2  Collect</a:t>
+            </a:r>
+          </a:p>
+        </p:txBody>
+      </p:sp>
+      <p:sp>
+        <p:nvSpPr>
+          <p:cNvPr id="11" name="Rectangle 10"/>
+          <p:cNvSpPr/>
+          <p:nvPr/>
+        </p:nvSpPr>
+        <p:spPr>
+          <a:xfrm>
+            <a:off x="2898648" y="1965960"/>
+            <a:ext cx="1993392" cy="1600200"/>
+          </a:xfrm>
+          <a:prstGeom prst="rect">
+            <a:avLst/>
+          </a:prstGeom>
+          <a:solidFill>
+            <a:srgbClr val="FFFFFF"/>
+          </a:solidFill>
+          <a:ln w="9525">
+            <a:solidFill>
+              <a:srgbClr val="C9D6E2"/>
+            </a:solidFill>
+          </a:ln>
+          <a:effectLst/>
+        </p:spPr>
+        <p:style>
+          <a:lnRef idx="1">
+            <a:schemeClr val="accent1"/>
+          </a:lnRef>
+          <a:fillRef idx="3">
+            <a:schemeClr val="accent1"/>
+          </a:fillRef>
+          <a:effectRef idx="2">
+            <a:schemeClr val="accent1"/>
+          </a:effectRef>
+          <a:fontRef idx="minor">
+            <a:schemeClr val="lt1"/>
+          </a:fontRef>
+        </p:style>
+        <p:txBody>
+          <a:bodyPr rtlCol="0" anchor="t" wrap="square"/>
+          <a:lstStyle/>
+          <a:p>
+            <a:pPr algn="l">
+              <a:spcAft>
+                <a:spcPts val="400"/>
+              </a:spcAft>
+            </a:pPr>
+            <a:r>
+              <a:rPr sz="1000" b="1" i="0">
+                <a:solidFill>
+                  <a:srgbClr val="48677E"/>
+                </a:solidFill>
+                <a:latin typeface="Bitstream Charter"/>
+              </a:rPr>
+              <a:t>Steam and SteamSpy APIs</a:t>
+            </a:r>
+          </a:p>
+          <a:p>
+            <a:pPr algn="l">
+              <a:spcAft>
+                <a:spcPts val="400"/>
+              </a:spcAft>
+            </a:pPr>
+            <a:r>
+              <a:rPr sz="1150" b="0" i="0">
+                <a:solidFill>
+                  <a:srgbClr val="263C50"/>
+                </a:solidFill>
+                <a:latin typeface="Bitstream Charter"/>
+              </a:rPr>
+              <a:t>• Store page and tags</a:t>
+            </a:r>
+          </a:p>
+          <a:p>
+            <a:pPr algn="l">
+              <a:spcAft>
+                <a:spcPts val="400"/>
+              </a:spcAft>
+            </a:pPr>
+            <a:r>
+              <a:rPr sz="1150" b="0" i="0">
+                <a:solidFill>
+                  <a:srgbClr val="263C50"/>
+                </a:solidFill>
+                <a:latin typeface="Bitstream Charter"/>
+              </a:rPr>
+              <a:t>• SteamSpy owners</a:t>
+            </a:r>
+          </a:p>
+          <a:p>
+            <a:pPr algn="l">
+              <a:spcAft>
+                <a:spcPts val="400"/>
+              </a:spcAft>
+            </a:pPr>
+            <a:r>
+              <a:rPr sz="1150" b="0" i="0">
+                <a:solidFill>
+                  <a:srgbClr val="263C50"/>
+                </a:solidFill>
+                <a:latin typeface="Bitstream Charter"/>
+              </a:rPr>
+              <a:t>• News (patches, sales)</a:t>
+            </a:r>
+          </a:p>
+          <a:p>
+            <a:pPr algn="l">
+              <a:spcAft>
+                <a:spcPts val="400"/>
+              </a:spcAft>
+            </a:pPr>
+            <a:r>
+              <a:rPr sz="1150" b="0" i="0">
+                <a:solidFill>
+                  <a:srgbClr val="263C50"/>
+                </a:solidFill>
+                <a:latin typeface="Bitstream Charter"/>
+              </a:rPr>
+              <a:t>• Reviews, 100 per page</a:t>
+            </a:r>
+          </a:p>
+        </p:txBody>
+      </p:sp>
+      <p:sp>
+        <p:nvSpPr>
+          <p:cNvPr id="12" name="Rectangle 11"/>
+          <p:cNvSpPr/>
+          <p:nvPr/>
+        </p:nvSpPr>
+        <p:spPr>
+          <a:xfrm>
+            <a:off x="2898648" y="3566160"/>
+            <a:ext cx="1993392" cy="914400"/>
+          </a:xfrm>
+          <a:prstGeom prst="rect">
+            <a:avLst/>
+          </a:prstGeom>
+          <a:solidFill>
+            <a:srgbClr val="EAF0F6"/>
+          </a:solidFill>
+          <a:ln w="9525">
+            <a:solidFill>
+              <a:srgbClr val="C9D6E2"/>
+            </a:solidFill>
+          </a:ln>
+          <a:effectLst/>
+        </p:spPr>
+        <p:style>
+          <a:lnRef idx="1">
+            <a:schemeClr val="accent1"/>
+          </a:lnRef>
+          <a:fillRef idx="3">
+            <a:schemeClr val="accent1"/>
+          </a:fillRef>
+          <a:effectRef idx="2">
+            <a:schemeClr val="accent1"/>
+          </a:effectRef>
+          <a:fontRef idx="minor">
+            <a:schemeClr val="lt1"/>
+          </a:fontRef>
+        </p:style>
+        <p:txBody>
+          <a:bodyPr rtlCol="0" anchor="t" wrap="square"/>
+          <a:lstStyle/>
+          <a:p>
+            <a:pPr algn="l">
+              <a:spcAft>
+                <a:spcPts val="100"/>
+              </a:spcAft>
+            </a:pPr>
+            <a:r>
+              <a:rPr sz="850" b="1" i="0">
+                <a:solidFill>
+                  <a:srgbClr val="48677E"/>
+                </a:solidFill>
+                <a:latin typeface="Bitstream Charter"/>
+              </a:rPr>
+              <a:t>OUTPUT</a:t>
+            </a:r>
+          </a:p>
+          <a:p>
+            <a:pPr algn="l">
+              <a:spcAft>
+                <a:spcPts val="100"/>
+              </a:spcAft>
+            </a:pPr>
+            <a:r>
+              <a:rPr sz="1000" b="0" i="0">
+                <a:solidFill>
+                  <a:srgbClr val="263C50"/>
+                </a:solidFill>
+                <a:latin typeface="Bitstream Charter"/>
+              </a:rPr>
+              <a:t>raw JSON files per game</a:t>
+            </a:r>
+          </a:p>
+          <a:p>
+            <a:pPr algn="l">
+              <a:spcAft>
+                <a:spcPts val="100"/>
+              </a:spcAft>
+            </a:pPr>
+            <a:r>
+              <a:rPr sz="1200" b="1" i="0">
+                <a:solidFill>
+                  <a:srgbClr val="132C43"/>
+                </a:solidFill>
+                <a:latin typeface="Bitstream Charter"/>
+              </a:rPr>
+              <a:t>1,652,999 reviews</a:t>
+            </a:r>
+          </a:p>
+        </p:txBody>
+      </p:sp>
+      <p:sp>
+        <p:nvSpPr>
+          <p:cNvPr id="13" name="Right Arrow 12"/>
+          <p:cNvSpPr/>
+          <p:nvPr/>
+        </p:nvSpPr>
+        <p:spPr>
+          <a:xfrm>
+            <a:off x="4873752" y="1600200"/>
+            <a:ext cx="219456" cy="274320"/>
+          </a:xfrm>
+          <a:prstGeom prst="rightArrow">
+            <a:avLst/>
+          </a:prstGeom>
+          <a:solidFill>
+            <a:srgbClr val="D1495B"/>
+          </a:solidFill>
+          <a:ln>
+            <a:noFill/>
+          </a:ln>
+          <a:effectLst/>
+        </p:spPr>
+        <p:style>
+          <a:lnRef idx="1">
+            <a:schemeClr val="accent1"/>
+          </a:lnRef>
+          <a:fillRef idx="3">
+            <a:schemeClr val="accent1"/>
+          </a:fillRef>
+          <a:effectRef idx="2">
+            <a:schemeClr val="accent1"/>
+          </a:effectRef>
+          <a:fontRef idx="minor">
+            <a:schemeClr val="lt1"/>
+          </a:fontRef>
+        </p:style>
+        <p:txBody>
+          <a:bodyPr rtlCol="0" anchor="ctr"/>
+          <a:lstStyle/>
+          <a:p>
+            <a:pPr algn="ctr"/>
+          </a:p>
+        </p:txBody>
+      </p:sp>
+      <p:sp>
+        <p:nvSpPr>
+          <p:cNvPr id="14" name="Rectangle 13"/>
+          <p:cNvSpPr/>
+          <p:nvPr/>
+        </p:nvSpPr>
+        <p:spPr>
+          <a:xfrm>
+            <a:off x="5074920" y="1508760"/>
+            <a:ext cx="1993392" cy="457200"/>
+          </a:xfrm>
+          <a:prstGeom prst="rect">
+            <a:avLst/>
+          </a:prstGeom>
+          <a:solidFill>
+            <a:srgbClr val="132C43"/>
+          </a:solidFill>
+          <a:ln>
+            <a:noFill/>
+          </a:ln>
+          <a:effectLst/>
+        </p:spPr>
+        <p:style>
+          <a:lnRef idx="1">
+            <a:schemeClr val="accent1"/>
+          </a:lnRef>
+          <a:fillRef idx="3">
+            <a:schemeClr val="accent1"/>
+          </a:fillRef>
+          <a:effectRef idx="2">
+            <a:schemeClr val="accent1"/>
+          </a:effectRef>
+          <a:fontRef idx="minor">
+            <a:schemeClr val="lt1"/>
+          </a:fontRef>
+        </p:style>
+        <p:txBody>
+          <a:bodyPr rtlCol="0" anchor="ctr" wrap="square"/>
+          <a:lstStyle/>
+          <a:p>
+            <a:pPr algn="l">
+              <a:spcAft>
+                <a:spcPts val="200"/>
+              </a:spcAft>
+            </a:pPr>
+            <a:r>
+              <a:rPr sz="1250" b="1" i="0">
+                <a:solidFill>
+                  <a:srgbClr val="FFFFFF"/>
+                </a:solidFill>
+                <a:latin typeface="Bitstream Charter"/>
+              </a:rPr>
+              <a:t>3  Flatten</a:t>
+            </a:r>
+          </a:p>
+        </p:txBody>
+      </p:sp>
+      <p:sp>
+        <p:nvSpPr>
+          <p:cNvPr id="15" name="Rectangle 14"/>
+          <p:cNvSpPr/>
+          <p:nvPr/>
+        </p:nvSpPr>
+        <p:spPr>
+          <a:xfrm>
+            <a:off x="5074920" y="1965960"/>
+            <a:ext cx="1993392" cy="1600200"/>
+          </a:xfrm>
+          <a:prstGeom prst="rect">
+            <a:avLst/>
+          </a:prstGeom>
+          <a:solidFill>
+            <a:srgbClr val="FFFFFF"/>
+          </a:solidFill>
+          <a:ln w="9525">
+            <a:solidFill>
+              <a:srgbClr val="C9D6E2"/>
+            </a:solidFill>
+          </a:ln>
+          <a:effectLst/>
+        </p:spPr>
+        <p:style>
+          <a:lnRef idx="1">
+            <a:schemeClr val="accent1"/>
+          </a:lnRef>
+          <a:fillRef idx="3">
+            <a:schemeClr val="accent1"/>
+          </a:fillRef>
+          <a:effectRef idx="2">
+            <a:schemeClr val="accent1"/>
+          </a:effectRef>
+          <a:fontRef idx="minor">
+            <a:schemeClr val="lt1"/>
+          </a:fontRef>
+        </p:style>
+        <p:txBody>
+          <a:bodyPr rtlCol="0" anchor="t" wrap="square"/>
+          <a:lstStyle/>
+          <a:p>
+            <a:pPr algn="l">
+              <a:spcAft>
+                <a:spcPts val="400"/>
+              </a:spcAft>
+            </a:pPr>
+            <a:r>
+              <a:rPr sz="1000" b="1" i="0">
+                <a:solidFill>
+                  <a:srgbClr val="48677E"/>
+                </a:solidFill>
+                <a:latin typeface="Bitstream Charter"/>
+              </a:rPr>
+              <a:t>src.clean.flatten</a:t>
+            </a:r>
+          </a:p>
+          <a:p>
+            <a:pPr algn="l">
+              <a:spcAft>
+                <a:spcPts val="400"/>
+              </a:spcAft>
+            </a:pPr>
+            <a:r>
+              <a:rPr sz="1150" b="0" i="0">
+                <a:solidFill>
+                  <a:srgbClr val="263C50"/>
+                </a:solidFill>
+                <a:latin typeface="Bitstream Charter"/>
+              </a:rPr>
+              <a:t>• Nested JSON into tables</a:t>
+            </a:r>
+          </a:p>
+          <a:p>
+            <a:pPr algn="l">
+              <a:spcAft>
+                <a:spcPts val="400"/>
+              </a:spcAft>
+            </a:pPr>
+            <a:r>
+              <a:rPr sz="1150" b="0" i="0">
+                <a:solidFill>
+                  <a:srgbClr val="263C50"/>
+                </a:solidFill>
+                <a:latin typeface="Bitstream Charter"/>
+              </a:rPr>
+              <a:t>• Author block into columns</a:t>
+            </a:r>
+          </a:p>
+          <a:p>
+            <a:pPr algn="l">
+              <a:spcAft>
+                <a:spcPts val="400"/>
+              </a:spcAft>
+            </a:pPr>
+            <a:r>
+              <a:rPr sz="1150" b="0" i="0">
+                <a:solidFill>
+                  <a:srgbClr val="263C50"/>
+                </a:solidFill>
+                <a:latin typeface="Bitstream Charter"/>
+              </a:rPr>
+              <a:t>• Names and avatars dropped</a:t>
+            </a:r>
+          </a:p>
+        </p:txBody>
+      </p:sp>
+      <p:sp>
+        <p:nvSpPr>
+          <p:cNvPr id="16" name="Rectangle 15"/>
+          <p:cNvSpPr/>
+          <p:nvPr/>
+        </p:nvSpPr>
+        <p:spPr>
+          <a:xfrm>
+            <a:off x="5074920" y="3566160"/>
+            <a:ext cx="1993392" cy="914400"/>
+          </a:xfrm>
+          <a:prstGeom prst="rect">
+            <a:avLst/>
+          </a:prstGeom>
+          <a:solidFill>
+            <a:srgbClr val="EAF0F6"/>
+          </a:solidFill>
+          <a:ln w="9525">
+            <a:solidFill>
+              <a:srgbClr val="C9D6E2"/>
+            </a:solidFill>
+          </a:ln>
+          <a:effectLst/>
+        </p:spPr>
+        <p:style>
+          <a:lnRef idx="1">
+            <a:schemeClr val="accent1"/>
+          </a:lnRef>
+          <a:fillRef idx="3">
+            <a:schemeClr val="accent1"/>
+          </a:fillRef>
+          <a:effectRef idx="2">
+            <a:schemeClr val="accent1"/>
+          </a:effectRef>
+          <a:fontRef idx="minor">
+            <a:schemeClr val="lt1"/>
+          </a:fontRef>
+        </p:style>
+        <p:txBody>
+          <a:bodyPr rtlCol="0" anchor="t" wrap="square"/>
+          <a:lstStyle/>
+          <a:p>
+            <a:pPr algn="l">
+              <a:spcAft>
+                <a:spcPts val="100"/>
+              </a:spcAft>
+            </a:pPr>
+            <a:r>
+              <a:rPr sz="850" b="1" i="0">
+                <a:solidFill>
+                  <a:srgbClr val="48677E"/>
+                </a:solidFill>
+                <a:latin typeface="Bitstream Charter"/>
+              </a:rPr>
+              <a:t>OUTPUT</a:t>
+            </a:r>
+          </a:p>
+          <a:p>
+            <a:pPr algn="l">
+              <a:spcAft>
+                <a:spcPts val="100"/>
+              </a:spcAft>
+            </a:pPr>
+            <a:r>
+              <a:rPr sz="1000" b="0" i="0">
+                <a:solidFill>
+                  <a:srgbClr val="263C50"/>
+                </a:solidFill>
+                <a:latin typeface="Bitstream Charter"/>
+              </a:rPr>
+              <a:t>interim parquet</a:t>
+            </a:r>
+          </a:p>
+          <a:p>
+            <a:pPr algn="l">
+              <a:spcAft>
+                <a:spcPts val="100"/>
+              </a:spcAft>
+            </a:pPr>
+            <a:r>
+              <a:rPr sz="1200" b="1" i="0">
+                <a:solidFill>
+                  <a:srgbClr val="132C43"/>
+                </a:solidFill>
+                <a:latin typeface="Bitstream Charter"/>
+              </a:rPr>
+              <a:t>games, reviews, news</a:t>
+            </a:r>
+          </a:p>
+        </p:txBody>
+      </p:sp>
+      <p:sp>
+        <p:nvSpPr>
+          <p:cNvPr id="17" name="Right Arrow 16"/>
+          <p:cNvSpPr/>
+          <p:nvPr/>
+        </p:nvSpPr>
+        <p:spPr>
+          <a:xfrm>
+            <a:off x="7050024" y="1600200"/>
+            <a:ext cx="219456" cy="274320"/>
+          </a:xfrm>
+          <a:prstGeom prst="rightArrow">
+            <a:avLst/>
+          </a:prstGeom>
+          <a:solidFill>
+            <a:srgbClr val="D1495B"/>
+          </a:solidFill>
+          <a:ln>
+            <a:noFill/>
+          </a:ln>
+          <a:effectLst/>
+        </p:spPr>
+        <p:style>
+          <a:lnRef idx="1">
+            <a:schemeClr val="accent1"/>
+          </a:lnRef>
+          <a:fillRef idx="3">
+            <a:schemeClr val="accent1"/>
+          </a:fillRef>
+          <a:effectRef idx="2">
+            <a:schemeClr val="accent1"/>
+          </a:effectRef>
+          <a:fontRef idx="minor">
+            <a:schemeClr val="lt1"/>
+          </a:fontRef>
+        </p:style>
+        <p:txBody>
+          <a:bodyPr rtlCol="0" anchor="ctr"/>
+          <a:lstStyle/>
+          <a:p>
+            <a:pPr algn="ctr"/>
+          </a:p>
+        </p:txBody>
+      </p:sp>
+      <p:sp>
+        <p:nvSpPr>
+          <p:cNvPr id="18" name="Rectangle 17"/>
+          <p:cNvSpPr/>
+          <p:nvPr/>
+        </p:nvSpPr>
+        <p:spPr>
+          <a:xfrm>
+            <a:off x="7251192" y="1508760"/>
+            <a:ext cx="1993392" cy="457200"/>
+          </a:xfrm>
+          <a:prstGeom prst="rect">
+            <a:avLst/>
+          </a:prstGeom>
+          <a:solidFill>
+            <a:srgbClr val="132C43"/>
+          </a:solidFill>
+          <a:ln>
+            <a:noFill/>
+          </a:ln>
+          <a:effectLst/>
+        </p:spPr>
+        <p:style>
+          <a:lnRef idx="1">
+            <a:schemeClr val="accent1"/>
+          </a:lnRef>
+          <a:fillRef idx="3">
+            <a:schemeClr val="accent1"/>
+          </a:fillRef>
+          <a:effectRef idx="2">
+            <a:schemeClr val="accent1"/>
+          </a:effectRef>
+          <a:fontRef idx="minor">
+            <a:schemeClr val="lt1"/>
+          </a:fontRef>
+        </p:style>
+        <p:txBody>
+          <a:bodyPr rtlCol="0" anchor="ctr" wrap="square"/>
+          <a:lstStyle/>
+          <a:p>
+            <a:pPr algn="l">
+              <a:spcAft>
+                <a:spcPts val="200"/>
+              </a:spcAft>
+            </a:pPr>
+            <a:r>
+              <a:rPr sz="1250" b="1" i="0">
+                <a:solidFill>
+                  <a:srgbClr val="FFFFFF"/>
+                </a:solidFill>
+                <a:latin typeface="Bitstream Charter"/>
+              </a:rPr>
+              <a:t>4  Clean</a:t>
+            </a:r>
+          </a:p>
+        </p:txBody>
+      </p:sp>
+      <p:sp>
+        <p:nvSpPr>
+          <p:cNvPr id="19" name="Rectangle 18"/>
+          <p:cNvSpPr/>
+          <p:nvPr/>
+        </p:nvSpPr>
+        <p:spPr>
+          <a:xfrm>
+            <a:off x="7251192" y="1965960"/>
+            <a:ext cx="1993392" cy="1600200"/>
+          </a:xfrm>
+          <a:prstGeom prst="rect">
+            <a:avLst/>
+          </a:prstGeom>
+          <a:solidFill>
+            <a:srgbClr val="FFFFFF"/>
+          </a:solidFill>
+          <a:ln w="9525">
+            <a:solidFill>
+              <a:srgbClr val="C9D6E2"/>
+            </a:solidFill>
+          </a:ln>
+          <a:effectLst/>
+        </p:spPr>
+        <p:style>
+          <a:lnRef idx="1">
+            <a:schemeClr val="accent1"/>
+          </a:lnRef>
+          <a:fillRef idx="3">
+            <a:schemeClr val="accent1"/>
+          </a:fillRef>
+          <a:effectRef idx="2">
+            <a:schemeClr val="accent1"/>
+          </a:effectRef>
+          <a:fontRef idx="minor">
+            <a:schemeClr val="lt1"/>
+          </a:fontRef>
+        </p:style>
+        <p:txBody>
+          <a:bodyPr rtlCol="0" anchor="t" wrap="square"/>
+          <a:lstStyle/>
+          <a:p>
+            <a:pPr algn="l">
+              <a:spcAft>
+                <a:spcPts val="400"/>
+              </a:spcAft>
+            </a:pPr>
+            <a:r>
+              <a:rPr sz="1000" b="1" i="0">
+                <a:solidFill>
+                  <a:srgbClr val="48677E"/>
+                </a:solidFill>
+                <a:latin typeface="Bitstream Charter"/>
+              </a:rPr>
+              <a:t>src.clean.clean</a:t>
+            </a:r>
+          </a:p>
+          <a:p>
+            <a:pPr algn="l">
+              <a:spcAft>
+                <a:spcPts val="400"/>
+              </a:spcAft>
+            </a:pPr>
+            <a:r>
+              <a:rPr sz="1150" b="0" i="0">
+                <a:solidFill>
+                  <a:srgbClr val="263C50"/>
+                </a:solidFill>
+                <a:latin typeface="Bitstream Charter"/>
+              </a:rPr>
+              <a:t>• 32 logged rules</a:t>
+            </a:r>
+          </a:p>
+          <a:p>
+            <a:pPr algn="l">
+              <a:spcAft>
+                <a:spcPts val="400"/>
+              </a:spcAft>
+            </a:pPr>
+            <a:r>
+              <a:rPr sz="1150" b="0" i="0">
+                <a:solidFill>
+                  <a:srgbClr val="263C50"/>
+                </a:solidFill>
+                <a:latin typeface="Bitstream Charter"/>
+              </a:rPr>
+              <a:t>• Drop only empty text</a:t>
+            </a:r>
+          </a:p>
+          <a:p>
+            <a:pPr algn="l">
+              <a:spcAft>
+                <a:spcPts val="400"/>
+              </a:spcAft>
+            </a:pPr>
+            <a:r>
+              <a:rPr sz="1150" b="0" i="0">
+                <a:solidFill>
+                  <a:srgbClr val="263C50"/>
+                </a:solidFill>
+                <a:latin typeface="Bitstream Charter"/>
+              </a:rPr>
+              <a:t>• Flag the rest, keep it</a:t>
+            </a:r>
+          </a:p>
+        </p:txBody>
+      </p:sp>
+      <p:sp>
+        <p:nvSpPr>
+          <p:cNvPr id="20" name="Rectangle 19"/>
+          <p:cNvSpPr/>
+          <p:nvPr/>
+        </p:nvSpPr>
+        <p:spPr>
+          <a:xfrm>
+            <a:off x="7251192" y="3566160"/>
+            <a:ext cx="1993392" cy="914400"/>
+          </a:xfrm>
+          <a:prstGeom prst="rect">
+            <a:avLst/>
+          </a:prstGeom>
+          <a:solidFill>
+            <a:srgbClr val="EAF0F6"/>
+          </a:solidFill>
+          <a:ln w="9525">
+            <a:solidFill>
+              <a:srgbClr val="C9D6E2"/>
+            </a:solidFill>
+          </a:ln>
+          <a:effectLst/>
+        </p:spPr>
+        <p:style>
+          <a:lnRef idx="1">
+            <a:schemeClr val="accent1"/>
+          </a:lnRef>
+          <a:fillRef idx="3">
+            <a:schemeClr val="accent1"/>
+          </a:fillRef>
+          <a:effectRef idx="2">
+            <a:schemeClr val="accent1"/>
+          </a:effectRef>
+          <a:fontRef idx="minor">
+            <a:schemeClr val="lt1"/>
+          </a:fontRef>
+        </p:style>
+        <p:txBody>
+          <a:bodyPr rtlCol="0" anchor="t" wrap="square"/>
+          <a:lstStyle/>
+          <a:p>
+            <a:pPr algn="l">
+              <a:spcAft>
+                <a:spcPts val="100"/>
+              </a:spcAft>
+            </a:pPr>
+            <a:r>
+              <a:rPr sz="850" b="1" i="0">
+                <a:solidFill>
+                  <a:srgbClr val="48677E"/>
+                </a:solidFill>
+                <a:latin typeface="Bitstream Charter"/>
+              </a:rPr>
+              <a:t>OUTPUT</a:t>
+            </a:r>
+          </a:p>
+          <a:p>
+            <a:pPr algn="l">
+              <a:spcAft>
+                <a:spcPts val="100"/>
+              </a:spcAft>
+            </a:pPr>
+            <a:r>
+              <a:rPr sz="1000" b="0" i="0">
+                <a:solidFill>
+                  <a:srgbClr val="263C50"/>
+                </a:solidFill>
+                <a:latin typeface="Bitstream Charter"/>
+              </a:rPr>
+              <a:t>processed parquet</a:t>
+            </a:r>
+          </a:p>
+          <a:p>
+            <a:pPr algn="l">
+              <a:spcAft>
+                <a:spcPts val="100"/>
+              </a:spcAft>
+            </a:pPr>
+            <a:r>
+              <a:rPr sz="1200" b="1" i="0">
+                <a:solidFill>
+                  <a:srgbClr val="132C43"/>
+                </a:solidFill>
+                <a:latin typeface="Bitstream Charter"/>
+              </a:rPr>
+              <a:t>1,648,387 reviews</a:t>
+            </a:r>
+          </a:p>
+        </p:txBody>
+      </p:sp>
+      <p:sp>
+        <p:nvSpPr>
+          <p:cNvPr id="21" name="Right Arrow 20"/>
+          <p:cNvSpPr/>
+          <p:nvPr/>
+        </p:nvSpPr>
+        <p:spPr>
+          <a:xfrm>
+            <a:off x="9226296" y="1600200"/>
+            <a:ext cx="219456" cy="274320"/>
+          </a:xfrm>
+          <a:prstGeom prst="rightArrow">
+            <a:avLst/>
+          </a:prstGeom>
+          <a:solidFill>
+            <a:srgbClr val="D1495B"/>
+          </a:solidFill>
+          <a:ln>
+            <a:noFill/>
+          </a:ln>
+          <a:effectLst/>
+        </p:spPr>
+        <p:style>
+          <a:lnRef idx="1">
+            <a:schemeClr val="accent1"/>
+          </a:lnRef>
+          <a:fillRef idx="3">
+            <a:schemeClr val="accent1"/>
+          </a:fillRef>
+          <a:effectRef idx="2">
+            <a:schemeClr val="accent1"/>
+          </a:effectRef>
+          <a:fontRef idx="minor">
+            <a:schemeClr val="lt1"/>
+          </a:fontRef>
+        </p:style>
+        <p:txBody>
+          <a:bodyPr rtlCol="0" anchor="ctr"/>
+          <a:lstStyle/>
+          <a:p>
+            <a:pPr algn="ctr"/>
+          </a:p>
+        </p:txBody>
+      </p:sp>
+      <p:sp>
+        <p:nvSpPr>
+          <p:cNvPr id="22" name="Rectangle 21"/>
+          <p:cNvSpPr/>
+          <p:nvPr/>
+        </p:nvSpPr>
+        <p:spPr>
+          <a:xfrm>
+            <a:off x="9427464" y="1508760"/>
+            <a:ext cx="1993392" cy="457200"/>
+          </a:xfrm>
+          <a:prstGeom prst="rect">
+            <a:avLst/>
+          </a:prstGeom>
+          <a:solidFill>
+            <a:srgbClr val="132C43"/>
+          </a:solidFill>
+          <a:ln>
+            <a:noFill/>
+          </a:ln>
+          <a:effectLst/>
+        </p:spPr>
+        <p:style>
+          <a:lnRef idx="1">
+            <a:schemeClr val="accent1"/>
+          </a:lnRef>
+          <a:fillRef idx="3">
+            <a:schemeClr val="accent1"/>
+          </a:fillRef>
+          <a:effectRef idx="2">
+            <a:schemeClr val="accent1"/>
+          </a:effectRef>
+          <a:fontRef idx="minor">
+            <a:schemeClr val="lt1"/>
+          </a:fontRef>
+        </p:style>
+        <p:txBody>
+          <a:bodyPr rtlCol="0" anchor="ctr" wrap="square"/>
+          <a:lstStyle/>
+          <a:p>
+            <a:pPr algn="l">
+              <a:spcAft>
+                <a:spcPts val="200"/>
+              </a:spcAft>
+            </a:pPr>
+            <a:r>
+              <a:rPr sz="1250" b="1" i="0">
+                <a:solidFill>
+                  <a:srgbClr val="FFFFFF"/>
+                </a:solidFill>
+                <a:latin typeface="Bitstream Charter"/>
+              </a:rPr>
+              <a:t>5  Features and split</a:t>
+            </a:r>
+          </a:p>
+        </p:txBody>
+      </p:sp>
+      <p:sp>
+        <p:nvSpPr>
+          <p:cNvPr id="23" name="Rectangle 22"/>
+          <p:cNvSpPr/>
+          <p:nvPr/>
+        </p:nvSpPr>
+        <p:spPr>
+          <a:xfrm>
+            <a:off x="9427464" y="1965960"/>
+            <a:ext cx="1993392" cy="1600200"/>
+          </a:xfrm>
+          <a:prstGeom prst="rect">
+            <a:avLst/>
+          </a:prstGeom>
+          <a:solidFill>
+            <a:srgbClr val="FFFFFF"/>
+          </a:solidFill>
+          <a:ln w="9525">
+            <a:solidFill>
+              <a:srgbClr val="C9D6E2"/>
+            </a:solidFill>
+          </a:ln>
+          <a:effectLst/>
+        </p:spPr>
+        <p:style>
+          <a:lnRef idx="1">
+            <a:schemeClr val="accent1"/>
+          </a:lnRef>
+          <a:fillRef idx="3">
+            <a:schemeClr val="accent1"/>
+          </a:fillRef>
+          <a:effectRef idx="2">
+            <a:schemeClr val="accent1"/>
+          </a:effectRef>
+          <a:fontRef idx="minor">
+            <a:schemeClr val="lt1"/>
+          </a:fontRef>
+        </p:style>
+        <p:txBody>
+          <a:bodyPr rtlCol="0" anchor="t" wrap="square"/>
+          <a:lstStyle/>
+          <a:p>
+            <a:pPr algn="l">
+              <a:spcAft>
+                <a:spcPts val="400"/>
+              </a:spcAft>
+            </a:pPr>
+            <a:r>
+              <a:rPr sz="1000" b="1" i="0">
+                <a:solidFill>
+                  <a:srgbClr val="48677E"/>
+                </a:solidFill>
+                <a:latin typeface="Bitstream Charter"/>
+              </a:rPr>
+              <a:t>src.features, src.splits</a:t>
+            </a:r>
+          </a:p>
+          <a:p>
+            <a:pPr algn="l">
+              <a:spcAft>
+                <a:spcPts val="400"/>
+              </a:spcAft>
+            </a:pPr>
+            <a:r>
+              <a:rPr sz="1150" b="0" i="0">
+                <a:solidFill>
+                  <a:srgbClr val="263C50"/>
+                </a:solidFill>
+                <a:latin typeface="Bitstream Charter"/>
+              </a:rPr>
+              <a:t>• Tags to PCA, text to SVD</a:t>
+            </a:r>
+          </a:p>
+          <a:p>
+            <a:pPr algn="l">
+              <a:spcAft>
+                <a:spcPts val="400"/>
+              </a:spcAft>
+            </a:pPr>
+            <a:r>
+              <a:rPr sz="1150" b="0" i="0">
+                <a:solidFill>
+                  <a:srgbClr val="263C50"/>
+                </a:solidFill>
+                <a:latin typeface="Bitstream Charter"/>
+              </a:rPr>
+              <a:t>• Targets and tiers</a:t>
+            </a:r>
+          </a:p>
+          <a:p>
+            <a:pPr algn="l">
+              <a:spcAft>
+                <a:spcPts val="400"/>
+              </a:spcAft>
+            </a:pPr>
+            <a:r>
+              <a:rPr sz="1150" b="0" i="0">
+                <a:solidFill>
+                  <a:srgbClr val="263C50"/>
+                </a:solidFill>
+                <a:latin typeface="Bitstream Charter"/>
+              </a:rPr>
+              <a:t>• Split by game</a:t>
+            </a:r>
+          </a:p>
+        </p:txBody>
+      </p:sp>
+      <p:sp>
+        <p:nvSpPr>
+          <p:cNvPr id="24" name="Rectangle 23"/>
+          <p:cNvSpPr/>
+          <p:nvPr/>
+        </p:nvSpPr>
+        <p:spPr>
+          <a:xfrm>
+            <a:off x="9427464" y="3566160"/>
+            <a:ext cx="1993392" cy="914400"/>
+          </a:xfrm>
+          <a:prstGeom prst="rect">
+            <a:avLst/>
+          </a:prstGeom>
+          <a:solidFill>
+            <a:srgbClr val="EAF0F6"/>
+          </a:solidFill>
+          <a:ln w="9525">
+            <a:solidFill>
+              <a:srgbClr val="C9D6E2"/>
+            </a:solidFill>
+          </a:ln>
+          <a:effectLst/>
+        </p:spPr>
+        <p:style>
+          <a:lnRef idx="1">
+            <a:schemeClr val="accent1"/>
+          </a:lnRef>
+          <a:fillRef idx="3">
+            <a:schemeClr val="accent1"/>
+          </a:fillRef>
+          <a:effectRef idx="2">
+            <a:schemeClr val="accent1"/>
+          </a:effectRef>
+          <a:fontRef idx="minor">
+            <a:schemeClr val="lt1"/>
+          </a:fontRef>
+        </p:style>
+        <p:txBody>
+          <a:bodyPr rtlCol="0" anchor="t" wrap="square"/>
+          <a:lstStyle/>
+          <a:p>
+            <a:pPr algn="l">
+              <a:spcAft>
+                <a:spcPts val="100"/>
+              </a:spcAft>
+            </a:pPr>
+            <a:r>
+              <a:rPr sz="850" b="1" i="0">
+                <a:solidFill>
+                  <a:srgbClr val="48677E"/>
+                </a:solidFill>
+                <a:latin typeface="Bitstream Charter"/>
+              </a:rPr>
+              <a:t>OUTPUT</a:t>
+            </a:r>
+          </a:p>
+          <a:p>
+            <a:pPr algn="l">
+              <a:spcAft>
+                <a:spcPts val="100"/>
+              </a:spcAft>
+            </a:pPr>
+            <a:r>
+              <a:rPr sz="1000" b="0" i="0">
+                <a:solidFill>
+                  <a:srgbClr val="263C50"/>
+                </a:solidFill>
+                <a:latin typeface="Bitstream Charter"/>
+              </a:rPr>
+              <a:t>feature tables</a:t>
+            </a:r>
+          </a:p>
+          <a:p>
+            <a:pPr algn="l">
+              <a:spcAft>
+                <a:spcPts val="100"/>
+              </a:spcAft>
+            </a:pPr>
+            <a:r>
+              <a:rPr sz="1200" b="1" i="0">
+                <a:solidFill>
+                  <a:srgbClr val="132C43"/>
+                </a:solidFill>
+                <a:latin typeface="Bitstream Charter"/>
+              </a:rPr>
+              <a:t>1,573,436 model rows</a:t>
+            </a:r>
+          </a:p>
+        </p:txBody>
+      </p:sp>
+      <p:sp>
+        <p:nvSpPr>
+          <p:cNvPr id="25" name="Rectangle 24"/>
+          <p:cNvSpPr/>
+          <p:nvPr/>
+        </p:nvSpPr>
+        <p:spPr>
+          <a:xfrm>
+            <a:off x="722376" y="4754880"/>
+            <a:ext cx="2633472" cy="548640"/>
+          </a:xfrm>
+          <a:prstGeom prst="rect">
+            <a:avLst/>
+          </a:prstGeom>
+          <a:solidFill>
+            <a:srgbClr val="FFFFFF"/>
+          </a:solidFill>
+          <a:ln w="9525">
+            <a:solidFill>
+              <a:srgbClr val="D1495B"/>
+            </a:solidFill>
+          </a:ln>
+          <a:effectLst/>
+        </p:spPr>
+        <p:style>
+          <a:lnRef idx="1">
+            <a:schemeClr val="accent1"/>
+          </a:lnRef>
+          <a:fillRef idx="3">
+            <a:schemeClr val="accent1"/>
+          </a:fillRef>
+          <a:effectRef idx="2">
+            <a:schemeClr val="accent1"/>
+          </a:effectRef>
+          <a:fontRef idx="minor">
+            <a:schemeClr val="lt1"/>
+          </a:fontRef>
+        </p:style>
+        <p:txBody>
+          <a:bodyPr rtlCol="0" anchor="ctr" wrap="square"/>
+          <a:lstStyle/>
+          <a:p>
+            <a:pPr algn="l">
+              <a:spcAft>
+                <a:spcPts val="200"/>
+              </a:spcAft>
+            </a:pPr>
+            <a:r>
+              <a:rPr sz="1000" b="1" i="0">
+                <a:solidFill>
+                  <a:srgbClr val="D1495B"/>
+                </a:solidFill>
+                <a:latin typeface="Bitstream Charter"/>
+              </a:rPr>
+              <a:t>Polite  </a:t>
+            </a:r>
+            <a:r>
+              <a:rPr sz="1000" b="0" i="0">
+                <a:solidFill>
+                  <a:srgbClr val="263C50"/>
+                </a:solidFill>
+                <a:latin typeface="Bitstream Charter"/>
+              </a:rPr>
+              <a:t>1.25 s between calls, one shared throttle</a:t>
+            </a:r>
+          </a:p>
+        </p:txBody>
+      </p:sp>
+      <p:sp>
+        <p:nvSpPr>
+          <p:cNvPr id="26" name="Rectangle 25"/>
+          <p:cNvSpPr/>
+          <p:nvPr/>
+        </p:nvSpPr>
+        <p:spPr>
+          <a:xfrm>
+            <a:off x="3465576" y="4754880"/>
+            <a:ext cx="2633472" cy="548640"/>
+          </a:xfrm>
+          <a:prstGeom prst="rect">
+            <a:avLst/>
+          </a:prstGeom>
+          <a:solidFill>
+            <a:srgbClr val="FFFFFF"/>
+          </a:solidFill>
+          <a:ln w="9525">
+            <a:solidFill>
+              <a:srgbClr val="D1495B"/>
+            </a:solidFill>
+          </a:ln>
+          <a:effectLst/>
+        </p:spPr>
+        <p:style>
+          <a:lnRef idx="1">
+            <a:schemeClr val="accent1"/>
+          </a:lnRef>
+          <a:fillRef idx="3">
+            <a:schemeClr val="accent1"/>
+          </a:fillRef>
+          <a:effectRef idx="2">
+            <a:schemeClr val="accent1"/>
+          </a:effectRef>
+          <a:fontRef idx="minor">
+            <a:schemeClr val="lt1"/>
+          </a:fontRef>
+        </p:style>
+        <p:txBody>
+          <a:bodyPr rtlCol="0" anchor="ctr" wrap="square"/>
+          <a:lstStyle/>
+          <a:p>
+            <a:pPr algn="l">
+              <a:spcAft>
+                <a:spcPts val="200"/>
+              </a:spcAft>
+            </a:pPr>
+            <a:r>
+              <a:rPr sz="1000" b="1" i="0">
+                <a:solidFill>
+                  <a:srgbClr val="D1495B"/>
+                </a:solidFill>
+                <a:latin typeface="Bitstream Charter"/>
+              </a:rPr>
+              <a:t>Resilient  </a:t>
+            </a:r>
+            <a:r>
+              <a:rPr sz="1000" b="0" i="0">
+                <a:solidFill>
+                  <a:srgbClr val="263C50"/>
+                </a:solidFill>
+                <a:latin typeface="Bitstream Charter"/>
+              </a:rPr>
+              <a:t>retry on 429, resume from a checkpoint</a:t>
+            </a:r>
+          </a:p>
+        </p:txBody>
+      </p:sp>
+      <p:sp>
+        <p:nvSpPr>
+          <p:cNvPr id="27" name="Rectangle 26"/>
+          <p:cNvSpPr/>
+          <p:nvPr/>
+        </p:nvSpPr>
+        <p:spPr>
+          <a:xfrm>
+            <a:off x="6208776" y="4754880"/>
+            <a:ext cx="2633472" cy="548640"/>
+          </a:xfrm>
+          <a:prstGeom prst="rect">
+            <a:avLst/>
+          </a:prstGeom>
+          <a:solidFill>
+            <a:srgbClr val="FFFFFF"/>
+          </a:solidFill>
+          <a:ln w="9525">
+            <a:solidFill>
+              <a:srgbClr val="D1495B"/>
+            </a:solidFill>
+          </a:ln>
+          <a:effectLst/>
+        </p:spPr>
+        <p:style>
+          <a:lnRef idx="1">
+            <a:schemeClr val="accent1"/>
+          </a:lnRef>
+          <a:fillRef idx="3">
+            <a:schemeClr val="accent1"/>
+          </a:fillRef>
+          <a:effectRef idx="2">
+            <a:schemeClr val="accent1"/>
+          </a:effectRef>
+          <a:fontRef idx="minor">
+            <a:schemeClr val="lt1"/>
+          </a:fontRef>
+        </p:style>
+        <p:txBody>
+          <a:bodyPr rtlCol="0" anchor="ctr" wrap="square"/>
+          <a:lstStyle/>
+          <a:p>
+            <a:pPr algn="l">
+              <a:spcAft>
+                <a:spcPts val="200"/>
+              </a:spcAft>
+            </a:pPr>
+            <a:r>
+              <a:rPr sz="1000" b="1" i="0">
+                <a:solidFill>
+                  <a:srgbClr val="D1495B"/>
+                </a:solidFill>
+                <a:latin typeface="Bitstream Charter"/>
+              </a:rPr>
+              <a:t>Private  </a:t>
+            </a:r>
+            <a:r>
+              <a:rPr sz="1000" b="0" i="0">
+                <a:solidFill>
+                  <a:srgbClr val="263C50"/>
+                </a:solidFill>
+                <a:latin typeface="Bitstream Charter"/>
+              </a:rPr>
+              <a:t>reviewer ID salted-hashed, names dropped</a:t>
+            </a:r>
+          </a:p>
+        </p:txBody>
+      </p:sp>
+      <p:sp>
+        <p:nvSpPr>
+          <p:cNvPr id="28" name="Rectangle 27"/>
+          <p:cNvSpPr/>
+          <p:nvPr/>
+        </p:nvSpPr>
+        <p:spPr>
+          <a:xfrm>
+            <a:off x="8951976" y="4754880"/>
+            <a:ext cx="2633472" cy="548640"/>
+          </a:xfrm>
+          <a:prstGeom prst="rect">
+            <a:avLst/>
+          </a:prstGeom>
+          <a:solidFill>
+            <a:srgbClr val="FFFFFF"/>
+          </a:solidFill>
+          <a:ln w="9525">
+            <a:solidFill>
+              <a:srgbClr val="D1495B"/>
+            </a:solidFill>
+          </a:ln>
+          <a:effectLst/>
+        </p:spPr>
+        <p:style>
+          <a:lnRef idx="1">
+            <a:schemeClr val="accent1"/>
+          </a:lnRef>
+          <a:fillRef idx="3">
+            <a:schemeClr val="accent1"/>
+          </a:fillRef>
+          <a:effectRef idx="2">
+            <a:schemeClr val="accent1"/>
+          </a:effectRef>
+          <a:fontRef idx="minor">
+            <a:schemeClr val="lt1"/>
+          </a:fontRef>
+        </p:style>
+        <p:txBody>
+          <a:bodyPr rtlCol="0" anchor="ctr" wrap="square"/>
+          <a:lstStyle/>
+          <a:p>
+            <a:pPr algn="l">
+              <a:spcAft>
+                <a:spcPts val="200"/>
+              </a:spcAft>
+            </a:pPr>
+            <a:r>
+              <a:rPr sz="1000" b="1" i="0">
+                <a:solidFill>
+                  <a:srgbClr val="D1495B"/>
+                </a:solidFill>
+                <a:latin typeface="Bitstream Charter"/>
+              </a:rPr>
+              <a:t>Frozen  </a:t>
+            </a:r>
+            <a:r>
+              <a:rPr sz="1000" b="0" i="0">
+                <a:solidFill>
+                  <a:srgbClr val="263C50"/>
+                </a:solidFill>
+                <a:latin typeface="Bitstream Charter"/>
+              </a:rPr>
+              <a:t>raw row counts and SHA256 hashes</a:t>
+            </a:r>
+          </a:p>
+        </p:txBody>
+      </p:sp>
+      <p:sp>
+        <p:nvSpPr>
+          <p:cNvPr id="29" name="Rectangle 28"/>
+          <p:cNvSpPr/>
+          <p:nvPr/>
+        </p:nvSpPr>
+        <p:spPr>
+          <a:xfrm>
+            <a:off x="722376" y="5623560"/>
+            <a:ext cx="64008" cy="457200"/>
+          </a:xfrm>
+          <a:prstGeom prst="rect">
+            <a:avLst/>
+          </a:prstGeom>
+          <a:solidFill>
+            <a:srgbClr val="D1495B"/>
+          </a:solidFill>
+          <a:ln>
+            <a:noFill/>
+          </a:ln>
+        </p:spPr>
+        <p:style>
+          <a:lnRef idx="1">
+            <a:schemeClr val="accent1"/>
+          </a:lnRef>
+          <a:fillRef idx="3">
+            <a:schemeClr val="accent1"/>
+          </a:fillRef>
+          <a:effectRef idx="2">
+            <a:schemeClr val="accent1"/>
+          </a:effectRef>
+          <a:fontRef idx="minor">
+            <a:schemeClr val="lt1"/>
+          </a:fontRef>
+        </p:style>
+        <p:txBody>
+          <a:bodyPr rtlCol="0" anchor="ctr"/>
+          <a:lstStyle/>
+          <a:p>
+            <a:pPr algn="ctr"/>
+          </a:p>
+        </p:txBody>
+      </p:sp>
+      <p:sp>
+        <p:nvSpPr>
+          <p:cNvPr id="30" name="Rectangle 29"/>
+          <p:cNvSpPr/>
+          <p:nvPr/>
+        </p:nvSpPr>
+        <p:spPr>
+          <a:xfrm>
+            <a:off x="786384" y="5623560"/>
+            <a:ext cx="10680192" cy="457200"/>
+          </a:xfrm>
+          <a:prstGeom prst="rect">
+            <a:avLst/>
+          </a:prstGeom>
+          <a:solidFill>
+            <a:srgbClr val="EAF0F6"/>
+          </a:solidFill>
+          <a:ln>
+            <a:noFill/>
+          </a:ln>
+        </p:spPr>
+        <p:style>
+          <a:lnRef idx="1">
+            <a:schemeClr val="accent1"/>
+          </a:lnRef>
+          <a:fillRef idx="3">
+            <a:schemeClr val="accent1"/>
+          </a:fillRef>
+          <a:effectRef idx="2">
+            <a:schemeClr val="accent1"/>
+          </a:effectRef>
+          <a:fontRef idx="minor">
+            <a:schemeClr val="lt1"/>
+          </a:fontRef>
+        </p:style>
+        <p:txBody>
+          <a:bodyPr rtlCol="0" anchor="ctr" lIns="137160" wrap="square"/>
+          <a:lstStyle/>
+          <a:p>
+            <a:pPr algn="l">
+              <a:spcAft>
+                <a:spcPts val="0"/>
+              </a:spcAft>
+            </a:pPr>
+            <a:r>
+              <a:rPr sz="1250" b="1" i="0">
+                <a:solidFill>
+                  <a:srgbClr val="D1495B"/>
+                </a:solidFill>
+                <a:latin typeface="Bitstream Charter"/>
+              </a:rPr>
+              <a:t>Takeaway  </a:t>
+            </a:r>
+            <a:r>
+              <a:rPr sz="1250" b="1" i="0">
+                <a:solidFill>
+                  <a:srgbClr val="132C43"/>
+                </a:solidFill>
+                <a:latin typeface="Bitstream Charter"/>
+              </a:rPr>
+              <a:t>Raw data is never edited: every later step reads the raw files and writes a new, logged table.</a:t>
             </a:r>
           </a:p>
         </p:txBody>
@@ -11876,6 +14016,2144 @@
         <p14:creationId xmlns:p14="http://schemas.microsoft.com/office/powerpoint/2010/main" val="236373673"/>
       </p:ext>
     </p:extLst>
+  </p:cSld>
+  <p:clrMapOvr>
+    <a:masterClrMapping/>
+  </p:clrMapOvr>
+</p:sld>
+</file>
+
+<file path=ppt/slides/slide20.xml><?xml version="1.0" encoding="utf-8"?>
+<p:sld xmlns:a="http://schemas.openxmlformats.org/drawingml/2006/main" xmlns:p="http://schemas.openxmlformats.org/presentationml/2006/main" xmlns:r="http://schemas.openxmlformats.org/officeDocument/2006/relationships">
+  <p:cSld>
+    <p:bg>
+      <p:bgPr>
+        <a:solidFill>
+          <a:srgbClr val="F7F9FC"/>
+        </a:solidFill>
+        <a:effectLst/>
+      </p:bgPr>
+    </p:bg>
+    <p:spTree>
+      <p:nvGrpSpPr>
+        <p:cNvPr id="1" name=""/>
+        <p:cNvGrpSpPr/>
+        <p:nvPr/>
+      </p:nvGrpSpPr>
+      <p:grpSpPr/>
+      <p:sp>
+        <p:nvSpPr>
+          <p:cNvPr id="5" name="Rectangle 4">
+            <a:extLst>
+              <a:ext uri="{FF2B5EF4-FFF2-40B4-BE49-F238E27FC236}">
+                <a16:creationId xmlns:a16="http://schemas.microsoft.com/office/drawing/2014/main" id="{27979FDE-990F-4C15-B33C-B2975BF50CD9}"/>
+              </a:ext>
+            </a:extLst>
+          </p:cNvPr>
+          <p:cNvSpPr>
+            <a:spLocks noGrp="1"/>
+          </p:cNvSpPr>
+          <p:nvPr/>
+        </p:nvSpPr>
+        <p:spPr>
+          <a:xfrm>
+            <a:off x="685800" y="523875"/>
+            <a:ext cx="10820400" cy="952500"/>
+          </a:xfrm>
+          <a:prstGeom prst="rect">
+            <a:avLst/>
+          </a:prstGeom>
+          <a:noFill/>
+          <a:ln w="0">
+            <a:noFill/>
+          </a:ln>
+        </p:spPr>
+        <p:txBody>
+          <a:bodyPr wrap="square">
+            <a:noAutofit/>
+          </a:bodyPr>
+          <a:lstStyle/>
+          <a:p>
+            <a:pPr>
+              <a:spcAft>
+                <a:spcPts val="400"/>
+              </a:spcAft>
+              <a:defRPr sz="3300" b="1">
+                <a:solidFill>
+                  <a:srgbClr val="132C43"/>
+                </a:solidFill>
+                <a:latin typeface="Bitstream Charter"/>
+                <a:ea typeface="Bitstream Charter"/>
+                <a:cs typeface="Bitstream Charter"/>
+              </a:defRPr>
+            </a:pPr>
+            <a:r>
+              <a:rPr sz="3300" b="1" i="0">
+                <a:solidFill>
+                  <a:srgbClr val="132C43"/>
+                </a:solidFill>
+                <a:latin typeface="Bitstream Charter"/>
+              </a:rPr>
+              <a:t>Data Acquisition: How One Game Is Scraped</a:t>
+            </a:r>
+          </a:p>
+        </p:txBody>
+      </p:sp>
+      <p:sp>
+        <p:nvSpPr>
+          <p:cNvPr id="4" name="Rectangle 3">
+            <a:extLst>
+              <a:ext uri="{FF2B5EF4-FFF2-40B4-BE49-F238E27FC236}">
+                <a16:creationId xmlns:a16="http://schemas.microsoft.com/office/drawing/2014/main" id="{C795E4D0-3C0B-473C-BB65-A65A174FB43B}"/>
+              </a:ext>
+            </a:extLst>
+          </p:cNvPr>
+          <p:cNvSpPr>
+            <a:spLocks noGrp="1"/>
+          </p:cNvSpPr>
+          <p:nvPr/>
+        </p:nvSpPr>
+        <p:spPr>
+          <a:xfrm>
+            <a:off x="11049000" y="6076950"/>
+            <a:ext cx="476250" cy="381000"/>
+          </a:xfrm>
+          <a:prstGeom prst="rect">
+            <a:avLst/>
+          </a:prstGeom>
+          <a:noFill/>
+          <a:ln w="0">
+            <a:noFill/>
+          </a:ln>
+        </p:spPr>
+        <p:txBody>
+          <a:bodyPr>
+            <a:noAutofit/>
+          </a:bodyPr>
+          <a:lstStyle/>
+          <a:p>
+            <a:pPr>
+              <a:defRPr sz="1500" b="0">
+                <a:solidFill>
+                  <a:srgbClr val="48677E"/>
+                </a:solidFill>
+                <a:latin typeface="Bitstream Charter"/>
+                <a:ea typeface="Bitstream Charter"/>
+                <a:cs typeface="Bitstream Charter"/>
+              </a:defRPr>
+            </a:pPr>
+            <a:r>
+              <a:rPr sz="1500" b="0">
+                <a:solidFill>
+                  <a:srgbClr val="48677E"/>
+                </a:solidFill>
+                <a:latin typeface="Bitstream Charter"/>
+                <a:ea typeface="Bitstream Charter"/>
+                <a:cs typeface="Bitstream Charter"/>
+              </a:rPr>
+              <a:t>06</a:t>
+            </a:r>
+          </a:p>
+        </p:txBody>
+      </p:sp>
+      <p:sp>
+        <p:nvSpPr>
+          <p:cNvPr id="6" name="Rectangle 5"/>
+          <p:cNvSpPr/>
+          <p:nvPr/>
+        </p:nvSpPr>
+        <p:spPr>
+          <a:xfrm>
+            <a:off x="722376" y="1508760"/>
+            <a:ext cx="4754880" cy="548640"/>
+          </a:xfrm>
+          <a:prstGeom prst="rect">
+            <a:avLst/>
+          </a:prstGeom>
+          <a:solidFill>
+            <a:srgbClr val="FFFFFF"/>
+          </a:solidFill>
+          <a:ln w="9525">
+            <a:solidFill>
+              <a:srgbClr val="C9D6E2"/>
+            </a:solidFill>
+          </a:ln>
+          <a:effectLst/>
+        </p:spPr>
+        <p:style>
+          <a:lnRef idx="1">
+            <a:schemeClr val="accent1"/>
+          </a:lnRef>
+          <a:fillRef idx="3">
+            <a:schemeClr val="accent1"/>
+          </a:fillRef>
+          <a:effectRef idx="2">
+            <a:schemeClr val="accent1"/>
+          </a:effectRef>
+          <a:fontRef idx="minor">
+            <a:schemeClr val="lt1"/>
+          </a:fontRef>
+        </p:style>
+        <p:txBody>
+          <a:bodyPr rtlCol="0" anchor="ctr" lIns="566928" rIns="566928" wrap="square"/>
+          <a:lstStyle/>
+          <a:p>
+            <a:pPr algn="l">
+              <a:spcAft>
+                <a:spcPts val="0"/>
+              </a:spcAft>
+            </a:pPr>
+            <a:r>
+              <a:rPr sz="1100" b="1" i="0">
+                <a:solidFill>
+                  <a:srgbClr val="132C43"/>
+                </a:solidFill>
+                <a:latin typeface="Bitstream Charter"/>
+              </a:rPr>
+              <a:t>Ask for a page</a:t>
+            </a:r>
+          </a:p>
+          <a:p>
+            <a:pPr algn="l">
+              <a:spcAft>
+                <a:spcPts val="0"/>
+              </a:spcAft>
+            </a:pPr>
+            <a:r>
+              <a:rPr sz="950" b="0" i="0">
+                <a:solidFill>
+                  <a:srgbClr val="263C50"/>
+                </a:solidFill>
+                <a:latin typeface="Bitstream Charter"/>
+              </a:rPr>
+              <a:t>GET /appreviews/&lt;appid&gt;, cursor, 100 per page, newest first</a:t>
+            </a:r>
+          </a:p>
+        </p:txBody>
+      </p:sp>
+      <p:sp>
+        <p:nvSpPr>
+          <p:cNvPr id="7" name="Rectangle 6"/>
+          <p:cNvSpPr/>
+          <p:nvPr/>
+        </p:nvSpPr>
+        <p:spPr>
+          <a:xfrm>
+            <a:off x="722376" y="1508760"/>
+            <a:ext cx="457200" cy="548640"/>
+          </a:xfrm>
+          <a:prstGeom prst="rect">
+            <a:avLst/>
+          </a:prstGeom>
+          <a:solidFill>
+            <a:srgbClr val="132C43"/>
+          </a:solidFill>
+          <a:ln>
+            <a:noFill/>
+          </a:ln>
+          <a:effectLst/>
+        </p:spPr>
+        <p:style>
+          <a:lnRef idx="1">
+            <a:schemeClr val="accent1"/>
+          </a:lnRef>
+          <a:fillRef idx="3">
+            <a:schemeClr val="accent1"/>
+          </a:fillRef>
+          <a:effectRef idx="2">
+            <a:schemeClr val="accent1"/>
+          </a:effectRef>
+          <a:fontRef idx="minor">
+            <a:schemeClr val="lt1"/>
+          </a:fontRef>
+        </p:style>
+        <p:txBody>
+          <a:bodyPr rtlCol="0" anchor="ctr" lIns="0" rIns="0" wrap="square"/>
+          <a:lstStyle/>
+          <a:p>
+            <a:pPr algn="ctr">
+              <a:spcAft>
+                <a:spcPts val="200"/>
+              </a:spcAft>
+            </a:pPr>
+            <a:r>
+              <a:rPr sz="1500" b="1" i="0">
+                <a:solidFill>
+                  <a:srgbClr val="FFFFFF"/>
+                </a:solidFill>
+                <a:latin typeface="Bitstream Charter"/>
+              </a:rPr>
+              <a:t>1</a:t>
+            </a:r>
+          </a:p>
+        </p:txBody>
+      </p:sp>
+      <p:sp>
+        <p:nvSpPr>
+          <p:cNvPr id="8" name="Down Arrow 7"/>
+          <p:cNvSpPr/>
+          <p:nvPr/>
+        </p:nvSpPr>
+        <p:spPr>
+          <a:xfrm>
+            <a:off x="2926080" y="2057400"/>
+            <a:ext cx="274320" cy="182880"/>
+          </a:xfrm>
+          <a:prstGeom prst="downArrow">
+            <a:avLst/>
+          </a:prstGeom>
+          <a:solidFill>
+            <a:srgbClr val="D1495B"/>
+          </a:solidFill>
+          <a:ln>
+            <a:noFill/>
+          </a:ln>
+          <a:effectLst/>
+        </p:spPr>
+        <p:style>
+          <a:lnRef idx="1">
+            <a:schemeClr val="accent1"/>
+          </a:lnRef>
+          <a:fillRef idx="3">
+            <a:schemeClr val="accent1"/>
+          </a:fillRef>
+          <a:effectRef idx="2">
+            <a:schemeClr val="accent1"/>
+          </a:effectRef>
+          <a:fontRef idx="minor">
+            <a:schemeClr val="lt1"/>
+          </a:fontRef>
+        </p:style>
+        <p:txBody>
+          <a:bodyPr rtlCol="0" anchor="ctr"/>
+          <a:lstStyle/>
+          <a:p>
+            <a:pPr algn="ctr"/>
+          </a:p>
+        </p:txBody>
+      </p:sp>
+      <p:sp>
+        <p:nvSpPr>
+          <p:cNvPr id="9" name="Rectangle 8"/>
+          <p:cNvSpPr/>
+          <p:nvPr/>
+        </p:nvSpPr>
+        <p:spPr>
+          <a:xfrm>
+            <a:off x="722376" y="2240280"/>
+            <a:ext cx="4754880" cy="548640"/>
+          </a:xfrm>
+          <a:prstGeom prst="rect">
+            <a:avLst/>
+          </a:prstGeom>
+          <a:solidFill>
+            <a:srgbClr val="FFFFFF"/>
+          </a:solidFill>
+          <a:ln w="9525">
+            <a:solidFill>
+              <a:srgbClr val="C9D6E2"/>
+            </a:solidFill>
+          </a:ln>
+          <a:effectLst/>
+        </p:spPr>
+        <p:style>
+          <a:lnRef idx="1">
+            <a:schemeClr val="accent1"/>
+          </a:lnRef>
+          <a:fillRef idx="3">
+            <a:schemeClr val="accent1"/>
+          </a:fillRef>
+          <a:effectRef idx="2">
+            <a:schemeClr val="accent1"/>
+          </a:effectRef>
+          <a:fontRef idx="minor">
+            <a:schemeClr val="lt1"/>
+          </a:fontRef>
+        </p:style>
+        <p:txBody>
+          <a:bodyPr rtlCol="0" anchor="ctr" lIns="566928" rIns="566928" wrap="square"/>
+          <a:lstStyle/>
+          <a:p>
+            <a:pPr algn="l">
+              <a:spcAft>
+                <a:spcPts val="0"/>
+              </a:spcAft>
+            </a:pPr>
+            <a:r>
+              <a:rPr sz="1100" b="1" i="0">
+                <a:solidFill>
+                  <a:srgbClr val="132C43"/>
+                </a:solidFill>
+                <a:latin typeface="Bitstream Charter"/>
+              </a:rPr>
+              <a:t>Steam answers</a:t>
+            </a:r>
+          </a:p>
+          <a:p>
+            <a:pPr algn="l">
+              <a:spcAft>
+                <a:spcPts val="0"/>
+              </a:spcAft>
+            </a:pPr>
+            <a:r>
+              <a:rPr sz="950" b="0" i="0">
+                <a:solidFill>
+                  <a:srgbClr val="263C50"/>
+                </a:solidFill>
+                <a:latin typeface="Bitstream Charter"/>
+              </a:rPr>
+              <a:t>100 reviews plus a cursor that points to the next page</a:t>
+            </a:r>
+          </a:p>
+        </p:txBody>
+      </p:sp>
+      <p:sp>
+        <p:nvSpPr>
+          <p:cNvPr id="10" name="Rectangle 9"/>
+          <p:cNvSpPr/>
+          <p:nvPr/>
+        </p:nvSpPr>
+        <p:spPr>
+          <a:xfrm>
+            <a:off x="722376" y="2240280"/>
+            <a:ext cx="457200" cy="548640"/>
+          </a:xfrm>
+          <a:prstGeom prst="rect">
+            <a:avLst/>
+          </a:prstGeom>
+          <a:solidFill>
+            <a:srgbClr val="132C43"/>
+          </a:solidFill>
+          <a:ln>
+            <a:noFill/>
+          </a:ln>
+          <a:effectLst/>
+        </p:spPr>
+        <p:style>
+          <a:lnRef idx="1">
+            <a:schemeClr val="accent1"/>
+          </a:lnRef>
+          <a:fillRef idx="3">
+            <a:schemeClr val="accent1"/>
+          </a:fillRef>
+          <a:effectRef idx="2">
+            <a:schemeClr val="accent1"/>
+          </a:effectRef>
+          <a:fontRef idx="minor">
+            <a:schemeClr val="lt1"/>
+          </a:fontRef>
+        </p:style>
+        <p:txBody>
+          <a:bodyPr rtlCol="0" anchor="ctr" lIns="0" rIns="0" wrap="square"/>
+          <a:lstStyle/>
+          <a:p>
+            <a:pPr algn="ctr">
+              <a:spcAft>
+                <a:spcPts val="200"/>
+              </a:spcAft>
+            </a:pPr>
+            <a:r>
+              <a:rPr sz="1500" b="1" i="0">
+                <a:solidFill>
+                  <a:srgbClr val="FFFFFF"/>
+                </a:solidFill>
+                <a:latin typeface="Bitstream Charter"/>
+              </a:rPr>
+              <a:t>2</a:t>
+            </a:r>
+          </a:p>
+        </p:txBody>
+      </p:sp>
+      <p:sp>
+        <p:nvSpPr>
+          <p:cNvPr id="11" name="Down Arrow 10"/>
+          <p:cNvSpPr/>
+          <p:nvPr/>
+        </p:nvSpPr>
+        <p:spPr>
+          <a:xfrm>
+            <a:off x="2926080" y="2788920"/>
+            <a:ext cx="274320" cy="182880"/>
+          </a:xfrm>
+          <a:prstGeom prst="downArrow">
+            <a:avLst/>
+          </a:prstGeom>
+          <a:solidFill>
+            <a:srgbClr val="D1495B"/>
+          </a:solidFill>
+          <a:ln>
+            <a:noFill/>
+          </a:ln>
+          <a:effectLst/>
+        </p:spPr>
+        <p:style>
+          <a:lnRef idx="1">
+            <a:schemeClr val="accent1"/>
+          </a:lnRef>
+          <a:fillRef idx="3">
+            <a:schemeClr val="accent1"/>
+          </a:fillRef>
+          <a:effectRef idx="2">
+            <a:schemeClr val="accent1"/>
+          </a:effectRef>
+          <a:fontRef idx="minor">
+            <a:schemeClr val="lt1"/>
+          </a:fontRef>
+        </p:style>
+        <p:txBody>
+          <a:bodyPr rtlCol="0" anchor="ctr"/>
+          <a:lstStyle/>
+          <a:p>
+            <a:pPr algn="ctr"/>
+          </a:p>
+        </p:txBody>
+      </p:sp>
+      <p:sp>
+        <p:nvSpPr>
+          <p:cNvPr id="12" name="Rectangle 11"/>
+          <p:cNvSpPr/>
+          <p:nvPr/>
+        </p:nvSpPr>
+        <p:spPr>
+          <a:xfrm>
+            <a:off x="722376" y="2971800"/>
+            <a:ext cx="4754880" cy="548640"/>
+          </a:xfrm>
+          <a:prstGeom prst="rect">
+            <a:avLst/>
+          </a:prstGeom>
+          <a:solidFill>
+            <a:srgbClr val="FFFFFF"/>
+          </a:solidFill>
+          <a:ln w="9525">
+            <a:solidFill>
+              <a:srgbClr val="C9D6E2"/>
+            </a:solidFill>
+          </a:ln>
+          <a:effectLst/>
+        </p:spPr>
+        <p:style>
+          <a:lnRef idx="1">
+            <a:schemeClr val="accent1"/>
+          </a:lnRef>
+          <a:fillRef idx="3">
+            <a:schemeClr val="accent1"/>
+          </a:fillRef>
+          <a:effectRef idx="2">
+            <a:schemeClr val="accent1"/>
+          </a:effectRef>
+          <a:fontRef idx="minor">
+            <a:schemeClr val="lt1"/>
+          </a:fontRef>
+        </p:style>
+        <p:txBody>
+          <a:bodyPr rtlCol="0" anchor="ctr" lIns="566928" rIns="566928" wrap="square"/>
+          <a:lstStyle/>
+          <a:p>
+            <a:pPr algn="l">
+              <a:spcAft>
+                <a:spcPts val="0"/>
+              </a:spcAft>
+            </a:pPr>
+            <a:r>
+              <a:rPr sz="1100" b="1" i="0">
+                <a:solidFill>
+                  <a:srgbClr val="132C43"/>
+                </a:solidFill>
+                <a:latin typeface="Bitstream Charter"/>
+              </a:rPr>
+              <a:t>Save and checkpoint</a:t>
+            </a:r>
+          </a:p>
+          <a:p>
+            <a:pPr algn="l">
+              <a:spcAft>
+                <a:spcPts val="0"/>
+              </a:spcAft>
+            </a:pPr>
+            <a:r>
+              <a:rPr sz="950" b="0" i="0">
+                <a:solidFill>
+                  <a:srgbClr val="263C50"/>
+                </a:solidFill>
+                <a:latin typeface="Bitstream Charter"/>
+              </a:rPr>
+              <a:t>append to .part.jsonl, write the cursor to .state.json</a:t>
+            </a:r>
+          </a:p>
+        </p:txBody>
+      </p:sp>
+      <p:sp>
+        <p:nvSpPr>
+          <p:cNvPr id="13" name="Rectangle 12"/>
+          <p:cNvSpPr/>
+          <p:nvPr/>
+        </p:nvSpPr>
+        <p:spPr>
+          <a:xfrm>
+            <a:off x="722376" y="2971800"/>
+            <a:ext cx="457200" cy="548640"/>
+          </a:xfrm>
+          <a:prstGeom prst="rect">
+            <a:avLst/>
+          </a:prstGeom>
+          <a:solidFill>
+            <a:srgbClr val="132C43"/>
+          </a:solidFill>
+          <a:ln>
+            <a:noFill/>
+          </a:ln>
+          <a:effectLst/>
+        </p:spPr>
+        <p:style>
+          <a:lnRef idx="1">
+            <a:schemeClr val="accent1"/>
+          </a:lnRef>
+          <a:fillRef idx="3">
+            <a:schemeClr val="accent1"/>
+          </a:fillRef>
+          <a:effectRef idx="2">
+            <a:schemeClr val="accent1"/>
+          </a:effectRef>
+          <a:fontRef idx="minor">
+            <a:schemeClr val="lt1"/>
+          </a:fontRef>
+        </p:style>
+        <p:txBody>
+          <a:bodyPr rtlCol="0" anchor="ctr" lIns="0" rIns="0" wrap="square"/>
+          <a:lstStyle/>
+          <a:p>
+            <a:pPr algn="ctr">
+              <a:spcAft>
+                <a:spcPts val="200"/>
+              </a:spcAft>
+            </a:pPr>
+            <a:r>
+              <a:rPr sz="1500" b="1" i="0">
+                <a:solidFill>
+                  <a:srgbClr val="FFFFFF"/>
+                </a:solidFill>
+                <a:latin typeface="Bitstream Charter"/>
+              </a:rPr>
+              <a:t>3</a:t>
+            </a:r>
+          </a:p>
+        </p:txBody>
+      </p:sp>
+      <p:sp>
+        <p:nvSpPr>
+          <p:cNvPr id="14" name="Down Arrow 13"/>
+          <p:cNvSpPr/>
+          <p:nvPr/>
+        </p:nvSpPr>
+        <p:spPr>
+          <a:xfrm>
+            <a:off x="2926080" y="3520440"/>
+            <a:ext cx="274320" cy="182880"/>
+          </a:xfrm>
+          <a:prstGeom prst="downArrow">
+            <a:avLst/>
+          </a:prstGeom>
+          <a:solidFill>
+            <a:srgbClr val="D1495B"/>
+          </a:solidFill>
+          <a:ln>
+            <a:noFill/>
+          </a:ln>
+          <a:effectLst/>
+        </p:spPr>
+        <p:style>
+          <a:lnRef idx="1">
+            <a:schemeClr val="accent1"/>
+          </a:lnRef>
+          <a:fillRef idx="3">
+            <a:schemeClr val="accent1"/>
+          </a:fillRef>
+          <a:effectRef idx="2">
+            <a:schemeClr val="accent1"/>
+          </a:effectRef>
+          <a:fontRef idx="minor">
+            <a:schemeClr val="lt1"/>
+          </a:fontRef>
+        </p:style>
+        <p:txBody>
+          <a:bodyPr rtlCol="0" anchor="ctr"/>
+          <a:lstStyle/>
+          <a:p>
+            <a:pPr algn="ctr"/>
+          </a:p>
+        </p:txBody>
+      </p:sp>
+      <p:sp>
+        <p:nvSpPr>
+          <p:cNvPr id="15" name="Rectangle 14"/>
+          <p:cNvSpPr/>
+          <p:nvPr/>
+        </p:nvSpPr>
+        <p:spPr>
+          <a:xfrm>
+            <a:off x="722376" y="3703320"/>
+            <a:ext cx="4754880" cy="548640"/>
+          </a:xfrm>
+          <a:prstGeom prst="rect">
+            <a:avLst/>
+          </a:prstGeom>
+          <a:solidFill>
+            <a:srgbClr val="FFFFFF"/>
+          </a:solidFill>
+          <a:ln w="9525">
+            <a:solidFill>
+              <a:srgbClr val="C9D6E2"/>
+            </a:solidFill>
+          </a:ln>
+          <a:effectLst/>
+        </p:spPr>
+        <p:style>
+          <a:lnRef idx="1">
+            <a:schemeClr val="accent1"/>
+          </a:lnRef>
+          <a:fillRef idx="3">
+            <a:schemeClr val="accent1"/>
+          </a:fillRef>
+          <a:effectRef idx="2">
+            <a:schemeClr val="accent1"/>
+          </a:effectRef>
+          <a:fontRef idx="minor">
+            <a:schemeClr val="lt1"/>
+          </a:fontRef>
+        </p:style>
+        <p:txBody>
+          <a:bodyPr rtlCol="0" anchor="ctr" lIns="566928" rIns="566928" wrap="square"/>
+          <a:lstStyle/>
+          <a:p>
+            <a:pPr algn="l">
+              <a:spcAft>
+                <a:spcPts val="0"/>
+              </a:spcAft>
+            </a:pPr>
+            <a:r>
+              <a:rPr sz="1100" b="1" i="0">
+                <a:solidFill>
+                  <a:srgbClr val="132C43"/>
+                </a:solidFill>
+                <a:latin typeface="Bitstream Charter"/>
+              </a:rPr>
+              <a:t>Repeat</a:t>
+            </a:r>
+          </a:p>
+          <a:p>
+            <a:pPr algn="l">
+              <a:spcAft>
+                <a:spcPts val="0"/>
+              </a:spcAft>
+            </a:pPr>
+            <a:r>
+              <a:rPr sz="950" b="0" i="0">
+                <a:solidFill>
+                  <a:srgbClr val="263C50"/>
+                </a:solidFill>
+                <a:latin typeface="Bitstream Charter"/>
+              </a:rPr>
+              <a:t>until the reviews run out, the cursor repeats, or the 15k cap is hit</a:t>
+            </a:r>
+          </a:p>
+        </p:txBody>
+      </p:sp>
+      <p:sp>
+        <p:nvSpPr>
+          <p:cNvPr id="16" name="Rectangle 15"/>
+          <p:cNvSpPr/>
+          <p:nvPr/>
+        </p:nvSpPr>
+        <p:spPr>
+          <a:xfrm>
+            <a:off x="722376" y="3703320"/>
+            <a:ext cx="457200" cy="548640"/>
+          </a:xfrm>
+          <a:prstGeom prst="rect">
+            <a:avLst/>
+          </a:prstGeom>
+          <a:solidFill>
+            <a:srgbClr val="D1495B"/>
+          </a:solidFill>
+          <a:ln>
+            <a:noFill/>
+          </a:ln>
+          <a:effectLst/>
+        </p:spPr>
+        <p:style>
+          <a:lnRef idx="1">
+            <a:schemeClr val="accent1"/>
+          </a:lnRef>
+          <a:fillRef idx="3">
+            <a:schemeClr val="accent1"/>
+          </a:fillRef>
+          <a:effectRef idx="2">
+            <a:schemeClr val="accent1"/>
+          </a:effectRef>
+          <a:fontRef idx="minor">
+            <a:schemeClr val="lt1"/>
+          </a:fontRef>
+        </p:style>
+        <p:txBody>
+          <a:bodyPr rtlCol="0" anchor="ctr" lIns="0" rIns="0" wrap="square"/>
+          <a:lstStyle/>
+          <a:p>
+            <a:pPr algn="ctr">
+              <a:spcAft>
+                <a:spcPts val="200"/>
+              </a:spcAft>
+            </a:pPr>
+            <a:r>
+              <a:rPr sz="1500" b="1" i="0">
+                <a:solidFill>
+                  <a:srgbClr val="FFFFFF"/>
+                </a:solidFill>
+                <a:latin typeface="Bitstream Charter"/>
+              </a:rPr>
+              <a:t>4</a:t>
+            </a:r>
+          </a:p>
+        </p:txBody>
+      </p:sp>
+      <p:sp>
+        <p:nvSpPr>
+          <p:cNvPr id="17" name="Down Arrow 16"/>
+          <p:cNvSpPr/>
+          <p:nvPr/>
+        </p:nvSpPr>
+        <p:spPr>
+          <a:xfrm>
+            <a:off x="2926080" y="4251960"/>
+            <a:ext cx="274320" cy="182880"/>
+          </a:xfrm>
+          <a:prstGeom prst="downArrow">
+            <a:avLst/>
+          </a:prstGeom>
+          <a:solidFill>
+            <a:srgbClr val="D1495B"/>
+          </a:solidFill>
+          <a:ln>
+            <a:noFill/>
+          </a:ln>
+          <a:effectLst/>
+        </p:spPr>
+        <p:style>
+          <a:lnRef idx="1">
+            <a:schemeClr val="accent1"/>
+          </a:lnRef>
+          <a:fillRef idx="3">
+            <a:schemeClr val="accent1"/>
+          </a:fillRef>
+          <a:effectRef idx="2">
+            <a:schemeClr val="accent1"/>
+          </a:effectRef>
+          <a:fontRef idx="minor">
+            <a:schemeClr val="lt1"/>
+          </a:fontRef>
+        </p:style>
+        <p:txBody>
+          <a:bodyPr rtlCol="0" anchor="ctr"/>
+          <a:lstStyle/>
+          <a:p>
+            <a:pPr algn="ctr"/>
+          </a:p>
+        </p:txBody>
+      </p:sp>
+      <p:sp>
+        <p:nvSpPr>
+          <p:cNvPr id="18" name="Rectangle 17"/>
+          <p:cNvSpPr/>
+          <p:nvPr/>
+        </p:nvSpPr>
+        <p:spPr>
+          <a:xfrm>
+            <a:off x="722376" y="4434840"/>
+            <a:ext cx="4754880" cy="548640"/>
+          </a:xfrm>
+          <a:prstGeom prst="rect">
+            <a:avLst/>
+          </a:prstGeom>
+          <a:solidFill>
+            <a:srgbClr val="FFFFFF"/>
+          </a:solidFill>
+          <a:ln w="9525">
+            <a:solidFill>
+              <a:srgbClr val="C9D6E2"/>
+            </a:solidFill>
+          </a:ln>
+          <a:effectLst/>
+        </p:spPr>
+        <p:style>
+          <a:lnRef idx="1">
+            <a:schemeClr val="accent1"/>
+          </a:lnRef>
+          <a:fillRef idx="3">
+            <a:schemeClr val="accent1"/>
+          </a:fillRef>
+          <a:effectRef idx="2">
+            <a:schemeClr val="accent1"/>
+          </a:effectRef>
+          <a:fontRef idx="minor">
+            <a:schemeClr val="lt1"/>
+          </a:fontRef>
+        </p:style>
+        <p:txBody>
+          <a:bodyPr rtlCol="0" anchor="ctr" lIns="566928" rIns="566928" wrap="square"/>
+          <a:lstStyle/>
+          <a:p>
+            <a:pPr algn="l">
+              <a:spcAft>
+                <a:spcPts val="0"/>
+              </a:spcAft>
+            </a:pPr>
+            <a:r>
+              <a:rPr sz="1100" b="1" i="0">
+                <a:solidFill>
+                  <a:srgbClr val="132C43"/>
+                </a:solidFill>
+                <a:latin typeface="Bitstream Charter"/>
+              </a:rPr>
+              <a:t>Finish</a:t>
+            </a:r>
+          </a:p>
+          <a:p>
+            <a:pPr algn="l">
+              <a:spcAft>
+                <a:spcPts val="0"/>
+              </a:spcAft>
+            </a:pPr>
+            <a:r>
+              <a:rPr sz="950" b="0" i="0">
+                <a:solidFill>
+                  <a:srgbClr val="263C50"/>
+                </a:solidFill>
+                <a:latin typeface="Bitstream Charter"/>
+              </a:rPr>
+              <a:t>gzip to &lt;appid&gt;.jsonl.gz and write &lt;appid&gt;.done.json</a:t>
+            </a:r>
+          </a:p>
+        </p:txBody>
+      </p:sp>
+      <p:sp>
+        <p:nvSpPr>
+          <p:cNvPr id="19" name="Rectangle 18"/>
+          <p:cNvSpPr/>
+          <p:nvPr/>
+        </p:nvSpPr>
+        <p:spPr>
+          <a:xfrm>
+            <a:off x="722376" y="4434840"/>
+            <a:ext cx="457200" cy="548640"/>
+          </a:xfrm>
+          <a:prstGeom prst="rect">
+            <a:avLst/>
+          </a:prstGeom>
+          <a:solidFill>
+            <a:srgbClr val="132C43"/>
+          </a:solidFill>
+          <a:ln>
+            <a:noFill/>
+          </a:ln>
+          <a:effectLst/>
+        </p:spPr>
+        <p:style>
+          <a:lnRef idx="1">
+            <a:schemeClr val="accent1"/>
+          </a:lnRef>
+          <a:fillRef idx="3">
+            <a:schemeClr val="accent1"/>
+          </a:fillRef>
+          <a:effectRef idx="2">
+            <a:schemeClr val="accent1"/>
+          </a:effectRef>
+          <a:fontRef idx="minor">
+            <a:schemeClr val="lt1"/>
+          </a:fontRef>
+        </p:style>
+        <p:txBody>
+          <a:bodyPr rtlCol="0" anchor="ctr" lIns="0" rIns="0" wrap="square"/>
+          <a:lstStyle/>
+          <a:p>
+            <a:pPr algn="ctr">
+              <a:spcAft>
+                <a:spcPts val="200"/>
+              </a:spcAft>
+            </a:pPr>
+            <a:r>
+              <a:rPr sz="1500" b="1" i="0">
+                <a:solidFill>
+                  <a:srgbClr val="FFFFFF"/>
+                </a:solidFill>
+                <a:latin typeface="Bitstream Charter"/>
+              </a:rPr>
+              <a:t>5</a:t>
+            </a:r>
+          </a:p>
+        </p:txBody>
+      </p:sp>
+      <p:sp>
+        <p:nvSpPr>
+          <p:cNvPr id="20" name="TextBox 19"/>
+          <p:cNvSpPr txBox="1"/>
+          <p:nvPr/>
+        </p:nvSpPr>
+        <p:spPr>
+          <a:xfrm>
+            <a:off x="5989320" y="1417320"/>
+            <a:ext cx="5486400" cy="274320"/>
+          </a:xfrm>
+          <a:prstGeom prst="rect">
+            <a:avLst/>
+          </a:prstGeom>
+          <a:noFill/>
+        </p:spPr>
+        <p:txBody>
+          <a:bodyPr wrap="square" lIns="45720" rIns="45720" tIns="27432" bIns="27432">
+            <a:spAutoFit/>
+          </a:bodyPr>
+          <a:lstStyle/>
+          <a:p>
+            <a:pPr>
+              <a:spcAft>
+                <a:spcPts val="400"/>
+              </a:spcAft>
+            </a:pPr>
+            <a:r>
+              <a:rPr sz="1150" b="1" i="0">
+                <a:solidFill>
+                  <a:srgbClr val="132C43"/>
+                </a:solidFill>
+                <a:latin typeface="Bitstream Charter"/>
+              </a:rPr>
+              <a:t>One raw review record, field by field</a:t>
+            </a:r>
+          </a:p>
+        </p:txBody>
+      </p:sp>
+      <p:graphicFrame>
+        <p:nvGraphicFramePr>
+          <p:cNvPr id="21" name="Table 20"/>
+          <p:cNvGraphicFramePr>
+            <a:graphicFrameLocks noGrp="1"/>
+          </p:cNvGraphicFramePr>
+          <p:nvPr/>
+        </p:nvGraphicFramePr>
+        <p:xfrm>
+          <a:off x="5989320" y="1719072"/>
+          <a:ext cx="5486400" cy="2715768"/>
+        </p:xfrm>
+        <a:graphic>
+          <a:graphicData uri="http://schemas.openxmlformats.org/drawingml/2006/table">
+            <a:tbl>
+              <a:tblPr firstRow="0" bandRow="0">
+                <a:tableStyleId>{2D5ABB26-0587-4C30-8999-92F81FD0307C}</a:tableStyleId>
+              </a:tblPr>
+              <a:tblGrid>
+                <a:gridCol w="2057400"/>
+                <a:gridCol w="731520"/>
+                <a:gridCol w="2697480"/>
+              </a:tblGrid>
+              <a:tr h="301752">
+                <a:tc>
+                  <a:txBody>
+                    <a:bodyPr wrap="square"/>
+                    <a:lstStyle/>
+                    <a:p>
+                      <a:r>
+                        <a:rPr sz="950" b="1" i="0">
+                          <a:solidFill>
+                            <a:srgbClr val="FFFFFF"/>
+                          </a:solidFill>
+                          <a:latin typeface="Bitstream Charter"/>
+                        </a:rPr>
+                        <a:t>Raw field</a:t>
+                      </a:r>
+                    </a:p>
+                  </a:txBody>
+                  <a:tcPr marL="64008" marR="64008" marT="32004" marB="32004" anchor="ctr">
+                    <a:solidFill>
+                      <a:srgbClr val="132C43"/>
+                    </a:solidFill>
+                  </a:tcPr>
+                </a:tc>
+                <a:tc>
+                  <a:txBody>
+                    <a:bodyPr wrap="square"/>
+                    <a:lstStyle/>
+                    <a:p>
+                      <a:r>
+                        <a:rPr sz="950" b="1" i="0">
+                          <a:solidFill>
+                            <a:srgbClr val="FFFFFF"/>
+                          </a:solidFill>
+                          <a:latin typeface="Bitstream Charter"/>
+                        </a:rPr>
+                        <a:t>Action</a:t>
+                      </a:r>
+                    </a:p>
+                  </a:txBody>
+                  <a:tcPr marL="64008" marR="64008" marT="32004" marB="32004" anchor="ctr">
+                    <a:solidFill>
+                      <a:srgbClr val="132C43"/>
+                    </a:solidFill>
+                  </a:tcPr>
+                </a:tc>
+                <a:tc>
+                  <a:txBody>
+                    <a:bodyPr wrap="square"/>
+                    <a:lstStyle/>
+                    <a:p>
+                      <a:r>
+                        <a:rPr sz="950" b="1" i="0">
+                          <a:solidFill>
+                            <a:srgbClr val="FFFFFF"/>
+                          </a:solidFill>
+                          <a:latin typeface="Bitstream Charter"/>
+                        </a:rPr>
+                        <a:t>Why</a:t>
+                      </a:r>
+                    </a:p>
+                  </a:txBody>
+                  <a:tcPr marL="64008" marR="64008" marT="32004" marB="32004" anchor="ctr">
+                    <a:solidFill>
+                      <a:srgbClr val="132C43"/>
+                    </a:solidFill>
+                  </a:tcPr>
+                </a:tc>
+              </a:tr>
+              <a:tr h="301752">
+                <a:tc>
+                  <a:txBody>
+                    <a:bodyPr wrap="square"/>
+                    <a:lstStyle/>
+                    <a:p>
+                      <a:r>
+                        <a:rPr sz="950" b="0" i="0">
+                          <a:solidFill>
+                            <a:srgbClr val="263C50"/>
+                          </a:solidFill>
+                          <a:latin typeface="Bitstream Charter"/>
+                        </a:rPr>
+                        <a:t>recommendationid</a:t>
+                      </a:r>
+                    </a:p>
+                  </a:txBody>
+                  <a:tcPr marL="64008" marR="64008" marT="32004" marB="32004" anchor="ctr">
+                    <a:lnB w="9525" cap="flat" cmpd="sng" algn="ctr">
+                      <a:solidFill>
+                        <a:srgbClr val="C9D6E2"/>
+                      </a:solidFill>
+                      <a:prstDash val="solid"/>
+                    </a:lnB>
+                    <a:solidFill>
+                      <a:srgbClr val="FFFFFF"/>
+                    </a:solidFill>
+                  </a:tcPr>
+                </a:tc>
+                <a:tc>
+                  <a:txBody>
+                    <a:bodyPr wrap="square"/>
+                    <a:lstStyle/>
+                    <a:p>
+                      <a:r>
+                        <a:rPr sz="950" b="0" i="0">
+                          <a:solidFill>
+                            <a:srgbClr val="263C50"/>
+                          </a:solidFill>
+                          <a:latin typeface="Bitstream Charter"/>
+                        </a:rPr>
+                        <a:t>kept</a:t>
+                      </a:r>
+                    </a:p>
+                  </a:txBody>
+                  <a:tcPr marL="64008" marR="64008" marT="32004" marB="32004" anchor="ctr">
+                    <a:lnB w="9525" cap="flat" cmpd="sng" algn="ctr">
+                      <a:solidFill>
+                        <a:srgbClr val="C9D6E2"/>
+                      </a:solidFill>
+                      <a:prstDash val="solid"/>
+                    </a:lnB>
+                    <a:solidFill>
+                      <a:srgbClr val="FFFFFF"/>
+                    </a:solidFill>
+                  </a:tcPr>
+                </a:tc>
+                <a:tc>
+                  <a:txBody>
+                    <a:bodyPr wrap="square"/>
+                    <a:lstStyle/>
+                    <a:p>
+                      <a:r>
+                        <a:rPr sz="950" b="0" i="0">
+                          <a:solidFill>
+                            <a:srgbClr val="263C50"/>
+                          </a:solidFill>
+                          <a:latin typeface="Bitstream Charter"/>
+                        </a:rPr>
+                        <a:t>unique review ID, used to remove duplicates</a:t>
+                      </a:r>
+                    </a:p>
+                  </a:txBody>
+                  <a:tcPr marL="64008" marR="64008" marT="32004" marB="32004" anchor="ctr">
+                    <a:lnB w="9525" cap="flat" cmpd="sng" algn="ctr">
+                      <a:solidFill>
+                        <a:srgbClr val="C9D6E2"/>
+                      </a:solidFill>
+                      <a:prstDash val="solid"/>
+                    </a:lnB>
+                    <a:solidFill>
+                      <a:srgbClr val="FFFFFF"/>
+                    </a:solidFill>
+                  </a:tcPr>
+                </a:tc>
+              </a:tr>
+              <a:tr h="301752">
+                <a:tc>
+                  <a:txBody>
+                    <a:bodyPr wrap="square"/>
+                    <a:lstStyle/>
+                    <a:p>
+                      <a:r>
+                        <a:rPr sz="950" b="0" i="0">
+                          <a:solidFill>
+                            <a:srgbClr val="263C50"/>
+                          </a:solidFill>
+                          <a:latin typeface="Bitstream Charter"/>
+                        </a:rPr>
+                        <a:t>author.steamid</a:t>
+                      </a:r>
+                    </a:p>
+                  </a:txBody>
+                  <a:tcPr marL="64008" marR="64008" marT="32004" marB="32004" anchor="ctr">
+                    <a:lnB w="9525" cap="flat" cmpd="sng" algn="ctr">
+                      <a:solidFill>
+                        <a:srgbClr val="C9D6E2"/>
+                      </a:solidFill>
+                      <a:prstDash val="solid"/>
+                    </a:lnB>
+                    <a:solidFill>
+                      <a:srgbClr val="EAF0F6"/>
+                    </a:solidFill>
+                  </a:tcPr>
+                </a:tc>
+                <a:tc>
+                  <a:txBody>
+                    <a:bodyPr wrap="square"/>
+                    <a:lstStyle/>
+                    <a:p>
+                      <a:r>
+                        <a:rPr sz="950" b="0" i="0">
+                          <a:solidFill>
+                            <a:srgbClr val="263C50"/>
+                          </a:solidFill>
+                          <a:latin typeface="Bitstream Charter"/>
+                        </a:rPr>
+                        <a:t>hashed</a:t>
+                      </a:r>
+                    </a:p>
+                  </a:txBody>
+                  <a:tcPr marL="64008" marR="64008" marT="32004" marB="32004" anchor="ctr">
+                    <a:lnB w="9525" cap="flat" cmpd="sng" algn="ctr">
+                      <a:solidFill>
+                        <a:srgbClr val="C9D6E2"/>
+                      </a:solidFill>
+                      <a:prstDash val="solid"/>
+                    </a:lnB>
+                    <a:solidFill>
+                      <a:srgbClr val="EAF0F6"/>
+                    </a:solidFill>
+                  </a:tcPr>
+                </a:tc>
+                <a:tc>
+                  <a:txBody>
+                    <a:bodyPr wrap="square"/>
+                    <a:lstStyle/>
+                    <a:p>
+                      <a:r>
+                        <a:rPr sz="950" b="0" i="0">
+                          <a:solidFill>
+                            <a:srgbClr val="263C50"/>
+                          </a:solidFill>
+                          <a:latin typeface="Bitstream Charter"/>
+                        </a:rPr>
+                        <a:t>salted SHA256, 20 characters; the raw ID is not stored</a:t>
+                      </a:r>
+                    </a:p>
+                  </a:txBody>
+                  <a:tcPr marL="64008" marR="64008" marT="32004" marB="32004" anchor="ctr">
+                    <a:lnB w="9525" cap="flat" cmpd="sng" algn="ctr">
+                      <a:solidFill>
+                        <a:srgbClr val="C9D6E2"/>
+                      </a:solidFill>
+                      <a:prstDash val="solid"/>
+                    </a:lnB>
+                    <a:solidFill>
+                      <a:srgbClr val="EAF0F6"/>
+                    </a:solidFill>
+                  </a:tcPr>
+                </a:tc>
+              </a:tr>
+              <a:tr h="301752">
+                <a:tc>
+                  <a:txBody>
+                    <a:bodyPr wrap="square"/>
+                    <a:lstStyle/>
+                    <a:p>
+                      <a:r>
+                        <a:rPr sz="950" b="0" i="0">
+                          <a:solidFill>
+                            <a:srgbClr val="263C50"/>
+                          </a:solidFill>
+                          <a:latin typeface="Bitstream Charter"/>
+                        </a:rPr>
+                        <a:t>personaname, avatar, profile_url</a:t>
+                      </a:r>
+                    </a:p>
+                  </a:txBody>
+                  <a:tcPr marL="64008" marR="64008" marT="32004" marB="32004" anchor="ctr">
+                    <a:lnB w="9525" cap="flat" cmpd="sng" algn="ctr">
+                      <a:solidFill>
+                        <a:srgbClr val="C9D6E2"/>
+                      </a:solidFill>
+                      <a:prstDash val="solid"/>
+                    </a:lnB>
+                    <a:solidFill>
+                      <a:srgbClr val="FFFFFF"/>
+                    </a:solidFill>
+                  </a:tcPr>
+                </a:tc>
+                <a:tc>
+                  <a:txBody>
+                    <a:bodyPr wrap="square"/>
+                    <a:lstStyle/>
+                    <a:p>
+                      <a:r>
+                        <a:rPr sz="950" b="1" i="0">
+                          <a:solidFill>
+                            <a:srgbClr val="D1495B"/>
+                          </a:solidFill>
+                          <a:latin typeface="Bitstream Charter"/>
+                        </a:rPr>
+                        <a:t>dropped</a:t>
+                      </a:r>
+                    </a:p>
+                  </a:txBody>
+                  <a:tcPr marL="64008" marR="64008" marT="32004" marB="32004" anchor="ctr">
+                    <a:lnB w="9525" cap="flat" cmpd="sng" algn="ctr">
+                      <a:solidFill>
+                        <a:srgbClr val="C9D6E2"/>
+                      </a:solidFill>
+                      <a:prstDash val="solid"/>
+                    </a:lnB>
+                    <a:solidFill>
+                      <a:srgbClr val="FFFFFF"/>
+                    </a:solidFill>
+                  </a:tcPr>
+                </a:tc>
+                <a:tc>
+                  <a:txBody>
+                    <a:bodyPr wrap="square"/>
+                    <a:lstStyle/>
+                    <a:p>
+                      <a:r>
+                        <a:rPr sz="950" b="0" i="0">
+                          <a:solidFill>
+                            <a:srgbClr val="263C50"/>
+                          </a:solidFill>
+                          <a:latin typeface="Bitstream Charter"/>
+                        </a:rPr>
+                        <a:t>personal details never saved</a:t>
+                      </a:r>
+                    </a:p>
+                  </a:txBody>
+                  <a:tcPr marL="64008" marR="64008" marT="32004" marB="32004" anchor="ctr">
+                    <a:lnB w="9525" cap="flat" cmpd="sng" algn="ctr">
+                      <a:solidFill>
+                        <a:srgbClr val="C9D6E2"/>
+                      </a:solidFill>
+                      <a:prstDash val="solid"/>
+                    </a:lnB>
+                    <a:solidFill>
+                      <a:srgbClr val="FFFFFF"/>
+                    </a:solidFill>
+                  </a:tcPr>
+                </a:tc>
+              </a:tr>
+              <a:tr h="301752">
+                <a:tc>
+                  <a:txBody>
+                    <a:bodyPr wrap="square"/>
+                    <a:lstStyle/>
+                    <a:p>
+                      <a:r>
+                        <a:rPr sz="950" b="0" i="0">
+                          <a:solidFill>
+                            <a:srgbClr val="263C50"/>
+                          </a:solidFill>
+                          <a:latin typeface="Bitstream Charter"/>
+                        </a:rPr>
+                        <a:t>review, language</a:t>
+                      </a:r>
+                    </a:p>
+                  </a:txBody>
+                  <a:tcPr marL="64008" marR="64008" marT="32004" marB="32004" anchor="ctr">
+                    <a:lnB w="9525" cap="flat" cmpd="sng" algn="ctr">
+                      <a:solidFill>
+                        <a:srgbClr val="C9D6E2"/>
+                      </a:solidFill>
+                      <a:prstDash val="solid"/>
+                    </a:lnB>
+                    <a:solidFill>
+                      <a:srgbClr val="EAF0F6"/>
+                    </a:solidFill>
+                  </a:tcPr>
+                </a:tc>
+                <a:tc>
+                  <a:txBody>
+                    <a:bodyPr wrap="square"/>
+                    <a:lstStyle/>
+                    <a:p>
+                      <a:r>
+                        <a:rPr sz="950" b="0" i="0">
+                          <a:solidFill>
+                            <a:srgbClr val="263C50"/>
+                          </a:solidFill>
+                          <a:latin typeface="Bitstream Charter"/>
+                        </a:rPr>
+                        <a:t>kept</a:t>
+                      </a:r>
+                    </a:p>
+                  </a:txBody>
+                  <a:tcPr marL="64008" marR="64008" marT="32004" marB="32004" anchor="ctr">
+                    <a:lnB w="9525" cap="flat" cmpd="sng" algn="ctr">
+                      <a:solidFill>
+                        <a:srgbClr val="C9D6E2"/>
+                      </a:solidFill>
+                      <a:prstDash val="solid"/>
+                    </a:lnB>
+                    <a:solidFill>
+                      <a:srgbClr val="EAF0F6"/>
+                    </a:solidFill>
+                  </a:tcPr>
+                </a:tc>
+                <a:tc>
+                  <a:txBody>
+                    <a:bodyPr wrap="square"/>
+                    <a:lstStyle/>
+                    <a:p>
+                      <a:r>
+                        <a:rPr sz="950" b="0" i="0">
+                          <a:solidFill>
+                            <a:srgbClr val="263C50"/>
+                          </a:solidFill>
+                          <a:latin typeface="Bitstream Charter"/>
+                        </a:rPr>
+                        <a:t>the text, and its language tag</a:t>
+                      </a:r>
+                    </a:p>
+                  </a:txBody>
+                  <a:tcPr marL="64008" marR="64008" marT="32004" marB="32004" anchor="ctr">
+                    <a:lnB w="9525" cap="flat" cmpd="sng" algn="ctr">
+                      <a:solidFill>
+                        <a:srgbClr val="C9D6E2"/>
+                      </a:solidFill>
+                      <a:prstDash val="solid"/>
+                    </a:lnB>
+                    <a:solidFill>
+                      <a:srgbClr val="EAF0F6"/>
+                    </a:solidFill>
+                  </a:tcPr>
+                </a:tc>
+              </a:tr>
+              <a:tr h="301752">
+                <a:tc>
+                  <a:txBody>
+                    <a:bodyPr wrap="square"/>
+                    <a:lstStyle/>
+                    <a:p>
+                      <a:r>
+                        <a:rPr sz="950" b="0" i="0">
+                          <a:solidFill>
+                            <a:srgbClr val="263C50"/>
+                          </a:solidFill>
+                          <a:latin typeface="Bitstream Charter"/>
+                        </a:rPr>
+                        <a:t>voted_up</a:t>
+                      </a:r>
+                    </a:p>
+                  </a:txBody>
+                  <a:tcPr marL="64008" marR="64008" marT="32004" marB="32004" anchor="ctr">
+                    <a:lnB w="9525" cap="flat" cmpd="sng" algn="ctr">
+                      <a:solidFill>
+                        <a:srgbClr val="C9D6E2"/>
+                      </a:solidFill>
+                      <a:prstDash val="solid"/>
+                    </a:lnB>
+                    <a:solidFill>
+                      <a:srgbClr val="FFFFFF"/>
+                    </a:solidFill>
+                  </a:tcPr>
+                </a:tc>
+                <a:tc>
+                  <a:txBody>
+                    <a:bodyPr wrap="square"/>
+                    <a:lstStyle/>
+                    <a:p>
+                      <a:r>
+                        <a:rPr sz="950" b="0" i="0">
+                          <a:solidFill>
+                            <a:srgbClr val="263C50"/>
+                          </a:solidFill>
+                          <a:latin typeface="Bitstream Charter"/>
+                        </a:rPr>
+                        <a:t>kept</a:t>
+                      </a:r>
+                    </a:p>
+                  </a:txBody>
+                  <a:tcPr marL="64008" marR="64008" marT="32004" marB="32004" anchor="ctr">
+                    <a:lnB w="9525" cap="flat" cmpd="sng" algn="ctr">
+                      <a:solidFill>
+                        <a:srgbClr val="C9D6E2"/>
+                      </a:solidFill>
+                      <a:prstDash val="solid"/>
+                    </a:lnB>
+                    <a:solidFill>
+                      <a:srgbClr val="FFFFFF"/>
+                    </a:solidFill>
+                  </a:tcPr>
+                </a:tc>
+                <a:tc>
+                  <a:txBody>
+                    <a:bodyPr wrap="square"/>
+                    <a:lstStyle/>
+                    <a:p>
+                      <a:r>
+                        <a:rPr sz="950" b="0" i="0">
+                          <a:solidFill>
+                            <a:srgbClr val="263C50"/>
+                          </a:solidFill>
+                          <a:latin typeface="Bitstream Charter"/>
+                        </a:rPr>
+                        <a:t>positive or negative: our prediction target</a:t>
+                      </a:r>
+                    </a:p>
+                  </a:txBody>
+                  <a:tcPr marL="64008" marR="64008" marT="32004" marB="32004" anchor="ctr">
+                    <a:lnB w="9525" cap="flat" cmpd="sng" algn="ctr">
+                      <a:solidFill>
+                        <a:srgbClr val="C9D6E2"/>
+                      </a:solidFill>
+                      <a:prstDash val="solid"/>
+                    </a:lnB>
+                    <a:solidFill>
+                      <a:srgbClr val="FFFFFF"/>
+                    </a:solidFill>
+                  </a:tcPr>
+                </a:tc>
+              </a:tr>
+              <a:tr h="301752">
+                <a:tc>
+                  <a:txBody>
+                    <a:bodyPr wrap="square"/>
+                    <a:lstStyle/>
+                    <a:p>
+                      <a:r>
+                        <a:rPr sz="950" b="0" i="0">
+                          <a:solidFill>
+                            <a:srgbClr val="263C50"/>
+                          </a:solidFill>
+                          <a:latin typeface="Bitstream Charter"/>
+                        </a:rPr>
+                        <a:t>author.playtime_at_review</a:t>
+                      </a:r>
+                    </a:p>
+                  </a:txBody>
+                  <a:tcPr marL="64008" marR="64008" marT="32004" marB="32004" anchor="ctr">
+                    <a:lnB w="9525" cap="flat" cmpd="sng" algn="ctr">
+                      <a:solidFill>
+                        <a:srgbClr val="C9D6E2"/>
+                      </a:solidFill>
+                      <a:prstDash val="solid"/>
+                    </a:lnB>
+                    <a:solidFill>
+                      <a:srgbClr val="EAF0F6"/>
+                    </a:solidFill>
+                  </a:tcPr>
+                </a:tc>
+                <a:tc>
+                  <a:txBody>
+                    <a:bodyPr wrap="square"/>
+                    <a:lstStyle/>
+                    <a:p>
+                      <a:r>
+                        <a:rPr sz="950" b="0" i="0">
+                          <a:solidFill>
+                            <a:srgbClr val="263C50"/>
+                          </a:solidFill>
+                          <a:latin typeface="Bitstream Charter"/>
+                        </a:rPr>
+                        <a:t>kept</a:t>
+                      </a:r>
+                    </a:p>
+                  </a:txBody>
+                  <a:tcPr marL="64008" marR="64008" marT="32004" marB="32004" anchor="ctr">
+                    <a:lnB w="9525" cap="flat" cmpd="sng" algn="ctr">
+                      <a:solidFill>
+                        <a:srgbClr val="C9D6E2"/>
+                      </a:solidFill>
+                      <a:prstDash val="solid"/>
+                    </a:lnB>
+                    <a:solidFill>
+                      <a:srgbClr val="EAF0F6"/>
+                    </a:solidFill>
+                  </a:tcPr>
+                </a:tc>
+                <a:tc>
+                  <a:txBody>
+                    <a:bodyPr wrap="square"/>
+                    <a:lstStyle/>
+                    <a:p>
+                      <a:r>
+                        <a:rPr sz="950" b="0" i="0">
+                          <a:solidFill>
+                            <a:srgbClr val="263C50"/>
+                          </a:solidFill>
+                          <a:latin typeface="Bitstream Charter"/>
+                        </a:rPr>
+                        <a:t>minutes played when the review was written</a:t>
+                      </a:r>
+                    </a:p>
+                  </a:txBody>
+                  <a:tcPr marL="64008" marR="64008" marT="32004" marB="32004" anchor="ctr">
+                    <a:lnB w="9525" cap="flat" cmpd="sng" algn="ctr">
+                      <a:solidFill>
+                        <a:srgbClr val="C9D6E2"/>
+                      </a:solidFill>
+                      <a:prstDash val="solid"/>
+                    </a:lnB>
+                    <a:solidFill>
+                      <a:srgbClr val="EAF0F6"/>
+                    </a:solidFill>
+                  </a:tcPr>
+                </a:tc>
+              </a:tr>
+              <a:tr h="301752">
+                <a:tc>
+                  <a:txBody>
+                    <a:bodyPr wrap="square"/>
+                    <a:lstStyle/>
+                    <a:p>
+                      <a:r>
+                        <a:rPr sz="950" b="0" i="0">
+                          <a:solidFill>
+                            <a:srgbClr val="263C50"/>
+                          </a:solidFill>
+                          <a:latin typeface="Bitstream Charter"/>
+                        </a:rPr>
+                        <a:t>timestamp_created</a:t>
+                      </a:r>
+                    </a:p>
+                  </a:txBody>
+                  <a:tcPr marL="64008" marR="64008" marT="32004" marB="32004" anchor="ctr">
+                    <a:lnB w="9525" cap="flat" cmpd="sng" algn="ctr">
+                      <a:solidFill>
+                        <a:srgbClr val="C9D6E2"/>
+                      </a:solidFill>
+                      <a:prstDash val="solid"/>
+                    </a:lnB>
+                    <a:solidFill>
+                      <a:srgbClr val="FFFFFF"/>
+                    </a:solidFill>
+                  </a:tcPr>
+                </a:tc>
+                <a:tc>
+                  <a:txBody>
+                    <a:bodyPr wrap="square"/>
+                    <a:lstStyle/>
+                    <a:p>
+                      <a:r>
+                        <a:rPr sz="950" b="0" i="0">
+                          <a:solidFill>
+                            <a:srgbClr val="263C50"/>
+                          </a:solidFill>
+                          <a:latin typeface="Bitstream Charter"/>
+                        </a:rPr>
+                        <a:t>kept</a:t>
+                      </a:r>
+                    </a:p>
+                  </a:txBody>
+                  <a:tcPr marL="64008" marR="64008" marT="32004" marB="32004" anchor="ctr">
+                    <a:lnB w="9525" cap="flat" cmpd="sng" algn="ctr">
+                      <a:solidFill>
+                        <a:srgbClr val="C9D6E2"/>
+                      </a:solidFill>
+                      <a:prstDash val="solid"/>
+                    </a:lnB>
+                    <a:solidFill>
+                      <a:srgbClr val="FFFFFF"/>
+                    </a:solidFill>
+                  </a:tcPr>
+                </a:tc>
+                <a:tc>
+                  <a:txBody>
+                    <a:bodyPr wrap="square"/>
+                    <a:lstStyle/>
+                    <a:p>
+                      <a:r>
+                        <a:rPr sz="950" b="0" i="0">
+                          <a:solidFill>
+                            <a:srgbClr val="263C50"/>
+                          </a:solidFill>
+                          <a:latin typeface="Bitstream Charter"/>
+                        </a:rPr>
+                        <a:t>converted to a UTC date</a:t>
+                      </a:r>
+                    </a:p>
+                  </a:txBody>
+                  <a:tcPr marL="64008" marR="64008" marT="32004" marB="32004" anchor="ctr">
+                    <a:lnB w="9525" cap="flat" cmpd="sng" algn="ctr">
+                      <a:solidFill>
+                        <a:srgbClr val="C9D6E2"/>
+                      </a:solidFill>
+                      <a:prstDash val="solid"/>
+                    </a:lnB>
+                    <a:solidFill>
+                      <a:srgbClr val="FFFFFF"/>
+                    </a:solidFill>
+                  </a:tcPr>
+                </a:tc>
+              </a:tr>
+              <a:tr h="301752">
+                <a:tc>
+                  <a:txBody>
+                    <a:bodyPr wrap="square"/>
+                    <a:lstStyle/>
+                    <a:p>
+                      <a:r>
+                        <a:rPr sz="950" b="0" i="0">
+                          <a:solidFill>
+                            <a:srgbClr val="263C50"/>
+                          </a:solidFill>
+                          <a:latin typeface="Bitstream Charter"/>
+                        </a:rPr>
+                        <a:t>hardware (CPU, GPU, RAM)</a:t>
+                      </a:r>
+                    </a:p>
+                  </a:txBody>
+                  <a:tcPr marL="64008" marR="64008" marT="32004" marB="32004" anchor="ctr">
+                    <a:lnB w="9525" cap="flat" cmpd="sng" algn="ctr">
+                      <a:solidFill>
+                        <a:srgbClr val="C9D6E2"/>
+                      </a:solidFill>
+                      <a:prstDash val="solid"/>
+                    </a:lnB>
+                    <a:solidFill>
+                      <a:srgbClr val="EAF0F6"/>
+                    </a:solidFill>
+                  </a:tcPr>
+                </a:tc>
+                <a:tc>
+                  <a:txBody>
+                    <a:bodyPr wrap="square"/>
+                    <a:lstStyle/>
+                    <a:p>
+                      <a:r>
+                        <a:rPr sz="950" b="1" i="0">
+                          <a:solidFill>
+                            <a:srgbClr val="D1495B"/>
+                          </a:solidFill>
+                          <a:latin typeface="Bitstream Charter"/>
+                        </a:rPr>
+                        <a:t>dropped</a:t>
+                      </a:r>
+                    </a:p>
+                  </a:txBody>
+                  <a:tcPr marL="64008" marR="64008" marT="32004" marB="32004" anchor="ctr">
+                    <a:lnB w="9525" cap="flat" cmpd="sng" algn="ctr">
+                      <a:solidFill>
+                        <a:srgbClr val="C9D6E2"/>
+                      </a:solidFill>
+                      <a:prstDash val="solid"/>
+                    </a:lnB>
+                    <a:solidFill>
+                      <a:srgbClr val="EAF0F6"/>
+                    </a:solidFill>
+                  </a:tcPr>
+                </a:tc>
+                <a:tc>
+                  <a:txBody>
+                    <a:bodyPr wrap="square"/>
+                    <a:lstStyle/>
+                    <a:p>
+                      <a:r>
+                        <a:rPr sz="950" b="0" i="0">
+                          <a:solidFill>
+                            <a:srgbClr val="263C50"/>
+                          </a:solidFill>
+                          <a:latin typeface="Bitstream Charter"/>
+                        </a:rPr>
+                        <a:t>not needed, so it is not carried forward</a:t>
+                      </a:r>
+                    </a:p>
+                  </a:txBody>
+                  <a:tcPr marL="64008" marR="64008" marT="32004" marB="32004" anchor="ctr">
+                    <a:lnB w="9525" cap="flat" cmpd="sng" algn="ctr">
+                      <a:solidFill>
+                        <a:srgbClr val="C9D6E2"/>
+                      </a:solidFill>
+                      <a:prstDash val="solid"/>
+                    </a:lnB>
+                    <a:solidFill>
+                      <a:srgbClr val="EAF0F6"/>
+                    </a:solidFill>
+                  </a:tcPr>
+                </a:tc>
+              </a:tr>
+            </a:tbl>
+          </a:graphicData>
+        </a:graphic>
+      </p:graphicFrame>
+      <p:sp>
+        <p:nvSpPr>
+          <p:cNvPr id="22" name="TextBox 21"/>
+          <p:cNvSpPr txBox="1"/>
+          <p:nvPr/>
+        </p:nvSpPr>
+        <p:spPr>
+          <a:xfrm>
+            <a:off x="5989320" y="4617720"/>
+            <a:ext cx="5486400" cy="256032"/>
+          </a:xfrm>
+          <a:prstGeom prst="rect">
+            <a:avLst/>
+          </a:prstGeom>
+          <a:noFill/>
+        </p:spPr>
+        <p:txBody>
+          <a:bodyPr wrap="square" lIns="45720" rIns="45720" tIns="27432" bIns="27432">
+            <a:spAutoFit/>
+          </a:bodyPr>
+          <a:lstStyle/>
+          <a:p>
+            <a:pPr>
+              <a:spcAft>
+                <a:spcPts val="400"/>
+              </a:spcAft>
+            </a:pPr>
+            <a:r>
+              <a:rPr sz="1100" b="1" i="0">
+                <a:solidFill>
+                  <a:srgbClr val="132C43"/>
+                </a:solidFill>
+                <a:latin typeface="Bitstream Charter"/>
+              </a:rPr>
+              <a:t>If something goes wrong</a:t>
+            </a:r>
+          </a:p>
+        </p:txBody>
+      </p:sp>
+      <p:sp>
+        <p:nvSpPr>
+          <p:cNvPr id="23" name="TextBox 22"/>
+          <p:cNvSpPr txBox="1"/>
+          <p:nvPr/>
+        </p:nvSpPr>
+        <p:spPr>
+          <a:xfrm>
+            <a:off x="5989320" y="4910327"/>
+            <a:ext cx="2743200" cy="292608"/>
+          </a:xfrm>
+          <a:prstGeom prst="rect">
+            <a:avLst/>
+          </a:prstGeom>
+          <a:noFill/>
+        </p:spPr>
+        <p:txBody>
+          <a:bodyPr wrap="square" lIns="45720" rIns="45720" tIns="27432" bIns="27432">
+            <a:spAutoFit/>
+          </a:bodyPr>
+          <a:lstStyle/>
+          <a:p>
+            <a:pPr>
+              <a:spcAft>
+                <a:spcPts val="0"/>
+              </a:spcAft>
+            </a:pPr>
+            <a:r>
+              <a:rPr sz="900" b="1" i="0">
+                <a:solidFill>
+                  <a:srgbClr val="D1495B"/>
+                </a:solidFill>
+                <a:latin typeface="Bitstream Charter"/>
+              </a:rPr>
+              <a:t>429 or network error: </a:t>
+            </a:r>
+            <a:r>
+              <a:rPr sz="900" b="0" i="0">
+                <a:solidFill>
+                  <a:srgbClr val="263C50"/>
+                </a:solidFill>
+                <a:latin typeface="Bitstream Charter"/>
+              </a:rPr>
+              <a:t>wait, retry, wait longer</a:t>
+            </a:r>
+          </a:p>
+        </p:txBody>
+      </p:sp>
+      <p:sp>
+        <p:nvSpPr>
+          <p:cNvPr id="24" name="TextBox 23"/>
+          <p:cNvSpPr txBox="1"/>
+          <p:nvPr/>
+        </p:nvSpPr>
+        <p:spPr>
+          <a:xfrm>
+            <a:off x="8750808" y="4910327"/>
+            <a:ext cx="2743200" cy="292608"/>
+          </a:xfrm>
+          <a:prstGeom prst="rect">
+            <a:avLst/>
+          </a:prstGeom>
+          <a:noFill/>
+        </p:spPr>
+        <p:txBody>
+          <a:bodyPr wrap="square" lIns="45720" rIns="45720" tIns="27432" bIns="27432">
+            <a:spAutoFit/>
+          </a:bodyPr>
+          <a:lstStyle/>
+          <a:p>
+            <a:pPr>
+              <a:spcAft>
+                <a:spcPts val="0"/>
+              </a:spcAft>
+            </a:pPr>
+            <a:r>
+              <a:rPr sz="900" b="1" i="0">
+                <a:solidFill>
+                  <a:srgbClr val="D1495B"/>
+                </a:solidFill>
+                <a:latin typeface="Bitstream Charter"/>
+              </a:rPr>
+              <a:t>Crash or Ctrl+C: </a:t>
+            </a:r>
+            <a:r>
+              <a:rPr sz="900" b="0" i="0">
+                <a:solidFill>
+                  <a:srgbClr val="263C50"/>
+                </a:solidFill>
+                <a:latin typeface="Bitstream Charter"/>
+              </a:rPr>
+              <a:t>resume from the saved cursor</a:t>
+            </a:r>
+          </a:p>
+        </p:txBody>
+      </p:sp>
+      <p:sp>
+        <p:nvSpPr>
+          <p:cNvPr id="25" name="TextBox 24"/>
+          <p:cNvSpPr txBox="1"/>
+          <p:nvPr/>
+        </p:nvSpPr>
+        <p:spPr>
+          <a:xfrm>
+            <a:off x="5989320" y="5166359"/>
+            <a:ext cx="2743200" cy="292608"/>
+          </a:xfrm>
+          <a:prstGeom prst="rect">
+            <a:avLst/>
+          </a:prstGeom>
+          <a:noFill/>
+        </p:spPr>
+        <p:txBody>
+          <a:bodyPr wrap="square" lIns="45720" rIns="45720" tIns="27432" bIns="27432">
+            <a:spAutoFit/>
+          </a:bodyPr>
+          <a:lstStyle/>
+          <a:p>
+            <a:pPr>
+              <a:spcAft>
+                <a:spcPts val="0"/>
+              </a:spcAft>
+            </a:pPr>
+            <a:r>
+              <a:rPr sz="900" b="1" i="0">
+                <a:solidFill>
+                  <a:srgbClr val="D1495B"/>
+                </a:solidFill>
+                <a:latin typeface="Bitstream Charter"/>
+              </a:rPr>
+              <a:t>Empty page too early: </a:t>
+            </a:r>
+            <a:r>
+              <a:rPr sz="900" b="0" i="0">
+                <a:solidFill>
+                  <a:srgbClr val="263C50"/>
+                </a:solidFill>
+                <a:latin typeface="Bitstream Charter"/>
+              </a:rPr>
+              <a:t>retry 3 times, then accept the end</a:t>
+            </a:r>
+          </a:p>
+        </p:txBody>
+      </p:sp>
+      <p:sp>
+        <p:nvSpPr>
+          <p:cNvPr id="26" name="TextBox 25"/>
+          <p:cNvSpPr txBox="1"/>
+          <p:nvPr/>
+        </p:nvSpPr>
+        <p:spPr>
+          <a:xfrm>
+            <a:off x="8750808" y="5166359"/>
+            <a:ext cx="2743200" cy="292608"/>
+          </a:xfrm>
+          <a:prstGeom prst="rect">
+            <a:avLst/>
+          </a:prstGeom>
+          <a:noFill/>
+        </p:spPr>
+        <p:txBody>
+          <a:bodyPr wrap="square" lIns="45720" rIns="45720" tIns="27432" bIns="27432">
+            <a:spAutoFit/>
+          </a:bodyPr>
+          <a:lstStyle/>
+          <a:p>
+            <a:pPr>
+              <a:spcAft>
+                <a:spcPts val="0"/>
+              </a:spcAft>
+            </a:pPr>
+            <a:r>
+              <a:rPr sz="900" b="1" i="0">
+                <a:solidFill>
+                  <a:srgbClr val="D1495B"/>
+                </a:solidFill>
+                <a:latin typeface="Bitstream Charter"/>
+              </a:rPr>
+              <a:t>Page saved twice: </a:t>
+            </a:r>
+            <a:r>
+              <a:rPr sz="900" b="0" i="0">
+                <a:solidFill>
+                  <a:srgbClr val="263C50"/>
+                </a:solidFill>
+                <a:latin typeface="Bitstream Charter"/>
+              </a:rPr>
+              <a:t>removed later on recommendationid</a:t>
+            </a:r>
+          </a:p>
+        </p:txBody>
+      </p:sp>
+      <p:sp>
+        <p:nvSpPr>
+          <p:cNvPr id="27" name="Rectangle 26"/>
+          <p:cNvSpPr/>
+          <p:nvPr/>
+        </p:nvSpPr>
+        <p:spPr>
+          <a:xfrm>
+            <a:off x="722376" y="5623560"/>
+            <a:ext cx="64008" cy="457200"/>
+          </a:xfrm>
+          <a:prstGeom prst="rect">
+            <a:avLst/>
+          </a:prstGeom>
+          <a:solidFill>
+            <a:srgbClr val="D1495B"/>
+          </a:solidFill>
+          <a:ln>
+            <a:noFill/>
+          </a:ln>
+        </p:spPr>
+        <p:style>
+          <a:lnRef idx="1">
+            <a:schemeClr val="accent1"/>
+          </a:lnRef>
+          <a:fillRef idx="3">
+            <a:schemeClr val="accent1"/>
+          </a:fillRef>
+          <a:effectRef idx="2">
+            <a:schemeClr val="accent1"/>
+          </a:effectRef>
+          <a:fontRef idx="minor">
+            <a:schemeClr val="lt1"/>
+          </a:fontRef>
+        </p:style>
+        <p:txBody>
+          <a:bodyPr rtlCol="0" anchor="ctr"/>
+          <a:lstStyle/>
+          <a:p>
+            <a:pPr algn="ctr"/>
+          </a:p>
+        </p:txBody>
+      </p:sp>
+      <p:sp>
+        <p:nvSpPr>
+          <p:cNvPr id="28" name="Rectangle 27"/>
+          <p:cNvSpPr/>
+          <p:nvPr/>
+        </p:nvSpPr>
+        <p:spPr>
+          <a:xfrm>
+            <a:off x="786384" y="5623560"/>
+            <a:ext cx="10680192" cy="457200"/>
+          </a:xfrm>
+          <a:prstGeom prst="rect">
+            <a:avLst/>
+          </a:prstGeom>
+          <a:solidFill>
+            <a:srgbClr val="EAF0F6"/>
+          </a:solidFill>
+          <a:ln>
+            <a:noFill/>
+          </a:ln>
+        </p:spPr>
+        <p:style>
+          <a:lnRef idx="1">
+            <a:schemeClr val="accent1"/>
+          </a:lnRef>
+          <a:fillRef idx="3">
+            <a:schemeClr val="accent1"/>
+          </a:fillRef>
+          <a:effectRef idx="2">
+            <a:schemeClr val="accent1"/>
+          </a:effectRef>
+          <a:fontRef idx="minor">
+            <a:schemeClr val="lt1"/>
+          </a:fontRef>
+        </p:style>
+        <p:txBody>
+          <a:bodyPr rtlCol="0" anchor="ctr" lIns="137160" wrap="square"/>
+          <a:lstStyle/>
+          <a:p>
+            <a:pPr algn="l">
+              <a:spcAft>
+                <a:spcPts val="0"/>
+              </a:spcAft>
+            </a:pPr>
+            <a:r>
+              <a:rPr sz="1250" b="1" i="0">
+                <a:solidFill>
+                  <a:srgbClr val="D1495B"/>
+                </a:solidFill>
+                <a:latin typeface="Bitstream Charter"/>
+              </a:rPr>
+              <a:t>Takeaway  </a:t>
+            </a:r>
+            <a:r>
+              <a:rPr sz="1250" b="1" i="0">
+                <a:solidFill>
+                  <a:srgbClr val="132C43"/>
+                </a:solidFill>
+                <a:latin typeface="Bitstream Charter"/>
+              </a:rPr>
+              <a:t>A game can be interrupted at any page and picked up again; no reviews are lost or counted twice.</a:t>
+            </a:r>
+          </a:p>
+        </p:txBody>
+      </p:sp>
+    </p:spTree>
   </p:cSld>
   <p:clrMapOvr>
     <a:masterClrMapping/>
@@ -14328,7 +18606,7 @@
                 <a:ea typeface="Bitstream Charter"/>
                 <a:cs typeface="Bitstream Charter"/>
               </a:rPr>
-              <a:t>05</a:t>
+              <a:t>07</a:t>
             </a:r>
           </a:p>
         </p:txBody>
@@ -15709,7 +19987,7 @@
                 <a:ea typeface="Bitstream Charter"/>
                 <a:cs typeface="Bitstream Charter"/>
               </a:rPr>
-              <a:t>06</a:t>
+              <a:t>08</a:t>
             </a:r>
           </a:p>
         </p:txBody>
@@ -16013,7 +20291,7 @@
                 <a:ea typeface="Bitstream Charter"/>
                 <a:cs typeface="Bitstream Charter"/>
               </a:rPr>
-              <a:t>11</a:t>
+              <a:t>13</a:t>
             </a:r>
           </a:p>
         </p:txBody>
@@ -16581,7 +20859,7 @@
                 <a:ea typeface="Bitstream Charter"/>
                 <a:cs typeface="Bitstream Charter"/>
               </a:rPr>
-              <a:t>12</a:t>
+              <a:t>14</a:t>
             </a:r>
           </a:p>
         </p:txBody>
@@ -17306,7 +21584,7 @@
                 <a:ea typeface="Bitstream Charter"/>
                 <a:cs typeface="Bitstream Charter"/>
               </a:rPr>
-              <a:t>13</a:t>
+              <a:t>15</a:t>
             </a:r>
           </a:p>
         </p:txBody>
@@ -18629,7 +22907,7 @@
                 <a:ea typeface="Bitstream Charter"/>
                 <a:cs typeface="Bitstream Charter"/>
               </a:rPr>
-              <a:t>17</a:t>
+              <a:t>19</a:t>
             </a:r>
           </a:p>
         </p:txBody>
@@ -20350,7 +24628,7 @@
                 </a:solidFill>
                 <a:latin typeface="Bitstream Charter"/>
               </a:rPr>
-              <a:t>37 commits and 12 merged pull requests so far.</a:t>
+              <a:t>38 commits and 12 merged pull requests so far.</a:t>
             </a:r>
           </a:p>
           <a:p>

</xml_diff>